<commit_message>
Revert "Merge pull request #5 from Evergarden0101/claude/racetrack-wall-boundaries-kvgieh"
This reverts commit 5e299afdc80eae998181a9f6fc36228976d2d4d9, reversing
changes made to c94b6b6dac7fb56dc3fd86549c00d461f6672a47.
</commit_message>
<xml_diff>
--- a/docs/CircuitAgents_intro_ja.pptx
+++ b/docs/CircuitAgents_intro_ja.pptx
@@ -16,12 +16,6 @@
     <p:sldId id="264" r:id="rId16"/>
     <p:sldId id="265" r:id="rId17"/>
     <p:sldId id="266" r:id="rId18"/>
-    <p:sldId id="267" r:id="rId19"/>
-    <p:sldId id="268" r:id="rId20"/>
-    <p:sldId id="269" r:id="rId21"/>
-    <p:sldId id="270" r:id="rId22"/>
-    <p:sldId id="271" r:id="rId23"/>
-    <p:sldId id="272" r:id="rId24"/>
   </p:sldIdLst>
   <p:sldSz cx="12191695" cy="6858000" type="screen4x3"/>
   <p:notesSz cx="6858000" cy="9144000"/>
@@ -518,7 +512,7 @@
           <a:lstStyle/>
           <a:p>
             <a:r>
-              <a:t>本日は CircuitAgents プロジェクトを 10 分で紹介します。highway-env をベースに、ゲームのレース環境に近づけるための改造を重ねて強化学習エージェントを育て、ONNX 経由で C# ゲームエンジンにデプロイするまでのパイプラインです。まず結果の映像とグラフをご覧いただき、その後で highway-env のデフォルト設定と我々が加えた変更の進化の過程、最後にセットアップとツールの使い方を説明します。</a:t>
+              <a:t>本日は CircuitAgents プロジェクトを紹介します。highway-env 上で強化学習させたレース走行エージェントを、ONNX 経由で C# ゲームエンジン (RE Engine) にデプロイするまでの一連のパイプラインです。まず結果からお見せし、その後に環境・学習設定の変更点、セットアップ方法、エクスポートツールの使い方を説明します。</a:t>
             </a:r>
           </a:p>
         </p:txBody>
@@ -588,7 +582,7 @@
           <a:lstStyle/>
           <a:p>
             <a:r>
-              <a:t>報酬設計です。グラフは実測した 1 ステップあたりの報酬で、状態ごとの「儲け」を示しています。設計の目標は、どんな抜け道よりも普通に走る方が得、という順序を作ることです。緑の 0.97 が正しく走った場合。壁でスタックしたら 0.45、壁に擦りながら進んでも 0.42 と、壁を使う行動は割に合いません。重要なのは青の 0.51、壁からバックで脱出する行動がスタックより明確に得なことです。実は最初、脱出報酬は壁に接触している間しか出ませんでした。すると脱出の一歩目、壁から 20 cm 離れた瞬間にバックのペナルティが復活してしまい、エージェントは「壁沿いを這う」ことを学びました。今は壁から 1 m の脱出ゾーンを設け、その中ではバック免除、壁から離れる距離に報酬を出します。もう 1 つの落とし穴が正規化です。合成報酬を [-3,3] から [0,1] に線形写像していますが、この範囲が実際の下限を覆っていないと、悪い状態が全部 0 に張り付いて「悪い」と「最悪」の区別が消え、学習が止まります。範囲の導出はコードにコメントで残し、重みを変えたら再導出するルールにしています。</a:t>
+              <a:t>学習済みモデルのエクスポートは export_onnx.py で行います。モードは 1 が full policy、2 が actor の channels-first、3 がエンジン用の channels-last NHWC、0 で全部です。エンジン側は必ず NHWC 版 ppo_actor_only_nhwc.onnx を使ってください。C# ビルダーは H×W×C の平坦配列を出力するため、channels-first 版に入れるとチャネルが混ざり、スロットル 0.4・ステア 0.2 程度のほぼ一定出力に退化します。トラック形状を変えたら export_track_json.py で JSON を再生成し、検証ハーネスを回します。C# 側には観測ビルダーに加えて、ステアリング平滑化・コーナー減速・スタック検出・学習と同一物理の CarController が入っています。</a:t>
             </a:r>
           </a:p>
         </p:txBody>
@@ -658,427 +652,7 @@
           <a:lstStyle/>
           <a:p>
             <a:r>
-              <a:t>観測はデフォルトの 2 チャネルから 10 チャネルに拡張しました。周囲車両の相対位置・相対速度、自車のレーンからの横ずれ lat_off と角度ずれ ang_off などです。追い越しと車線維持の両方に必要な情報です。視野も変えました。デフォルトは前後対称 ±18 m ですが、レースで重要なのは前方です。後方 9 m・前方 27 m の非対称にしました。27 m という数字は制動距離から来ています。16 m/s から 5 m/s² でフル制動すると 25.6 m。前方視野がこれより短いと、コーナーが見えてからでは止まれません。ぎりぎり収まるのが 27 m です。重要な注意として、自車の絶対座標は観測に含まれません。これによりコース暗記が不可能になり、反射的なレーン追従を学習せざるを得なくなります。これが 5 コース汎化の種明かしです。</a:t>
-            </a:r>
-          </a:p>
-        </p:txBody>
-      </p:sp>
-      <p:sp>
-        <p:nvSpPr>
-          <p:cNvPr id="4" name="Slide Number Placeholder 3"/>
-          <p:cNvSpPr>
-            <a:spLocks noGrp="1"/>
-          </p:cNvSpPr>
-          <p:nvPr>
-            <p:ph type="sldNum" idx="5" sz="quarter"/>
-          </p:nvPr>
-        </p:nvSpPr>
-        <p:spPr/>
-      </p:sp>
-    </p:spTree>
-  </p:cSld>
-  <p:clrMapOvr>
-    <a:masterClrMapping/>
-  </p:clrMapOvr>
-</p:notes>
-</file>
-
-<file path=ppt/notesSlides/notesSlide12.xml><?xml version="1.0" encoding="utf-8"?>
-<p:notes xmlns:a="http://schemas.openxmlformats.org/drawingml/2006/main" xmlns:p="http://schemas.openxmlformats.org/presentationml/2006/main" xmlns:r="http://schemas.openxmlformats.org/officeDocument/2006/relationships">
-  <p:cSld>
-    <p:spTree>
-      <p:nvGrpSpPr>
-        <p:cNvPr id="1" name=""/>
-        <p:cNvGrpSpPr/>
-        <p:nvPr/>
-      </p:nvGrpSpPr>
-      <p:grpSpPr>
-        <a:xfrm>
-          <a:off x="0" y="0"/>
-          <a:ext cx="0" cy="0"/>
-          <a:chOff x="0" y="0"/>
-          <a:chExt cx="0" cy="0"/>
-        </a:xfrm>
-      </p:grpSpPr>
-      <p:sp>
-        <p:nvSpPr>
-          <p:cNvPr id="2" name="Slide Image Placeholder 1"/>
-          <p:cNvSpPr>
-            <a:spLocks noGrp="1"/>
-          </p:cNvSpPr>
-          <p:nvPr>
-            <p:ph type="sldImg" idx="2"/>
-          </p:nvPr>
-        </p:nvSpPr>
-        <p:spPr/>
-      </p:sp>
-      <p:sp>
-        <p:nvSpPr>
-          <p:cNvPr id="3" name="Notes Placeholder 2"/>
-          <p:cNvSpPr>
-            <a:spLocks noGrp="1"/>
-          </p:cNvSpPr>
-          <p:nvPr>
-            <p:ph type="body" idx="3" sz="quarter"/>
-          </p:nvPr>
-        </p:nvSpPr>
-        <p:spPr/>
-        <p:txBody>
-          <a:bodyPr/>
-          <a:lstStyle/>
-          <a:p>
-            <a:r>
-              <a:t>コースも 1 つから 5 つに増やしました。oval と stadium が基礎、rect は 90 度コーナーの反復、chicane は左右の切り返しと最小半径 10 m のキンク、fast がメインの難コースです。config の track を random にするとエピソードごとに再抽選され、これが汎化学習になります。各トラックは C# 側にもプリセットと JSON で複製されていて、検証ハーネスがPython と C# の幾何が一致することを自動チェックします。トラックを追加するときはrace_env にビルダーを書き、C# プリセットを足し、JSON を再生成して検証を回す、という手順です。</a:t>
-            </a:r>
-          </a:p>
-        </p:txBody>
-      </p:sp>
-      <p:sp>
-        <p:nvSpPr>
-          <p:cNvPr id="4" name="Slide Number Placeholder 3"/>
-          <p:cNvSpPr>
-            <a:spLocks noGrp="1"/>
-          </p:cNvSpPr>
-          <p:nvPr>
-            <p:ph type="sldNum" idx="5" sz="quarter"/>
-          </p:nvPr>
-        </p:nvSpPr>
-        <p:spPr/>
-      </p:sp>
-    </p:spTree>
-  </p:cSld>
-  <p:clrMapOvr>
-    <a:masterClrMapping/>
-  </p:clrMapOvr>
-</p:notes>
-</file>
-
-<file path=ppt/notesSlides/notesSlide13.xml><?xml version="1.0" encoding="utf-8"?>
-<p:notes xmlns:a="http://schemas.openxmlformats.org/drawingml/2006/main" xmlns:p="http://schemas.openxmlformats.org/presentationml/2006/main" xmlns:r="http://schemas.openxmlformats.org/officeDocument/2006/relationships">
-  <p:cSld>
-    <p:spTree>
-      <p:nvGrpSpPr>
-        <p:cNvPr id="1" name=""/>
-        <p:cNvGrpSpPr/>
-        <p:nvPr/>
-      </p:nvGrpSpPr>
-      <p:grpSpPr>
-        <a:xfrm>
-          <a:off x="0" y="0"/>
-          <a:ext cx="0" cy="0"/>
-          <a:chOff x="0" y="0"/>
-          <a:chExt cx="0" cy="0"/>
-        </a:xfrm>
-      </p:grpSpPr>
-      <p:sp>
-        <p:nvSpPr>
-          <p:cNvPr id="2" name="Slide Image Placeholder 1"/>
-          <p:cNvSpPr>
-            <a:spLocks noGrp="1"/>
-          </p:cNvSpPr>
-          <p:nvPr>
-            <p:ph type="sldImg" idx="2"/>
-          </p:nvPr>
-        </p:nvSpPr>
-        <p:spPr/>
-      </p:sp>
-      <p:sp>
-        <p:nvSpPr>
-          <p:cNvPr id="3" name="Notes Placeholder 2"/>
-          <p:cNvSpPr>
-            <a:spLocks noGrp="1"/>
-          </p:cNvSpPr>
-          <p:nvPr>
-            <p:ph type="body" idx="3" sz="quarter"/>
-          </p:nvPr>
-        </p:nvSpPr>
-        <p:spPr/>
-        <p:txBody>
-          <a:bodyPr/>
-          <a:lstStyle/>
-          <a:p>
-            <a:r>
-              <a:t>学習は 2 フェーズの PPO です。フェーズ 1 で他車なしのレーン追従を覚え、フェーズ 2 で NPC を入れて学習率を下げ、追い越しをファインチューニングします。特徴抽出はカスタム CNN で、初期方策のスロットルバイアスを +0.4 にずらして序盤の探索が前に進むようにしています。ここでの教訓は fast-dev、つまり動作確認用の短縮設定です。以前はエントロピー係数 0.10 の 6.5 万ステップで、何度回しても曲がれるようになりませんでした。原因は、エントロピー報酬が『ランダムでい続けること』に支払われるため、報酬が [0,1] に圧縮された本環境では方策が確定するインセンティブに勝ってしまうことでした。現在は本番と同じ ent 0.02・lr 2e-4 のまま 12 万ステップに短縮し、『周回まで確実に到達する最小構成』としてエンドツーエンドで実測検証済みです。また PPO は学習終盤に退行することがあるため、最終モデルではなく EvalCallback のベストモデルを採用します。ノートブックには eval 報酬を周回数に換算するヤードスティックのセルを入れてあり、TensorBoard の数字だけで進捗判断ができます。</a:t>
-            </a:r>
-          </a:p>
-        </p:txBody>
-      </p:sp>
-      <p:sp>
-        <p:nvSpPr>
-          <p:cNvPr id="4" name="Slide Number Placeholder 3"/>
-          <p:cNvSpPr>
-            <a:spLocks noGrp="1"/>
-          </p:cNvSpPr>
-          <p:nvPr>
-            <p:ph type="sldNum" idx="5" sz="quarter"/>
-          </p:nvPr>
-        </p:nvSpPr>
-        <p:spPr/>
-      </p:sp>
-    </p:spTree>
-  </p:cSld>
-  <p:clrMapOvr>
-    <a:masterClrMapping/>
-  </p:clrMapOvr>
-</p:notes>
-</file>
-
-<file path=ppt/notesSlides/notesSlide14.xml><?xml version="1.0" encoding="utf-8"?>
-<p:notes xmlns:a="http://schemas.openxmlformats.org/drawingml/2006/main" xmlns:p="http://schemas.openxmlformats.org/presentationml/2006/main" xmlns:r="http://schemas.openxmlformats.org/officeDocument/2006/relationships">
-  <p:cSld>
-    <p:spTree>
-      <p:nvGrpSpPr>
-        <p:cNvPr id="1" name=""/>
-        <p:cNvGrpSpPr/>
-        <p:nvPr/>
-      </p:nvGrpSpPr>
-      <p:grpSpPr>
-        <a:xfrm>
-          <a:off x="0" y="0"/>
-          <a:ext cx="0" cy="0"/>
-          <a:chOff x="0" y="0"/>
-          <a:chExt cx="0" cy="0"/>
-        </a:xfrm>
-      </p:grpSpPr>
-      <p:sp>
-        <p:nvSpPr>
-          <p:cNvPr id="2" name="Slide Image Placeholder 1"/>
-          <p:cNvSpPr>
-            <a:spLocks noGrp="1"/>
-          </p:cNvSpPr>
-          <p:nvPr>
-            <p:ph type="sldImg" idx="2"/>
-          </p:nvPr>
-        </p:nvSpPr>
-        <p:spPr/>
-      </p:sp>
-      <p:sp>
-        <p:nvSpPr>
-          <p:cNvPr id="3" name="Notes Placeholder 2"/>
-          <p:cNvSpPr>
-            <a:spLocks noGrp="1"/>
-          </p:cNvSpPr>
-          <p:nvPr>
-            <p:ph type="body" idx="3" sz="quarter"/>
-          </p:nvPr>
-        </p:nvSpPr>
-        <p:spPr/>
-        <p:txBody>
-          <a:bodyPr/>
-          <a:lstStyle/>
-          <a:p>
-            <a:r>
-              <a:t>学習した方策をそのままゲームに載せると、シミュレータと実車の違いが問題になります。そのために C# 側に 4 つの支援クラスを用意しました。まず SteeringSmoother。方策は観測グリッドが 3 m 刻みで量子化されている影響で、直線でステアを細かく左右に振ります。デコード後のステア角に EMA をかけるだけで、符号反転が 100 ステップあたり 34 回から 12 回に減り、直線の中央維持もむしろ改善しました。次に CorneringLimiter。実車はハンドルを瞬時に切れないのでステア速度を制限し、曲率から計算した限界速度を超えたら超過量に比例した弱いブレーキをかけます。速度床があるので絶対に止まりません。StuckRecovery は移動距離ベースのスタック検出で、前進指示なのに 1 秒で 0.3 m も動けなければ壁に刺さっていると判断してバック指示を出します。発進時は動けるので誤発動しません。最後に CarController は学習時と同一のBicycle 動力学を C# に移植したもので、Python と 1e-7 で一致します。</a:t>
-            </a:r>
-          </a:p>
-        </p:txBody>
-      </p:sp>
-      <p:sp>
-        <p:nvSpPr>
-          <p:cNvPr id="4" name="Slide Number Placeholder 3"/>
-          <p:cNvSpPr>
-            <a:spLocks noGrp="1"/>
-          </p:cNvSpPr>
-          <p:nvPr>
-            <p:ph type="sldNum" idx="5" sz="quarter"/>
-          </p:nvPr>
-        </p:nvSpPr>
-        <p:spPr/>
-      </p:sp>
-    </p:spTree>
-  </p:cSld>
-  <p:clrMapOvr>
-    <a:masterClrMapping/>
-  </p:clrMapOvr>
-</p:notes>
-</file>
-
-<file path=ppt/notesSlides/notesSlide15.xml><?xml version="1.0" encoding="utf-8"?>
-<p:notes xmlns:a="http://schemas.openxmlformats.org/drawingml/2006/main" xmlns:p="http://schemas.openxmlformats.org/presentationml/2006/main" xmlns:r="http://schemas.openxmlformats.org/officeDocument/2006/relationships">
-  <p:cSld>
-    <p:spTree>
-      <p:nvGrpSpPr>
-        <p:cNvPr id="1" name=""/>
-        <p:cNvGrpSpPr/>
-        <p:nvPr/>
-      </p:nvGrpSpPr>
-      <p:grpSpPr>
-        <a:xfrm>
-          <a:off x="0" y="0"/>
-          <a:ext cx="0" cy="0"/>
-          <a:chOff x="0" y="0"/>
-          <a:chExt cx="0" cy="0"/>
-        </a:xfrm>
-      </p:grpSpPr>
-      <p:sp>
-        <p:nvSpPr>
-          <p:cNvPr id="2" name="Slide Image Placeholder 1"/>
-          <p:cNvSpPr>
-            <a:spLocks noGrp="1"/>
-          </p:cNvSpPr>
-          <p:nvPr>
-            <p:ph type="sldImg" idx="2"/>
-          </p:nvPr>
-        </p:nvSpPr>
-        <p:spPr/>
-      </p:sp>
-      <p:sp>
-        <p:nvSpPr>
-          <p:cNvPr id="3" name="Notes Placeholder 2"/>
-          <p:cNvSpPr>
-            <a:spLocks noGrp="1"/>
-          </p:cNvSpPr>
-          <p:nvPr>
-            <p:ph type="body" idx="3" sz="quarter"/>
-          </p:nvPr>
-        </p:nvSpPr>
-        <p:spPr/>
-        <p:txBody>
-          <a:bodyPr/>
-          <a:lstStyle/>
-          <a:p>
-            <a:r>
-              <a:t>使い方です。環境構築はスライドの 1 行だけです。注意点として、リポジトリ直下のrequirements.txt は旧 TensorFlow スタック用なので使わないでください。ノートブックは 2 つ。task2 が fast トラック専用、task3 がランダムトラックの汎化学習です。設定セルの FAST_DEV_RUN で短縮学習と本番を切り替えます。学習後は軌跡プロット、トラック別評価レポート、5 トラック並列動画、そして今回のスライドに使った図と動画を生成して保存するセルまで、すべてノートブック内にあります。C# ポートの検証は re_engine/verify で dotnet run するだけです。</a:t>
-            </a:r>
-          </a:p>
-        </p:txBody>
-      </p:sp>
-      <p:sp>
-        <p:nvSpPr>
-          <p:cNvPr id="4" name="Slide Number Placeholder 3"/>
-          <p:cNvSpPr>
-            <a:spLocks noGrp="1"/>
-          </p:cNvSpPr>
-          <p:nvPr>
-            <p:ph type="sldNum" idx="5" sz="quarter"/>
-          </p:nvPr>
-        </p:nvSpPr>
-        <p:spPr/>
-      </p:sp>
-    </p:spTree>
-  </p:cSld>
-  <p:clrMapOvr>
-    <a:masterClrMapping/>
-  </p:clrMapOvr>
-</p:notes>
-</file>
-
-<file path=ppt/notesSlides/notesSlide16.xml><?xml version="1.0" encoding="utf-8"?>
-<p:notes xmlns:a="http://schemas.openxmlformats.org/drawingml/2006/main" xmlns:p="http://schemas.openxmlformats.org/presentationml/2006/main" xmlns:r="http://schemas.openxmlformats.org/officeDocument/2006/relationships">
-  <p:cSld>
-    <p:spTree>
-      <p:nvGrpSpPr>
-        <p:cNvPr id="1" name=""/>
-        <p:cNvGrpSpPr/>
-        <p:nvPr/>
-      </p:nvGrpSpPr>
-      <p:grpSpPr>
-        <a:xfrm>
-          <a:off x="0" y="0"/>
-          <a:ext cx="0" cy="0"/>
-          <a:chOff x="0" y="0"/>
-          <a:chExt cx="0" cy="0"/>
-        </a:xfrm>
-      </p:grpSpPr>
-      <p:sp>
-        <p:nvSpPr>
-          <p:cNvPr id="2" name="Slide Image Placeholder 1"/>
-          <p:cNvSpPr>
-            <a:spLocks noGrp="1"/>
-          </p:cNvSpPr>
-          <p:nvPr>
-            <p:ph type="sldImg" idx="2"/>
-          </p:nvPr>
-        </p:nvSpPr>
-        <p:spPr/>
-      </p:sp>
-      <p:sp>
-        <p:nvSpPr>
-          <p:cNvPr id="3" name="Notes Placeholder 2"/>
-          <p:cNvSpPr>
-            <a:spLocks noGrp="1"/>
-          </p:cNvSpPr>
-          <p:nvPr>
-            <p:ph type="body" idx="3" sz="quarter"/>
-          </p:nvPr>
-        </p:nvSpPr>
-        <p:spPr/>
-        <p:txBody>
-          <a:bodyPr/>
-          <a:lstStyle/>
-          <a:p>
-            <a:r>
-              <a:t>デプロイ用のエクスポートは export_onnx.py です。モード 3 がエンジン用のchannels-last NHWC 版で、これが推奨です。C# の観測ビルダーは H×W×C の平坦配列を出力するため、channels-first 版のモデルに入れるとチャネルが混ざり、スロットル 0.4・ステア 0.2 程度のほぼ一定の出力に退化します。実際にこの症状で『モデルが曲がらない』というデバッグを経験したので、症状として覚えておいてください。トラックや観測の設定を変えたら、export_track_json.py で C# 側の正解データを再生成し、検証ハーネスを回します。加速度レンジなどの定数は C# 側に意図的に複製されているので、変更時は C# 定数、JSON 再生成、検証、ONNX 再エクスポートの 4 点セットを忘れずに。</a:t>
-            </a:r>
-          </a:p>
-        </p:txBody>
-      </p:sp>
-      <p:sp>
-        <p:nvSpPr>
-          <p:cNvPr id="4" name="Slide Number Placeholder 3"/>
-          <p:cNvSpPr>
-            <a:spLocks noGrp="1"/>
-          </p:cNvSpPr>
-          <p:nvPr>
-            <p:ph type="sldNum" idx="5" sz="quarter"/>
-          </p:nvPr>
-        </p:nvSpPr>
-        <p:spPr/>
-      </p:sp>
-    </p:spTree>
-  </p:cSld>
-  <p:clrMapOvr>
-    <a:masterClrMapping/>
-  </p:clrMapOvr>
-</p:notes>
-</file>
-
-<file path=ppt/notesSlides/notesSlide17.xml><?xml version="1.0" encoding="utf-8"?>
-<p:notes xmlns:a="http://schemas.openxmlformats.org/drawingml/2006/main" xmlns:p="http://schemas.openxmlformats.org/presentationml/2006/main" xmlns:r="http://schemas.openxmlformats.org/officeDocument/2006/relationships">
-  <p:cSld>
-    <p:spTree>
-      <p:nvGrpSpPr>
-        <p:cNvPr id="1" name=""/>
-        <p:cNvGrpSpPr/>
-        <p:nvPr/>
-      </p:nvGrpSpPr>
-      <p:grpSpPr>
-        <a:xfrm>
-          <a:off x="0" y="0"/>
-          <a:ext cx="0" cy="0"/>
-          <a:chOff x="0" y="0"/>
-          <a:chExt cx="0" cy="0"/>
-        </a:xfrm>
-      </p:grpSpPr>
-      <p:sp>
-        <p:nvSpPr>
-          <p:cNvPr id="2" name="Slide Image Placeholder 1"/>
-          <p:cNvSpPr>
-            <a:spLocks noGrp="1"/>
-          </p:cNvSpPr>
-          <p:nvPr>
-            <p:ph type="sldImg" idx="2"/>
-          </p:nvPr>
-        </p:nvSpPr>
-        <p:spPr/>
-      </p:sp>
-      <p:sp>
-        <p:nvSpPr>
-          <p:cNvPr id="3" name="Notes Placeholder 2"/>
-          <p:cNvSpPr>
-            <a:spLocks noGrp="1"/>
-          </p:cNvSpPr>
-          <p:nvPr>
-            <p:ph type="body" idx="3" sz="quarter"/>
-          </p:nvPr>
-        </p:nvSpPr>
-        <p:spPr/>
-        <p:txBody>
-          <a:bodyPr/>
-          <a:lstStyle/>
-          <a:p>
-            <a:r>
-              <a:t>まとめます。highway-env のデフォルトはステアリングだけの車線追従環境でした。そこにスロットルと実車動力学、物理的な壁、速く走る報酬、前方に偏った視野を段階的に加え、壁擦りや壁這いといった抜け道をひとつずつ経済的に割に合わなくして、最終的に 6 万ステップで周回を学習する環境になりました。汎化は自己位置を見せないという観測設計から生まれ、C# 側は数値一致の検証で「移植したら挙動が変わった」を排除しています。今後は RE Engine 内での実走検証と、実車ダイナミクスへの適合が次のステップです。ご清聴ありがとうございました。</a:t>
+              <a:t>まとめです。壁の物理と報酬の経済設計を作り込むことで、PPO は 6 万ステップで周回を学習し、ランダムトラック学習によって 1 つの方策が 5 コースすべてを走れるようになりました。C# 側は観測・物理ともに Python と数値一致で検証済みなので、エンジンに載せた瞬間から学習時と同じ挙動が期待できます。今後はゲーム内での実走検証と、実車ダイナミクスに合わせた微調整が次のステップです。ご清聴ありがとうございました。</a:t>
             </a:r>
           </a:p>
         </p:txBody>
@@ -1148,7 +722,7 @@
           <a:lstStyle/>
           <a:p>
             <a:r>
-              <a:t>説明の前に、まず走りをご覧ください。これはエピソードごとにコースをランダムに切り替えて学習した「汎化モデル」1 つを、5 つのコースで同時に評価した動画です。赤い点が車、軌跡の色が速度です。直線では黄色、つまり制限速度の 16 m/s 付近、コーナーでは適切に減速しているのが分かります。どのコースも 2 分間、壁への衝突ゼロで周回し続けます。では、この走りがどう作られたかを見ていきます。</a:t>
+              <a:t>最初に結果です。PPO エージェントはメインの fast トラックを制限速度 16 m/s で安定走行し、800 秒のエピソードで 37 周、壁への衝突ゼロを達成しました。学習は 3 万〜6 万ステップで周回能力が立ち上がり、12 万ステップの fast-dev 設定でも周回します。さらに、ランダムトラックで学習した汎化モデルは、5 種類すべてのコースを同一の重みで走り切ります。C# 側の観測生成は Python 環境とビット一致で検証済みです。</a:t>
             </a:r>
           </a:p>
         </p:txBody>
@@ -1218,7 +792,7 @@
           <a:lstStyle/>
           <a:p>
             <a:r>
-              <a:t>学習の速さです。横軸が学習ステップ、縦軸が 1 エピソードあたりの周回数です。青が fast トラック単体の学習で、3 万ステップでは 1 周で壁に刺さりますが、6 万で 32 周、9 万で 36 周に達し、以降は制限速度巡航に収束します。オレンジがランダムトラック学習で、最難関の chicane 評価でも 5 万ステップから 33 周と、ほぼ同じ速度で立ち上がります。この速さは偶然ではなく、後で説明する報酬設計の結果です。</a:t>
+              <a:t>学習の立ち上がりです。横軸が学習ステップ、縦軸がエピソードあたりの周回数です。3 万ステップでは 1 周程度で壁に刺さりますが、6 万ステップで 32 周、9 万で 36 周に達し、以降は制限速度での巡航に収束します。ランダムトラック学習 (task3) でも、最難関の chicane 評価で 5 万ステップ時点から 33 周と、ほぼ同じ速度で立ち上がります。報酬が密に設計されているため学習が速いのが特徴です。</a:t>
             </a:r>
           </a:p>
         </p:txBody>
@@ -1288,7 +862,7 @@
           <a:lstStyle/>
           <a:p>
             <a:r>
-              <a:t>1 台分の軌跡を拡大したものです。12 万ステップの fast-dev モデルの 2 分間で、黒線がコースの物理壁、点の色が速度です。直線で最高速に達し、ヘアピン進入で青く、つまりしっかり減速し、出口で再加速しています。以前は S 字の先の e-f コーナーで壁に張り付いて動けなくなる問題がありましたが、報酬の再設計で解消しました。この「壁に張り付く」問題との戦いが、本プロジェクトの中心的なエピソードです。</a:t>
+              <a:t>12 万ステップの fast-dev モデルの 2 分間の走行軌跡です。黒線がコース外壁、点の色が速度を表します。直線では 16 m/s、ヘアピンでは適切に減速して立て直しているのが分かります。以前問題になっていた e-f コーナーの壁張り付きも解消されています。</a:t>
             </a:r>
           </a:p>
         </p:txBody>
@@ -1358,7 +932,7 @@
           <a:lstStyle/>
           <a:p>
             <a:r>
-              <a:t>映像で見ていただいた結果を数字でまとめます。fast トラックで 800 秒 37 周・無衝突。周回能力の獲得は 3 万から 6 万ステップ。12 万ステップの短縮設定 fast-dev でも、NPC ありのフェーズ 2 まで通して 37 周を維持します。汎化モデルは 5 コースすべてを平均 15.7 m/s で走破。そして C# 側の観測生成は Python とビット一致、車両物理も 1e-7 で一致しており、エンジンに載せた瞬間から学習時と同じ挙動が保証されます。</a:t>
+              <a:t>こちらが汎化モデルの結果です。エピソードごとにトラックをランダムに切り替えて 15 万ステップ学習した1 つの方策を、5 つのコースで同時に評価しました。すべてのコースを平均 15.7 m/s、2 分間ノーミスで周回します。エージェントは自己位置を観測できないため、コース形状を暗記できず、反射的なレーン追従を学習したことが汎化の理由です。動画はスライドに埋め込んであります。再生してご覧ください。</a:t>
             </a:r>
           </a:p>
         </p:txBody>
@@ -1428,7 +1002,7 @@
           <a:lstStyle/>
           <a:p>
             <a:r>
-              <a:t>ここからが本題です。ベースにした highway-env は自動運転研究向けの軽量シミュレータで、racetrack 環境がレース走行に一番近いものです。ただしデフォルト設定を詳しく見ると、ゲームのレースとはかなり違います。まず行動はステアリングのみで、速度は 0・5・10 の離散ターゲットから選ぶだけ。スロットルという概念がありません。観測は presence と on_road の2 チャネルだけで、周囲 18 m の対称視野。報酬は車線中央維持と操作量ペナルティが中心で、速く走る動機がありません。そして路外に出ても物理的な壁はなく、エピソードが終わるだけです。車両も既定ではタイヤスリップのない運動学モデルです。</a:t>
+              <a:t>使用している 5 つのトラックです。すべて 2 車線・幅 5 m で、直線と円弧のみで構成しています。fast は S 字と 2 つのヘアピンを持つメインコース、oval と stadium は基礎、rect は 90 度コーナーの繰り返し、chicane は左右両方向の切り返しと最小半径 10 m のキンクを持ちます。各トラックは C# 側のプリセットと track_&lt;name&gt;.json にも複製され、検証ハーネスが両者の幾何一致を自動チェックします。</a:t>
             </a:r>
           </a:p>
         </p:txBody>
@@ -1498,7 +1072,7 @@
           <a:lstStyle/>
           <a:p>
             <a:r>
-              <a:t>左が highway-env デフォルトの racetrack、右が我々の fast トラックです。形状も作り直し、S 字と 2 つのヘアピンを持たせて難所を意図的に作りました。しかし本質的な違いは形ではなく物理です。左はステアリングだけ・壁なし・10 m/s、右はスロットル制御・外周が物理壁・16 m/s で、壁に当たると停止しバックでしか脱出できません。この差を埋めるために行った変更を、これから順番に説明します。</a:t>
+              <a:t>オリジナルの highway-env racetrack 環境との違いです。1 つ目は壁の物理です。標準では路外に出ても罰則だけですが、本環境ではコース外周だけを物理的な壁とし、車線間の白線は壁にしません。壁に当たると停止し、バックでしか脱出できません。2 つ目は報酬設計です。速度・車線中央維持・チェックポイント/ラップボーナスを生の単位で合成し、[-3,3] から [0,1] へ線形写像します。この範囲が実際の報酬の下限を覆っていないと、悪い状態がすべて 0 に飽和して勾配が消えるため、範囲の導出をコメントで管理しています。3 つ目は壁脱出の経済設計です。壁から 1 m 以内ではバック走行のペナルティを免除し、壁からの距離増加に報酬を与えます。これがないと、脱出の一歩目で罰せられて壁沿いを這う局所解を学習してしまいます。</a:t>
             </a:r>
           </a:p>
         </p:txBody>
@@ -1568,7 +1142,7 @@
           <a:lstStyle/>
           <a:p>
             <a:r>
-              <a:t>最初の変更は行動空間です。ゲームの車はアクセルとブレーキを踏むので、ステアリング専用だったものを連続スロットル付きの 2 次元連続行動に変更し、加速度レンジは ±5 m/s²、ステアは ±30 度としました。車両モデルもタイヤスリップを持つ動的 Bicycle モデルに切り替えています。加速度レンジは実験で決めました。グラフの赤い破線が ±2.5 m/s² に絞った実験で、10 万ステップで 22 周までは学習できるものの巡航速度が 10 m/s に頭打ちし、終盤には退行しました。原因は制動距離です。16 m/s から 2.5 m/s² で止まるには 51 m 必要ですが、観測の前方視野は 27 m しかなく、「見えてから減速」が物理的に間に合いません。エンジン出力を絞りたい場合はブレーキだけ強い非対称レンジ [−5, +2.5] を推奨しています。</a:t>
+              <a:t>観測は 10 チャネル 12x12 の OccupancyGrid で、前方 27 m・後方 9 m の非対称な視野にしています。レース走行ではコーナーの先読みが重要なためです。行動は連続値のスロットルとステアリングで、学習時と同じ動力学モデル (タイヤスリップ付き Bicycle model) を使います。学習は 2 フェーズの PPO です。フェーズ 1 で他車なしのレーン追従、フェーズ 2 で NPC を加えた追い越しをファインチューニングします。初期方策のスロットルバイアスを +0.4 にずらし、序盤の探索で前進が出やすくしています。fast-dev は 12 万ステップで、本番と同じハイパーパラメータのまま短縮した「周回まで確実に到達する最小構成」です。</a:t>
             </a:r>
           </a:p>
         </p:txBody>
@@ -1638,7 +1212,7 @@
           <a:lstStyle/>
           <a:p>
             <a:r>
-              <a:t>次に壁です。ここが一番試行錯誤した部分です。最初は壁がなく、路外に出たら終了するだけでした。これだとエージェントはコーナーを膨らんでショートカットする走りを覚えます。次に反発壁を入れましたが、今度は「壁に擦りながら曲がる」wall-riding が最速解になりました。壁が勝手に車の向きを変えてくれるので、ステアリングを学ぶ必要がなくなるんです。最終形は停止壁です。壁に当たると止まり、バックでしか脱出できない。さらに壁接触中は速度報酬をゼロにし、接触が 7 秒続いたらクラッシュ扱いで終了します。もう 1 つ重要なのは、壁はコース外周だけという点です。車線の白線を壁にすると2 車線を使ったライン取りができなくなります。この判定は最初閉じた車線単位で書いてしまい、白線が壁になるバグを踏みました。現在は「コリドー両端の車線の外側だけが壁」という実装です。</a:t>
+              <a:t>環境構築はこの 1 行です。リポジトリ直下の requirements.txt は旧 TensorFlow 系スタック用なので使わないでください。ノートブックは 2 つあり、task2 が fast トラック専用、task3 がランダムトラックの汎化学習用です。設定セルの FAST_DEV_RUN を True にすると短縮学習、False にすると本番学習になります。学習の進捗は Reward yardstick セルの数値と TensorBoard で確認でき、eval/mean_reward が周回相当値を超えたら周回できています。</a:t>
             </a:r>
           </a:p>
         </p:txBody>
@@ -4684,18 +4258,18 @@
                 </a:solidFill>
                 <a:latin typeface="Meiryo"/>
               </a:rPr>
-              <a:t>強化学習によるサーキット走行エージェント — highway-env をゲーム環境へ進化させる</a:t>
+              <a:t>強化学習によるサーキット走行エージェント — highway-env + PPO から RE Engine (ONNX) まで</a:t>
             </a:r>
           </a:p>
           <a:p>
             <a:r>
               <a:rPr sz="1800">
                 <a:solidFill>
-                  <a:srgbClr val="595959"/>
+                  <a:srgbClr val="666666"/>
                 </a:solidFill>
                 <a:latin typeface="Meiryo"/>
               </a:rPr>
-              <a:t>環境設計の変遷・学習パイプライン・RE Engine (ONNX/C#) デプロイ</a:t>
+              <a:t>学習環境・報酬設計・C# デプロイパイプラインの全体紹介</a:t>
             </a:r>
           </a:p>
         </p:txBody>
@@ -4726,8 +4300,8 @@
         </p:nvSpPr>
         <p:spPr>
           <a:xfrm>
-            <a:off x="457200" y="201168"/>
-            <a:ext cx="11247120" cy="777240"/>
+            <a:off x="457200" y="228600"/>
+            <a:ext cx="11247120" cy="822960"/>
           </a:xfrm>
           <a:prstGeom prst="rect">
             <a:avLst/>
@@ -4741,51 +4315,27 @@
           <a:lstStyle/>
           <a:p>
             <a:r>
-              <a:rPr sz="2800" b="1">
+              <a:rPr sz="3000" b="1">
                 <a:solidFill>
                   <a:srgbClr val="1B5EA8"/>
                 </a:solidFill>
                 <a:latin typeface="Meiryo"/>
               </a:rPr>
-              <a:t>進化 (3) 報酬の経済設計 — 抜け道より運転が得になるまで</a:t>
-            </a:r>
-          </a:p>
-        </p:txBody>
-      </p:sp>
-      <p:pic>
-        <p:nvPicPr>
-          <p:cNvPr id="3" name="Picture 2" descr="reward_economics.png"/>
-          <p:cNvPicPr>
-            <a:picLocks noChangeAspect="1"/>
-          </p:cNvPicPr>
+              <a:t>エクスポートツールと C# デプロイ</a:t>
+            </a:r>
+          </a:p>
+        </p:txBody>
+      </p:sp>
+      <p:sp>
+        <p:nvSpPr>
+          <p:cNvPr id="3" name="TextBox 2"/>
+          <p:cNvSpPr txBox="1"/>
           <p:nvPr/>
-        </p:nvPicPr>
-        <p:blipFill>
-          <a:blip r:embed="rId3"/>
-          <a:stretch>
-            <a:fillRect/>
-          </a:stretch>
-        </p:blipFill>
+        </p:nvSpPr>
         <p:spPr>
           <a:xfrm>
-            <a:off x="640080" y="1188720"/>
-            <a:ext cx="6766560" cy="3304599"/>
-          </a:xfrm>
-          <a:prstGeom prst="rect">
-            <a:avLst/>
-          </a:prstGeom>
-        </p:spPr>
-      </p:pic>
-      <p:sp>
-        <p:nvSpPr>
-          <p:cNvPr id="4" name="TextBox 3"/>
-          <p:cNvSpPr txBox="1"/>
-          <p:nvPr/>
-        </p:nvSpPr>
-        <p:spPr>
-          <a:xfrm>
-            <a:off x="7589520" y="1371600"/>
-            <a:ext cx="4206240" cy="5394960"/>
+            <a:off x="548640" y="1280160"/>
+            <a:ext cx="11064240" cy="5120640"/>
           </a:xfrm>
           <a:prstGeom prst="rect">
             <a:avLst/>
@@ -4800,97 +4350,129 @@
           <a:p>
             <a:pPr>
               <a:spcAft>
-                <a:spcPts val="500"/>
+                <a:spcPts val="600"/>
               </a:spcAft>
             </a:pPr>
             <a:r>
-              <a:rPr sz="1400" b="1">
+              <a:rPr sz="1700" b="1">
                 <a:solidFill>
                   <a:srgbClr val="222222"/>
                 </a:solidFill>
                 <a:latin typeface="Meiryo"/>
               </a:rPr>
-              <a:t>目標: 運転 &gt; 脱出 &gt; 停滞 &gt; 壁擦り の順序</a:t>
+              <a:t>python export_onnx.py &lt;model.zip&gt; -m 3        # エンジン用 NHWC (推奨)</a:t>
+            </a:r>
+          </a:p>
+          <a:p>
+            <a:pPr lvl="1">
+              <a:spcAft>
+                <a:spcPts val="600"/>
+              </a:spcAft>
+            </a:pPr>
+            <a:r>
+              <a:rPr sz="1500" b="0">
+                <a:solidFill>
+                  <a:srgbClr val="666666"/>
+                </a:solidFill>
+                <a:latin typeface="Meiryo"/>
+              </a:rPr>
+              <a:t>  -m: 1=full policy / 2=actor CHW / 3=actor NHWC / 0=全部,  -o で出力名指定</a:t>
             </a:r>
           </a:p>
           <a:p>
             <a:pPr>
               <a:spcAft>
-                <a:spcPts val="500"/>
+                <a:spcPts val="600"/>
               </a:spcAft>
             </a:pPr>
             <a:r>
-              <a:rPr sz="1400" b="0">
+              <a:rPr sz="1700" b="0">
                 <a:solidFill>
                   <a:srgbClr val="222222"/>
                 </a:solidFill>
                 <a:latin typeface="Meiryo"/>
               </a:rPr>
-              <a:t>脱出ゾーン (壁 1 m): バック免除 +</a:t>
+              <a:t>python re_engine/convert_onnx_nhwc.py &lt;actor.onnx&gt;  # 既存 CHW を NHWC 化</a:t>
+            </a:r>
+          </a:p>
+          <a:p>
+            <a:pPr>
+              <a:spcAft>
+                <a:spcPts val="600"/>
+              </a:spcAft>
+            </a:pPr>
+            <a:r>
+              <a:rPr sz="1700" b="0">
+                <a:solidFill>
+                  <a:srgbClr val="222222"/>
+                </a:solidFill>
+                <a:latin typeface="Meiryo"/>
+              </a:rPr>
+              <a:t>python re_engine/export_track_json.py  # トラック変更後に JSON + 参照観測を再生成</a:t>
+            </a:r>
+          </a:p>
+          <a:p>
+            <a:pPr>
+              <a:spcAft>
+                <a:spcPts val="600"/>
+              </a:spcAft>
+            </a:pPr>
+            <a:r>
+              <a:rPr sz="1700" b="1">
+                <a:solidFill>
+                  <a:srgbClr val="222222"/>
+                </a:solidFill>
+                <a:latin typeface="Meiryo"/>
+              </a:rPr>
+              <a:t>エンジンは ppo_actor_only_nhwc.onnx (入力 [1,12,12,10]) を使用</a:t>
             </a:r>
           </a:p>
           <a:p>
             <a:pPr lvl="1">
               <a:spcAft>
-                <a:spcPts val="500"/>
+                <a:spcPts val="600"/>
               </a:spcAft>
             </a:pPr>
             <a:r>
-              <a:rPr sz="1200" b="0">
-                <a:solidFill>
-                  <a:srgbClr val="595959"/>
+              <a:rPr sz="1500" b="0">
+                <a:solidFill>
+                  <a:srgbClr val="666666"/>
                 </a:solidFill>
                 <a:latin typeface="Meiryo"/>
               </a:rPr>
-              <a:t>  距離増加に報酬 — 「壁を這う」局所解を排除</a:t>
+              <a:t>  理由: C# は HWC 平坦列を出力 — CHW 版に入れると出力がほぼ一定に退化</a:t>
             </a:r>
           </a:p>
           <a:p>
             <a:pPr>
               <a:spcAft>
-                <a:spcPts val="500"/>
+                <a:spcPts val="600"/>
               </a:spcAft>
             </a:pPr>
             <a:r>
-              <a:rPr sz="1400" b="0">
+              <a:rPr sz="1700" b="0">
                 <a:solidFill>
                   <a:srgbClr val="222222"/>
                 </a:solidFill>
                 <a:latin typeface="Meiryo"/>
               </a:rPr>
-              <a:t>lmap [-3,3]→[0,1]: 範囲が下限を覆わないと</a:t>
+              <a:t>C# 支援クラス: SteeringSmoother / CorneringLimiter / StuckRecovery / CarController</a:t>
             </a:r>
           </a:p>
           <a:p>
             <a:pPr lvl="1">
               <a:spcAft>
-                <a:spcPts val="500"/>
+                <a:spcPts val="600"/>
               </a:spcAft>
             </a:pPr>
             <a:r>
-              <a:rPr sz="1200" b="0">
-                <a:solidFill>
-                  <a:srgbClr val="595959"/>
+              <a:rPr sz="1500" b="0">
+                <a:solidFill>
+                  <a:srgbClr val="666666"/>
                 </a:solidFill>
                 <a:latin typeface="Meiryo"/>
               </a:rPr>
-              <a:t>  勾配消失 (導出をコメントで管理)</a:t>
-            </a:r>
-          </a:p>
-          <a:p>
-            <a:pPr>
-              <a:spcAft>
-                <a:spcPts val="500"/>
-              </a:spcAft>
-            </a:pPr>
-            <a:r>
-              <a:rPr sz="1400" b="0">
-                <a:solidFill>
-                  <a:srgbClr val="222222"/>
-                </a:solidFill>
-                <a:latin typeface="Meiryo"/>
-              </a:rPr>
-              <a:t>チェックポイント/ラップボーナスは生単位で加算</a:t>
+              <a:t>  CarController は学習時と同一の Bicycle 動力学 (Python と 1e-7 一致) で速度 Vector3 を出力</a:t>
             </a:r>
           </a:p>
         </p:txBody>
@@ -4921,8 +4503,8 @@
         </p:nvSpPr>
         <p:spPr>
           <a:xfrm>
-            <a:off x="457200" y="201168"/>
-            <a:ext cx="11247120" cy="777240"/>
+            <a:off x="457200" y="228600"/>
+            <a:ext cx="11247120" cy="822960"/>
           </a:xfrm>
           <a:prstGeom prst="rect">
             <a:avLst/>
@@ -4936,13 +4518,13 @@
           <a:lstStyle/>
           <a:p>
             <a:r>
-              <a:rPr sz="2800" b="1">
+              <a:rPr sz="3000" b="1">
                 <a:solidFill>
                   <a:srgbClr val="1B5EA8"/>
                 </a:solidFill>
                 <a:latin typeface="Meiryo"/>
               </a:rPr>
-              <a:t>進化 (4) 観測 — 2ch から 10ch へ、前方に偏った視野へ</a:t>
+              <a:t>まとめ</a:t>
             </a:r>
           </a:p>
         </p:txBody>
@@ -4955,8 +4537,8 @@
         </p:nvSpPr>
         <p:spPr>
           <a:xfrm>
-            <a:off x="548640" y="1325880"/>
-            <a:ext cx="11064240" cy="5394960"/>
+            <a:off x="548640" y="1463040"/>
+            <a:ext cx="11064240" cy="5120640"/>
           </a:xfrm>
           <a:prstGeom prst="rect">
             <a:avLst/>
@@ -4971,1030 +4553,43 @@
           <a:p>
             <a:pPr>
               <a:spcAft>
-                <a:spcPts val="500"/>
+                <a:spcPts val="600"/>
               </a:spcAft>
             </a:pPr>
             <a:r>
-              <a:rPr sz="1700" b="1">
+              <a:rPr sz="2000" b="1">
                 <a:solidFill>
                   <a:srgbClr val="222222"/>
                 </a:solidFill>
                 <a:latin typeface="Meiryo"/>
               </a:rPr>
-              <a:t>2ch (presence/on_road) → 10ch: + 相対位置 x,y / 相対速度 vx,vy / 向き cos_h,sin_h / lat_off / ang_off</a:t>
+              <a:t>報酬・壁の経済設計が学習速度を決める: 周回獲得は 3〜6 万ステップ</a:t>
             </a:r>
           </a:p>
           <a:p>
             <a:pPr>
               <a:spcAft>
-                <a:spcPts val="500"/>
+                <a:spcPts val="600"/>
               </a:spcAft>
             </a:pPr>
             <a:r>
-              <a:rPr sz="1700" b="1">
+              <a:rPr sz="2000" b="1">
                 <a:solidFill>
                   <a:srgbClr val="222222"/>
                 </a:solidFill>
                 <a:latin typeface="Meiryo"/>
               </a:rPr>
-              <a:t>視野: ±18 m 対称 → 前方 27 m / 後方 9 m の非対称 (12×12 セル, 3 m 刻み)</a:t>
-            </a:r>
-          </a:p>
-          <a:p>
-            <a:pPr lvl="1">
+              <a:t>ランダムトラック学習で 1 方策 5 コース走破 — 自己位置非観測が汎化の鍵</a:t>
+            </a:r>
+          </a:p>
+          <a:p>
+            <a:pPr>
               <a:spcAft>
-                <a:spcPts val="500"/>
+                <a:spcPts val="600"/>
               </a:spcAft>
             </a:pPr>
             <a:r>
-              <a:rPr sz="1500" b="0">
-                <a:solidFill>
-                  <a:srgbClr val="595959"/>
-                </a:solidFill>
-                <a:latin typeface="Meiryo"/>
-              </a:rPr>
-              <a:t>根拠: 制動距離 16 m/s ÷ 5 m/s² = 25.6 m &lt; 27 m — 「見えてから止まれる」最小視野</a:t>
-            </a:r>
-          </a:p>
-          <a:p>
-            <a:pPr>
-              <a:spcAft>
-                <a:spcPts val="500"/>
-              </a:spcAft>
-            </a:pPr>
-            <a:r>
-              <a:rPr sz="1700" b="1">
-                <a:solidFill>
-                  <a:srgbClr val="222222"/>
-                </a:solidFill>
-                <a:latin typeface="Meiryo"/>
-              </a:rPr>
-              <a:t>自車の絶対座標は観測に含まない → コース暗記が不可能 → 汎化の鍵</a:t>
-            </a:r>
-          </a:p>
-          <a:p>
-            <a:pPr>
-              <a:spcAft>
-                <a:spcPts val="500"/>
-              </a:spcAft>
-            </a:pPr>
-            <a:r>
-              <a:rPr sz="1700" b="0">
-                <a:solidFill>
-                  <a:srgbClr val="222222"/>
-                </a:solidFill>
-                <a:latin typeface="Meiryo"/>
-              </a:rPr>
-              <a:t>on_road はレーン中心線のトレース (塗りつぶしマスクではない) — C# 移植時の要注意点</a:t>
-            </a:r>
-          </a:p>
-        </p:txBody>
-      </p:sp>
-    </p:spTree>
-  </p:cSld>
-  <p:clrMapOvr>
-    <a:masterClrMapping/>
-  </p:clrMapOvr>
-</p:sld>
-</file>
-
-<file path=ppt/slides/slide12.xml><?xml version="1.0" encoding="utf-8"?>
-<p:sld xmlns:a="http://schemas.openxmlformats.org/drawingml/2006/main" xmlns:p="http://schemas.openxmlformats.org/presentationml/2006/main" xmlns:r="http://schemas.openxmlformats.org/officeDocument/2006/relationships">
-  <p:cSld>
-    <p:spTree>
-      <p:nvGrpSpPr>
-        <p:cNvPr id="1" name=""/>
-        <p:cNvGrpSpPr/>
-        <p:nvPr/>
-      </p:nvGrpSpPr>
-      <p:grpSpPr/>
-      <p:sp>
-        <p:nvSpPr>
-          <p:cNvPr id="2" name="TextBox 1"/>
-          <p:cNvSpPr txBox="1"/>
-          <p:nvPr/>
-        </p:nvSpPr>
-        <p:spPr>
-          <a:xfrm>
-            <a:off x="457200" y="201168"/>
-            <a:ext cx="11247120" cy="777240"/>
-          </a:xfrm>
-          <a:prstGeom prst="rect">
-            <a:avLst/>
-          </a:prstGeom>
-          <a:noFill/>
-        </p:spPr>
-        <p:txBody>
-          <a:bodyPr wrap="none">
-            <a:spAutoFit/>
-          </a:bodyPr>
-          <a:lstStyle/>
-          <a:p>
-            <a:r>
-              <a:rPr sz="2800" b="1">
-                <a:solidFill>
-                  <a:srgbClr val="1B5EA8"/>
-                </a:solidFill>
-                <a:latin typeface="Meiryo"/>
-              </a:rPr>
-              <a:t>進化 (5) トラックを 1 → 5 種に — 汎化学習</a:t>
-            </a:r>
-          </a:p>
-        </p:txBody>
-      </p:sp>
-      <p:pic>
-        <p:nvPicPr>
-          <p:cNvPr id="3" name="Picture 2" descr="track_shapes.png"/>
-          <p:cNvPicPr>
-            <a:picLocks noChangeAspect="1"/>
-          </p:cNvPicPr>
-          <p:nvPr/>
-        </p:nvPicPr>
-        <p:blipFill>
-          <a:blip r:embed="rId3"/>
-          <a:stretch>
-            <a:fillRect/>
-          </a:stretch>
-        </p:blipFill>
-        <p:spPr>
-          <a:xfrm>
-            <a:off x="411480" y="1554480"/>
-            <a:ext cx="11338560" cy="2267712"/>
-          </a:xfrm>
-          <a:prstGeom prst="rect">
-            <a:avLst/>
-          </a:prstGeom>
-        </p:spPr>
-      </p:pic>
-    </p:spTree>
-  </p:cSld>
-  <p:clrMapOvr>
-    <a:masterClrMapping/>
-  </p:clrMapOvr>
-</p:sld>
-</file>
-
-<file path=ppt/slides/slide13.xml><?xml version="1.0" encoding="utf-8"?>
-<p:sld xmlns:a="http://schemas.openxmlformats.org/drawingml/2006/main" xmlns:p="http://schemas.openxmlformats.org/presentationml/2006/main" xmlns:r="http://schemas.openxmlformats.org/officeDocument/2006/relationships">
-  <p:cSld>
-    <p:spTree>
-      <p:nvGrpSpPr>
-        <p:cNvPr id="1" name=""/>
-        <p:cNvGrpSpPr/>
-        <p:nvPr/>
-      </p:nvGrpSpPr>
-      <p:grpSpPr/>
-      <p:sp>
-        <p:nvSpPr>
-          <p:cNvPr id="2" name="TextBox 1"/>
-          <p:cNvSpPr txBox="1"/>
-          <p:nvPr/>
-        </p:nvSpPr>
-        <p:spPr>
-          <a:xfrm>
-            <a:off x="457200" y="201168"/>
-            <a:ext cx="11247120" cy="777240"/>
-          </a:xfrm>
-          <a:prstGeom prst="rect">
-            <a:avLst/>
-          </a:prstGeom>
-          <a:noFill/>
-        </p:spPr>
-        <p:txBody>
-          <a:bodyPr wrap="none">
-            <a:spAutoFit/>
-          </a:bodyPr>
-          <a:lstStyle/>
-          <a:p>
-            <a:r>
-              <a:rPr sz="2800" b="1">
-                <a:solidFill>
-                  <a:srgbClr val="1B5EA8"/>
-                </a:solidFill>
-                <a:latin typeface="Meiryo"/>
-              </a:rPr>
-              <a:t>学習パイプライン — 2 フェーズ PPO と fast-dev の教訓</a:t>
-            </a:r>
-          </a:p>
-        </p:txBody>
-      </p:sp>
-      <p:sp>
-        <p:nvSpPr>
-          <p:cNvPr id="3" name="TextBox 2"/>
-          <p:cNvSpPr txBox="1"/>
-          <p:nvPr/>
-        </p:nvSpPr>
-        <p:spPr>
-          <a:xfrm>
-            <a:off x="548640" y="1280160"/>
-            <a:ext cx="11064240" cy="5394960"/>
-          </a:xfrm>
-          <a:prstGeom prst="rect">
-            <a:avLst/>
-          </a:prstGeom>
-          <a:noFill/>
-        </p:spPr>
-        <p:txBody>
-          <a:bodyPr wrap="square">
-            <a:spAutoFit/>
-          </a:bodyPr>
-          <a:lstStyle/>
-          <a:p>
-            <a:pPr>
-              <a:spcAft>
-                <a:spcPts val="500"/>
-              </a:spcAft>
-            </a:pPr>
-            <a:r>
-              <a:rPr sz="1700" b="1">
-                <a:solidFill>
-                  <a:srgbClr val="222222"/>
-                </a:solidFill>
-                <a:latin typeface="Meiryo"/>
-              </a:rPr>
-              <a:t>2 フェーズ PPO: ①NPC なしレーン追従 (120k〜1M) → ②NPC あり追い越し FT (lr 減)</a:t>
-            </a:r>
-          </a:p>
-          <a:p>
-            <a:pPr>
-              <a:spcAft>
-                <a:spcPts val="500"/>
-              </a:spcAft>
-            </a:pPr>
-            <a:r>
-              <a:rPr sz="1700" b="0">
-                <a:solidFill>
-                  <a:srgbClr val="222222"/>
-                </a:solidFill>
-                <a:latin typeface="Meiryo"/>
-              </a:rPr>
-              <a:t>カスタム CNN (10ch→512) + 初期スロットルバイアス +0.4 (前進探索)</a:t>
-            </a:r>
-          </a:p>
-          <a:p>
-            <a:pPr>
-              <a:spcAft>
-                <a:spcPts val="500"/>
-              </a:spcAft>
-            </a:pPr>
-            <a:r>
-              <a:rPr sz="1700" b="1">
-                <a:solidFill>
-                  <a:srgbClr val="222222"/>
-                </a:solidFill>
-                <a:latin typeface="Meiryo"/>
-              </a:rPr>
-              <a:t>fast-dev の進化: 65k @ ent 0.10 (曲がれない) → 120k @ ent 0.02 本番ハイパラ (37 周)</a:t>
-            </a:r>
-          </a:p>
-          <a:p>
-            <a:pPr lvl="1">
-              <a:spcAft>
-                <a:spcPts val="500"/>
-              </a:spcAft>
-            </a:pPr>
-            <a:r>
-              <a:rPr sz="1500" b="0">
-                <a:solidFill>
-                  <a:srgbClr val="B32D2D"/>
-                </a:solidFill>
-                <a:latin typeface="Meiryo"/>
-              </a:rPr>
-              <a:t>  教訓: 高エントロピーは [0,1] 圧縮報酬下で「ランダムでいる」ことが得になる</a:t>
-            </a:r>
-          </a:p>
-          <a:p>
-            <a:pPr>
-              <a:spcAft>
-                <a:spcPts val="500"/>
-              </a:spcAft>
-            </a:pPr>
-            <a:r>
-              <a:rPr sz="1700" b="0">
-                <a:solidFill>
-                  <a:srgbClr val="222222"/>
-                </a:solidFill>
-                <a:latin typeface="Meiryo"/>
-              </a:rPr>
-              <a:t>EvalCallback ベストモデル採用 (PPO は終盤退行あり) — best/phase1|phase2/</a:t>
-            </a:r>
-          </a:p>
-          <a:p>
-            <a:pPr>
-              <a:spcAft>
-                <a:spcPts val="500"/>
-              </a:spcAft>
-            </a:pPr>
-            <a:r>
-              <a:rPr sz="1700" b="0">
-                <a:solidFill>
-                  <a:srgbClr val="222222"/>
-                </a:solidFill>
-                <a:latin typeface="Meiryo"/>
-              </a:rPr>
-              <a:t>Reward yardstick: 1 周 ≈ 101, アイドル床 ≈ 0.53/step — eval 値を周回数として読む</a:t>
-            </a:r>
-          </a:p>
-        </p:txBody>
-      </p:sp>
-    </p:spTree>
-  </p:cSld>
-  <p:clrMapOvr>
-    <a:masterClrMapping/>
-  </p:clrMapOvr>
-</p:sld>
-</file>
-
-<file path=ppt/slides/slide14.xml><?xml version="1.0" encoding="utf-8"?>
-<p:sld xmlns:a="http://schemas.openxmlformats.org/drawingml/2006/main" xmlns:p="http://schemas.openxmlformats.org/presentationml/2006/main" xmlns:r="http://schemas.openxmlformats.org/officeDocument/2006/relationships">
-  <p:cSld>
-    <p:spTree>
-      <p:nvGrpSpPr>
-        <p:cNvPr id="1" name=""/>
-        <p:cNvGrpSpPr/>
-        <p:nvPr/>
-      </p:nvGrpSpPr>
-      <p:grpSpPr/>
-      <p:sp>
-        <p:nvSpPr>
-          <p:cNvPr id="2" name="TextBox 1"/>
-          <p:cNvSpPr txBox="1"/>
-          <p:nvPr/>
-        </p:nvSpPr>
-        <p:spPr>
-          <a:xfrm>
-            <a:off x="457200" y="201168"/>
-            <a:ext cx="11247120" cy="777240"/>
-          </a:xfrm>
-          <a:prstGeom prst="rect">
-            <a:avLst/>
-          </a:prstGeom>
-          <a:noFill/>
-        </p:spPr>
-        <p:txBody>
-          <a:bodyPr wrap="none">
-            <a:spAutoFit/>
-          </a:bodyPr>
-          <a:lstStyle/>
-          <a:p>
-            <a:r>
-              <a:rPr sz="2800" b="1">
-                <a:solidFill>
-                  <a:srgbClr val="1B5EA8"/>
-                </a:solidFill>
-                <a:latin typeface="Meiryo"/>
-              </a:rPr>
-              <a:t>実ゲームとのギャップを埋める C# 支援クラス</a:t>
-            </a:r>
-          </a:p>
-        </p:txBody>
-      </p:sp>
-      <p:pic>
-        <p:nvPicPr>
-          <p:cNvPr id="3" name="Picture 2" descr="smoothing_effect.png"/>
-          <p:cNvPicPr>
-            <a:picLocks noChangeAspect="1"/>
-          </p:cNvPicPr>
-          <p:nvPr/>
-        </p:nvPicPr>
-        <p:blipFill>
-          <a:blip r:embed="rId3"/>
-          <a:stretch>
-            <a:fillRect/>
-          </a:stretch>
-        </p:blipFill>
-        <p:spPr>
-          <a:xfrm>
-            <a:off x="640080" y="1234440"/>
-            <a:ext cx="6035040" cy="2084832"/>
-          </a:xfrm>
-          <a:prstGeom prst="rect">
-            <a:avLst/>
-          </a:prstGeom>
-        </p:spPr>
-      </p:pic>
-      <p:sp>
-        <p:nvSpPr>
-          <p:cNvPr id="4" name="TextBox 3"/>
-          <p:cNvSpPr txBox="1"/>
-          <p:nvPr/>
-        </p:nvSpPr>
-        <p:spPr>
-          <a:xfrm>
-            <a:off x="6858000" y="1371600"/>
-            <a:ext cx="4937760" cy="5394960"/>
-          </a:xfrm>
-          <a:prstGeom prst="rect">
-            <a:avLst/>
-          </a:prstGeom>
-          <a:noFill/>
-        </p:spPr>
-        <p:txBody>
-          <a:bodyPr wrap="square">
-            <a:spAutoFit/>
-          </a:bodyPr>
-          <a:lstStyle/>
-          <a:p>
-            <a:pPr>
-              <a:spcAft>
-                <a:spcPts val="500"/>
-              </a:spcAft>
-            </a:pPr>
-            <a:r>
-              <a:rPr sz="1400" b="1">
-                <a:solidFill>
-                  <a:srgbClr val="222222"/>
-                </a:solidFill>
-                <a:latin typeface="Meiryo"/>
-              </a:rPr>
-              <a:t>SteeringSmoother: EMA α0.6 — 蛇行 34→12 回/100步</a:t>
-            </a:r>
-          </a:p>
-          <a:p>
-            <a:pPr>
-              <a:spcAft>
-                <a:spcPts val="500"/>
-              </a:spcAft>
-            </a:pPr>
-            <a:r>
-              <a:rPr sz="1400" b="1">
-                <a:solidFill>
-                  <a:srgbClr val="222222"/>
-                </a:solidFill>
-                <a:latin typeface="Meiryo"/>
-              </a:rPr>
-              <a:t>CorneringLimiter: ステア速度制限 + 比例ブレーキ</a:t>
-            </a:r>
-          </a:p>
-          <a:p>
-            <a:pPr lvl="1">
-              <a:spcAft>
-                <a:spcPts val="500"/>
-              </a:spcAft>
-            </a:pPr>
-            <a:r>
-              <a:rPr sz="1200" b="0">
-                <a:solidFill>
-                  <a:srgbClr val="595959"/>
-                </a:solidFill>
-                <a:latin typeface="Meiryo"/>
-              </a:rPr>
-              <a:t>  速度床 5 m/s — 減速はしても停止はしない</a:t>
-            </a:r>
-          </a:p>
-          <a:p>
-            <a:pPr>
-              <a:spcAft>
-                <a:spcPts val="500"/>
-              </a:spcAft>
-            </a:pPr>
-            <a:r>
-              <a:rPr sz="1400" b="1">
-                <a:solidFill>
-                  <a:srgbClr val="222222"/>
-                </a:solidFill>
-                <a:latin typeface="Meiryo"/>
-              </a:rPr>
-              <a:t>StuckRecovery: 移動距離でスタック検出→バック指示</a:t>
-            </a:r>
-          </a:p>
-          <a:p>
-            <a:pPr lvl="1">
-              <a:spcAft>
-                <a:spcPts val="500"/>
-              </a:spcAft>
-            </a:pPr>
-            <a:r>
-              <a:rPr sz="1200" b="0">
-                <a:solidFill>
-                  <a:srgbClr val="595959"/>
-                </a:solidFill>
-                <a:latin typeface="Meiryo"/>
-              </a:rPr>
-              <a:t>  発進の低速と壁刺さりを距離で区別 (レーン不要)</a:t>
-            </a:r>
-          </a:p>
-          <a:p>
-            <a:pPr>
-              <a:spcAft>
-                <a:spcPts val="500"/>
-              </a:spcAft>
-            </a:pPr>
-            <a:r>
-              <a:rPr sz="1400" b="1">
-                <a:solidFill>
-                  <a:srgbClr val="222222"/>
-                </a:solidFill>
-                <a:latin typeface="Meiryo"/>
-              </a:rPr>
-              <a:t>CarController: 学習と同一物理 (Python と 1e-7 一致)</a:t>
-            </a:r>
-          </a:p>
-        </p:txBody>
-      </p:sp>
-    </p:spTree>
-  </p:cSld>
-  <p:clrMapOvr>
-    <a:masterClrMapping/>
-  </p:clrMapOvr>
-</p:sld>
-</file>
-
-<file path=ppt/slides/slide15.xml><?xml version="1.0" encoding="utf-8"?>
-<p:sld xmlns:a="http://schemas.openxmlformats.org/drawingml/2006/main" xmlns:p="http://schemas.openxmlformats.org/presentationml/2006/main" xmlns:r="http://schemas.openxmlformats.org/officeDocument/2006/relationships">
-  <p:cSld>
-    <p:spTree>
-      <p:nvGrpSpPr>
-        <p:cNvPr id="1" name=""/>
-        <p:cNvGrpSpPr/>
-        <p:nvPr/>
-      </p:nvGrpSpPr>
-      <p:grpSpPr/>
-      <p:sp>
-        <p:nvSpPr>
-          <p:cNvPr id="2" name="TextBox 1"/>
-          <p:cNvSpPr txBox="1"/>
-          <p:nvPr/>
-        </p:nvSpPr>
-        <p:spPr>
-          <a:xfrm>
-            <a:off x="457200" y="201168"/>
-            <a:ext cx="11247120" cy="777240"/>
-          </a:xfrm>
-          <a:prstGeom prst="rect">
-            <a:avLst/>
-          </a:prstGeom>
-          <a:noFill/>
-        </p:spPr>
-        <p:txBody>
-          <a:bodyPr wrap="none">
-            <a:spAutoFit/>
-          </a:bodyPr>
-          <a:lstStyle/>
-          <a:p>
-            <a:r>
-              <a:rPr sz="2800" b="1">
-                <a:solidFill>
-                  <a:srgbClr val="1B5EA8"/>
-                </a:solidFill>
-                <a:latin typeface="Meiryo"/>
-              </a:rPr>
-              <a:t>セットアップとノートブックの使い方</a:t>
-            </a:r>
-          </a:p>
-        </p:txBody>
-      </p:sp>
-      <p:sp>
-        <p:nvSpPr>
-          <p:cNvPr id="3" name="TextBox 2"/>
-          <p:cNvSpPr txBox="1"/>
-          <p:nvPr/>
-        </p:nvSpPr>
-        <p:spPr>
-          <a:xfrm>
-            <a:off x="548640" y="1325880"/>
-            <a:ext cx="11064240" cy="5394960"/>
-          </a:xfrm>
-          <a:prstGeom prst="rect">
-            <a:avLst/>
-          </a:prstGeom>
-          <a:noFill/>
-        </p:spPr>
-        <p:txBody>
-          <a:bodyPr wrap="square">
-            <a:spAutoFit/>
-          </a:bodyPr>
-          <a:lstStyle/>
-          <a:p>
-            <a:pPr>
-              <a:spcAft>
-                <a:spcPts val="500"/>
-              </a:spcAft>
-            </a:pPr>
-            <a:r>
-              <a:rPr sz="1700" b="1">
-                <a:solidFill>
-                  <a:srgbClr val="222222"/>
-                </a:solidFill>
-                <a:latin typeface="Meiryo"/>
-              </a:rPr>
-              <a:t>pip install "highway-env&gt;=1.8" "stable-baselines3[extra]&gt;=2.0" gymnasium torch tensorboard moviepy onnx onnxruntime</a:t>
-            </a:r>
-          </a:p>
-          <a:p>
-            <a:pPr lvl="1">
-              <a:spcAft>
-                <a:spcPts val="500"/>
-              </a:spcAft>
-            </a:pPr>
-            <a:r>
-              <a:rPr sz="1500" b="0">
-                <a:solidFill>
-                  <a:srgbClr val="B32D2D"/>
-                </a:solidFill>
-                <a:latin typeface="Meiryo"/>
-              </a:rPr>
-              <a:t>(リポジトリの requirements.txt は旧スタック用 — 使わない)</a:t>
-            </a:r>
-          </a:p>
-          <a:p>
-            <a:pPr>
-              <a:spcAft>
-                <a:spcPts val="500"/>
-              </a:spcAft>
-            </a:pPr>
-            <a:r>
-              <a:rPr sz="1700" b="0">
-                <a:solidFill>
-                  <a:srgbClr val="222222"/>
-                </a:solidFill>
-                <a:latin typeface="Meiryo"/>
-              </a:rPr>
-              <a:t>task2_laning_overtaking_sb3_ppo.ipynb — fast トラック学習</a:t>
-            </a:r>
-          </a:p>
-          <a:p>
-            <a:pPr>
-              <a:spcAft>
-                <a:spcPts val="500"/>
-              </a:spcAft>
-            </a:pPr>
-            <a:r>
-              <a:rPr sz="1700" b="0">
-                <a:solidFill>
-                  <a:srgbClr val="222222"/>
-                </a:solidFill>
-                <a:latin typeface="Meiryo"/>
-              </a:rPr>
-              <a:t>task3_generalization_sb3_ppo.ipynb — random 学習 + トラック別レポート + 5 連動画</a:t>
-            </a:r>
-          </a:p>
-          <a:p>
-            <a:pPr>
-              <a:spcAft>
-                <a:spcPts val="500"/>
-              </a:spcAft>
-            </a:pPr>
-            <a:r>
-              <a:rPr sz="1700" b="1">
-                <a:solidFill>
-                  <a:srgbClr val="222222"/>
-                </a:solidFill>
-                <a:latin typeface="Meiryo"/>
-              </a:rPr>
-              <a:t>FAST_DEV_RUN=True: 12-15 万ステップ (周回到達を実測保証) / False: 本番 100 万+</a:t>
-            </a:r>
-          </a:p>
-          <a:p>
-            <a:pPr>
-              <a:spcAft>
-                <a:spcPts val="500"/>
-              </a:spcAft>
-            </a:pPr>
-            <a:r>
-              <a:rPr sz="1700" b="1">
-                <a:solidFill>
-                  <a:srgbClr val="222222"/>
-                </a:solidFill>
-                <a:latin typeface="Meiryo"/>
-              </a:rPr>
-              <a:t>Presentation Media セル: 学習曲線・軌跡・5 トラック動画を生成し VIDEO_DIR に保存</a:t>
-            </a:r>
-          </a:p>
-          <a:p>
-            <a:pPr>
-              <a:spcAft>
-                <a:spcPts val="500"/>
-              </a:spcAft>
-            </a:pPr>
-            <a:r>
-              <a:rPr sz="1700" b="0">
-                <a:solidFill>
-                  <a:srgbClr val="222222"/>
-                </a:solidFill>
-                <a:latin typeface="Meiryo"/>
-              </a:rPr>
-              <a:t>検証: cd re_engine/verify &amp;&amp; dotnet run -- ..  → ALL SCENARIOS MATCH</a:t>
-            </a:r>
-          </a:p>
-        </p:txBody>
-      </p:sp>
-    </p:spTree>
-  </p:cSld>
-  <p:clrMapOvr>
-    <a:masterClrMapping/>
-  </p:clrMapOvr>
-</p:sld>
-</file>
-
-<file path=ppt/slides/slide16.xml><?xml version="1.0" encoding="utf-8"?>
-<p:sld xmlns:a="http://schemas.openxmlformats.org/drawingml/2006/main" xmlns:p="http://schemas.openxmlformats.org/presentationml/2006/main" xmlns:r="http://schemas.openxmlformats.org/officeDocument/2006/relationships">
-  <p:cSld>
-    <p:spTree>
-      <p:nvGrpSpPr>
-        <p:cNvPr id="1" name=""/>
-        <p:cNvGrpSpPr/>
-        <p:nvPr/>
-      </p:nvGrpSpPr>
-      <p:grpSpPr/>
-      <p:sp>
-        <p:nvSpPr>
-          <p:cNvPr id="2" name="TextBox 1"/>
-          <p:cNvSpPr txBox="1"/>
-          <p:nvPr/>
-        </p:nvSpPr>
-        <p:spPr>
-          <a:xfrm>
-            <a:off x="457200" y="201168"/>
-            <a:ext cx="11247120" cy="777240"/>
-          </a:xfrm>
-          <a:prstGeom prst="rect">
-            <a:avLst/>
-          </a:prstGeom>
-          <a:noFill/>
-        </p:spPr>
-        <p:txBody>
-          <a:bodyPr wrap="none">
-            <a:spAutoFit/>
-          </a:bodyPr>
-          <a:lstStyle/>
-          <a:p>
-            <a:r>
-              <a:rPr sz="2800" b="1">
-                <a:solidFill>
-                  <a:srgbClr val="1B5EA8"/>
-                </a:solidFill>
-                <a:latin typeface="Meiryo"/>
-              </a:rPr>
-              <a:t>エクスポートツールと ONNX の注意点</a:t>
-            </a:r>
-          </a:p>
-        </p:txBody>
-      </p:sp>
-      <p:sp>
-        <p:nvSpPr>
-          <p:cNvPr id="3" name="TextBox 2"/>
-          <p:cNvSpPr txBox="1"/>
-          <p:nvPr/>
-        </p:nvSpPr>
-        <p:spPr>
-          <a:xfrm>
-            <a:off x="548640" y="1325880"/>
-            <a:ext cx="11064240" cy="5394960"/>
-          </a:xfrm>
-          <a:prstGeom prst="rect">
-            <a:avLst/>
-          </a:prstGeom>
-          <a:noFill/>
-        </p:spPr>
-        <p:txBody>
-          <a:bodyPr wrap="square">
-            <a:spAutoFit/>
-          </a:bodyPr>
-          <a:lstStyle/>
-          <a:p>
-            <a:pPr>
-              <a:spcAft>
-                <a:spcPts val="500"/>
-              </a:spcAft>
-            </a:pPr>
-            <a:r>
-              <a:rPr sz="1700" b="1">
-                <a:solidFill>
-                  <a:srgbClr val="222222"/>
-                </a:solidFill>
-                <a:latin typeface="Meiryo"/>
-              </a:rPr>
-              <a:t>python export_onnx.py &lt;model.zip&gt; -m 3   # エンジン用 NHWC [1,12,12,10] (推奨)</a:t>
-            </a:r>
-          </a:p>
-          <a:p>
-            <a:pPr lvl="1">
-              <a:spcAft>
-                <a:spcPts val="500"/>
-              </a:spcAft>
-            </a:pPr>
-            <a:r>
-              <a:rPr sz="1500" b="0">
-                <a:solidFill>
-                  <a:srgbClr val="595959"/>
-                </a:solidFill>
-                <a:latin typeface="Meiryo"/>
-              </a:rPr>
-              <a:t>  -m 1: full policy / 2: actor CHW / 3: actor NHWC / 0: 全部 — 各エクスポートは torch と自動照合</a:t>
-            </a:r>
-          </a:p>
-          <a:p>
-            <a:pPr>
-              <a:spcAft>
-                <a:spcPts val="500"/>
-              </a:spcAft>
-            </a:pPr>
-            <a:r>
-              <a:rPr sz="1700" b="0">
-                <a:solidFill>
-                  <a:srgbClr val="222222"/>
-                </a:solidFill>
-                <a:latin typeface="Meiryo"/>
-              </a:rPr>
-              <a:t>python re_engine/convert_onnx_nhwc.py &lt;actor.onnx&gt;   # 既存 CHW を NHWC 化</a:t>
-            </a:r>
-          </a:p>
-          <a:p>
-            <a:pPr>
-              <a:spcAft>
-                <a:spcPts val="500"/>
-              </a:spcAft>
-            </a:pPr>
-            <a:r>
-              <a:rPr sz="1700" b="0">
-                <a:solidFill>
-                  <a:srgbClr val="222222"/>
-                </a:solidFill>
-                <a:latin typeface="Meiryo"/>
-              </a:rPr>
-              <a:t>python re_engine/export_track_json.py   # トラック/観測変更後に参照データ再生成</a:t>
-            </a:r>
-          </a:p>
-          <a:p>
-            <a:pPr>
-              <a:spcAft>
-                <a:spcPts val="500"/>
-              </a:spcAft>
-            </a:pPr>
-            <a:r>
-              <a:rPr sz="1700" b="1">
-                <a:solidFill>
-                  <a:srgbClr val="B32D2D"/>
-                </a:solidFill>
-                <a:latin typeface="Meiryo"/>
-              </a:rPr>
-              <a:t>症状で覚える: 出力がほぼ一定 (throttle≈0.4, steer≈0.2) = レイアウト不一致</a:t>
-            </a:r>
-          </a:p>
-          <a:p>
-            <a:pPr>
-              <a:spcAft>
-                <a:spcPts val="500"/>
-              </a:spcAft>
-            </a:pPr>
-            <a:r>
-              <a:rPr sz="1700" b="0">
-                <a:solidFill>
-                  <a:srgbClr val="222222"/>
-                </a:solidFill>
-                <a:latin typeface="Meiryo"/>
-              </a:rPr>
-              <a:t>定数同期: accel/steer レンジ・5 Hz・グリッド設定は C# に複製 — 変更時は 4 点セット</a:t>
-            </a:r>
-          </a:p>
-          <a:p>
-            <a:pPr>
-              <a:spcAft>
-                <a:spcPts val="500"/>
-              </a:spcAft>
-            </a:pPr>
-            <a:r>
-              <a:rPr sz="1700" b="0">
-                <a:solidFill>
-                  <a:srgbClr val="222222"/>
-                </a:solidFill>
-                <a:latin typeface="Meiryo"/>
-              </a:rPr>
-              <a:t>単位は全て m/s・m・rad。km/h の Vector3 は KphToMs で変換 (kph 直入れは無警告で劣化)</a:t>
-            </a:r>
-          </a:p>
-        </p:txBody>
-      </p:sp>
-    </p:spTree>
-  </p:cSld>
-  <p:clrMapOvr>
-    <a:masterClrMapping/>
-  </p:clrMapOvr>
-</p:sld>
-</file>
-
-<file path=ppt/slides/slide17.xml><?xml version="1.0" encoding="utf-8"?>
-<p:sld xmlns:a="http://schemas.openxmlformats.org/drawingml/2006/main" xmlns:p="http://schemas.openxmlformats.org/presentationml/2006/main" xmlns:r="http://schemas.openxmlformats.org/officeDocument/2006/relationships">
-  <p:cSld>
-    <p:spTree>
-      <p:nvGrpSpPr>
-        <p:cNvPr id="1" name=""/>
-        <p:cNvGrpSpPr/>
-        <p:nvPr/>
-      </p:nvGrpSpPr>
-      <p:grpSpPr/>
-      <p:sp>
-        <p:nvSpPr>
-          <p:cNvPr id="2" name="TextBox 1"/>
-          <p:cNvSpPr txBox="1"/>
-          <p:nvPr/>
-        </p:nvSpPr>
-        <p:spPr>
-          <a:xfrm>
-            <a:off x="457200" y="201168"/>
-            <a:ext cx="11247120" cy="777240"/>
-          </a:xfrm>
-          <a:prstGeom prst="rect">
-            <a:avLst/>
-          </a:prstGeom>
-          <a:noFill/>
-        </p:spPr>
-        <p:txBody>
-          <a:bodyPr wrap="none">
-            <a:spAutoFit/>
-          </a:bodyPr>
-          <a:lstStyle/>
-          <a:p>
-            <a:r>
-              <a:rPr sz="2800" b="1">
-                <a:solidFill>
-                  <a:srgbClr val="1B5EA8"/>
-                </a:solidFill>
-                <a:latin typeface="Meiryo"/>
-              </a:rPr>
-              <a:t>まとめ — 環境設計こそが学習を決める</a:t>
-            </a:r>
-          </a:p>
-        </p:txBody>
-      </p:sp>
-      <p:sp>
-        <p:nvSpPr>
-          <p:cNvPr id="3" name="TextBox 2"/>
-          <p:cNvSpPr txBox="1"/>
-          <p:nvPr/>
-        </p:nvSpPr>
-        <p:spPr>
-          <a:xfrm>
-            <a:off x="548640" y="1417320"/>
-            <a:ext cx="11064240" cy="5394960"/>
-          </a:xfrm>
-          <a:prstGeom prst="rect">
-            <a:avLst/>
-          </a:prstGeom>
-          <a:noFill/>
-        </p:spPr>
-        <p:txBody>
-          <a:bodyPr wrap="square">
-            <a:spAutoFit/>
-          </a:bodyPr>
-          <a:lstStyle/>
-          <a:p>
-            <a:pPr>
-              <a:spcAft>
-                <a:spcPts val="500"/>
-              </a:spcAft>
-            </a:pPr>
-            <a:r>
-              <a:rPr sz="1900" b="1">
-                <a:solidFill>
-                  <a:srgbClr val="222222"/>
-                </a:solidFill>
-                <a:latin typeface="Meiryo"/>
-              </a:rPr>
-              <a:t>デフォルト racetrack → ゲーム環境へ: 行動・壁・報酬・観測・トラックを段階的に進化</a:t>
-            </a:r>
-          </a:p>
-          <a:p>
-            <a:pPr>
-              <a:spcAft>
-                <a:spcPts val="500"/>
-              </a:spcAft>
-            </a:pPr>
-            <a:r>
-              <a:rPr sz="1900" b="1">
-                <a:solidFill>
-                  <a:srgbClr val="222222"/>
-                </a:solidFill>
-                <a:latin typeface="Meiryo"/>
-              </a:rPr>
-              <a:t>抜け道 (ショートカット / wall-riding / 壁這い) を報酬の経済設計で排除 → 6 万ステップで周回</a:t>
-            </a:r>
-          </a:p>
-          <a:p>
-            <a:pPr>
-              <a:spcAft>
-                <a:spcPts val="500"/>
-              </a:spcAft>
-            </a:pPr>
-            <a:r>
-              <a:rPr sz="1900" b="1">
-                <a:solidFill>
-                  <a:srgbClr val="222222"/>
-                </a:solidFill>
-                <a:latin typeface="Meiryo"/>
-              </a:rPr>
-              <a:t>自己位置を観測に入れない設計が 5 コース汎化を生んだ</a:t>
-            </a:r>
-          </a:p>
-          <a:p>
-            <a:pPr>
-              <a:spcAft>
-                <a:spcPts val="500"/>
-              </a:spcAft>
-            </a:pPr>
-            <a:r>
-              <a:rPr sz="1900" b="0">
+              <a:rPr sz="2000" b="1">
                 <a:solidFill>
                   <a:srgbClr val="222222"/>
                 </a:solidFill>
@@ -6006,33 +4601,33 @@
           <a:p>
             <a:pPr>
               <a:spcAft>
-                <a:spcPts val="500"/>
+                <a:spcPts val="600"/>
               </a:spcAft>
             </a:pPr>
             <a:r>
-              <a:rPr sz="1900" b="0">
+              <a:rPr sz="2000" b="0">
                 <a:solidFill>
                   <a:srgbClr val="222222"/>
                 </a:solidFill>
                 <a:latin typeface="Meiryo"/>
               </a:rPr>
-              <a:t>媒体生成コードはすべてノートブック内 (Presentation Media セル) — 本スライドは再現可能</a:t>
+              <a:t>再現手順・注意点は CLAUDE.md / re_engine/README.md に集約</a:t>
             </a:r>
           </a:p>
           <a:p>
             <a:pPr>
               <a:spcAft>
-                <a:spcPts val="500"/>
+                <a:spcPts val="600"/>
               </a:spcAft>
             </a:pPr>
             <a:r>
-              <a:rPr sz="1900" b="0">
+              <a:rPr sz="2000" b="0">
                 <a:solidFill>
                   <a:srgbClr val="222222"/>
                 </a:solidFill>
                 <a:latin typeface="Meiryo"/>
               </a:rPr>
-              <a:t>次のステップ: RE Engine 実走検証・実車ダイナミクス適合・NPC レース</a:t>
+              <a:t>次のステップ: RE Engine 内での実走検証、実車ダイナミクスへの適合</a:t>
             </a:r>
           </a:p>
         </p:txBody>
@@ -6063,8 +4658,8 @@
         </p:nvSpPr>
         <p:spPr>
           <a:xfrm>
-            <a:off x="457200" y="201168"/>
-            <a:ext cx="11247120" cy="777240"/>
+            <a:off x="457200" y="228600"/>
+            <a:ext cx="11247120" cy="822960"/>
           </a:xfrm>
           <a:prstGeom prst="rect">
             <a:avLst/>
@@ -6078,101 +4673,141 @@
           <a:lstStyle/>
           <a:p>
             <a:r>
-              <a:rPr sz="2800" b="1">
+              <a:rPr sz="3000" b="1">
                 <a:solidFill>
                   <a:srgbClr val="1B5EA8"/>
                 </a:solidFill>
                 <a:latin typeface="Meiryo"/>
               </a:rPr>
-              <a:t>まず結果から — 1 つの方策で 5 トラック同時走行</a:t>
-            </a:r>
-          </a:p>
-        </p:txBody>
-      </p:sp>
-      <p:pic>
-        <p:nvPicPr>
-          <p:cNvPr id="3" name="Picture 2" descr="gen_tracks_grid.png"/>
-          <p:cNvPicPr>
-            <a:picLocks noChangeAspect="1"/>
-          </p:cNvPicPr>
+              <a:t>結果ハイライト</a:t>
+            </a:r>
+          </a:p>
+        </p:txBody>
+      </p:sp>
+      <p:sp>
+        <p:nvSpPr>
+          <p:cNvPr id="3" name="TextBox 2"/>
+          <p:cNvSpPr txBox="1"/>
           <p:nvPr/>
-        </p:nvPicPr>
-        <p:blipFill>
-          <a:blip r:embed="rId3"/>
-          <a:stretch>
-            <a:fillRect/>
-          </a:stretch>
-        </p:blipFill>
+        </p:nvSpPr>
         <p:spPr>
           <a:xfrm>
-            <a:off x="411480" y="1143000"/>
-            <a:ext cx="11338560" cy="2789689"/>
+            <a:off x="548640" y="1371600"/>
+            <a:ext cx="11064240" cy="5120640"/>
           </a:xfrm>
           <a:prstGeom prst="rect">
             <a:avLst/>
           </a:prstGeom>
+          <a:noFill/>
         </p:spPr>
-      </p:pic>
-      <p:pic>
-        <p:nvPicPr>
-          <p:cNvPr id="4" name="gen_all_tracks.mp4">
-            <a:hlinkClick r:id="" action="ppaction://media"/>
-          </p:cNvPr>
-          <p:cNvPicPr>
-            <a:picLocks noChangeAspect="1"/>
-          </p:cNvPicPr>
-          <p:nvPr>
-            <a:videoFile r:link="rId5"/>
-            <p:extLst>
-              <p:ext uri="{DAA4B4D4-6D71-4841-9C94-3DE7FCFB9230}">
-                <p14:media xmlns:p14="http://schemas.microsoft.com/office/powerpoint/2010/main" r:embed="rId4"/>
-              </p:ext>
-            </p:extLst>
-          </p:nvPr>
-        </p:nvPicPr>
-        <p:blipFill>
-          <a:blip r:embed="rId3"/>
-          <a:stretch>
-            <a:fillRect/>
-          </a:stretch>
-        </p:blipFill>
-        <p:spPr>
-          <a:xfrm>
-            <a:off x="2651760" y="3977639"/>
-            <a:ext cx="6858000" cy="2057400"/>
-          </a:xfrm>
-          <a:prstGeom prst="rect">
-            <a:avLst/>
-          </a:prstGeom>
-        </p:spPr>
-      </p:pic>
+        <p:txBody>
+          <a:bodyPr wrap="square">
+            <a:spAutoFit/>
+          </a:bodyPr>
+          <a:lstStyle/>
+          <a:p>
+            <a:pPr>
+              <a:spcAft>
+                <a:spcPts val="600"/>
+              </a:spcAft>
+            </a:pPr>
+            <a:r>
+              <a:rPr sz="2000" b="1">
+                <a:solidFill>
+                  <a:srgbClr val="222222"/>
+                </a:solidFill>
+                <a:latin typeface="Meiryo"/>
+              </a:rPr>
+              <a:t>37 周 / 800 秒エピソード・16 m/s (制限速度) で無衝突 — fast トラック</a:t>
+            </a:r>
+          </a:p>
+          <a:p>
+            <a:pPr>
+              <a:spcAft>
+                <a:spcPts val="600"/>
+              </a:spcAft>
+            </a:pPr>
+            <a:r>
+              <a:rPr sz="2000" b="0">
+                <a:solidFill>
+                  <a:srgbClr val="222222"/>
+                </a:solidFill>
+                <a:latin typeface="Meiryo"/>
+              </a:rPr>
+              <a:t>周回能力は 3〜6 万ステップで獲得 (実測) — fast-dev (12万) でも確実に周回</a:t>
+            </a:r>
+          </a:p>
+          <a:p>
+            <a:pPr>
+              <a:spcAft>
+                <a:spcPts val="600"/>
+              </a:spcAft>
+            </a:pPr>
+            <a:r>
+              <a:rPr sz="2000" b="1">
+                <a:solidFill>
+                  <a:srgbClr val="222222"/>
+                </a:solidFill>
+                <a:latin typeface="Meiryo"/>
+              </a:rPr>
+              <a:t>汎化モデル: 1 つの方策で 5 トラックすべてを 2 分間ノーミス走行</a:t>
+            </a:r>
+          </a:p>
+          <a:p>
+            <a:pPr>
+              <a:spcAft>
+                <a:spcPts val="600"/>
+              </a:spcAft>
+            </a:pPr>
+            <a:r>
+              <a:rPr sz="2000" b="0">
+                <a:solidFill>
+                  <a:srgbClr val="222222"/>
+                </a:solidFill>
+                <a:latin typeface="Meiryo"/>
+              </a:rPr>
+              <a:t>ゼロショット転移: fast のみで学習した方策が他 4 トラックも制限速度で走行</a:t>
+            </a:r>
+          </a:p>
+          <a:p>
+            <a:pPr>
+              <a:spcAft>
+                <a:spcPts val="600"/>
+              </a:spcAft>
+            </a:pPr>
+            <a:r>
+              <a:rPr sz="2000" b="1">
+                <a:solidFill>
+                  <a:srgbClr val="222222"/>
+                </a:solidFill>
+                <a:latin typeface="Meiryo"/>
+              </a:rPr>
+              <a:t>C# 観測ポート: Python とビット一致 (maxDiff = 0.0) を検証ハーネスで保証</a:t>
+            </a:r>
+          </a:p>
+          <a:p>
+            <a:pPr>
+              <a:spcAft>
+                <a:spcPts val="600"/>
+              </a:spcAft>
+            </a:pPr>
+            <a:r>
+              <a:rPr sz="2000" b="0">
+                <a:solidFill>
+                  <a:srgbClr val="222222"/>
+                </a:solidFill>
+                <a:latin typeface="Meiryo"/>
+              </a:rPr>
+              <a:t>ONNX 3 種 (full / actor CHW / actor NHWC) をエクスポート、エンジンは NHWC を使用</a:t>
+            </a:r>
+          </a:p>
+        </p:txBody>
+      </p:sp>
     </p:spTree>
   </p:cSld>
   <p:clrMapOvr>
     <a:masterClrMapping/>
   </p:clrMapOvr>
-  <p:timing>
-    <p:tnLst>
-      <p:par>
-        <p:cTn id="1" dur="indefinite" restart="never" nodeType="tmRoot">
-          <p:childTnLst>
-            <p:video>
-              <p:cMediaNode vol="80000">
-                <p:cTn id="2" fill="hold" display="0">
-                  <p:stCondLst>
-                    <p:cond delay="indefinite"/>
-                  </p:stCondLst>
-                </p:cTn>
-                <p:tgtEl>
-                  <p:spTgt spid="4"/>
-                </p:tgtEl>
-              </p:cMediaNode>
-            </p:video>
-          </p:childTnLst>
-        </p:cTn>
-      </p:par>
-    </p:tnLst>
-  </p:timing>
 </p:sld>
 </file>
 
@@ -6194,8 +4829,8 @@
         </p:nvSpPr>
         <p:spPr>
           <a:xfrm>
-            <a:off x="457200" y="201168"/>
-            <a:ext cx="11247120" cy="777240"/>
+            <a:off x="457200" y="228600"/>
+            <a:ext cx="11247120" cy="822960"/>
           </a:xfrm>
           <a:prstGeom prst="rect">
             <a:avLst/>
@@ -6209,13 +4844,13 @@
           <a:lstStyle/>
           <a:p>
             <a:r>
-              <a:rPr sz="2800" b="1">
+              <a:rPr sz="3000" b="1">
                 <a:solidFill>
                   <a:srgbClr val="1B5EA8"/>
                 </a:solidFill>
                 <a:latin typeface="Meiryo"/>
               </a:rPr>
-              <a:t>学習曲線 — 周回能力は 3〜6 万ステップで立ち上がる</a:t>
+              <a:t>学習曲線 — 周回数 vs 学習ステップ</a:t>
             </a:r>
           </a:p>
         </p:txBody>
@@ -6236,8 +4871,8 @@
         </p:blipFill>
         <p:spPr>
           <a:xfrm>
-            <a:off x="2468880" y="1234440"/>
-            <a:ext cx="7315200" cy="4096512"/>
+            <a:off x="2377440" y="1234440"/>
+            <a:ext cx="7498079" cy="4198924"/>
           </a:xfrm>
           <a:prstGeom prst="rect">
             <a:avLst/>
@@ -6270,8 +4905,8 @@
         </p:nvSpPr>
         <p:spPr>
           <a:xfrm>
-            <a:off x="457200" y="201168"/>
-            <a:ext cx="11247120" cy="777240"/>
+            <a:off x="457200" y="228600"/>
+            <a:ext cx="11247120" cy="822960"/>
           </a:xfrm>
           <a:prstGeom prst="rect">
             <a:avLst/>
@@ -6285,13 +4920,13 @@
           <a:lstStyle/>
           <a:p>
             <a:r>
-              <a:rPr sz="2800" b="1">
+              <a:rPr sz="3000" b="1">
                 <a:solidFill>
                   <a:srgbClr val="1B5EA8"/>
                 </a:solidFill>
                 <a:latin typeface="Meiryo"/>
               </a:rPr>
-              <a:t>走行軌跡 — 減速と立ち上がりの質</a:t>
+              <a:t>走行軌跡 — fast トラック (fast-dev モデル)</a:t>
             </a:r>
           </a:p>
         </p:txBody>
@@ -6346,8 +4981,8 @@
         </p:nvSpPr>
         <p:spPr>
           <a:xfrm>
-            <a:off x="457200" y="201168"/>
-            <a:ext cx="11247120" cy="777240"/>
+            <a:off x="457200" y="228600"/>
+            <a:ext cx="11247120" cy="822960"/>
           </a:xfrm>
           <a:prstGeom prst="rect">
             <a:avLst/>
@@ -6361,141 +4996,101 @@
           <a:lstStyle/>
           <a:p>
             <a:r>
-              <a:rPr sz="2800" b="1">
+              <a:rPr sz="3000" b="1">
                 <a:solidFill>
                   <a:srgbClr val="1B5EA8"/>
                 </a:solidFill>
                 <a:latin typeface="Meiryo"/>
               </a:rPr>
-              <a:t>結果サマリ (すべて実測値)</a:t>
-            </a:r>
-          </a:p>
-        </p:txBody>
-      </p:sp>
-      <p:sp>
-        <p:nvSpPr>
-          <p:cNvPr id="3" name="TextBox 2"/>
-          <p:cNvSpPr txBox="1"/>
+              <a:t>汎化モデル — 1 つの方策で 5 トラック</a:t>
+            </a:r>
+          </a:p>
+        </p:txBody>
+      </p:sp>
+      <p:pic>
+        <p:nvPicPr>
+          <p:cNvPr id="3" name="Picture 2" descr="gen_tracks_grid.png"/>
+          <p:cNvPicPr>
+            <a:picLocks noChangeAspect="1"/>
+          </p:cNvPicPr>
           <p:nvPr/>
-        </p:nvSpPr>
+        </p:nvPicPr>
+        <p:blipFill>
+          <a:blip r:embed="rId3"/>
+          <a:stretch>
+            <a:fillRect/>
+          </a:stretch>
+        </p:blipFill>
         <p:spPr>
           <a:xfrm>
-            <a:off x="548640" y="1325880"/>
-            <a:ext cx="11064240" cy="5394960"/>
+            <a:off x="411480" y="1371600"/>
+            <a:ext cx="11338560" cy="2789689"/>
           </a:xfrm>
           <a:prstGeom prst="rect">
             <a:avLst/>
           </a:prstGeom>
-          <a:noFill/>
         </p:spPr>
-        <p:txBody>
-          <a:bodyPr wrap="square">
-            <a:spAutoFit/>
-          </a:bodyPr>
-          <a:lstStyle/>
-          <a:p>
-            <a:pPr>
-              <a:spcAft>
-                <a:spcPts val="500"/>
-              </a:spcAft>
-            </a:pPr>
-            <a:r>
-              <a:rPr sz="1900" b="1">
-                <a:solidFill>
-                  <a:srgbClr val="222222"/>
-                </a:solidFill>
-                <a:latin typeface="Meiryo"/>
-              </a:rPr>
-              <a:t>fast トラック: 37 周 / 800 秒・16 m/s (制限速度)・無衝突</a:t>
-            </a:r>
-          </a:p>
-          <a:p>
-            <a:pPr>
-              <a:spcAft>
-                <a:spcPts val="500"/>
-              </a:spcAft>
-            </a:pPr>
-            <a:r>
-              <a:rPr sz="1900" b="0">
-                <a:solidFill>
-                  <a:srgbClr val="222222"/>
-                </a:solidFill>
-                <a:latin typeface="Meiryo"/>
-              </a:rPr>
-              <a:t>周回能力の獲得: 3〜6 万ステップ (6 万で 32 周 → 9 万で 36 周)</a:t>
-            </a:r>
-          </a:p>
-          <a:p>
-            <a:pPr>
-              <a:spcAft>
-                <a:spcPts val="500"/>
-              </a:spcAft>
-            </a:pPr>
-            <a:r>
-              <a:rPr sz="1900" b="0">
-                <a:solidFill>
-                  <a:srgbClr val="222222"/>
-                </a:solidFill>
-                <a:latin typeface="Meiryo"/>
-              </a:rPr>
-              <a:t>fast-dev (12 万, 本番ハイパラ): フェーズ 2 (NPC あり lr 3e-4) 込みで 37 周 — 退行なし</a:t>
-            </a:r>
-          </a:p>
-          <a:p>
-            <a:pPr>
-              <a:spcAft>
-                <a:spcPts val="500"/>
-              </a:spcAft>
-            </a:pPr>
-            <a:r>
-              <a:rPr sz="1900" b="1">
-                <a:solidFill>
-                  <a:srgbClr val="222222"/>
-                </a:solidFill>
-                <a:latin typeface="Meiryo"/>
-              </a:rPr>
-              <a:t>汎化モデル (random 学習 15 万): 5 トラックすべて 2 分間ノーミス・平均 15.7 m/s</a:t>
-            </a:r>
-          </a:p>
-          <a:p>
-            <a:pPr>
-              <a:spcAft>
-                <a:spcPts val="500"/>
-              </a:spcAft>
-            </a:pPr>
-            <a:r>
-              <a:rPr sz="1900" b="0">
-                <a:solidFill>
-                  <a:srgbClr val="222222"/>
-                </a:solidFill>
-                <a:latin typeface="Meiryo"/>
-              </a:rPr>
-              <a:t>ゼロショット転移: fast 専用モデルも他 4 コースを制限速度で走行 (自己位置非観測が鍵)</a:t>
-            </a:r>
-          </a:p>
-          <a:p>
-            <a:pPr>
-              <a:spcAft>
-                <a:spcPts val="500"/>
-              </a:spcAft>
-            </a:pPr>
-            <a:r>
-              <a:rPr sz="1900" b="1">
-                <a:solidFill>
-                  <a:srgbClr val="222222"/>
-                </a:solidFill>
-                <a:latin typeface="Meiryo"/>
-              </a:rPr>
-              <a:t>C# デプロイ: 観測ビット一致 (maxDiff=0.0) + 車両物理 1e-7 一致 — 検証ハーネスで自動確認</a:t>
-            </a:r>
-          </a:p>
-        </p:txBody>
-      </p:sp>
+      </p:pic>
+      <p:pic>
+        <p:nvPicPr>
+          <p:cNvPr id="4" name="gen_all_tracks.mp4">
+            <a:hlinkClick r:id="" action="ppaction://media"/>
+          </p:cNvPr>
+          <p:cNvPicPr>
+            <a:picLocks noChangeAspect="1"/>
+          </p:cNvPicPr>
+          <p:nvPr>
+            <a:videoFile r:link="rId5"/>
+            <p:extLst>
+              <p:ext uri="{DAA4B4D4-6D71-4841-9C94-3DE7FCFB9230}">
+                <p14:media xmlns:p14="http://schemas.microsoft.com/office/powerpoint/2010/main" r:embed="rId4"/>
+              </p:ext>
+            </p:extLst>
+          </p:nvPr>
+        </p:nvPicPr>
+        <p:blipFill>
+          <a:blip r:embed="rId3"/>
+          <a:stretch>
+            <a:fillRect/>
+          </a:stretch>
+        </p:blipFill>
+        <p:spPr>
+          <a:xfrm>
+            <a:off x="3566160" y="4206240"/>
+            <a:ext cx="5029200" cy="1508760"/>
+          </a:xfrm>
+          <a:prstGeom prst="rect">
+            <a:avLst/>
+          </a:prstGeom>
+        </p:spPr>
+      </p:pic>
     </p:spTree>
   </p:cSld>
   <p:clrMapOvr>
     <a:masterClrMapping/>
   </p:clrMapOvr>
+  <p:timing>
+    <p:tnLst>
+      <p:par>
+        <p:cTn id="1" dur="indefinite" restart="never" nodeType="tmRoot">
+          <p:childTnLst>
+            <p:video>
+              <p:cMediaNode vol="80000">
+                <p:cTn id="2" fill="hold" display="0">
+                  <p:stCondLst>
+                    <p:cond delay="indefinite"/>
+                  </p:stCondLst>
+                </p:cTn>
+                <p:tgtEl>
+                  <p:spTgt spid="4"/>
+                </p:tgtEl>
+              </p:cMediaNode>
+            </p:video>
+          </p:childTnLst>
+        </p:cTn>
+      </p:par>
+    </p:tnLst>
+  </p:timing>
 </p:sld>
 </file>
 
@@ -6517,8 +5112,8 @@
         </p:nvSpPr>
         <p:spPr>
           <a:xfrm>
-            <a:off x="457200" y="201168"/>
-            <a:ext cx="11247120" cy="777240"/>
+            <a:off x="457200" y="228600"/>
+            <a:ext cx="11247120" cy="822960"/>
           </a:xfrm>
           <a:prstGeom prst="rect">
             <a:avLst/>
@@ -6532,152 +5127,41 @@
           <a:lstStyle/>
           <a:p>
             <a:r>
-              <a:rPr sz="2800" b="1">
+              <a:rPr sz="3000" b="1">
                 <a:solidFill>
                   <a:srgbClr val="1B5EA8"/>
                 </a:solidFill>
                 <a:latin typeface="Meiryo"/>
               </a:rPr>
-              <a:t>ベースライン: highway-env の racetrack 環境 (デフォルト設定)</a:t>
-            </a:r>
-          </a:p>
-        </p:txBody>
-      </p:sp>
-      <p:sp>
-        <p:nvSpPr>
-          <p:cNvPr id="3" name="TextBox 2"/>
-          <p:cNvSpPr txBox="1"/>
+              <a:t>学習トラック一覧 (race_env.py)</a:t>
+            </a:r>
+          </a:p>
+        </p:txBody>
+      </p:sp>
+      <p:pic>
+        <p:nvPicPr>
+          <p:cNvPr id="3" name="Picture 2" descr="track_shapes.png"/>
+          <p:cNvPicPr>
+            <a:picLocks noChangeAspect="1"/>
+          </p:cNvPicPr>
           <p:nvPr/>
-        </p:nvSpPr>
+        </p:nvPicPr>
+        <p:blipFill>
+          <a:blip r:embed="rId3"/>
+          <a:stretch>
+            <a:fillRect/>
+          </a:stretch>
+        </p:blipFill>
         <p:spPr>
           <a:xfrm>
-            <a:off x="548640" y="1280160"/>
-            <a:ext cx="11064240" cy="5394960"/>
+            <a:off x="411480" y="1737360"/>
+            <a:ext cx="11338560" cy="2267712"/>
           </a:xfrm>
           <a:prstGeom prst="rect">
             <a:avLst/>
           </a:prstGeom>
-          <a:noFill/>
         </p:spPr>
-        <p:txBody>
-          <a:bodyPr wrap="square">
-            <a:spAutoFit/>
-          </a:bodyPr>
-          <a:lstStyle/>
-          <a:p>
-            <a:pPr>
-              <a:spcAft>
-                <a:spcPts val="500"/>
-              </a:spcAft>
-            </a:pPr>
-            <a:r>
-              <a:rPr sz="1700" b="1">
-                <a:solidFill>
-                  <a:srgbClr val="222222"/>
-                </a:solidFill>
-                <a:latin typeface="Meiryo"/>
-              </a:rPr>
-              <a:t>行動: ステアリングのみ (longitudinal=False)。速度は離散 target_speeds [0, 5, 10] から選択</a:t>
-            </a:r>
-          </a:p>
-          <a:p>
-            <a:pPr>
-              <a:spcAft>
-                <a:spcPts val="500"/>
-              </a:spcAft>
-            </a:pPr>
-            <a:r>
-              <a:rPr sz="1700" b="1">
-                <a:solidFill>
-                  <a:srgbClr val="222222"/>
-                </a:solidFill>
-                <a:latin typeface="Meiryo"/>
-              </a:rPr>
-              <a:t>観測: OccupancyGrid 2ch (presence / on_road) のみ、±18 m の対称視野</a:t>
-            </a:r>
-          </a:p>
-          <a:p>
-            <a:pPr>
-              <a:spcAft>
-                <a:spcPts val="500"/>
-              </a:spcAft>
-            </a:pPr>
-            <a:r>
-              <a:rPr sz="1700" b="1">
-                <a:solidFill>
-                  <a:srgbClr val="222222"/>
-                </a:solidFill>
-                <a:latin typeface="Meiryo"/>
-              </a:rPr>
-              <a:t>報酬: 車線中央維持 1/(1+4·lat²) + 操作量ペナルティ −0.3·|action| + 衝突 −1</a:t>
-            </a:r>
-          </a:p>
-          <a:p>
-            <a:pPr>
-              <a:spcAft>
-                <a:spcPts val="500"/>
-              </a:spcAft>
-            </a:pPr>
-            <a:r>
-              <a:rPr sz="1700" b="0">
-                <a:solidFill>
-                  <a:srgbClr val="222222"/>
-                </a:solidFill>
-                <a:latin typeface="Meiryo"/>
-              </a:rPr>
-              <a:t>速度: speed_limit 10 m/s。「速く走る」インセンティブが存在しない</a:t>
-            </a:r>
-          </a:p>
-          <a:p>
-            <a:pPr>
-              <a:spcAft>
-                <a:spcPts val="500"/>
-              </a:spcAft>
-            </a:pPr>
-            <a:r>
-              <a:rPr sz="1700" b="1">
-                <a:solidFill>
-                  <a:srgbClr val="222222"/>
-                </a:solidFill>
-                <a:latin typeface="Meiryo"/>
-              </a:rPr>
-              <a:t>壁: 存在しない — 路外は終了 (または放置)。すり抜け・ショートカットが物理的に可能</a:t>
-            </a:r>
-          </a:p>
-          <a:p>
-            <a:pPr>
-              <a:spcAft>
-                <a:spcPts val="500"/>
-              </a:spcAft>
-            </a:pPr>
-            <a:r>
-              <a:rPr sz="1700" b="0">
-                <a:solidFill>
-                  <a:srgbClr val="222222"/>
-                </a:solidFill>
-                <a:latin typeface="Meiryo"/>
-              </a:rPr>
-              <a:t>車両: 運動学 Bicycle (スリップなし)。NPC 1 台、エピソード 300 秒</a:t>
-            </a:r>
-          </a:p>
-          <a:p>
-            <a:pPr>
-              <a:spcAft>
-                <a:spcPts val="500"/>
-              </a:spcAft>
-            </a:pPr>
-            <a:r>
-              <a:rPr sz="1700" b="1">
-                <a:solidFill>
-                  <a:srgbClr val="B32D2D"/>
-                </a:solidFill>
-                <a:latin typeface="Meiryo"/>
-              </a:rPr>
-              <a:t>→ 「レーンをなぞる」研究環境としては優秀。しかしゲームのレースには遠い</a:t>
-            </a:r>
-          </a:p>
-        </p:txBody>
-      </p:sp>
+      </p:pic>
     </p:spTree>
   </p:cSld>
   <p:clrMapOvr>
@@ -6704,8 +5188,8 @@
         </p:nvSpPr>
         <p:spPr>
           <a:xfrm>
-            <a:off x="457200" y="201168"/>
-            <a:ext cx="11247120" cy="777240"/>
+            <a:off x="457200" y="228600"/>
+            <a:ext cx="11247120" cy="822960"/>
           </a:xfrm>
           <a:prstGeom prst="rect">
             <a:avLst/>
@@ -6719,41 +5203,168 @@
           <a:lstStyle/>
           <a:p>
             <a:r>
-              <a:rPr sz="2800" b="1">
+              <a:rPr sz="3000" b="1">
                 <a:solidFill>
                   <a:srgbClr val="1B5EA8"/>
                 </a:solidFill>
                 <a:latin typeface="Meiryo"/>
               </a:rPr>
-              <a:t>デフォルト racetrack と本プロジェクトの fast トラック</a:t>
-            </a:r>
-          </a:p>
-        </p:txBody>
-      </p:sp>
-      <p:pic>
-        <p:nvPicPr>
-          <p:cNvPr id="3" name="Picture 2" descr="default_vs_ours.png"/>
-          <p:cNvPicPr>
-            <a:picLocks noChangeAspect="1"/>
-          </p:cNvPicPr>
+              <a:t>highway-env からの変更点 (1) 環境</a:t>
+            </a:r>
+          </a:p>
+        </p:txBody>
+      </p:sp>
+      <p:sp>
+        <p:nvSpPr>
+          <p:cNvPr id="3" name="TextBox 2"/>
+          <p:cNvSpPr txBox="1"/>
           <p:nvPr/>
-        </p:nvPicPr>
-        <p:blipFill>
-          <a:blip r:embed="rId3"/>
-          <a:stretch>
-            <a:fillRect/>
-          </a:stretch>
-        </p:blipFill>
+        </p:nvSpPr>
         <p:spPr>
           <a:xfrm>
-            <a:off x="822960" y="1371600"/>
-            <a:ext cx="10515600" cy="3720905"/>
+            <a:off x="548640" y="1280160"/>
+            <a:ext cx="11064240" cy="5120640"/>
           </a:xfrm>
           <a:prstGeom prst="rect">
             <a:avLst/>
           </a:prstGeom>
+          <a:noFill/>
         </p:spPr>
-      </p:pic>
+        <p:txBody>
+          <a:bodyPr wrap="square">
+            <a:spAutoFit/>
+          </a:bodyPr>
+          <a:lstStyle/>
+          <a:p>
+            <a:pPr>
+              <a:spcAft>
+                <a:spcPts val="600"/>
+              </a:spcAft>
+            </a:pPr>
+            <a:r>
+              <a:rPr sz="1700" b="1">
+                <a:solidFill>
+                  <a:srgbClr val="222222"/>
+                </a:solidFill>
+                <a:latin typeface="Meiryo"/>
+              </a:rPr>
+              <a:t>壁 = コース外周のみ (車線境界線は壁ではない)・接触で停止・バックで脱出</a:t>
+            </a:r>
+          </a:p>
+          <a:p>
+            <a:pPr lvl="1">
+              <a:spcAft>
+                <a:spcPts val="600"/>
+              </a:spcAft>
+            </a:pPr>
+            <a:r>
+              <a:rPr sz="1500" b="0">
+                <a:solidFill>
+                  <a:srgbClr val="666666"/>
+                </a:solidFill>
+                <a:latin typeface="Meiryo"/>
+              </a:rPr>
+              <a:t>理由: ゲーム側の物理と一致させ、壁ずり走行 (wall-riding) を防ぐ</a:t>
+            </a:r>
+          </a:p>
+          <a:p>
+            <a:pPr>
+              <a:spcAft>
+                <a:spcPts val="600"/>
+              </a:spcAft>
+            </a:pPr>
+            <a:r>
+              <a:rPr sz="1700" b="0">
+                <a:solidFill>
+                  <a:srgbClr val="222222"/>
+                </a:solidFill>
+                <a:latin typeface="Meiryo"/>
+              </a:rPr>
+              <a:t>壁接触が 35 ステップ続くとクラッシュ扱いで終了 — 壁沿い周回の悪用を遮断</a:t>
+            </a:r>
+          </a:p>
+          <a:p>
+            <a:pPr>
+              <a:spcAft>
+                <a:spcPts val="600"/>
+              </a:spcAft>
+            </a:pPr>
+            <a:r>
+              <a:rPr sz="1700" b="1">
+                <a:solidFill>
+                  <a:srgbClr val="222222"/>
+                </a:solidFill>
+                <a:latin typeface="Meiryo"/>
+              </a:rPr>
+              <a:t>報酬: 速度 + 車線中央 + チェックポイント/ラップボーナス → lmap [-3,3]→[0,1]</a:t>
+            </a:r>
+          </a:p>
+          <a:p>
+            <a:pPr lvl="1">
+              <a:spcAft>
+                <a:spcPts val="600"/>
+              </a:spcAft>
+            </a:pPr>
+            <a:r>
+              <a:rPr sz="1500" b="0">
+                <a:solidFill>
+                  <a:srgbClr val="666666"/>
+                </a:solidFill>
+                <a:latin typeface="Meiryo"/>
+              </a:rPr>
+              <a:t>理由: 範囲が真の下限を覆わないと悪い状態が 0 に飽和し勾配消失 (導出をコメントで管理)</a:t>
+            </a:r>
+          </a:p>
+          <a:p>
+            <a:pPr>
+              <a:spcAft>
+                <a:spcPts val="600"/>
+              </a:spcAft>
+            </a:pPr>
+            <a:r>
+              <a:rPr sz="1700" b="1">
+                <a:solidFill>
+                  <a:srgbClr val="222222"/>
+                </a:solidFill>
+                <a:latin typeface="Meiryo"/>
+              </a:rPr>
+              <a:t>壁脱出ゾーン (1 m): バック免除 + 距離増加に報酬</a:t>
+            </a:r>
+          </a:p>
+          <a:p>
+            <a:pPr lvl="1">
+              <a:spcAft>
+                <a:spcPts val="600"/>
+              </a:spcAft>
+            </a:pPr>
+            <a:r>
+              <a:rPr sz="1500" b="0">
+                <a:solidFill>
+                  <a:srgbClr val="666666"/>
+                </a:solidFill>
+                <a:latin typeface="Meiryo"/>
+              </a:rPr>
+              <a:t>理由: 脱出直後に罰すると「壁を這う」局所解に陥る (実測で確認)</a:t>
+            </a:r>
+          </a:p>
+          <a:p>
+            <a:pPr>
+              <a:spcAft>
+                <a:spcPts val="600"/>
+              </a:spcAft>
+            </a:pPr>
+            <a:r>
+              <a:rPr sz="1700" b="0">
+                <a:solidFill>
+                  <a:srgbClr val="222222"/>
+                </a:solidFill>
+                <a:latin typeface="Meiryo"/>
+              </a:rPr>
+              <a:t>トラック 5 種 + random (エピソード毎に再抽選) で汎化学習</a:t>
+            </a:r>
+          </a:p>
+        </p:txBody>
+      </p:sp>
     </p:spTree>
   </p:cSld>
   <p:clrMapOvr>
@@ -6780,8 +5391,8 @@
         </p:nvSpPr>
         <p:spPr>
           <a:xfrm>
-            <a:off x="457200" y="201168"/>
-            <a:ext cx="11247120" cy="777240"/>
+            <a:off x="457200" y="228600"/>
+            <a:ext cx="11247120" cy="822960"/>
           </a:xfrm>
           <a:prstGeom prst="rect">
             <a:avLst/>
@@ -6795,13 +5406,13 @@
           <a:lstStyle/>
           <a:p>
             <a:r>
-              <a:rPr sz="2800" b="1">
+              <a:rPr sz="3000" b="1">
                 <a:solidFill>
                   <a:srgbClr val="1B5EA8"/>
                 </a:solidFill>
                 <a:latin typeface="Meiryo"/>
               </a:rPr>
-              <a:t>進化 (1) 行動と車両 — スロットルを持たせ、実車に近づける</a:t>
+              <a:t>highway-env からの変更点 (2) 観測・行動・学習設定</a:t>
             </a:r>
           </a:p>
         </p:txBody>
@@ -6814,8 +5425,8 @@
         </p:nvSpPr>
         <p:spPr>
           <a:xfrm>
-            <a:off x="548640" y="1097280"/>
-            <a:ext cx="11064240" cy="5394960"/>
+            <a:off x="548640" y="1280160"/>
+            <a:ext cx="11064240" cy="5120640"/>
           </a:xfrm>
           <a:prstGeom prst="rect">
             <a:avLst/>
@@ -6830,61 +5441,133 @@
           <a:p>
             <a:pPr>
               <a:spcAft>
-                <a:spcPts val="500"/>
+                <a:spcPts val="600"/>
               </a:spcAft>
             </a:pPr>
             <a:r>
-              <a:rPr sz="1600" b="1">
+              <a:rPr sz="1700" b="1">
                 <a:solidFill>
                   <a:srgbClr val="222222"/>
                 </a:solidFill>
                 <a:latin typeface="Meiryo"/>
               </a:rPr>
-              <a:t>ContinuousAction: ステアのみ → スロットル + ステア (±5 m/s², ±π/6)、dynamical=True</a:t>
+              <a:t>観測: OccupancyGrid (10ch, 12x12), 前方 27 m / 後方 9 m の非対称視野</a:t>
+            </a:r>
+          </a:p>
+          <a:p>
+            <a:pPr lvl="1">
+              <a:spcAft>
+                <a:spcPts val="600"/>
+              </a:spcAft>
+            </a:pPr>
+            <a:r>
+              <a:rPr sz="1500" b="0">
+                <a:solidFill>
+                  <a:srgbClr val="666666"/>
+                </a:solidFill>
+                <a:latin typeface="Meiryo"/>
+              </a:rPr>
+              <a:t>理由: 制動距離とコーナー先読み (16 m/s から 5 m/s² 制動で 25.6 m &lt; 27 m)</a:t>
             </a:r>
           </a:p>
           <a:p>
             <a:pPr>
               <a:spcAft>
-                <a:spcPts val="500"/>
+                <a:spcPts val="600"/>
               </a:spcAft>
             </a:pPr>
             <a:r>
-              <a:rPr sz="1600" b="0">
+              <a:rPr sz="1700" b="0">
                 <a:solidFill>
                   <a:srgbClr val="222222"/>
                 </a:solidFill>
                 <a:latin typeface="Meiryo"/>
               </a:rPr>
-              <a:t>速度上限 10 → 16 m/s、前進報酬を追加 — 「速く走る」動機を導入</a:t>
-            </a:r>
-          </a:p>
-        </p:txBody>
-      </p:sp>
-      <p:pic>
-        <p:nvPicPr>
-          <p:cNvPr id="4" name="Picture 3" descr="range_experiment.png"/>
-          <p:cNvPicPr>
-            <a:picLocks noChangeAspect="1"/>
-          </p:cNvPicPr>
-          <p:nvPr/>
-        </p:nvPicPr>
-        <p:blipFill>
-          <a:blip r:embed="rId3"/>
-          <a:stretch>
-            <a:fillRect/>
-          </a:stretch>
-        </p:blipFill>
-        <p:spPr>
-          <a:xfrm>
-            <a:off x="3017520" y="2286000"/>
-            <a:ext cx="6217920" cy="3316224"/>
-          </a:xfrm>
-          <a:prstGeom prst="rect">
-            <a:avLst/>
-          </a:prstGeom>
-        </p:spPr>
-      </p:pic>
+              <a:t>行動: 連続スロットル [-5,5] m/s² + ステア ±π/6, dynamical=True (タイヤスリップ)</a:t>
+            </a:r>
+          </a:p>
+          <a:p>
+            <a:pPr>
+              <a:spcAft>
+                <a:spcPts val="600"/>
+              </a:spcAft>
+            </a:pPr>
+            <a:r>
+              <a:rPr sz="1700" b="1">
+                <a:solidFill>
+                  <a:srgbClr val="222222"/>
+                </a:solidFill>
+                <a:latin typeface="Meiryo"/>
+              </a:rPr>
+              <a:t>2 フェーズ PPO: ①NPC なしでレーン追従 → ②NPC ありで追い越し (lr を下げて FT)</a:t>
+            </a:r>
+          </a:p>
+          <a:p>
+            <a:pPr>
+              <a:spcAft>
+                <a:spcPts val="600"/>
+              </a:spcAft>
+            </a:pPr>
+            <a:r>
+              <a:rPr sz="1700" b="0">
+                <a:solidFill>
+                  <a:srgbClr val="222222"/>
+                </a:solidFill>
+                <a:latin typeface="Meiryo"/>
+              </a:rPr>
+              <a:t>カスタム CNN 特徴抽出器 + 初期スロットルバイアス +0.4 (前進探索を促進)</a:t>
+            </a:r>
+          </a:p>
+          <a:p>
+            <a:pPr>
+              <a:spcAft>
+                <a:spcPts val="600"/>
+              </a:spcAft>
+            </a:pPr>
+            <a:r>
+              <a:rPr sz="1700" b="1">
+                <a:solidFill>
+                  <a:srgbClr val="222222"/>
+                </a:solidFill>
+                <a:latin typeface="Meiryo"/>
+              </a:rPr>
+              <a:t>fast-dev = 12 万ステップ・本番ハイパラ (ent 0.02, lr 2e-4) — 周回到達を実測保証</a:t>
+            </a:r>
+          </a:p>
+          <a:p>
+            <a:pPr lvl="1">
+              <a:spcAft>
+                <a:spcPts val="600"/>
+              </a:spcAft>
+            </a:pPr>
+            <a:r>
+              <a:rPr sz="1500" b="0">
+                <a:solidFill>
+                  <a:srgbClr val="666666"/>
+                </a:solidFill>
+                <a:latin typeface="Meiryo"/>
+              </a:rPr>
+              <a:t>理由: 高エントロピー設定 (旧 0.10) は方策がランダムに留まり永遠に曲がれない</a:t>
+            </a:r>
+          </a:p>
+          <a:p>
+            <a:pPr>
+              <a:spcAft>
+                <a:spcPts val="600"/>
+              </a:spcAft>
+            </a:pPr>
+            <a:r>
+              <a:rPr sz="1700" b="0">
+                <a:solidFill>
+                  <a:srgbClr val="222222"/>
+                </a:solidFill>
+                <a:latin typeface="Meiryo"/>
+              </a:rPr>
+              <a:t>EvalCallback のベストモデルを採用 (PPO は終盤に退行することがある)</a:t>
+            </a:r>
+          </a:p>
+        </p:txBody>
+      </p:sp>
     </p:spTree>
   </p:cSld>
   <p:clrMapOvr>
@@ -6911,8 +5594,8 @@
         </p:nvSpPr>
         <p:spPr>
           <a:xfrm>
-            <a:off x="457200" y="201168"/>
-            <a:ext cx="11247120" cy="777240"/>
+            <a:off x="457200" y="228600"/>
+            <a:ext cx="11247120" cy="822960"/>
           </a:xfrm>
           <a:prstGeom prst="rect">
             <a:avLst/>
@@ -6926,13 +5609,13 @@
           <a:lstStyle/>
           <a:p>
             <a:r>
-              <a:rPr sz="2800" b="1">
+              <a:rPr sz="3000" b="1">
                 <a:solidFill>
                   <a:srgbClr val="1B5EA8"/>
                 </a:solidFill>
                 <a:latin typeface="Meiryo"/>
               </a:rPr>
-              <a:t>進化 (2) 壁の物理 — 「なし → 反発 → 停止」の変遷</a:t>
+              <a:t>セットアップとノートブックの使い方</a:t>
             </a:r>
           </a:p>
         </p:txBody>
@@ -6945,8 +5628,8 @@
         </p:nvSpPr>
         <p:spPr>
           <a:xfrm>
-            <a:off x="548640" y="1234440"/>
-            <a:ext cx="11064240" cy="5394960"/>
+            <a:off x="548640" y="1280160"/>
+            <a:ext cx="11064240" cy="5120640"/>
           </a:xfrm>
           <a:prstGeom prst="rect">
             <a:avLst/>
@@ -6961,55 +5644,71 @@
           <a:p>
             <a:pPr>
               <a:spcAft>
-                <a:spcPts val="500"/>
+                <a:spcPts val="600"/>
               </a:spcAft>
             </a:pPr>
             <a:r>
-              <a:rPr sz="1700" b="0">
+              <a:rPr sz="1700" b="1">
                 <a:solidFill>
                   <a:srgbClr val="222222"/>
                 </a:solidFill>
                 <a:latin typeface="Meiryo"/>
               </a:rPr>
-              <a:t>v0: 壁なし (デフォルト) → コーナーを路外ショートカットする走りを学習</a:t>
+              <a:t>pip install "highway-env&gt;=1.8" "stable-baselines3[extra]&gt;=2.0" gymnasium torch tensorboard moviepy onnx onnxruntime</a:t>
+            </a:r>
+          </a:p>
+          <a:p>
+            <a:pPr lvl="1">
+              <a:spcAft>
+                <a:spcPts val="600"/>
+              </a:spcAft>
+            </a:pPr>
+            <a:r>
+              <a:rPr sz="1500" b="0">
+                <a:solidFill>
+                  <a:srgbClr val="666666"/>
+                </a:solidFill>
+                <a:latin typeface="Meiryo"/>
+              </a:rPr>
+              <a:t>注意: リポジトリの requirements.txt は旧スタック (TF2.6/gym0.21) 用 — 使わない</a:t>
             </a:r>
           </a:p>
           <a:p>
             <a:pPr>
               <a:spcAft>
-                <a:spcPts val="500"/>
+                <a:spcPts val="600"/>
               </a:spcAft>
             </a:pPr>
             <a:r>
               <a:rPr sz="1700" b="0">
                 <a:solidFill>
-                  <a:srgbClr val="B32D2D"/>
+                  <a:srgbClr val="222222"/>
                 </a:solidFill>
                 <a:latin typeface="Meiryo"/>
               </a:rPr>
-              <a:t>v1: 反発壁 (bounce) → 壁に擦って曲がる wall-riding が最速解に</a:t>
+              <a:t>task2_laning_overtaking_sb3_ppo.ipynb — fast トラック専用の学習</a:t>
             </a:r>
           </a:p>
           <a:p>
             <a:pPr>
               <a:spcAft>
-                <a:spcPts val="500"/>
+                <a:spcPts val="600"/>
               </a:spcAft>
             </a:pPr>
             <a:r>
-              <a:rPr sz="1700" b="1">
+              <a:rPr sz="1700" b="0">
                 <a:solidFill>
                   <a:srgbClr val="222222"/>
                 </a:solidFill>
                 <a:latin typeface="Meiryo"/>
               </a:rPr>
-              <a:t>v2 (最終): 停止壁 (stop) + 壁接触中は速度報酬ゼロ + 接触 35 ステップで終了</a:t>
+              <a:t>task3_generalization_sb3_ppo.ipynb — random トラック学習 + トラック別評価レポート + 5 連動画</a:t>
             </a:r>
           </a:p>
           <a:p>
             <a:pPr>
               <a:spcAft>
-                <a:spcPts val="500"/>
+                <a:spcPts val="600"/>
               </a:spcAft>
             </a:pPr>
             <a:r>
@@ -7019,23 +5718,55 @@
                 </a:solidFill>
                 <a:latin typeface="Meiryo"/>
               </a:rPr>
-              <a:t>壁 = コース外周のみ。車線境界の白線は壁ではない (2 車線を使うライン取りを許す)</a:t>
-            </a:r>
-          </a:p>
-          <a:p>
-            <a:pPr lvl="1">
+              <a:t>FAST_DEV_RUN=True: 12〜15 万ステップの短縮学習 (周回まで到達) / False: 本番 (100万+)</a:t>
+            </a:r>
+          </a:p>
+          <a:p>
+            <a:pPr>
               <a:spcAft>
-                <a:spcPts val="500"/>
+                <a:spcPts val="600"/>
               </a:spcAft>
             </a:pPr>
             <a:r>
-              <a:rPr sz="1500" b="0">
-                <a:solidFill>
-                  <a:srgbClr val="595959"/>
+              <a:rPr sz="1700" b="0">
+                <a:solidFill>
+                  <a:srgbClr val="222222"/>
                 </a:solidFill>
                 <a:latin typeface="Meiryo"/>
               </a:rPr>
-              <a:t>目的: ゲームの物理と一致 + 「壁を使う」抜け道をすべて塞ぐ</a:t>
+              <a:t>Reward yardstick セル: eval/mean_reward を「周回数」として読むための換算値を表示</a:t>
+            </a:r>
+          </a:p>
+          <a:p>
+            <a:pPr>
+              <a:spcAft>
+                <a:spcPts val="600"/>
+              </a:spcAft>
+            </a:pPr>
+            <a:r>
+              <a:rPr sz="1700" b="0">
+                <a:solidFill>
+                  <a:srgbClr val="222222"/>
+                </a:solidFill>
+                <a:latin typeface="Meiryo"/>
+              </a:rPr>
+              <a:t>ベストモデルは runs/&lt;EXP_ID&gt;/models/best/phase1|phase2/best_model.zip に保存</a:t>
+            </a:r>
+          </a:p>
+          <a:p>
+            <a:pPr>
+              <a:spcAft>
+                <a:spcPts val="600"/>
+              </a:spcAft>
+            </a:pPr>
+            <a:r>
+              <a:rPr sz="1700" b="0">
+                <a:solidFill>
+                  <a:srgbClr val="222222"/>
+                </a:solidFill>
+                <a:latin typeface="Meiryo"/>
+              </a:rPr>
+              <a:t>検証: cd re_engine/verify &amp;&amp; dotnet run -- ..  → ALL SCENARIOS MATCH</a:t>
             </a:r>
           </a:p>
         </p:txBody>

</xml_diff>

<commit_message>
Add Japanese project docs directly to main (deck v3 + overview)
Slide deck (21 slides, speaker notes throughout): media-first opening,
highway-env default-settings baseline, five-step evolution story with
measured evidence, and four new expert-level slides — POMDP
formalization (decision frequency, discount horizon, Markov-izing
features), PPO design judgments (on-policy rationale, clip 0.15,
entropy-reward scale coupling, initialization bias), reward theory
(specification gaming taxonomy, potential-based shaping per Ng+ 1999,
dense/sparse hybrid), and generalization/sim-to-real (domain
randomization vs observation inductive bias, two-layer gap handling).
Overview document gains the same material as a professional appendix.

Co-Authored-By: Claude Fable 5 <noreply@anthropic.com>
Claude-Session: https://claude.ai/code/session_01RNWAkxuGbbryAR3VqKTcDq
</commit_message>
<xml_diff>
--- a/docs/CircuitAgents_intro_ja.pptx
+++ b/docs/CircuitAgents_intro_ja.pptx
@@ -16,6 +16,16 @@
     <p:sldId id="264" r:id="rId16"/>
     <p:sldId id="265" r:id="rId17"/>
     <p:sldId id="266" r:id="rId18"/>
+    <p:sldId id="267" r:id="rId19"/>
+    <p:sldId id="268" r:id="rId20"/>
+    <p:sldId id="269" r:id="rId21"/>
+    <p:sldId id="270" r:id="rId22"/>
+    <p:sldId id="271" r:id="rId23"/>
+    <p:sldId id="272" r:id="rId24"/>
+    <p:sldId id="273" r:id="rId25"/>
+    <p:sldId id="274" r:id="rId26"/>
+    <p:sldId id="275" r:id="rId27"/>
+    <p:sldId id="276" r:id="rId28"/>
   </p:sldIdLst>
   <p:sldSz cx="12191695" cy="6858000" type="screen4x3"/>
   <p:notesSz cx="6858000" cy="9144000"/>
@@ -512,7 +522,7 @@
           <a:lstStyle/>
           <a:p>
             <a:r>
-              <a:t>本日は CircuitAgents プロジェクトを紹介します。highway-env 上で強化学習させたレース走行エージェントを、ONNX 経由で C# ゲームエンジン (RE Engine) にデプロイするまでの一連のパイプラインです。まず結果からお見せし、その後に環境・学習設定の変更点、セットアップ方法、エクスポートツールの使い方を説明します。</a:t>
+              <a:t>本日は CircuitAgents プロジェクトを 10 分で紹介します。highway-env をベースに、ゲームのレース環境に近づけるための改造を重ねて強化学習エージェントを育て、ONNX 経由で C# ゲームエンジンにデプロイするまでのパイプラインです。まず結果の映像とグラフをご覧いただき、その後で highway-env のデフォルト設定と我々が加えた変更の進化の過程、最後にセットアップとツールの使い方を説明します。</a:t>
             </a:r>
           </a:p>
         </p:txBody>
@@ -582,7 +592,7 @@
           <a:lstStyle/>
           <a:p>
             <a:r>
-              <a:t>学習済みモデルのエクスポートは export_onnx.py で行います。モードは 1 が full policy、2 が actor の channels-first、3 がエンジン用の channels-last NHWC、0 で全部です。エンジン側は必ず NHWC 版 ppo_actor_only_nhwc.onnx を使ってください。C# ビルダーは H×W×C の平坦配列を出力するため、channels-first 版に入れるとチャネルが混ざり、スロットル 0.4・ステア 0.2 程度のほぼ一定出力に退化します。トラック形状を変えたら export_track_json.py で JSON を再生成し、検証ハーネスを回します。C# 側には観測ビルダーに加えて、ステアリング平滑化・コーナー減速・スタック検出・学習と同一物理の CarController が入っています。</a:t>
+              <a:t>次に壁です。ここが一番試行錯誤した部分です。最初は壁がなく、路外に出たら終了するだけでした。これだとエージェントはコーナーを膨らんでショートカットする走りを覚えます。次に反発壁を入れましたが、今度は「壁に擦りながら曲がる」wall-riding が最速解になりました。壁が勝手に車の向きを変えてくれるので、ステアリングを学ぶ必要がなくなるんです。最終形は停止壁です。壁に当たると止まり、バックでしか脱出できない。さらに壁接触中は速度報酬をゼロにし、接触が 7 秒続いたらクラッシュ扱いで終了します。もう 1 つ重要なのは、壁はコース外周だけという点です。車線の白線を壁にすると2 車線を使ったライン取りができなくなります。この判定は最初閉じた車線単位で書いてしまい、白線が壁になるバグを踏みました。現在は「コリドー両端の車線の外側だけが壁」という実装です。</a:t>
             </a:r>
           </a:p>
         </p:txBody>
@@ -652,7 +662,567 @@
           <a:lstStyle/>
           <a:p>
             <a:r>
-              <a:t>まとめです。壁の物理と報酬の経済設計を作り込むことで、PPO は 6 万ステップで周回を学習し、ランダムトラック学習によって 1 つの方策が 5 コースすべてを走れるようになりました。C# 側は観測・物理ともに Python と数値一致で検証済みなので、エンジンに載せた瞬間から学習時と同じ挙動が期待できます。今後はゲーム内での実走検証と、実車ダイナミクスに合わせた微調整が次のステップです。ご清聴ありがとうございました。</a:t>
+              <a:t>報酬設計です。グラフは実測した 1 ステップあたりの報酬で、状態ごとの「儲け」を示しています。設計の目標は、どんな抜け道よりも普通に走る方が得、という順序を作ることです。緑の 0.97 が正しく走った場合。壁でスタックしたら 0.45、壁に擦りながら進んでも 0.42 と、壁を使う行動は割に合いません。重要なのは青の 0.51、壁からバックで脱出する行動がスタックより明確に得なことです。実は最初、脱出報酬は壁に接触している間しか出ませんでした。すると脱出の一歩目、壁から 20 cm 離れた瞬間にバックのペナルティが復活してしまい、エージェントは「壁沿いを這う」ことを学びました。今は壁から 1 m の脱出ゾーンを設け、その中ではバック免除、壁から離れる距離に報酬を出します。もう 1 つの落とし穴が正規化です。合成報酬を [-3,3] から [0,1] に線形写像していますが、この範囲が実際の下限を覆っていないと、悪い状態が全部 0 に張り付いて「悪い」と「最悪」の区別が消え、学習が止まります。範囲の導出はコードにコメントで残し、重みを変えたら再導出するルールにしています。</a:t>
+            </a:r>
+          </a:p>
+        </p:txBody>
+      </p:sp>
+      <p:sp>
+        <p:nvSpPr>
+          <p:cNvPr id="4" name="Slide Number Placeholder 3"/>
+          <p:cNvSpPr>
+            <a:spLocks noGrp="1"/>
+          </p:cNvSpPr>
+          <p:nvPr>
+            <p:ph type="sldNum" idx="5" sz="quarter"/>
+          </p:nvPr>
+        </p:nvSpPr>
+        <p:spPr/>
+      </p:sp>
+    </p:spTree>
+  </p:cSld>
+  <p:clrMapOvr>
+    <a:masterClrMapping/>
+  </p:clrMapOvr>
+</p:notes>
+</file>
+
+<file path=ppt/notesSlides/notesSlide12.xml><?xml version="1.0" encoding="utf-8"?>
+<p:notes xmlns:a="http://schemas.openxmlformats.org/drawingml/2006/main" xmlns:p="http://schemas.openxmlformats.org/presentationml/2006/main" xmlns:r="http://schemas.openxmlformats.org/officeDocument/2006/relationships">
+  <p:cSld>
+    <p:spTree>
+      <p:nvGrpSpPr>
+        <p:cNvPr id="1" name=""/>
+        <p:cNvGrpSpPr/>
+        <p:nvPr/>
+      </p:nvGrpSpPr>
+      <p:grpSpPr>
+        <a:xfrm>
+          <a:off x="0" y="0"/>
+          <a:ext cx="0" cy="0"/>
+          <a:chOff x="0" y="0"/>
+          <a:chExt cx="0" cy="0"/>
+        </a:xfrm>
+      </p:grpSpPr>
+      <p:sp>
+        <p:nvSpPr>
+          <p:cNvPr id="2" name="Slide Image Placeholder 1"/>
+          <p:cNvSpPr>
+            <a:spLocks noGrp="1"/>
+          </p:cNvSpPr>
+          <p:nvPr>
+            <p:ph type="sldImg" idx="2"/>
+          </p:nvPr>
+        </p:nvSpPr>
+        <p:spPr/>
+      </p:sp>
+      <p:sp>
+        <p:nvSpPr>
+          <p:cNvPr id="3" name="Notes Placeholder 2"/>
+          <p:cNvSpPr>
+            <a:spLocks noGrp="1"/>
+          </p:cNvSpPr>
+          <p:nvPr>
+            <p:ph type="body" idx="3" sz="quarter"/>
+          </p:nvPr>
+        </p:nvSpPr>
+        <p:spPr/>
+        <p:txBody>
+          <a:bodyPr/>
+          <a:lstStyle/>
+          <a:p>
+            <a:r>
+              <a:t>いま見た壁擦り・壁這いは、文献で言う specification gaming、報酬ハッキングの実例です。報酬関数の字面を最適化した結果、設計者の意図しない解に到達する現象で、本プロジェクトでは 3 種類を実際に踏みました。対策の理論的支柱が 2 つあります。1 つは potential-based reward shaping です。壁からのクリアランスをポテンシャル関数として、その差分に報酬を与える形にすることで、最適方策を原理的に歪めずに探索だけを誘導できます。Ng らの 1999 年の結果が根拠です。もう 1 つは報酬の順序設計で、全状態の per-step 報酬を実測し、意図する行動が抜け道より必ず高くなることをテーブルで検証しています。また milestone 報酬 (チェックポイント) はsparse な進捗信号として dense な shaping と併用し、正規化後の飽和 (クリップ) は意図的に milestone ステップにのみ許しています。</a:t>
+            </a:r>
+          </a:p>
+        </p:txBody>
+      </p:sp>
+      <p:sp>
+        <p:nvSpPr>
+          <p:cNvPr id="4" name="Slide Number Placeholder 3"/>
+          <p:cNvSpPr>
+            <a:spLocks noGrp="1"/>
+          </p:cNvSpPr>
+          <p:nvPr>
+            <p:ph type="sldNum" idx="5" sz="quarter"/>
+          </p:nvPr>
+        </p:nvSpPr>
+        <p:spPr/>
+      </p:sp>
+    </p:spTree>
+  </p:cSld>
+  <p:clrMapOvr>
+    <a:masterClrMapping/>
+  </p:clrMapOvr>
+</p:notes>
+</file>
+
+<file path=ppt/notesSlides/notesSlide13.xml><?xml version="1.0" encoding="utf-8"?>
+<p:notes xmlns:a="http://schemas.openxmlformats.org/drawingml/2006/main" xmlns:p="http://schemas.openxmlformats.org/presentationml/2006/main" xmlns:r="http://schemas.openxmlformats.org/officeDocument/2006/relationships">
+  <p:cSld>
+    <p:spTree>
+      <p:nvGrpSpPr>
+        <p:cNvPr id="1" name=""/>
+        <p:cNvGrpSpPr/>
+        <p:nvPr/>
+      </p:nvGrpSpPr>
+      <p:grpSpPr>
+        <a:xfrm>
+          <a:off x="0" y="0"/>
+          <a:ext cx="0" cy="0"/>
+          <a:chOff x="0" y="0"/>
+          <a:chExt cx="0" cy="0"/>
+        </a:xfrm>
+      </p:grpSpPr>
+      <p:sp>
+        <p:nvSpPr>
+          <p:cNvPr id="2" name="Slide Image Placeholder 1"/>
+          <p:cNvSpPr>
+            <a:spLocks noGrp="1"/>
+          </p:cNvSpPr>
+          <p:nvPr>
+            <p:ph type="sldImg" idx="2"/>
+          </p:nvPr>
+        </p:nvSpPr>
+        <p:spPr/>
+      </p:sp>
+      <p:sp>
+        <p:nvSpPr>
+          <p:cNvPr id="3" name="Notes Placeholder 2"/>
+          <p:cNvSpPr>
+            <a:spLocks noGrp="1"/>
+          </p:cNvSpPr>
+          <p:nvPr>
+            <p:ph type="body" idx="3" sz="quarter"/>
+          </p:nvPr>
+        </p:nvSpPr>
+        <p:spPr/>
+        <p:txBody>
+          <a:bodyPr/>
+          <a:lstStyle/>
+          <a:p>
+            <a:r>
+              <a:t>観測はデフォルトの 2 チャネルから 10 チャネルに拡張しました。周囲車両の相対位置・相対速度、自車のレーンからの横ずれ lat_off と角度ずれ ang_off などです。追い越しと車線維持の両方に必要な情報です。視野も変えました。デフォルトは前後対称 ±18 m ですが、レースで重要なのは前方です。後方 9 m・前方 27 m の非対称にしました。27 m という数字は制動距離から来ています。16 m/s から 5 m/s² でフル制動すると 25.6 m。前方視野がこれより短いと、コーナーが見えてからでは止まれません。ぎりぎり収まるのが 27 m です。重要な注意として、自車の絶対座標は観測に含まれません。これによりコース暗記が不可能になり、反射的なレーン追従を学習せざるを得なくなります。これが 5 コース汎化の種明かしです。</a:t>
+            </a:r>
+          </a:p>
+        </p:txBody>
+      </p:sp>
+      <p:sp>
+        <p:nvSpPr>
+          <p:cNvPr id="4" name="Slide Number Placeholder 3"/>
+          <p:cNvSpPr>
+            <a:spLocks noGrp="1"/>
+          </p:cNvSpPr>
+          <p:nvPr>
+            <p:ph type="sldNum" idx="5" sz="quarter"/>
+          </p:nvPr>
+        </p:nvSpPr>
+        <p:spPr/>
+      </p:sp>
+    </p:spTree>
+  </p:cSld>
+  <p:clrMapOvr>
+    <a:masterClrMapping/>
+  </p:clrMapOvr>
+</p:notes>
+</file>
+
+<file path=ppt/notesSlides/notesSlide14.xml><?xml version="1.0" encoding="utf-8"?>
+<p:notes xmlns:a="http://schemas.openxmlformats.org/drawingml/2006/main" xmlns:p="http://schemas.openxmlformats.org/presentationml/2006/main" xmlns:r="http://schemas.openxmlformats.org/officeDocument/2006/relationships">
+  <p:cSld>
+    <p:spTree>
+      <p:nvGrpSpPr>
+        <p:cNvPr id="1" name=""/>
+        <p:cNvGrpSpPr/>
+        <p:nvPr/>
+      </p:nvGrpSpPr>
+      <p:grpSpPr>
+        <a:xfrm>
+          <a:off x="0" y="0"/>
+          <a:ext cx="0" cy="0"/>
+          <a:chOff x="0" y="0"/>
+          <a:chExt cx="0" cy="0"/>
+        </a:xfrm>
+      </p:grpSpPr>
+      <p:sp>
+        <p:nvSpPr>
+          <p:cNvPr id="2" name="Slide Image Placeholder 1"/>
+          <p:cNvSpPr>
+            <a:spLocks noGrp="1"/>
+          </p:cNvSpPr>
+          <p:nvPr>
+            <p:ph type="sldImg" idx="2"/>
+          </p:nvPr>
+        </p:nvSpPr>
+        <p:spPr/>
+      </p:sp>
+      <p:sp>
+        <p:nvSpPr>
+          <p:cNvPr id="3" name="Notes Placeholder 2"/>
+          <p:cNvSpPr>
+            <a:spLocks noGrp="1"/>
+          </p:cNvSpPr>
+          <p:nvPr>
+            <p:ph type="body" idx="3" sz="quarter"/>
+          </p:nvPr>
+        </p:nvSpPr>
+        <p:spPr/>
+        <p:txBody>
+          <a:bodyPr/>
+          <a:lstStyle/>
+          <a:p>
+            <a:r>
+              <a:t>コースも 1 つから 5 つに増やしました。oval と stadium が基礎、rect は 90 度コーナーの反復、chicane は左右の切り返しと最小半径 10 m のキンク、fast がメインの難コースです。config の track を random にするとエピソードごとに再抽選され、これが汎化学習になります。各トラックは C# 側にもプリセットと JSON で複製されていて、検証ハーネスがPython と C# の幾何が一致することを自動チェックします。トラックを追加するときはrace_env にビルダーを書き、C# プリセットを足し、JSON を再生成して検証を回す、という手順です。</a:t>
+            </a:r>
+          </a:p>
+        </p:txBody>
+      </p:sp>
+      <p:sp>
+        <p:nvSpPr>
+          <p:cNvPr id="4" name="Slide Number Placeholder 3"/>
+          <p:cNvSpPr>
+            <a:spLocks noGrp="1"/>
+          </p:cNvSpPr>
+          <p:nvPr>
+            <p:ph type="sldNum" idx="5" sz="quarter"/>
+          </p:nvPr>
+        </p:nvSpPr>
+        <p:spPr/>
+      </p:sp>
+    </p:spTree>
+  </p:cSld>
+  <p:clrMapOvr>
+    <a:masterClrMapping/>
+  </p:clrMapOvr>
+</p:notes>
+</file>
+
+<file path=ppt/notesSlides/notesSlide15.xml><?xml version="1.0" encoding="utf-8"?>
+<p:notes xmlns:a="http://schemas.openxmlformats.org/drawingml/2006/main" xmlns:p="http://schemas.openxmlformats.org/presentationml/2006/main" xmlns:r="http://schemas.openxmlformats.org/officeDocument/2006/relationships">
+  <p:cSld>
+    <p:spTree>
+      <p:nvGrpSpPr>
+        <p:cNvPr id="1" name=""/>
+        <p:cNvGrpSpPr/>
+        <p:nvPr/>
+      </p:nvGrpSpPr>
+      <p:grpSpPr>
+        <a:xfrm>
+          <a:off x="0" y="0"/>
+          <a:ext cx="0" cy="0"/>
+          <a:chOff x="0" y="0"/>
+          <a:chExt cx="0" cy="0"/>
+        </a:xfrm>
+      </p:grpSpPr>
+      <p:sp>
+        <p:nvSpPr>
+          <p:cNvPr id="2" name="Slide Image Placeholder 1"/>
+          <p:cNvSpPr>
+            <a:spLocks noGrp="1"/>
+          </p:cNvSpPr>
+          <p:nvPr>
+            <p:ph type="sldImg" idx="2"/>
+          </p:nvPr>
+        </p:nvSpPr>
+        <p:spPr/>
+      </p:sp>
+      <p:sp>
+        <p:nvSpPr>
+          <p:cNvPr id="3" name="Notes Placeholder 2"/>
+          <p:cNvSpPr>
+            <a:spLocks noGrp="1"/>
+          </p:cNvSpPr>
+          <p:nvPr>
+            <p:ph type="body" idx="3" sz="quarter"/>
+          </p:nvPr>
+        </p:nvSpPr>
+        <p:spPr/>
+        <p:txBody>
+          <a:bodyPr/>
+          <a:lstStyle/>
+          <a:p>
+            <a:r>
+              <a:t>学習は 2 フェーズの PPO です。フェーズ 1 で他車なしのレーン追従を覚え、フェーズ 2 で NPC を入れて学習率を下げ、追い越しをファインチューニングします。特徴抽出はカスタム CNN で、初期方策のスロットルバイアスを +0.4 にずらして序盤の探索が前に進むようにしています。ここでの教訓は fast-dev、つまり動作確認用の短縮設定です。以前はエントロピー係数 0.10 の 6.5 万ステップで、何度回しても曲がれるようになりませんでした。原因は、エントロピー報酬が『ランダムでい続けること』に支払われるため、報酬が [0,1] に圧縮された本環境では方策が確定するインセンティブに勝ってしまうことでした。現在は本番と同じ ent 0.02・lr 2e-4 のまま 12 万ステップに短縮し、『周回まで確実に到達する最小構成』としてエンドツーエンドで実測検証済みです。また PPO は学習終盤に退行することがあるため、最終モデルではなく EvalCallback のベストモデルを採用します。ノートブックには eval 報酬を周回数に換算するヤードスティックのセルを入れてあり、TensorBoard の数字だけで進捗判断ができます。</a:t>
+            </a:r>
+          </a:p>
+        </p:txBody>
+      </p:sp>
+      <p:sp>
+        <p:nvSpPr>
+          <p:cNvPr id="4" name="Slide Number Placeholder 3"/>
+          <p:cNvSpPr>
+            <a:spLocks noGrp="1"/>
+          </p:cNvSpPr>
+          <p:nvPr>
+            <p:ph type="sldNum" idx="5" sz="quarter"/>
+          </p:nvPr>
+        </p:nvSpPr>
+        <p:spPr/>
+      </p:sp>
+    </p:spTree>
+  </p:cSld>
+  <p:clrMapOvr>
+    <a:masterClrMapping/>
+  </p:clrMapOvr>
+</p:notes>
+</file>
+
+<file path=ppt/notesSlides/notesSlide16.xml><?xml version="1.0" encoding="utf-8"?>
+<p:notes xmlns:a="http://schemas.openxmlformats.org/drawingml/2006/main" xmlns:p="http://schemas.openxmlformats.org/presentationml/2006/main" xmlns:r="http://schemas.openxmlformats.org/officeDocument/2006/relationships">
+  <p:cSld>
+    <p:spTree>
+      <p:nvGrpSpPr>
+        <p:cNvPr id="1" name=""/>
+        <p:cNvGrpSpPr/>
+        <p:nvPr/>
+      </p:nvGrpSpPr>
+      <p:grpSpPr>
+        <a:xfrm>
+          <a:off x="0" y="0"/>
+          <a:ext cx="0" cy="0"/>
+          <a:chOff x="0" y="0"/>
+          <a:chExt cx="0" cy="0"/>
+        </a:xfrm>
+      </p:grpSpPr>
+      <p:sp>
+        <p:nvSpPr>
+          <p:cNvPr id="2" name="Slide Image Placeholder 1"/>
+          <p:cNvSpPr>
+            <a:spLocks noGrp="1"/>
+          </p:cNvSpPr>
+          <p:nvPr>
+            <p:ph type="sldImg" idx="2"/>
+          </p:nvPr>
+        </p:nvSpPr>
+        <p:spPr/>
+      </p:sp>
+      <p:sp>
+        <p:nvSpPr>
+          <p:cNvPr id="3" name="Notes Placeholder 2"/>
+          <p:cNvSpPr>
+            <a:spLocks noGrp="1"/>
+          </p:cNvSpPr>
+          <p:nvPr>
+            <p:ph type="body" idx="3" sz="quarter"/>
+          </p:nvPr>
+        </p:nvSpPr>
+        <p:spPr/>
+        <p:txBody>
+          <a:bodyPr/>
+          <a:lstStyle/>
+          <a:p>
+            <a:r>
+              <a:t>PPO の設定を専門的に補足します。オンポリシー法を選んだ理由は、環境改造を繰り返す本プロジェクトではリプレイバッファの古いデータが即座に無効になること、シミュレータが軽くサンプル効率より壁時計効率が支配的なことです。クリップ範囲は 0.15 と標準の 0.2 より狭くしています。2 次元連続行動で方策更新が大きく振れると、壁ペナルティ由来の高分散アドバンテージで崩壊しやすいためです。GAE λ は 0.98 と高めで、密な報酬のおかげで分散増を許容しつつ、コーナー 1 つ分の時間スケールの信用割当を確保します。エントロピー係数は報酬スケールと結合する点に注意が必要です。報酬が [0,1] に圧縮された環境では、係数 0.10 はエントロピー項が報酬差を支配し、方策標準偏差が 1.6 まで成長して事実上ランダムのままでした。0.02 が均衡点です。初期化は SB3 標準の直交初期化のあと、スロットル次元のバイアスだけ +0.4 に手動シフトします。ガウス方策の平均が 0 のままだと前進と後退が等確率で、前進報酬に到達する前に壁ペナルティばかり集めるためです。</a:t>
+            </a:r>
+          </a:p>
+        </p:txBody>
+      </p:sp>
+      <p:sp>
+        <p:nvSpPr>
+          <p:cNvPr id="4" name="Slide Number Placeholder 3"/>
+          <p:cNvSpPr>
+            <a:spLocks noGrp="1"/>
+          </p:cNvSpPr>
+          <p:nvPr>
+            <p:ph type="sldNum" idx="5" sz="quarter"/>
+          </p:nvPr>
+        </p:nvSpPr>
+        <p:spPr/>
+      </p:sp>
+    </p:spTree>
+  </p:cSld>
+  <p:clrMapOvr>
+    <a:masterClrMapping/>
+  </p:clrMapOvr>
+</p:notes>
+</file>
+
+<file path=ppt/notesSlides/notesSlide17.xml><?xml version="1.0" encoding="utf-8"?>
+<p:notes xmlns:a="http://schemas.openxmlformats.org/drawingml/2006/main" xmlns:p="http://schemas.openxmlformats.org/presentationml/2006/main" xmlns:r="http://schemas.openxmlformats.org/officeDocument/2006/relationships">
+  <p:cSld>
+    <p:spTree>
+      <p:nvGrpSpPr>
+        <p:cNvPr id="1" name=""/>
+        <p:cNvGrpSpPr/>
+        <p:nvPr/>
+      </p:nvGrpSpPr>
+      <p:grpSpPr>
+        <a:xfrm>
+          <a:off x="0" y="0"/>
+          <a:ext cx="0" cy="0"/>
+          <a:chOff x="0" y="0"/>
+          <a:chExt cx="0" cy="0"/>
+        </a:xfrm>
+      </p:grpSpPr>
+      <p:sp>
+        <p:nvSpPr>
+          <p:cNvPr id="2" name="Slide Image Placeholder 1"/>
+          <p:cNvSpPr>
+            <a:spLocks noGrp="1"/>
+          </p:cNvSpPr>
+          <p:nvPr>
+            <p:ph type="sldImg" idx="2"/>
+          </p:nvPr>
+        </p:nvSpPr>
+        <p:spPr/>
+      </p:sp>
+      <p:sp>
+        <p:nvSpPr>
+          <p:cNvPr id="3" name="Notes Placeholder 2"/>
+          <p:cNvSpPr>
+            <a:spLocks noGrp="1"/>
+          </p:cNvSpPr>
+          <p:nvPr>
+            <p:ph type="body" idx="3" sz="quarter"/>
+          </p:nvPr>
+        </p:nvSpPr>
+        <p:spPr/>
+        <p:txBody>
+          <a:bodyPr/>
+          <a:lstStyle/>
+          <a:p>
+            <a:r>
+              <a:t>学習した方策をそのままゲームに載せると、シミュレータと実車の違いが問題になります。そのために C# 側に 4 つの支援クラスを用意しました。まず SteeringSmoother。方策は観測グリッドが 3 m 刻みで量子化されている影響で、直線でステアを細かく左右に振ります。デコード後のステア角に EMA をかけるだけで、符号反転が 100 ステップあたり 34 回から 12 回に減り、直線の中央維持もむしろ改善しました。次に CorneringLimiter。実車はハンドルを瞬時に切れないのでステア速度を制限し、曲率から計算した限界速度を超えたら超過量に比例した弱いブレーキをかけます。速度床があるので絶対に止まりません。StuckRecovery は移動距離ベースのスタック検出で、前進指示なのに 1 秒で 0.3 m も動けなければ壁に刺さっていると判断してバック指示を出します。発進時は動けるので誤発動しません。最後に CarController は学習時と同一のBicycle 動力学を C# に移植したもので、Python と 1e-7 で一致します。</a:t>
+            </a:r>
+          </a:p>
+        </p:txBody>
+      </p:sp>
+      <p:sp>
+        <p:nvSpPr>
+          <p:cNvPr id="4" name="Slide Number Placeholder 3"/>
+          <p:cNvSpPr>
+            <a:spLocks noGrp="1"/>
+          </p:cNvSpPr>
+          <p:nvPr>
+            <p:ph type="sldNum" idx="5" sz="quarter"/>
+          </p:nvPr>
+        </p:nvSpPr>
+        <p:spPr/>
+      </p:sp>
+    </p:spTree>
+  </p:cSld>
+  <p:clrMapOvr>
+    <a:masterClrMapping/>
+  </p:clrMapOvr>
+</p:notes>
+</file>
+
+<file path=ppt/notesSlides/notesSlide18.xml><?xml version="1.0" encoding="utf-8"?>
+<p:notes xmlns:a="http://schemas.openxmlformats.org/drawingml/2006/main" xmlns:p="http://schemas.openxmlformats.org/presentationml/2006/main" xmlns:r="http://schemas.openxmlformats.org/officeDocument/2006/relationships">
+  <p:cSld>
+    <p:spTree>
+      <p:nvGrpSpPr>
+        <p:cNvPr id="1" name=""/>
+        <p:cNvGrpSpPr/>
+        <p:nvPr/>
+      </p:nvGrpSpPr>
+      <p:grpSpPr>
+        <a:xfrm>
+          <a:off x="0" y="0"/>
+          <a:ext cx="0" cy="0"/>
+          <a:chOff x="0" y="0"/>
+          <a:chExt cx="0" cy="0"/>
+        </a:xfrm>
+      </p:grpSpPr>
+      <p:sp>
+        <p:nvSpPr>
+          <p:cNvPr id="2" name="Slide Image Placeholder 1"/>
+          <p:cNvSpPr>
+            <a:spLocks noGrp="1"/>
+          </p:cNvSpPr>
+          <p:nvPr>
+            <p:ph type="sldImg" idx="2"/>
+          </p:nvPr>
+        </p:nvSpPr>
+        <p:spPr/>
+      </p:sp>
+      <p:sp>
+        <p:nvSpPr>
+          <p:cNvPr id="3" name="Notes Placeholder 2"/>
+          <p:cNvSpPr>
+            <a:spLocks noGrp="1"/>
+          </p:cNvSpPr>
+          <p:nvPr>
+            <p:ph type="body" idx="3" sz="quarter"/>
+          </p:nvPr>
+        </p:nvSpPr>
+        <p:spPr/>
+        <p:txBody>
+          <a:bodyPr/>
+          <a:lstStyle/>
+          <a:p>
+            <a:r>
+              <a:t>デプロイを見据えた汎化の設計です。トラックのランダム化はドメインランダマイゼーションの一種で、方策がコース固有の系列を暗記することを分布レベルで禁止します。ただし本質はむしろ観測の帰納バイアスです。自己座標を観測に入れず、エゴセントリックなグリッドにすることで、方策は平行移動と回転に対して不変になり、「見えている道路形状への反射」だけが学習可能な解空間になります。実際、fast 単体で学習した方策が未見の 4 コースをゼロショットで走ったのはこの不変性の帰結です。sim-to-real ギャップへの対処は 2 層です。観測と車両物理は C# に数値一致で移植し、ギャップ自体を消す。残るゲーム固有の動力学差は、方策を再学習せずデプロイ側のアクションフィルタ(平滑化・レートリミット・旋回ブレーキ) で吸収します。フィルタは閉ループ特性を変えるため、シミュレータ内で同じフィルタを通した評価で周回数が落ちないことを確認済みです。</a:t>
+            </a:r>
+          </a:p>
+        </p:txBody>
+      </p:sp>
+      <p:sp>
+        <p:nvSpPr>
+          <p:cNvPr id="4" name="Slide Number Placeholder 3"/>
+          <p:cNvSpPr>
+            <a:spLocks noGrp="1"/>
+          </p:cNvSpPr>
+          <p:nvPr>
+            <p:ph type="sldNum" idx="5" sz="quarter"/>
+          </p:nvPr>
+        </p:nvSpPr>
+        <p:spPr/>
+      </p:sp>
+    </p:spTree>
+  </p:cSld>
+  <p:clrMapOvr>
+    <a:masterClrMapping/>
+  </p:clrMapOvr>
+</p:notes>
+</file>
+
+<file path=ppt/notesSlides/notesSlide19.xml><?xml version="1.0" encoding="utf-8"?>
+<p:notes xmlns:a="http://schemas.openxmlformats.org/drawingml/2006/main" xmlns:p="http://schemas.openxmlformats.org/presentationml/2006/main" xmlns:r="http://schemas.openxmlformats.org/officeDocument/2006/relationships">
+  <p:cSld>
+    <p:spTree>
+      <p:nvGrpSpPr>
+        <p:cNvPr id="1" name=""/>
+        <p:cNvGrpSpPr/>
+        <p:nvPr/>
+      </p:nvGrpSpPr>
+      <p:grpSpPr>
+        <a:xfrm>
+          <a:off x="0" y="0"/>
+          <a:ext cx="0" cy="0"/>
+          <a:chOff x="0" y="0"/>
+          <a:chExt cx="0" cy="0"/>
+        </a:xfrm>
+      </p:grpSpPr>
+      <p:sp>
+        <p:nvSpPr>
+          <p:cNvPr id="2" name="Slide Image Placeholder 1"/>
+          <p:cNvSpPr>
+            <a:spLocks noGrp="1"/>
+          </p:cNvSpPr>
+          <p:nvPr>
+            <p:ph type="sldImg" idx="2"/>
+          </p:nvPr>
+        </p:nvSpPr>
+        <p:spPr/>
+      </p:sp>
+      <p:sp>
+        <p:nvSpPr>
+          <p:cNvPr id="3" name="Notes Placeholder 2"/>
+          <p:cNvSpPr>
+            <a:spLocks noGrp="1"/>
+          </p:cNvSpPr>
+          <p:nvPr>
+            <p:ph type="body" idx="3" sz="quarter"/>
+          </p:nvPr>
+        </p:nvSpPr>
+        <p:spPr/>
+        <p:txBody>
+          <a:bodyPr/>
+          <a:lstStyle/>
+          <a:p>
+            <a:r>
+              <a:t>使い方です。環境構築はスライドの 1 行だけです。注意点として、リポジトリ直下のrequirements.txt は旧 TensorFlow スタック用なので使わないでください。ノートブックは 2 つ。task2 が fast トラック専用、task3 がランダムトラックの汎化学習です。設定セルの FAST_DEV_RUN で短縮学習と本番を切り替えます。学習後は軌跡プロット、トラック別評価レポート、5 トラック並列動画、そして今回のスライドに使った図と動画を生成して保存するセルまで、すべてノートブック内にあります。C# ポートの検証は re_engine/verify で dotnet run するだけです。</a:t>
             </a:r>
           </a:p>
         </p:txBody>
@@ -722,7 +1292,147 @@
           <a:lstStyle/>
           <a:p>
             <a:r>
-              <a:t>最初に結果です。PPO エージェントはメインの fast トラックを制限速度 16 m/s で安定走行し、800 秒のエピソードで 37 周、壁への衝突ゼロを達成しました。学習は 3 万〜6 万ステップで周回能力が立ち上がり、12 万ステップの fast-dev 設定でも周回します。さらに、ランダムトラックで学習した汎化モデルは、5 種類すべてのコースを同一の重みで走り切ります。C# 側の観測生成は Python 環境とビット一致で検証済みです。</a:t>
+              <a:t>説明の前に、まず走りをご覧ください。これはエピソードごとにコースをランダムに切り替えて学習した「汎化モデル」1 つを、5 つのコースで同時に評価した動画です。赤い点が車、軌跡の色が速度です。直線では黄色、つまり制限速度の 16 m/s 付近、コーナーでは適切に減速しているのが分かります。どのコースも 2 分間、壁への衝突ゼロで周回し続けます。では、この走りがどう作られたかを見ていきます。</a:t>
+            </a:r>
+          </a:p>
+        </p:txBody>
+      </p:sp>
+      <p:sp>
+        <p:nvSpPr>
+          <p:cNvPr id="4" name="Slide Number Placeholder 3"/>
+          <p:cNvSpPr>
+            <a:spLocks noGrp="1"/>
+          </p:cNvSpPr>
+          <p:nvPr>
+            <p:ph type="sldNum" idx="5" sz="quarter"/>
+          </p:nvPr>
+        </p:nvSpPr>
+        <p:spPr/>
+      </p:sp>
+    </p:spTree>
+  </p:cSld>
+  <p:clrMapOvr>
+    <a:masterClrMapping/>
+  </p:clrMapOvr>
+</p:notes>
+</file>
+
+<file path=ppt/notesSlides/notesSlide20.xml><?xml version="1.0" encoding="utf-8"?>
+<p:notes xmlns:a="http://schemas.openxmlformats.org/drawingml/2006/main" xmlns:p="http://schemas.openxmlformats.org/presentationml/2006/main" xmlns:r="http://schemas.openxmlformats.org/officeDocument/2006/relationships">
+  <p:cSld>
+    <p:spTree>
+      <p:nvGrpSpPr>
+        <p:cNvPr id="1" name=""/>
+        <p:cNvGrpSpPr/>
+        <p:nvPr/>
+      </p:nvGrpSpPr>
+      <p:grpSpPr>
+        <a:xfrm>
+          <a:off x="0" y="0"/>
+          <a:ext cx="0" cy="0"/>
+          <a:chOff x="0" y="0"/>
+          <a:chExt cx="0" cy="0"/>
+        </a:xfrm>
+      </p:grpSpPr>
+      <p:sp>
+        <p:nvSpPr>
+          <p:cNvPr id="2" name="Slide Image Placeholder 1"/>
+          <p:cNvSpPr>
+            <a:spLocks noGrp="1"/>
+          </p:cNvSpPr>
+          <p:nvPr>
+            <p:ph type="sldImg" idx="2"/>
+          </p:nvPr>
+        </p:nvSpPr>
+        <p:spPr/>
+      </p:sp>
+      <p:sp>
+        <p:nvSpPr>
+          <p:cNvPr id="3" name="Notes Placeholder 2"/>
+          <p:cNvSpPr>
+            <a:spLocks noGrp="1"/>
+          </p:cNvSpPr>
+          <p:nvPr>
+            <p:ph type="body" idx="3" sz="quarter"/>
+          </p:nvPr>
+        </p:nvSpPr>
+        <p:spPr/>
+        <p:txBody>
+          <a:bodyPr/>
+          <a:lstStyle/>
+          <a:p>
+            <a:r>
+              <a:t>デプロイ用のエクスポートは export_onnx.py です。モード 3 がエンジン用のchannels-last NHWC 版で、これが推奨です。C# の観測ビルダーは H×W×C の平坦配列を出力するため、channels-first 版のモデルに入れるとチャネルが混ざり、スロットル 0.4・ステア 0.2 程度のほぼ一定の出力に退化します。実際にこの症状で『モデルが曲がらない』というデバッグを経験したので、症状として覚えておいてください。トラックや観測の設定を変えたら、export_track_json.py で C# 側の正解データを再生成し、検証ハーネスを回します。加速度レンジなどの定数は C# 側に意図的に複製されているので、変更時は C# 定数、JSON 再生成、検証、ONNX 再エクスポートの 4 点セットを忘れずに。</a:t>
+            </a:r>
+          </a:p>
+        </p:txBody>
+      </p:sp>
+      <p:sp>
+        <p:nvSpPr>
+          <p:cNvPr id="4" name="Slide Number Placeholder 3"/>
+          <p:cNvSpPr>
+            <a:spLocks noGrp="1"/>
+          </p:cNvSpPr>
+          <p:nvPr>
+            <p:ph type="sldNum" idx="5" sz="quarter"/>
+          </p:nvPr>
+        </p:nvSpPr>
+        <p:spPr/>
+      </p:sp>
+    </p:spTree>
+  </p:cSld>
+  <p:clrMapOvr>
+    <a:masterClrMapping/>
+  </p:clrMapOvr>
+</p:notes>
+</file>
+
+<file path=ppt/notesSlides/notesSlide21.xml><?xml version="1.0" encoding="utf-8"?>
+<p:notes xmlns:a="http://schemas.openxmlformats.org/drawingml/2006/main" xmlns:p="http://schemas.openxmlformats.org/presentationml/2006/main" xmlns:r="http://schemas.openxmlformats.org/officeDocument/2006/relationships">
+  <p:cSld>
+    <p:spTree>
+      <p:nvGrpSpPr>
+        <p:cNvPr id="1" name=""/>
+        <p:cNvGrpSpPr/>
+        <p:nvPr/>
+      </p:nvGrpSpPr>
+      <p:grpSpPr>
+        <a:xfrm>
+          <a:off x="0" y="0"/>
+          <a:ext cx="0" cy="0"/>
+          <a:chOff x="0" y="0"/>
+          <a:chExt cx="0" cy="0"/>
+        </a:xfrm>
+      </p:grpSpPr>
+      <p:sp>
+        <p:nvSpPr>
+          <p:cNvPr id="2" name="Slide Image Placeholder 1"/>
+          <p:cNvSpPr>
+            <a:spLocks noGrp="1"/>
+          </p:cNvSpPr>
+          <p:nvPr>
+            <p:ph type="sldImg" idx="2"/>
+          </p:nvPr>
+        </p:nvSpPr>
+        <p:spPr/>
+      </p:sp>
+      <p:sp>
+        <p:nvSpPr>
+          <p:cNvPr id="3" name="Notes Placeholder 2"/>
+          <p:cNvSpPr>
+            <a:spLocks noGrp="1"/>
+          </p:cNvSpPr>
+          <p:nvPr>
+            <p:ph type="body" idx="3" sz="quarter"/>
+          </p:nvPr>
+        </p:nvSpPr>
+        <p:spPr/>
+        <p:txBody>
+          <a:bodyPr/>
+          <a:lstStyle/>
+          <a:p>
+            <a:r>
+              <a:t>まとめます。highway-env のデフォルトはステアリングだけの車線追従環境でした。そこにスロットルと実車動力学、物理的な壁、速く走る報酬、前方に偏った視野を段階的に加え、壁擦りや壁這いといった抜け道をひとつずつ経済的に割に合わなくして、最終的に 6 万ステップで周回を学習する環境になりました。汎化は自己位置を見せないという観測設計から生まれ、C# 側は数値一致の検証で「移植したら挙動が変わった」を排除しています。今後は RE Engine 内での実走検証と、実車ダイナミクスへの適合が次のステップです。ご清聴ありがとうございました。</a:t>
             </a:r>
           </a:p>
         </p:txBody>
@@ -792,7 +1502,7 @@
           <a:lstStyle/>
           <a:p>
             <a:r>
-              <a:t>学習の立ち上がりです。横軸が学習ステップ、縦軸がエピソードあたりの周回数です。3 万ステップでは 1 周程度で壁に刺さりますが、6 万ステップで 32 周、9 万で 36 周に達し、以降は制限速度での巡航に収束します。ランダムトラック学習 (task3) でも、最難関の chicane 評価で 5 万ステップ時点から 33 周と、ほぼ同じ速度で立ち上がります。報酬が密に設計されているため学習が速いのが特徴です。</a:t>
+              <a:t>学習の速さです。横軸が学習ステップ、縦軸が 1 エピソードあたりの周回数です。青が fast トラック単体の学習で、3 万ステップでは 1 周で壁に刺さりますが、6 万で 32 周、9 万で 36 周に達し、以降は制限速度巡航に収束します。オレンジがランダムトラック学習で、最難関の chicane 評価でも 5 万ステップから 33 周と、ほぼ同じ速度で立ち上がります。この速さは偶然ではなく、後で説明する報酬設計の結果です。</a:t>
             </a:r>
           </a:p>
         </p:txBody>
@@ -862,7 +1572,7 @@
           <a:lstStyle/>
           <a:p>
             <a:r>
-              <a:t>12 万ステップの fast-dev モデルの 2 分間の走行軌跡です。黒線がコース外壁、点の色が速度を表します。直線では 16 m/s、ヘアピンでは適切に減速して立て直しているのが分かります。以前問題になっていた e-f コーナーの壁張り付きも解消されています。</a:t>
+              <a:t>1 台分の軌跡を拡大したものです。12 万ステップの fast-dev モデルの 2 分間で、黒線がコースの物理壁、点の色が速度です。直線で最高速に達し、ヘアピン進入で青く、つまりしっかり減速し、出口で再加速しています。以前は S 字の先の e-f コーナーで壁に張り付いて動けなくなる問題がありましたが、報酬の再設計で解消しました。この「壁に張り付く」問題との戦いが、本プロジェクトの中心的なエピソードです。</a:t>
             </a:r>
           </a:p>
         </p:txBody>
@@ -932,7 +1642,7 @@
           <a:lstStyle/>
           <a:p>
             <a:r>
-              <a:t>こちらが汎化モデルの結果です。エピソードごとにトラックをランダムに切り替えて 15 万ステップ学習した1 つの方策を、5 つのコースで同時に評価しました。すべてのコースを平均 15.7 m/s、2 分間ノーミスで周回します。エージェントは自己位置を観測できないため、コース形状を暗記できず、反射的なレーン追従を学習したことが汎化の理由です。動画はスライドに埋め込んであります。再生してご覧ください。</a:t>
+              <a:t>映像で見ていただいた結果を数字でまとめます。fast トラックで 800 秒 37 周・無衝突。周回能力の獲得は 3 万から 6 万ステップ。12 万ステップの短縮設定 fast-dev でも、NPC ありのフェーズ 2 まで通して 37 周を維持します。汎化モデルは 5 コースすべてを平均 15.7 m/s で走破。そして C# 側の観測生成は Python とビット一致、車両物理も 1e-7 で一致しており、エンジンに載せた瞬間から学習時と同じ挙動が保証されます。</a:t>
             </a:r>
           </a:p>
         </p:txBody>
@@ -1002,7 +1712,7 @@
           <a:lstStyle/>
           <a:p>
             <a:r>
-              <a:t>使用している 5 つのトラックです。すべて 2 車線・幅 5 m で、直線と円弧のみで構成しています。fast は S 字と 2 つのヘアピンを持つメインコース、oval と stadium は基礎、rect は 90 度コーナーの繰り返し、chicane は左右両方向の切り返しと最小半径 10 m のキンクを持ちます。各トラックは C# 側のプリセットと track_&lt;name&gt;.json にも複製され、検証ハーネスが両者の幾何一致を自動チェックします。</a:t>
+              <a:t>ここからが本題です。ベースにした highway-env は自動運転研究向けの軽量シミュレータで、racetrack 環境がレース走行に一番近いものです。ただしデフォルト設定を詳しく見ると、ゲームのレースとはかなり違います。まず行動はステアリングのみで、速度は 0・5・10 の離散ターゲットから選ぶだけ。スロットルという概念がありません。観測は presence と on_road の2 チャネルだけで、周囲 18 m の対称視野。報酬は車線中央維持と操作量ペナルティが中心で、速く走る動機がありません。そして路外に出ても物理的な壁はなく、エピソードが終わるだけです。車両も既定ではタイヤスリップのない運動学モデルです。</a:t>
             </a:r>
           </a:p>
         </p:txBody>
@@ -1072,7 +1782,7 @@
           <a:lstStyle/>
           <a:p>
             <a:r>
-              <a:t>オリジナルの highway-env racetrack 環境との違いです。1 つ目は壁の物理です。標準では路外に出ても罰則だけですが、本環境ではコース外周だけを物理的な壁とし、車線間の白線は壁にしません。壁に当たると停止し、バックでしか脱出できません。2 つ目は報酬設計です。速度・車線中央維持・チェックポイント/ラップボーナスを生の単位で合成し、[-3,3] から [0,1] へ線形写像します。この範囲が実際の報酬の下限を覆っていないと、悪い状態がすべて 0 に飽和して勾配が消えるため、範囲の導出をコメントで管理しています。3 つ目は壁脱出の経済設計です。壁から 1 m 以内ではバック走行のペナルティを免除し、壁からの距離増加に報酬を与えます。これがないと、脱出の一歩目で罰せられて壁沿いを這う局所解を学習してしまいます。</a:t>
+              <a:t>左が highway-env デフォルトの racetrack、右が我々の fast トラックです。形状も作り直し、S 字と 2 つのヘアピンを持たせて難所を意図的に作りました。しかし本質的な違いは形ではなく物理です。左はステアリングだけ・壁なし・10 m/s、右はスロットル制御・外周が物理壁・16 m/s で、壁に当たると停止しバックでしか脱出できません。この差を埋めるために行った変更を、これから順番に説明します。</a:t>
             </a:r>
           </a:p>
         </p:txBody>
@@ -1142,7 +1852,7 @@
           <a:lstStyle/>
           <a:p>
             <a:r>
-              <a:t>観測は 10 チャネル 12x12 の OccupancyGrid で、前方 27 m・後方 9 m の非対称な視野にしています。レース走行ではコーナーの先読みが重要なためです。行動は連続値のスロットルとステアリングで、学習時と同じ動力学モデル (タイヤスリップ付き Bicycle model) を使います。学習は 2 フェーズの PPO です。フェーズ 1 で他車なしのレーン追従、フェーズ 2 で NPC を加えた追い越しをファインチューニングします。初期方策のスロットルバイアスを +0.4 にずらし、序盤の探索で前進が出やすくしています。fast-dev は 12 万ステップで、本番と同じハイパーパラメータのまま短縮した「周回まで確実に到達する最小構成」です。</a:t>
+              <a:t>専門家向けに問題設定を形式化しておきます。タスクは部分観測マルコフ決定過程です。エージェントは 5 Hz で意思決定し、物理は 15 Hz で刻みます。1 アクションを 3 物理ステップ保持するフレームスキップ構成です。観測に相対速度と自車の速度由来特徴が含まれるため、フレームスタックなしでも近似的にマルコフ性が成り立ちます。割引率 0.99 は 5 Hz で実効ホライズン約 20 秒、つまりちょうど 1 周分に相当し、コーナー進入前の減速判断に必要な信用割当が 1 周スケールで届く設計です。報酬は毎ステップ [0,1] に正規化されており、PPO のアドバンテージ正規化と併せてスケール不変な学習を狙っています。</a:t>
             </a:r>
           </a:p>
         </p:txBody>
@@ -1212,7 +1922,7 @@
           <a:lstStyle/>
           <a:p>
             <a:r>
-              <a:t>環境構築はこの 1 行です。リポジトリ直下の requirements.txt は旧 TensorFlow 系スタック用なので使わないでください。ノートブックは 2 つあり、task2 が fast トラック専用、task3 がランダムトラックの汎化学習用です。設定セルの FAST_DEV_RUN を True にすると短縮学習、False にすると本番学習になります。学習の進捗は Reward yardstick セルの数値と TensorBoard で確認でき、eval/mean_reward が周回相当値を超えたら周回できています。</a:t>
+              <a:t>最初の変更は行動空間です。ゲームの車はアクセルとブレーキを踏むので、ステアリング専用だったものを連続スロットル付きの 2 次元連続行動に変更し、加速度レンジは ±5 m/s²、ステアは ±30 度としました。車両モデルもタイヤスリップを持つ動的 Bicycle モデルに切り替えています。加速度レンジは実験で決めました。グラフの赤い破線が ±2.5 m/s² に絞った実験で、10 万ステップで 22 周までは学習できるものの巡航速度が 10 m/s に頭打ちし、終盤には退行しました。原因は制動距離です。16 m/s から 2.5 m/s² で止まるには 51 m 必要ですが、観測の前方視野は 27 m しかなく、「見えてから減速」が物理的に間に合いません。エンジン出力を絞りたい場合はブレーキだけ強い非対称レンジ [−5, +2.5] を推奨しています。</a:t>
             </a:r>
           </a:p>
         </p:txBody>
@@ -4258,18 +4968,18 @@
                 </a:solidFill>
                 <a:latin typeface="Meiryo"/>
               </a:rPr>
-              <a:t>強化学習によるサーキット走行エージェント — highway-env + PPO から RE Engine (ONNX) まで</a:t>
+              <a:t>強化学習によるサーキット走行エージェント — highway-env をゲーム環境へ進化させる</a:t>
             </a:r>
           </a:p>
           <a:p>
             <a:r>
               <a:rPr sz="1800">
                 <a:solidFill>
-                  <a:srgbClr val="666666"/>
-                </a:solidFill>
-                <a:latin typeface="Meiryo"/>
-              </a:rPr>
-              <a:t>学習環境・報酬設計・C# デプロイパイプラインの全体紹介</a:t>
+                  <a:srgbClr val="595959"/>
+                </a:solidFill>
+                <a:latin typeface="Meiryo"/>
+              </a:rPr>
+              <a:t>環境設計の変遷・学習パイプライン・RE Engine (ONNX/C#) デプロイ</a:t>
             </a:r>
           </a:p>
         </p:txBody>
@@ -4300,8 +5010,8 @@
         </p:nvSpPr>
         <p:spPr>
           <a:xfrm>
-            <a:off x="457200" y="228600"/>
-            <a:ext cx="11247120" cy="822960"/>
+            <a:off x="457200" y="201168"/>
+            <a:ext cx="11247120" cy="777240"/>
           </a:xfrm>
           <a:prstGeom prst="rect">
             <a:avLst/>
@@ -4315,13 +5025,13 @@
           <a:lstStyle/>
           <a:p>
             <a:r>
-              <a:rPr sz="3000" b="1">
+              <a:rPr sz="2800" b="1">
                 <a:solidFill>
                   <a:srgbClr val="1B5EA8"/>
                 </a:solidFill>
                 <a:latin typeface="Meiryo"/>
               </a:rPr>
-              <a:t>エクスポートツールと C# デプロイ</a:t>
+              <a:t>進化 (2) 壁の物理 — 「なし → 反発 → 停止」の変遷</a:t>
             </a:r>
           </a:p>
         </p:txBody>
@@ -4334,8 +5044,8 @@
         </p:nvSpPr>
         <p:spPr>
           <a:xfrm>
-            <a:off x="548640" y="1280160"/>
-            <a:ext cx="11064240" cy="5120640"/>
+            <a:off x="548640" y="1234440"/>
+            <a:ext cx="11064240" cy="5394960"/>
           </a:xfrm>
           <a:prstGeom prst="rect">
             <a:avLst/>
@@ -4350,129 +5060,81 @@
           <a:p>
             <a:pPr>
               <a:spcAft>
-                <a:spcPts val="600"/>
+                <a:spcPts val="500"/>
               </a:spcAft>
             </a:pPr>
             <a:r>
+              <a:rPr sz="1700" b="0">
+                <a:solidFill>
+                  <a:srgbClr val="222222"/>
+                </a:solidFill>
+                <a:latin typeface="Meiryo"/>
+              </a:rPr>
+              <a:t>v0: 壁なし (デフォルト) → コーナーを路外ショートカットする走りを学習</a:t>
+            </a:r>
+          </a:p>
+          <a:p>
+            <a:pPr>
+              <a:spcAft>
+                <a:spcPts val="500"/>
+              </a:spcAft>
+            </a:pPr>
+            <a:r>
+              <a:rPr sz="1700" b="0">
+                <a:solidFill>
+                  <a:srgbClr val="B32D2D"/>
+                </a:solidFill>
+                <a:latin typeface="Meiryo"/>
+              </a:rPr>
+              <a:t>v1: 反発壁 (bounce) → 壁に擦って曲がる wall-riding が最速解に</a:t>
+            </a:r>
+          </a:p>
+          <a:p>
+            <a:pPr>
+              <a:spcAft>
+                <a:spcPts val="500"/>
+              </a:spcAft>
+            </a:pPr>
+            <a:r>
               <a:rPr sz="1700" b="1">
                 <a:solidFill>
                   <a:srgbClr val="222222"/>
                 </a:solidFill>
                 <a:latin typeface="Meiryo"/>
               </a:rPr>
-              <a:t>python export_onnx.py &lt;model.zip&gt; -m 3        # エンジン用 NHWC (推奨)</a:t>
+              <a:t>v2 (最終): 停止壁 (stop) + 壁接触中は速度報酬ゼロ + 接触 35 ステップで終了</a:t>
+            </a:r>
+          </a:p>
+          <a:p>
+            <a:pPr>
+              <a:spcAft>
+                <a:spcPts val="500"/>
+              </a:spcAft>
+            </a:pPr>
+            <a:r>
+              <a:rPr sz="1700" b="1">
+                <a:solidFill>
+                  <a:srgbClr val="222222"/>
+                </a:solidFill>
+                <a:latin typeface="Meiryo"/>
+              </a:rPr>
+              <a:t>壁 = コース外周のみ。車線境界の白線は壁ではない (2 車線を使うライン取りを許す)</a:t>
             </a:r>
           </a:p>
           <a:p>
             <a:pPr lvl="1">
               <a:spcAft>
-                <a:spcPts val="600"/>
+                <a:spcPts val="500"/>
               </a:spcAft>
             </a:pPr>
             <a:r>
               <a:rPr sz="1500" b="0">
                 <a:solidFill>
-                  <a:srgbClr val="666666"/>
-                </a:solidFill>
-                <a:latin typeface="Meiryo"/>
-              </a:rPr>
-              <a:t>  -m: 1=full policy / 2=actor CHW / 3=actor NHWC / 0=全部,  -o で出力名指定</a:t>
-            </a:r>
-          </a:p>
-          <a:p>
-            <a:pPr>
-              <a:spcAft>
-                <a:spcPts val="600"/>
-              </a:spcAft>
-            </a:pPr>
-            <a:r>
-              <a:rPr sz="1700" b="0">
-                <a:solidFill>
-                  <a:srgbClr val="222222"/>
-                </a:solidFill>
-                <a:latin typeface="Meiryo"/>
-              </a:rPr>
-              <a:t>python re_engine/convert_onnx_nhwc.py &lt;actor.onnx&gt;  # 既存 CHW を NHWC 化</a:t>
-            </a:r>
-          </a:p>
-          <a:p>
-            <a:pPr>
-              <a:spcAft>
-                <a:spcPts val="600"/>
-              </a:spcAft>
-            </a:pPr>
-            <a:r>
-              <a:rPr sz="1700" b="0">
-                <a:solidFill>
-                  <a:srgbClr val="222222"/>
-                </a:solidFill>
-                <a:latin typeface="Meiryo"/>
-              </a:rPr>
-              <a:t>python re_engine/export_track_json.py  # トラック変更後に JSON + 参照観測を再生成</a:t>
-            </a:r>
-          </a:p>
-          <a:p>
-            <a:pPr>
-              <a:spcAft>
-                <a:spcPts val="600"/>
-              </a:spcAft>
-            </a:pPr>
-            <a:r>
-              <a:rPr sz="1700" b="1">
-                <a:solidFill>
-                  <a:srgbClr val="222222"/>
-                </a:solidFill>
-                <a:latin typeface="Meiryo"/>
-              </a:rPr>
-              <a:t>エンジンは ppo_actor_only_nhwc.onnx (入力 [1,12,12,10]) を使用</a:t>
-            </a:r>
-          </a:p>
-          <a:p>
-            <a:pPr lvl="1">
-              <a:spcAft>
-                <a:spcPts val="600"/>
-              </a:spcAft>
-            </a:pPr>
-            <a:r>
-              <a:rPr sz="1500" b="0">
-                <a:solidFill>
-                  <a:srgbClr val="666666"/>
-                </a:solidFill>
-                <a:latin typeface="Meiryo"/>
-              </a:rPr>
-              <a:t>  理由: C# は HWC 平坦列を出力 — CHW 版に入れると出力がほぼ一定に退化</a:t>
-            </a:r>
-          </a:p>
-          <a:p>
-            <a:pPr>
-              <a:spcAft>
-                <a:spcPts val="600"/>
-              </a:spcAft>
-            </a:pPr>
-            <a:r>
-              <a:rPr sz="1700" b="0">
-                <a:solidFill>
-                  <a:srgbClr val="222222"/>
-                </a:solidFill>
-                <a:latin typeface="Meiryo"/>
-              </a:rPr>
-              <a:t>C# 支援クラス: SteeringSmoother / CorneringLimiter / StuckRecovery / CarController</a:t>
-            </a:r>
-          </a:p>
-          <a:p>
-            <a:pPr lvl="1">
-              <a:spcAft>
-                <a:spcPts val="600"/>
-              </a:spcAft>
-            </a:pPr>
-            <a:r>
-              <a:rPr sz="1500" b="0">
-                <a:solidFill>
-                  <a:srgbClr val="666666"/>
-                </a:solidFill>
-                <a:latin typeface="Meiryo"/>
-              </a:rPr>
-              <a:t>  CarController は学習時と同一の Bicycle 動力学 (Python と 1e-7 一致) で速度 Vector3 を出力</a:t>
+                  <a:srgbClr val="595959"/>
+                </a:solidFill>
+                <a:latin typeface="Meiryo"/>
+              </a:rPr>
+              <a:t>目的: ゲームの物理と一致 + 「壁を使う」抜け道をすべて塞ぐ</a:t>
             </a:r>
           </a:p>
         </p:txBody>
@@ -4503,8 +5165,8 @@
         </p:nvSpPr>
         <p:spPr>
           <a:xfrm>
-            <a:off x="457200" y="228600"/>
-            <a:ext cx="11247120" cy="822960"/>
+            <a:off x="457200" y="201168"/>
+            <a:ext cx="11247120" cy="777240"/>
           </a:xfrm>
           <a:prstGeom prst="rect">
             <a:avLst/>
@@ -4518,27 +5180,51 @@
           <a:lstStyle/>
           <a:p>
             <a:r>
-              <a:rPr sz="3000" b="1">
+              <a:rPr sz="2800" b="1">
                 <a:solidFill>
                   <a:srgbClr val="1B5EA8"/>
                 </a:solidFill>
                 <a:latin typeface="Meiryo"/>
               </a:rPr>
-              <a:t>まとめ</a:t>
-            </a:r>
-          </a:p>
-        </p:txBody>
-      </p:sp>
-      <p:sp>
-        <p:nvSpPr>
-          <p:cNvPr id="3" name="TextBox 2"/>
+              <a:t>進化 (3) 報酬の経済設計 — 抜け道より運転が得になるまで</a:t>
+            </a:r>
+          </a:p>
+        </p:txBody>
+      </p:sp>
+      <p:pic>
+        <p:nvPicPr>
+          <p:cNvPr id="3" name="Picture 2" descr="reward_economics.png"/>
+          <p:cNvPicPr>
+            <a:picLocks noChangeAspect="1"/>
+          </p:cNvPicPr>
+          <p:nvPr/>
+        </p:nvPicPr>
+        <p:blipFill>
+          <a:blip r:embed="rId3"/>
+          <a:stretch>
+            <a:fillRect/>
+          </a:stretch>
+        </p:blipFill>
+        <p:spPr>
+          <a:xfrm>
+            <a:off x="640080" y="1188720"/>
+            <a:ext cx="6766560" cy="3304599"/>
+          </a:xfrm>
+          <a:prstGeom prst="rect">
+            <a:avLst/>
+          </a:prstGeom>
+        </p:spPr>
+      </p:pic>
+      <p:sp>
+        <p:nvSpPr>
+          <p:cNvPr id="4" name="TextBox 3"/>
           <p:cNvSpPr txBox="1"/>
           <p:nvPr/>
         </p:nvSpPr>
         <p:spPr>
           <a:xfrm>
-            <a:off x="548640" y="1463040"/>
-            <a:ext cx="11064240" cy="5120640"/>
+            <a:off x="7589520" y="1371600"/>
+            <a:ext cx="4206240" cy="5394960"/>
           </a:xfrm>
           <a:prstGeom prst="rect">
             <a:avLst/>
@@ -4553,81 +5239,1394 @@
           <a:p>
             <a:pPr>
               <a:spcAft>
-                <a:spcPts val="600"/>
+                <a:spcPts val="500"/>
               </a:spcAft>
             </a:pPr>
             <a:r>
-              <a:rPr sz="2000" b="1">
+              <a:rPr sz="1400" b="1">
                 <a:solidFill>
                   <a:srgbClr val="222222"/>
                 </a:solidFill>
                 <a:latin typeface="Meiryo"/>
               </a:rPr>
-              <a:t>報酬・壁の経済設計が学習速度を決める: 周回獲得は 3〜6 万ステップ</a:t>
+              <a:t>目標: 運転 &gt; 脱出 &gt; 停滞 &gt; 壁擦り の順序</a:t>
             </a:r>
           </a:p>
           <a:p>
             <a:pPr>
               <a:spcAft>
-                <a:spcPts val="600"/>
+                <a:spcPts val="500"/>
               </a:spcAft>
             </a:pPr>
             <a:r>
-              <a:rPr sz="2000" b="1">
+              <a:rPr sz="1400" b="0">
                 <a:solidFill>
                   <a:srgbClr val="222222"/>
                 </a:solidFill>
                 <a:latin typeface="Meiryo"/>
               </a:rPr>
-              <a:t>ランダムトラック学習で 1 方策 5 コース走破 — 自己位置非観測が汎化の鍵</a:t>
+              <a:t>脱出ゾーン (壁 1 m): バック免除 +</a:t>
+            </a:r>
+          </a:p>
+          <a:p>
+            <a:pPr lvl="1">
+              <a:spcAft>
+                <a:spcPts val="500"/>
+              </a:spcAft>
+            </a:pPr>
+            <a:r>
+              <a:rPr sz="1200" b="0">
+                <a:solidFill>
+                  <a:srgbClr val="595959"/>
+                </a:solidFill>
+                <a:latin typeface="Meiryo"/>
+              </a:rPr>
+              <a:t>  距離増加に報酬 — 「壁を這う」局所解を排除</a:t>
             </a:r>
           </a:p>
           <a:p>
             <a:pPr>
               <a:spcAft>
-                <a:spcPts val="600"/>
+                <a:spcPts val="500"/>
               </a:spcAft>
             </a:pPr>
             <a:r>
-              <a:rPr sz="2000" b="1">
+              <a:rPr sz="1400" b="0">
                 <a:solidFill>
                   <a:srgbClr val="222222"/>
                 </a:solidFill>
                 <a:latin typeface="Meiryo"/>
               </a:rPr>
-              <a:t>C# ポートは観測ビット一致 + 物理 1e-7 一致 — 「動くはず」ではなく「同じ」</a:t>
+              <a:t>lmap [-3,3]→[0,1]: 範囲が下限を覆わないと</a:t>
+            </a:r>
+          </a:p>
+          <a:p>
+            <a:pPr lvl="1">
+              <a:spcAft>
+                <a:spcPts val="500"/>
+              </a:spcAft>
+            </a:pPr>
+            <a:r>
+              <a:rPr sz="1200" b="0">
+                <a:solidFill>
+                  <a:srgbClr val="595959"/>
+                </a:solidFill>
+                <a:latin typeface="Meiryo"/>
+              </a:rPr>
+              <a:t>  勾配消失 (導出をコメントで管理)</a:t>
             </a:r>
           </a:p>
           <a:p>
             <a:pPr>
               <a:spcAft>
-                <a:spcPts val="600"/>
+                <a:spcPts val="500"/>
               </a:spcAft>
             </a:pPr>
             <a:r>
-              <a:rPr sz="2000" b="0">
+              <a:rPr sz="1400" b="0">
                 <a:solidFill>
                   <a:srgbClr val="222222"/>
                 </a:solidFill>
                 <a:latin typeface="Meiryo"/>
               </a:rPr>
-              <a:t>再現手順・注意点は CLAUDE.md / re_engine/README.md に集約</a:t>
-            </a:r>
-          </a:p>
+              <a:t>チェックポイント/ラップボーナスは生単位で加算</a:t>
+            </a:r>
+          </a:p>
+        </p:txBody>
+      </p:sp>
+    </p:spTree>
+  </p:cSld>
+  <p:clrMapOvr>
+    <a:masterClrMapping/>
+  </p:clrMapOvr>
+</p:sld>
+</file>
+
+<file path=ppt/slides/slide12.xml><?xml version="1.0" encoding="utf-8"?>
+<p:sld xmlns:a="http://schemas.openxmlformats.org/drawingml/2006/main" xmlns:p="http://schemas.openxmlformats.org/presentationml/2006/main" xmlns:r="http://schemas.openxmlformats.org/officeDocument/2006/relationships">
+  <p:cSld>
+    <p:spTree>
+      <p:nvGrpSpPr>
+        <p:cNvPr id="1" name=""/>
+        <p:cNvGrpSpPr/>
+        <p:nvPr/>
+      </p:nvGrpSpPr>
+      <p:grpSpPr/>
+      <p:sp>
+        <p:nvSpPr>
+          <p:cNvPr id="2" name="TextBox 1"/>
+          <p:cNvSpPr txBox="1"/>
+          <p:nvPr/>
+        </p:nvSpPr>
+        <p:spPr>
+          <a:xfrm>
+            <a:off x="457200" y="201168"/>
+            <a:ext cx="11247120" cy="777240"/>
+          </a:xfrm>
+          <a:prstGeom prst="rect">
+            <a:avLst/>
+          </a:prstGeom>
+          <a:noFill/>
+        </p:spPr>
+        <p:txBody>
+          <a:bodyPr wrap="none">
+            <a:spAutoFit/>
+          </a:bodyPr>
+          <a:lstStyle/>
+          <a:p>
+            <a:r>
+              <a:rPr sz="2800" b="1">
+                <a:solidFill>
+                  <a:srgbClr val="1B5EA8"/>
+                </a:solidFill>
+                <a:latin typeface="Meiryo"/>
+              </a:rPr>
+              <a:t>報酬設計の理論背景 — specification gaming と shaping</a:t>
+            </a:r>
+          </a:p>
+        </p:txBody>
+      </p:sp>
+      <p:sp>
+        <p:nvSpPr>
+          <p:cNvPr id="3" name="TextBox 2"/>
+          <p:cNvSpPr txBox="1"/>
+          <p:nvPr/>
+        </p:nvSpPr>
+        <p:spPr>
+          <a:xfrm>
+            <a:off x="548640" y="1325880"/>
+            <a:ext cx="11064240" cy="5394960"/>
+          </a:xfrm>
+          <a:prstGeom prst="rect">
+            <a:avLst/>
+          </a:prstGeom>
+          <a:noFill/>
+        </p:spPr>
+        <p:txBody>
+          <a:bodyPr wrap="square">
+            <a:spAutoFit/>
+          </a:bodyPr>
+          <a:lstStyle/>
           <a:p>
             <a:pPr>
               <a:spcAft>
-                <a:spcPts val="600"/>
+                <a:spcPts val="500"/>
               </a:spcAft>
             </a:pPr>
             <a:r>
-              <a:rPr sz="2000" b="0">
+              <a:rPr sz="1700" b="1">
                 <a:solidFill>
                   <a:srgbClr val="222222"/>
                 </a:solidFill>
                 <a:latin typeface="Meiryo"/>
               </a:rPr>
-              <a:t>次のステップ: RE Engine 内での実走検証、実車ダイナミクスへの適合</a:t>
+              <a:t>観測された specification gaming: ①路外ショートカット ②wall-riding ③壁這い (creeping)</a:t>
+            </a:r>
+          </a:p>
+          <a:p>
+            <a:pPr>
+              <a:spcAft>
+                <a:spcPts val="500"/>
+              </a:spcAft>
+            </a:pPr>
+            <a:r>
+              <a:rPr sz="1700" b="1">
+                <a:solidFill>
+                  <a:srgbClr val="222222"/>
+                </a:solidFill>
+                <a:latin typeface="Meiryo"/>
+              </a:rPr>
+              <a:t>対策 1: potential-based shaping (Ng+ 1999) — 壁クリアランス φ の差分報酬は最適方策を保存</a:t>
+            </a:r>
+          </a:p>
+          <a:p>
+            <a:pPr>
+              <a:spcAft>
+                <a:spcPts val="500"/>
+              </a:spcAft>
+            </a:pPr>
+            <a:r>
+              <a:rPr sz="1700" b="0">
+                <a:solidFill>
+                  <a:srgbClr val="222222"/>
+                </a:solidFill>
+                <a:latin typeface="Meiryo"/>
+              </a:rPr>
+              <a:t>対策 2: 状態別 per-step 報酬の実測テーブルで順序 (運転&gt;脱出&gt;停滞&gt;壁擦り) を検証</a:t>
+            </a:r>
+          </a:p>
+          <a:p>
+            <a:pPr>
+              <a:spcAft>
+                <a:spcPts val="500"/>
+              </a:spcAft>
+            </a:pPr>
+            <a:r>
+              <a:rPr sz="1700" b="0">
+                <a:solidFill>
+                  <a:srgbClr val="222222"/>
+                </a:solidFill>
+                <a:latin typeface="Meiryo"/>
+              </a:rPr>
+              <a:t>dense (速度・車線) + sparse (チェックポイント) のハイブリッド — 学習速度と方向性の両立</a:t>
+            </a:r>
+          </a:p>
+          <a:p>
+            <a:pPr>
+              <a:spcAft>
+                <a:spcPts val="500"/>
+              </a:spcAft>
+            </a:pPr>
+            <a:r>
+              <a:rPr sz="1700" b="1">
+                <a:solidFill>
+                  <a:srgbClr val="222222"/>
+                </a:solidFill>
+                <a:latin typeface="Meiryo"/>
+              </a:rPr>
+              <a:t>正規化 [0,1] はクリップを伴う → 範囲設計を誤ると勾配消失。飽和は milestone のみに許容</a:t>
+            </a:r>
+          </a:p>
+          <a:p>
+            <a:pPr>
+              <a:spcAft>
+                <a:spcPts val="500"/>
+              </a:spcAft>
+            </a:pPr>
+            <a:r>
+              <a:rPr sz="1700" b="0">
+                <a:solidFill>
+                  <a:srgbClr val="222222"/>
+                </a:solidFill>
+                <a:latin typeface="Meiryo"/>
+              </a:rPr>
+              <a:t>PPO はアドバンテージ正規化により報酬のアフィン変換に不変 — 正規化は診断のための設計</a:t>
+            </a:r>
+          </a:p>
+        </p:txBody>
+      </p:sp>
+    </p:spTree>
+  </p:cSld>
+  <p:clrMapOvr>
+    <a:masterClrMapping/>
+  </p:clrMapOvr>
+</p:sld>
+</file>
+
+<file path=ppt/slides/slide13.xml><?xml version="1.0" encoding="utf-8"?>
+<p:sld xmlns:a="http://schemas.openxmlformats.org/drawingml/2006/main" xmlns:p="http://schemas.openxmlformats.org/presentationml/2006/main" xmlns:r="http://schemas.openxmlformats.org/officeDocument/2006/relationships">
+  <p:cSld>
+    <p:spTree>
+      <p:nvGrpSpPr>
+        <p:cNvPr id="1" name=""/>
+        <p:cNvGrpSpPr/>
+        <p:nvPr/>
+      </p:nvGrpSpPr>
+      <p:grpSpPr/>
+      <p:sp>
+        <p:nvSpPr>
+          <p:cNvPr id="2" name="TextBox 1"/>
+          <p:cNvSpPr txBox="1"/>
+          <p:nvPr/>
+        </p:nvSpPr>
+        <p:spPr>
+          <a:xfrm>
+            <a:off x="457200" y="201168"/>
+            <a:ext cx="11247120" cy="777240"/>
+          </a:xfrm>
+          <a:prstGeom prst="rect">
+            <a:avLst/>
+          </a:prstGeom>
+          <a:noFill/>
+        </p:spPr>
+        <p:txBody>
+          <a:bodyPr wrap="none">
+            <a:spAutoFit/>
+          </a:bodyPr>
+          <a:lstStyle/>
+          <a:p>
+            <a:r>
+              <a:rPr sz="2800" b="1">
+                <a:solidFill>
+                  <a:srgbClr val="1B5EA8"/>
+                </a:solidFill>
+                <a:latin typeface="Meiryo"/>
+              </a:rPr>
+              <a:t>進化 (4) 観測 — 2ch から 10ch へ、前方に偏った視野へ</a:t>
+            </a:r>
+          </a:p>
+        </p:txBody>
+      </p:sp>
+      <p:sp>
+        <p:nvSpPr>
+          <p:cNvPr id="3" name="TextBox 2"/>
+          <p:cNvSpPr txBox="1"/>
+          <p:nvPr/>
+        </p:nvSpPr>
+        <p:spPr>
+          <a:xfrm>
+            <a:off x="548640" y="1325880"/>
+            <a:ext cx="11064240" cy="5394960"/>
+          </a:xfrm>
+          <a:prstGeom prst="rect">
+            <a:avLst/>
+          </a:prstGeom>
+          <a:noFill/>
+        </p:spPr>
+        <p:txBody>
+          <a:bodyPr wrap="square">
+            <a:spAutoFit/>
+          </a:bodyPr>
+          <a:lstStyle/>
+          <a:p>
+            <a:pPr>
+              <a:spcAft>
+                <a:spcPts val="500"/>
+              </a:spcAft>
+            </a:pPr>
+            <a:r>
+              <a:rPr sz="1700" b="1">
+                <a:solidFill>
+                  <a:srgbClr val="222222"/>
+                </a:solidFill>
+                <a:latin typeface="Meiryo"/>
+              </a:rPr>
+              <a:t>2ch (presence/on_road) → 10ch: + 相対位置 x,y / 相対速度 vx,vy / 向き cos_h,sin_h / lat_off / ang_off</a:t>
+            </a:r>
+          </a:p>
+          <a:p>
+            <a:pPr>
+              <a:spcAft>
+                <a:spcPts val="500"/>
+              </a:spcAft>
+            </a:pPr>
+            <a:r>
+              <a:rPr sz="1700" b="1">
+                <a:solidFill>
+                  <a:srgbClr val="222222"/>
+                </a:solidFill>
+                <a:latin typeface="Meiryo"/>
+              </a:rPr>
+              <a:t>視野: ±18 m 対称 → 前方 27 m / 後方 9 m の非対称 (12×12 セル, 3 m 刻み)</a:t>
+            </a:r>
+          </a:p>
+          <a:p>
+            <a:pPr lvl="1">
+              <a:spcAft>
+                <a:spcPts val="500"/>
+              </a:spcAft>
+            </a:pPr>
+            <a:r>
+              <a:rPr sz="1500" b="0">
+                <a:solidFill>
+                  <a:srgbClr val="595959"/>
+                </a:solidFill>
+                <a:latin typeface="Meiryo"/>
+              </a:rPr>
+              <a:t>根拠: 制動距離 16 m/s ÷ 5 m/s² = 25.6 m &lt; 27 m — 「見えてから止まれる」最小視野</a:t>
+            </a:r>
+          </a:p>
+          <a:p>
+            <a:pPr>
+              <a:spcAft>
+                <a:spcPts val="500"/>
+              </a:spcAft>
+            </a:pPr>
+            <a:r>
+              <a:rPr sz="1700" b="1">
+                <a:solidFill>
+                  <a:srgbClr val="222222"/>
+                </a:solidFill>
+                <a:latin typeface="Meiryo"/>
+              </a:rPr>
+              <a:t>自車の絶対座標は観測に含まない → コース暗記が不可能 → 汎化の鍵</a:t>
+            </a:r>
+          </a:p>
+          <a:p>
+            <a:pPr>
+              <a:spcAft>
+                <a:spcPts val="500"/>
+              </a:spcAft>
+            </a:pPr>
+            <a:r>
+              <a:rPr sz="1700" b="0">
+                <a:solidFill>
+                  <a:srgbClr val="222222"/>
+                </a:solidFill>
+                <a:latin typeface="Meiryo"/>
+              </a:rPr>
+              <a:t>on_road はレーン中心線のトレース (塗りつぶしマスクではない) — C# 移植時の要注意点</a:t>
+            </a:r>
+          </a:p>
+        </p:txBody>
+      </p:sp>
+    </p:spTree>
+  </p:cSld>
+  <p:clrMapOvr>
+    <a:masterClrMapping/>
+  </p:clrMapOvr>
+</p:sld>
+</file>
+
+<file path=ppt/slides/slide14.xml><?xml version="1.0" encoding="utf-8"?>
+<p:sld xmlns:a="http://schemas.openxmlformats.org/drawingml/2006/main" xmlns:p="http://schemas.openxmlformats.org/presentationml/2006/main" xmlns:r="http://schemas.openxmlformats.org/officeDocument/2006/relationships">
+  <p:cSld>
+    <p:spTree>
+      <p:nvGrpSpPr>
+        <p:cNvPr id="1" name=""/>
+        <p:cNvGrpSpPr/>
+        <p:nvPr/>
+      </p:nvGrpSpPr>
+      <p:grpSpPr/>
+      <p:sp>
+        <p:nvSpPr>
+          <p:cNvPr id="2" name="TextBox 1"/>
+          <p:cNvSpPr txBox="1"/>
+          <p:nvPr/>
+        </p:nvSpPr>
+        <p:spPr>
+          <a:xfrm>
+            <a:off x="457200" y="201168"/>
+            <a:ext cx="11247120" cy="777240"/>
+          </a:xfrm>
+          <a:prstGeom prst="rect">
+            <a:avLst/>
+          </a:prstGeom>
+          <a:noFill/>
+        </p:spPr>
+        <p:txBody>
+          <a:bodyPr wrap="none">
+            <a:spAutoFit/>
+          </a:bodyPr>
+          <a:lstStyle/>
+          <a:p>
+            <a:r>
+              <a:rPr sz="2800" b="1">
+                <a:solidFill>
+                  <a:srgbClr val="1B5EA8"/>
+                </a:solidFill>
+                <a:latin typeface="Meiryo"/>
+              </a:rPr>
+              <a:t>進化 (5) トラックを 1 → 5 種に — 汎化学習</a:t>
+            </a:r>
+          </a:p>
+        </p:txBody>
+      </p:sp>
+      <p:pic>
+        <p:nvPicPr>
+          <p:cNvPr id="3" name="Picture 2" descr="track_shapes.png"/>
+          <p:cNvPicPr>
+            <a:picLocks noChangeAspect="1"/>
+          </p:cNvPicPr>
+          <p:nvPr/>
+        </p:nvPicPr>
+        <p:blipFill>
+          <a:blip r:embed="rId3"/>
+          <a:stretch>
+            <a:fillRect/>
+          </a:stretch>
+        </p:blipFill>
+        <p:spPr>
+          <a:xfrm>
+            <a:off x="411480" y="1554480"/>
+            <a:ext cx="11338560" cy="2267712"/>
+          </a:xfrm>
+          <a:prstGeom prst="rect">
+            <a:avLst/>
+          </a:prstGeom>
+        </p:spPr>
+      </p:pic>
+    </p:spTree>
+  </p:cSld>
+  <p:clrMapOvr>
+    <a:masterClrMapping/>
+  </p:clrMapOvr>
+</p:sld>
+</file>
+
+<file path=ppt/slides/slide15.xml><?xml version="1.0" encoding="utf-8"?>
+<p:sld xmlns:a="http://schemas.openxmlformats.org/drawingml/2006/main" xmlns:p="http://schemas.openxmlformats.org/presentationml/2006/main" xmlns:r="http://schemas.openxmlformats.org/officeDocument/2006/relationships">
+  <p:cSld>
+    <p:spTree>
+      <p:nvGrpSpPr>
+        <p:cNvPr id="1" name=""/>
+        <p:cNvGrpSpPr/>
+        <p:nvPr/>
+      </p:nvGrpSpPr>
+      <p:grpSpPr/>
+      <p:sp>
+        <p:nvSpPr>
+          <p:cNvPr id="2" name="TextBox 1"/>
+          <p:cNvSpPr txBox="1"/>
+          <p:nvPr/>
+        </p:nvSpPr>
+        <p:spPr>
+          <a:xfrm>
+            <a:off x="457200" y="201168"/>
+            <a:ext cx="11247120" cy="777240"/>
+          </a:xfrm>
+          <a:prstGeom prst="rect">
+            <a:avLst/>
+          </a:prstGeom>
+          <a:noFill/>
+        </p:spPr>
+        <p:txBody>
+          <a:bodyPr wrap="none">
+            <a:spAutoFit/>
+          </a:bodyPr>
+          <a:lstStyle/>
+          <a:p>
+            <a:r>
+              <a:rPr sz="2800" b="1">
+                <a:solidFill>
+                  <a:srgbClr val="1B5EA8"/>
+                </a:solidFill>
+                <a:latin typeface="Meiryo"/>
+              </a:rPr>
+              <a:t>学習パイプライン — 2 フェーズ PPO と fast-dev の教訓</a:t>
+            </a:r>
+          </a:p>
+        </p:txBody>
+      </p:sp>
+      <p:sp>
+        <p:nvSpPr>
+          <p:cNvPr id="3" name="TextBox 2"/>
+          <p:cNvSpPr txBox="1"/>
+          <p:nvPr/>
+        </p:nvSpPr>
+        <p:spPr>
+          <a:xfrm>
+            <a:off x="548640" y="1280160"/>
+            <a:ext cx="11064240" cy="5394960"/>
+          </a:xfrm>
+          <a:prstGeom prst="rect">
+            <a:avLst/>
+          </a:prstGeom>
+          <a:noFill/>
+        </p:spPr>
+        <p:txBody>
+          <a:bodyPr wrap="square">
+            <a:spAutoFit/>
+          </a:bodyPr>
+          <a:lstStyle/>
+          <a:p>
+            <a:pPr>
+              <a:spcAft>
+                <a:spcPts val="500"/>
+              </a:spcAft>
+            </a:pPr>
+            <a:r>
+              <a:rPr sz="1700" b="1">
+                <a:solidFill>
+                  <a:srgbClr val="222222"/>
+                </a:solidFill>
+                <a:latin typeface="Meiryo"/>
+              </a:rPr>
+              <a:t>2 フェーズ PPO: ①NPC なしレーン追従 (120k〜1M) → ②NPC あり追い越し FT (lr 減)</a:t>
+            </a:r>
+          </a:p>
+          <a:p>
+            <a:pPr>
+              <a:spcAft>
+                <a:spcPts val="500"/>
+              </a:spcAft>
+            </a:pPr>
+            <a:r>
+              <a:rPr sz="1700" b="0">
+                <a:solidFill>
+                  <a:srgbClr val="222222"/>
+                </a:solidFill>
+                <a:latin typeface="Meiryo"/>
+              </a:rPr>
+              <a:t>カスタム CNN (10ch→512) + 初期スロットルバイアス +0.4 (前進探索)</a:t>
+            </a:r>
+          </a:p>
+          <a:p>
+            <a:pPr>
+              <a:spcAft>
+                <a:spcPts val="500"/>
+              </a:spcAft>
+            </a:pPr>
+            <a:r>
+              <a:rPr sz="1700" b="1">
+                <a:solidFill>
+                  <a:srgbClr val="222222"/>
+                </a:solidFill>
+                <a:latin typeface="Meiryo"/>
+              </a:rPr>
+              <a:t>fast-dev の進化: 65k @ ent 0.10 (曲がれない) → 120k @ ent 0.02 本番ハイパラ (37 周)</a:t>
+            </a:r>
+          </a:p>
+          <a:p>
+            <a:pPr lvl="1">
+              <a:spcAft>
+                <a:spcPts val="500"/>
+              </a:spcAft>
+            </a:pPr>
+            <a:r>
+              <a:rPr sz="1500" b="0">
+                <a:solidFill>
+                  <a:srgbClr val="B32D2D"/>
+                </a:solidFill>
+                <a:latin typeface="Meiryo"/>
+              </a:rPr>
+              <a:t>  教訓: 高エントロピーは [0,1] 圧縮報酬下で「ランダムでいる」ことが得になる</a:t>
+            </a:r>
+          </a:p>
+          <a:p>
+            <a:pPr>
+              <a:spcAft>
+                <a:spcPts val="500"/>
+              </a:spcAft>
+            </a:pPr>
+            <a:r>
+              <a:rPr sz="1700" b="0">
+                <a:solidFill>
+                  <a:srgbClr val="222222"/>
+                </a:solidFill>
+                <a:latin typeface="Meiryo"/>
+              </a:rPr>
+              <a:t>EvalCallback ベストモデル採用 (PPO は終盤退行あり) — best/phase1|phase2/</a:t>
+            </a:r>
+          </a:p>
+          <a:p>
+            <a:pPr>
+              <a:spcAft>
+                <a:spcPts val="500"/>
+              </a:spcAft>
+            </a:pPr>
+            <a:r>
+              <a:rPr sz="1700" b="0">
+                <a:solidFill>
+                  <a:srgbClr val="222222"/>
+                </a:solidFill>
+                <a:latin typeface="Meiryo"/>
+              </a:rPr>
+              <a:t>Reward yardstick: 1 周 ≈ 101, アイドル床 ≈ 0.53/step — eval 値を周回数として読む</a:t>
+            </a:r>
+          </a:p>
+        </p:txBody>
+      </p:sp>
+    </p:spTree>
+  </p:cSld>
+  <p:clrMapOvr>
+    <a:masterClrMapping/>
+  </p:clrMapOvr>
+</p:sld>
+</file>
+
+<file path=ppt/slides/slide16.xml><?xml version="1.0" encoding="utf-8"?>
+<p:sld xmlns:a="http://schemas.openxmlformats.org/drawingml/2006/main" xmlns:p="http://schemas.openxmlformats.org/presentationml/2006/main" xmlns:r="http://schemas.openxmlformats.org/officeDocument/2006/relationships">
+  <p:cSld>
+    <p:spTree>
+      <p:nvGrpSpPr>
+        <p:cNvPr id="1" name=""/>
+        <p:cNvGrpSpPr/>
+        <p:nvPr/>
+      </p:nvGrpSpPr>
+      <p:grpSpPr/>
+      <p:sp>
+        <p:nvSpPr>
+          <p:cNvPr id="2" name="TextBox 1"/>
+          <p:cNvSpPr txBox="1"/>
+          <p:nvPr/>
+        </p:nvSpPr>
+        <p:spPr>
+          <a:xfrm>
+            <a:off x="457200" y="201168"/>
+            <a:ext cx="11247120" cy="777240"/>
+          </a:xfrm>
+          <a:prstGeom prst="rect">
+            <a:avLst/>
+          </a:prstGeom>
+          <a:noFill/>
+        </p:spPr>
+        <p:txBody>
+          <a:bodyPr wrap="none">
+            <a:spAutoFit/>
+          </a:bodyPr>
+          <a:lstStyle/>
+          <a:p>
+            <a:r>
+              <a:rPr sz="2800" b="1">
+                <a:solidFill>
+                  <a:srgbClr val="1B5EA8"/>
+                </a:solidFill>
+                <a:latin typeface="Meiryo"/>
+              </a:rPr>
+              <a:t>PPO ハイパーパラメータの設計判断</a:t>
+            </a:r>
+          </a:p>
+        </p:txBody>
+      </p:sp>
+      <p:sp>
+        <p:nvSpPr>
+          <p:cNvPr id="3" name="TextBox 2"/>
+          <p:cNvSpPr txBox="1"/>
+          <p:nvPr/>
+        </p:nvSpPr>
+        <p:spPr>
+          <a:xfrm>
+            <a:off x="548640" y="1325880"/>
+            <a:ext cx="11064240" cy="5394960"/>
+          </a:xfrm>
+          <a:prstGeom prst="rect">
+            <a:avLst/>
+          </a:prstGeom>
+          <a:noFill/>
+        </p:spPr>
+        <p:txBody>
+          <a:bodyPr wrap="square">
+            <a:spAutoFit/>
+          </a:bodyPr>
+          <a:lstStyle/>
+          <a:p>
+            <a:pPr>
+              <a:spcAft>
+                <a:spcPts val="500"/>
+              </a:spcAft>
+            </a:pPr>
+            <a:r>
+              <a:rPr sz="1700" b="1">
+                <a:solidFill>
+                  <a:srgbClr val="222222"/>
+                </a:solidFill>
+                <a:latin typeface="Meiryo"/>
+              </a:rPr>
+              <a:t>オンポリシー選択: 環境を頻繁に改造 → 古い経験が即無効。sim が軽く wall-clock 優位</a:t>
+            </a:r>
+          </a:p>
+          <a:p>
+            <a:pPr>
+              <a:spcAft>
+                <a:spcPts val="500"/>
+              </a:spcAft>
+            </a:pPr>
+            <a:r>
+              <a:rPr sz="1700" b="0">
+                <a:solidFill>
+                  <a:srgbClr val="222222"/>
+                </a:solidFill>
+                <a:latin typeface="Meiryo"/>
+              </a:rPr>
+              <a:t>clip ε = 0.15 (&lt; 標準 0.2): 高分散アドバンテージ下での方策崩壊を抑制</a:t>
+            </a:r>
+          </a:p>
+          <a:p>
+            <a:pPr>
+              <a:spcAft>
+                <a:spcPts val="500"/>
+              </a:spcAft>
+            </a:pPr>
+            <a:r>
+              <a:rPr sz="1700" b="0">
+                <a:solidFill>
+                  <a:srgbClr val="222222"/>
+                </a:solidFill>
+                <a:latin typeface="Meiryo"/>
+              </a:rPr>
+              <a:t>γ 0.99 / GAE λ 0.98 / n_steps 512 × 8 env / minibatch 256 / 8–15 epochs / linear LR decay</a:t>
+            </a:r>
+          </a:p>
+          <a:p>
+            <a:pPr>
+              <a:spcAft>
+                <a:spcPts val="500"/>
+              </a:spcAft>
+            </a:pPr>
+            <a:r>
+              <a:rPr sz="1700" b="1">
+                <a:solidFill>
+                  <a:srgbClr val="222222"/>
+                </a:solidFill>
+                <a:latin typeface="Meiryo"/>
+              </a:rPr>
+              <a:t>ent_coef は報酬スケールと結合: [0,1] 圧縮下で 0.10 → σ≈1.6 の実質ランダム方策 (実測)</a:t>
+            </a:r>
+          </a:p>
+          <a:p>
+            <a:pPr>
+              <a:spcAft>
+                <a:spcPts val="500"/>
+              </a:spcAft>
+            </a:pPr>
+            <a:r>
+              <a:rPr sz="1700" b="0">
+                <a:solidFill>
+                  <a:srgbClr val="222222"/>
+                </a:solidFill>
+                <a:latin typeface="Meiryo"/>
+              </a:rPr>
+              <a:t>直交初期化 + throttle バイアス +0.4: 探索の対称性を意図的に破り前進を先に発見させる</a:t>
+            </a:r>
+          </a:p>
+          <a:p>
+            <a:pPr>
+              <a:spcAft>
+                <a:spcPts val="500"/>
+              </a:spcAft>
+            </a:pPr>
+            <a:r>
+              <a:rPr sz="1700" b="0">
+                <a:solidFill>
+                  <a:srgbClr val="222222"/>
+                </a:solidFill>
+                <a:latin typeface="Meiryo"/>
+              </a:rPr>
+              <a:t>EvalCallback (決定論的評価) でモデル選択 — 方策エントロピー残存下の stochastic 評価は過小評価</a:t>
+            </a:r>
+          </a:p>
+        </p:txBody>
+      </p:sp>
+    </p:spTree>
+  </p:cSld>
+  <p:clrMapOvr>
+    <a:masterClrMapping/>
+  </p:clrMapOvr>
+</p:sld>
+</file>
+
+<file path=ppt/slides/slide17.xml><?xml version="1.0" encoding="utf-8"?>
+<p:sld xmlns:a="http://schemas.openxmlformats.org/drawingml/2006/main" xmlns:p="http://schemas.openxmlformats.org/presentationml/2006/main" xmlns:r="http://schemas.openxmlformats.org/officeDocument/2006/relationships">
+  <p:cSld>
+    <p:spTree>
+      <p:nvGrpSpPr>
+        <p:cNvPr id="1" name=""/>
+        <p:cNvGrpSpPr/>
+        <p:nvPr/>
+      </p:nvGrpSpPr>
+      <p:grpSpPr/>
+      <p:sp>
+        <p:nvSpPr>
+          <p:cNvPr id="2" name="TextBox 1"/>
+          <p:cNvSpPr txBox="1"/>
+          <p:nvPr/>
+        </p:nvSpPr>
+        <p:spPr>
+          <a:xfrm>
+            <a:off x="457200" y="201168"/>
+            <a:ext cx="11247120" cy="777240"/>
+          </a:xfrm>
+          <a:prstGeom prst="rect">
+            <a:avLst/>
+          </a:prstGeom>
+          <a:noFill/>
+        </p:spPr>
+        <p:txBody>
+          <a:bodyPr wrap="none">
+            <a:spAutoFit/>
+          </a:bodyPr>
+          <a:lstStyle/>
+          <a:p>
+            <a:r>
+              <a:rPr sz="2800" b="1">
+                <a:solidFill>
+                  <a:srgbClr val="1B5EA8"/>
+                </a:solidFill>
+                <a:latin typeface="Meiryo"/>
+              </a:rPr>
+              <a:t>実ゲームとのギャップを埋める C# 支援クラス</a:t>
+            </a:r>
+          </a:p>
+        </p:txBody>
+      </p:sp>
+      <p:pic>
+        <p:nvPicPr>
+          <p:cNvPr id="3" name="Picture 2" descr="smoothing_effect.png"/>
+          <p:cNvPicPr>
+            <a:picLocks noChangeAspect="1"/>
+          </p:cNvPicPr>
+          <p:nvPr/>
+        </p:nvPicPr>
+        <p:blipFill>
+          <a:blip r:embed="rId3"/>
+          <a:stretch>
+            <a:fillRect/>
+          </a:stretch>
+        </p:blipFill>
+        <p:spPr>
+          <a:xfrm>
+            <a:off x="640080" y="1234440"/>
+            <a:ext cx="6035040" cy="2084832"/>
+          </a:xfrm>
+          <a:prstGeom prst="rect">
+            <a:avLst/>
+          </a:prstGeom>
+        </p:spPr>
+      </p:pic>
+      <p:sp>
+        <p:nvSpPr>
+          <p:cNvPr id="4" name="TextBox 3"/>
+          <p:cNvSpPr txBox="1"/>
+          <p:nvPr/>
+        </p:nvSpPr>
+        <p:spPr>
+          <a:xfrm>
+            <a:off x="6858000" y="1371600"/>
+            <a:ext cx="4937760" cy="5394960"/>
+          </a:xfrm>
+          <a:prstGeom prst="rect">
+            <a:avLst/>
+          </a:prstGeom>
+          <a:noFill/>
+        </p:spPr>
+        <p:txBody>
+          <a:bodyPr wrap="square">
+            <a:spAutoFit/>
+          </a:bodyPr>
+          <a:lstStyle/>
+          <a:p>
+            <a:pPr>
+              <a:spcAft>
+                <a:spcPts val="500"/>
+              </a:spcAft>
+            </a:pPr>
+            <a:r>
+              <a:rPr sz="1400" b="1">
+                <a:solidFill>
+                  <a:srgbClr val="222222"/>
+                </a:solidFill>
+                <a:latin typeface="Meiryo"/>
+              </a:rPr>
+              <a:t>SteeringSmoother: EMA α0.6 — 蛇行 34→12 回/100步</a:t>
+            </a:r>
+          </a:p>
+          <a:p>
+            <a:pPr>
+              <a:spcAft>
+                <a:spcPts val="500"/>
+              </a:spcAft>
+            </a:pPr>
+            <a:r>
+              <a:rPr sz="1400" b="1">
+                <a:solidFill>
+                  <a:srgbClr val="222222"/>
+                </a:solidFill>
+                <a:latin typeface="Meiryo"/>
+              </a:rPr>
+              <a:t>CorneringLimiter: ステア速度制限 + 比例ブレーキ</a:t>
+            </a:r>
+          </a:p>
+          <a:p>
+            <a:pPr lvl="1">
+              <a:spcAft>
+                <a:spcPts val="500"/>
+              </a:spcAft>
+            </a:pPr>
+            <a:r>
+              <a:rPr sz="1200" b="0">
+                <a:solidFill>
+                  <a:srgbClr val="595959"/>
+                </a:solidFill>
+                <a:latin typeface="Meiryo"/>
+              </a:rPr>
+              <a:t>  速度床 5 m/s — 減速はしても停止はしない</a:t>
+            </a:r>
+          </a:p>
+          <a:p>
+            <a:pPr>
+              <a:spcAft>
+                <a:spcPts val="500"/>
+              </a:spcAft>
+            </a:pPr>
+            <a:r>
+              <a:rPr sz="1400" b="1">
+                <a:solidFill>
+                  <a:srgbClr val="222222"/>
+                </a:solidFill>
+                <a:latin typeface="Meiryo"/>
+              </a:rPr>
+              <a:t>StuckRecovery: 移動距離でスタック検出→バック指示</a:t>
+            </a:r>
+          </a:p>
+          <a:p>
+            <a:pPr lvl="1">
+              <a:spcAft>
+                <a:spcPts val="500"/>
+              </a:spcAft>
+            </a:pPr>
+            <a:r>
+              <a:rPr sz="1200" b="0">
+                <a:solidFill>
+                  <a:srgbClr val="595959"/>
+                </a:solidFill>
+                <a:latin typeface="Meiryo"/>
+              </a:rPr>
+              <a:t>  発進の低速と壁刺さりを距離で区別 (レーン不要)</a:t>
+            </a:r>
+          </a:p>
+          <a:p>
+            <a:pPr>
+              <a:spcAft>
+                <a:spcPts val="500"/>
+              </a:spcAft>
+            </a:pPr>
+            <a:r>
+              <a:rPr sz="1400" b="1">
+                <a:solidFill>
+                  <a:srgbClr val="222222"/>
+                </a:solidFill>
+                <a:latin typeface="Meiryo"/>
+              </a:rPr>
+              <a:t>CarController: 学習と同一物理 (Python と 1e-7 一致)</a:t>
+            </a:r>
+          </a:p>
+        </p:txBody>
+      </p:sp>
+    </p:spTree>
+  </p:cSld>
+  <p:clrMapOvr>
+    <a:masterClrMapping/>
+  </p:clrMapOvr>
+</p:sld>
+</file>
+
+<file path=ppt/slides/slide18.xml><?xml version="1.0" encoding="utf-8"?>
+<p:sld xmlns:a="http://schemas.openxmlformats.org/drawingml/2006/main" xmlns:p="http://schemas.openxmlformats.org/presentationml/2006/main" xmlns:r="http://schemas.openxmlformats.org/officeDocument/2006/relationships">
+  <p:cSld>
+    <p:spTree>
+      <p:nvGrpSpPr>
+        <p:cNvPr id="1" name=""/>
+        <p:cNvGrpSpPr/>
+        <p:nvPr/>
+      </p:nvGrpSpPr>
+      <p:grpSpPr/>
+      <p:sp>
+        <p:nvSpPr>
+          <p:cNvPr id="2" name="TextBox 1"/>
+          <p:cNvSpPr txBox="1"/>
+          <p:nvPr/>
+        </p:nvSpPr>
+        <p:spPr>
+          <a:xfrm>
+            <a:off x="457200" y="201168"/>
+            <a:ext cx="11247120" cy="777240"/>
+          </a:xfrm>
+          <a:prstGeom prst="rect">
+            <a:avLst/>
+          </a:prstGeom>
+          <a:noFill/>
+        </p:spPr>
+        <p:txBody>
+          <a:bodyPr wrap="none">
+            <a:spAutoFit/>
+          </a:bodyPr>
+          <a:lstStyle/>
+          <a:p>
+            <a:r>
+              <a:rPr sz="2800" b="1">
+                <a:solidFill>
+                  <a:srgbClr val="1B5EA8"/>
+                </a:solidFill>
+                <a:latin typeface="Meiryo"/>
+              </a:rPr>
+              <a:t>汎化・sim-to-real の設計 — 何が転移を担保するか</a:t>
+            </a:r>
+          </a:p>
+        </p:txBody>
+      </p:sp>
+      <p:sp>
+        <p:nvSpPr>
+          <p:cNvPr id="3" name="TextBox 2"/>
+          <p:cNvSpPr txBox="1"/>
+          <p:nvPr/>
+        </p:nvSpPr>
+        <p:spPr>
+          <a:xfrm>
+            <a:off x="548640" y="1325880"/>
+            <a:ext cx="11064240" cy="5394960"/>
+          </a:xfrm>
+          <a:prstGeom prst="rect">
+            <a:avLst/>
+          </a:prstGeom>
+          <a:noFill/>
+        </p:spPr>
+        <p:txBody>
+          <a:bodyPr wrap="square">
+            <a:spAutoFit/>
+          </a:bodyPr>
+          <a:lstStyle/>
+          <a:p>
+            <a:pPr>
+              <a:spcAft>
+                <a:spcPts val="500"/>
+              </a:spcAft>
+            </a:pPr>
+            <a:r>
+              <a:rPr sz="1700" b="1">
+                <a:solidFill>
+                  <a:srgbClr val="222222"/>
+                </a:solidFill>
+                <a:latin typeface="Meiryo"/>
+              </a:rPr>
+              <a:t>トラックランダム化 = ドメインランダマイゼーション — 暗記解を分布レベルで排除</a:t>
+            </a:r>
+          </a:p>
+          <a:p>
+            <a:pPr>
+              <a:spcAft>
+                <a:spcPts val="500"/>
+              </a:spcAft>
+            </a:pPr>
+            <a:r>
+              <a:rPr sz="1700" b="1">
+                <a:solidFill>
+                  <a:srgbClr val="222222"/>
+                </a:solidFill>
+                <a:latin typeface="Meiryo"/>
+              </a:rPr>
+              <a:t>より本質: エゴセントリック観測 + 自己座標なし → 平行移動・回転不変な方策クラスに制約</a:t>
+            </a:r>
+          </a:p>
+          <a:p>
+            <a:pPr>
+              <a:spcAft>
+                <a:spcPts val="500"/>
+              </a:spcAft>
+            </a:pPr>
+            <a:r>
+              <a:rPr sz="1700" b="0">
+                <a:solidFill>
+                  <a:srgbClr val="222222"/>
+                </a:solidFill>
+                <a:latin typeface="Meiryo"/>
+              </a:rPr>
+              <a:t>ゼロショット転移 (fast→他4コース) はこの不変性の帰結 — 検証済み</a:t>
+            </a:r>
+          </a:p>
+          <a:p>
+            <a:pPr>
+              <a:spcAft>
+                <a:spcPts val="500"/>
+              </a:spcAft>
+            </a:pPr>
+            <a:r>
+              <a:rPr sz="1700" b="1">
+                <a:solidFill>
+                  <a:srgbClr val="222222"/>
+                </a:solidFill>
+                <a:latin typeface="Meiryo"/>
+              </a:rPr>
+              <a:t>sim-to-real 層 1: 観測ビット一致・物理 1e-7 一致の移植でギャップ自体を消す</a:t>
+            </a:r>
+          </a:p>
+          <a:p>
+            <a:pPr>
+              <a:spcAft>
+                <a:spcPts val="500"/>
+              </a:spcAft>
+            </a:pPr>
+            <a:r>
+              <a:rPr sz="1700" b="0">
+                <a:solidFill>
+                  <a:srgbClr val="222222"/>
+                </a:solidFill>
+                <a:latin typeface="Meiryo"/>
+              </a:rPr>
+              <a:t>層 2: 残差はデプロイ側アクションフィルタで吸収 (平滑化/レート制限/旋回ブレーキ)</a:t>
+            </a:r>
+          </a:p>
+          <a:p>
+            <a:pPr lvl="1">
+              <a:spcAft>
+                <a:spcPts val="500"/>
+              </a:spcAft>
+            </a:pPr>
+            <a:r>
+              <a:rPr sz="1500" b="0">
+                <a:solidFill>
+                  <a:srgbClr val="595959"/>
+                </a:solidFill>
+                <a:latin typeface="Meiryo"/>
+              </a:rPr>
+              <a:t>  フィルタは閉ループを変える → sim 内で同フィルタ通し評価し周回数維持を確認</a:t>
+            </a:r>
+          </a:p>
+        </p:txBody>
+      </p:sp>
+    </p:spTree>
+  </p:cSld>
+  <p:clrMapOvr>
+    <a:masterClrMapping/>
+  </p:clrMapOvr>
+</p:sld>
+</file>
+
+<file path=ppt/slides/slide19.xml><?xml version="1.0" encoding="utf-8"?>
+<p:sld xmlns:a="http://schemas.openxmlformats.org/drawingml/2006/main" xmlns:p="http://schemas.openxmlformats.org/presentationml/2006/main" xmlns:r="http://schemas.openxmlformats.org/officeDocument/2006/relationships">
+  <p:cSld>
+    <p:spTree>
+      <p:nvGrpSpPr>
+        <p:cNvPr id="1" name=""/>
+        <p:cNvGrpSpPr/>
+        <p:nvPr/>
+      </p:nvGrpSpPr>
+      <p:grpSpPr/>
+      <p:sp>
+        <p:nvSpPr>
+          <p:cNvPr id="2" name="TextBox 1"/>
+          <p:cNvSpPr txBox="1"/>
+          <p:nvPr/>
+        </p:nvSpPr>
+        <p:spPr>
+          <a:xfrm>
+            <a:off x="457200" y="201168"/>
+            <a:ext cx="11247120" cy="777240"/>
+          </a:xfrm>
+          <a:prstGeom prst="rect">
+            <a:avLst/>
+          </a:prstGeom>
+          <a:noFill/>
+        </p:spPr>
+        <p:txBody>
+          <a:bodyPr wrap="none">
+            <a:spAutoFit/>
+          </a:bodyPr>
+          <a:lstStyle/>
+          <a:p>
+            <a:r>
+              <a:rPr sz="2800" b="1">
+                <a:solidFill>
+                  <a:srgbClr val="1B5EA8"/>
+                </a:solidFill>
+                <a:latin typeface="Meiryo"/>
+              </a:rPr>
+              <a:t>セットアップとノートブックの使い方</a:t>
+            </a:r>
+          </a:p>
+        </p:txBody>
+      </p:sp>
+      <p:sp>
+        <p:nvSpPr>
+          <p:cNvPr id="3" name="TextBox 2"/>
+          <p:cNvSpPr txBox="1"/>
+          <p:nvPr/>
+        </p:nvSpPr>
+        <p:spPr>
+          <a:xfrm>
+            <a:off x="548640" y="1325880"/>
+            <a:ext cx="11064240" cy="5394960"/>
+          </a:xfrm>
+          <a:prstGeom prst="rect">
+            <a:avLst/>
+          </a:prstGeom>
+          <a:noFill/>
+        </p:spPr>
+        <p:txBody>
+          <a:bodyPr wrap="square">
+            <a:spAutoFit/>
+          </a:bodyPr>
+          <a:lstStyle/>
+          <a:p>
+            <a:pPr>
+              <a:spcAft>
+                <a:spcPts val="500"/>
+              </a:spcAft>
+            </a:pPr>
+            <a:r>
+              <a:rPr sz="1700" b="1">
+                <a:solidFill>
+                  <a:srgbClr val="222222"/>
+                </a:solidFill>
+                <a:latin typeface="Meiryo"/>
+              </a:rPr>
+              <a:t>pip install "highway-env&gt;=1.8" "stable-baselines3[extra]&gt;=2.0" gymnasium torch tensorboard moviepy onnx onnxruntime</a:t>
+            </a:r>
+          </a:p>
+          <a:p>
+            <a:pPr lvl="1">
+              <a:spcAft>
+                <a:spcPts val="500"/>
+              </a:spcAft>
+            </a:pPr>
+            <a:r>
+              <a:rPr sz="1500" b="0">
+                <a:solidFill>
+                  <a:srgbClr val="B32D2D"/>
+                </a:solidFill>
+                <a:latin typeface="Meiryo"/>
+              </a:rPr>
+              <a:t>(リポジトリの requirements.txt は旧スタック用 — 使わない)</a:t>
+            </a:r>
+          </a:p>
+          <a:p>
+            <a:pPr>
+              <a:spcAft>
+                <a:spcPts val="500"/>
+              </a:spcAft>
+            </a:pPr>
+            <a:r>
+              <a:rPr sz="1700" b="0">
+                <a:solidFill>
+                  <a:srgbClr val="222222"/>
+                </a:solidFill>
+                <a:latin typeface="Meiryo"/>
+              </a:rPr>
+              <a:t>task2_laning_overtaking_sb3_ppo.ipynb — fast トラック学習</a:t>
+            </a:r>
+          </a:p>
+          <a:p>
+            <a:pPr>
+              <a:spcAft>
+                <a:spcPts val="500"/>
+              </a:spcAft>
+            </a:pPr>
+            <a:r>
+              <a:rPr sz="1700" b="0">
+                <a:solidFill>
+                  <a:srgbClr val="222222"/>
+                </a:solidFill>
+                <a:latin typeface="Meiryo"/>
+              </a:rPr>
+              <a:t>task3_generalization_sb3_ppo.ipynb — random 学習 + トラック別レポート + 5 連動画</a:t>
+            </a:r>
+          </a:p>
+          <a:p>
+            <a:pPr>
+              <a:spcAft>
+                <a:spcPts val="500"/>
+              </a:spcAft>
+            </a:pPr>
+            <a:r>
+              <a:rPr sz="1700" b="1">
+                <a:solidFill>
+                  <a:srgbClr val="222222"/>
+                </a:solidFill>
+                <a:latin typeface="Meiryo"/>
+              </a:rPr>
+              <a:t>FAST_DEV_RUN=True: 12-15 万ステップ (周回到達を実測保証) / False: 本番 100 万+</a:t>
+            </a:r>
+          </a:p>
+          <a:p>
+            <a:pPr>
+              <a:spcAft>
+                <a:spcPts val="500"/>
+              </a:spcAft>
+            </a:pPr>
+            <a:r>
+              <a:rPr sz="1700" b="1">
+                <a:solidFill>
+                  <a:srgbClr val="222222"/>
+                </a:solidFill>
+                <a:latin typeface="Meiryo"/>
+              </a:rPr>
+              <a:t>Presentation Media セル: 学習曲線・軌跡・5 トラック動画を生成し VIDEO_DIR に保存</a:t>
+            </a:r>
+          </a:p>
+          <a:p>
+            <a:pPr>
+              <a:spcAft>
+                <a:spcPts val="500"/>
+              </a:spcAft>
+            </a:pPr>
+            <a:r>
+              <a:rPr sz="1700" b="0">
+                <a:solidFill>
+                  <a:srgbClr val="222222"/>
+                </a:solidFill>
+                <a:latin typeface="Meiryo"/>
+              </a:rPr>
+              <a:t>検証: cd re_engine/verify &amp;&amp; dotnet run -- ..  → ALL SCENARIOS MATCH</a:t>
             </a:r>
           </a:p>
         </p:txBody>
@@ -4658,8 +6657,8 @@
         </p:nvSpPr>
         <p:spPr>
           <a:xfrm>
-            <a:off x="457200" y="228600"/>
-            <a:ext cx="11247120" cy="822960"/>
+            <a:off x="457200" y="201168"/>
+            <a:ext cx="11247120" cy="777240"/>
           </a:xfrm>
           <a:prstGeom prst="rect">
             <a:avLst/>
@@ -4673,27 +6672,124 @@
           <a:lstStyle/>
           <a:p>
             <a:r>
-              <a:rPr sz="3000" b="1">
+              <a:rPr sz="2800" b="1">
                 <a:solidFill>
                   <a:srgbClr val="1B5EA8"/>
                 </a:solidFill>
                 <a:latin typeface="Meiryo"/>
               </a:rPr>
-              <a:t>結果ハイライト</a:t>
-            </a:r>
-          </a:p>
-        </p:txBody>
-      </p:sp>
-      <p:sp>
-        <p:nvSpPr>
-          <p:cNvPr id="3" name="TextBox 2"/>
+              <a:t>まず結果から — 1 つの方策で 5 トラック同時走行</a:t>
+            </a:r>
+          </a:p>
+        </p:txBody>
+      </p:sp>
+      <p:pic>
+        <p:nvPicPr>
+          <p:cNvPr id="3" name="Picture 2" descr="gen_tracks_grid.png"/>
+          <p:cNvPicPr>
+            <a:picLocks noChangeAspect="1"/>
+          </p:cNvPicPr>
+          <p:nvPr/>
+        </p:nvPicPr>
+        <p:blipFill>
+          <a:blip r:embed="rId3"/>
+          <a:stretch>
+            <a:fillRect/>
+          </a:stretch>
+        </p:blipFill>
+        <p:spPr>
+          <a:xfrm>
+            <a:off x="411480" y="1143000"/>
+            <a:ext cx="11338560" cy="2789689"/>
+          </a:xfrm>
+          <a:prstGeom prst="rect">
+            <a:avLst/>
+          </a:prstGeom>
+        </p:spPr>
+      </p:pic>
+      <p:pic>
+        <p:nvPicPr>
+          <p:cNvPr id="4" name="gen_all_tracks.mp4">
+            <a:hlinkClick r:id="" action="ppaction://media"/>
+          </p:cNvPr>
+          <p:cNvPicPr>
+            <a:picLocks noChangeAspect="1"/>
+          </p:cNvPicPr>
+          <p:nvPr>
+            <a:videoFile r:link="rId5"/>
+            <p:extLst>
+              <p:ext uri="{DAA4B4D4-6D71-4841-9C94-3DE7FCFB9230}">
+                <p14:media xmlns:p14="http://schemas.microsoft.com/office/powerpoint/2010/main" r:embed="rId4"/>
+              </p:ext>
+            </p:extLst>
+          </p:nvPr>
+        </p:nvPicPr>
+        <p:blipFill>
+          <a:blip r:embed="rId3"/>
+          <a:stretch>
+            <a:fillRect/>
+          </a:stretch>
+        </p:blipFill>
+        <p:spPr>
+          <a:xfrm>
+            <a:off x="2651760" y="3977639"/>
+            <a:ext cx="6858000" cy="2057400"/>
+          </a:xfrm>
+          <a:prstGeom prst="rect">
+            <a:avLst/>
+          </a:prstGeom>
+        </p:spPr>
+      </p:pic>
+    </p:spTree>
+  </p:cSld>
+  <p:clrMapOvr>
+    <a:masterClrMapping/>
+  </p:clrMapOvr>
+  <p:timing>
+    <p:tnLst>
+      <p:par>
+        <p:cTn id="1" dur="indefinite" restart="never" nodeType="tmRoot">
+          <p:childTnLst>
+            <p:video>
+              <p:cMediaNode vol="80000">
+                <p:cTn id="2" fill="hold" display="0">
+                  <p:stCondLst>
+                    <p:cond delay="indefinite"/>
+                  </p:stCondLst>
+                </p:cTn>
+                <p:tgtEl>
+                  <p:spTgt spid="4"/>
+                </p:tgtEl>
+              </p:cMediaNode>
+            </p:video>
+          </p:childTnLst>
+        </p:cTn>
+      </p:par>
+    </p:tnLst>
+  </p:timing>
+</p:sld>
+</file>
+
+<file path=ppt/slides/slide20.xml><?xml version="1.0" encoding="utf-8"?>
+<p:sld xmlns:a="http://schemas.openxmlformats.org/drawingml/2006/main" xmlns:p="http://schemas.openxmlformats.org/presentationml/2006/main" xmlns:r="http://schemas.openxmlformats.org/officeDocument/2006/relationships">
+  <p:cSld>
+    <p:spTree>
+      <p:nvGrpSpPr>
+        <p:cNvPr id="1" name=""/>
+        <p:cNvGrpSpPr/>
+        <p:nvPr/>
+      </p:nvGrpSpPr>
+      <p:grpSpPr/>
+      <p:sp>
+        <p:nvSpPr>
+          <p:cNvPr id="2" name="TextBox 1"/>
           <p:cNvSpPr txBox="1"/>
           <p:nvPr/>
         </p:nvSpPr>
         <p:spPr>
           <a:xfrm>
-            <a:off x="548640" y="1371600"/>
-            <a:ext cx="11064240" cy="5120640"/>
+            <a:off x="457200" y="201168"/>
+            <a:ext cx="11247120" cy="777240"/>
           </a:xfrm>
           <a:prstGeom prst="rect">
             <a:avLst/>
@@ -4701,6 +6797,40 @@
           <a:noFill/>
         </p:spPr>
         <p:txBody>
+          <a:bodyPr wrap="none">
+            <a:spAutoFit/>
+          </a:bodyPr>
+          <a:lstStyle/>
+          <a:p>
+            <a:r>
+              <a:rPr sz="2800" b="1">
+                <a:solidFill>
+                  <a:srgbClr val="1B5EA8"/>
+                </a:solidFill>
+                <a:latin typeface="Meiryo"/>
+              </a:rPr>
+              <a:t>エクスポートツールと ONNX の注意点</a:t>
+            </a:r>
+          </a:p>
+        </p:txBody>
+      </p:sp>
+      <p:sp>
+        <p:nvSpPr>
+          <p:cNvPr id="3" name="TextBox 2"/>
+          <p:cNvSpPr txBox="1"/>
+          <p:nvPr/>
+        </p:nvSpPr>
+        <p:spPr>
+          <a:xfrm>
+            <a:off x="548640" y="1325880"/>
+            <a:ext cx="11064240" cy="5394960"/>
+          </a:xfrm>
+          <a:prstGeom prst="rect">
+            <a:avLst/>
+          </a:prstGeom>
+          <a:noFill/>
+        </p:spPr>
+        <p:txBody>
           <a:bodyPr wrap="square">
             <a:spAutoFit/>
           </a:bodyPr>
@@ -4708,97 +6838,284 @@
           <a:p>
             <a:pPr>
               <a:spcAft>
-                <a:spcPts val="600"/>
+                <a:spcPts val="500"/>
               </a:spcAft>
             </a:pPr>
             <a:r>
-              <a:rPr sz="2000" b="1">
+              <a:rPr sz="1700" b="1">
                 <a:solidFill>
                   <a:srgbClr val="222222"/>
                 </a:solidFill>
                 <a:latin typeface="Meiryo"/>
               </a:rPr>
-              <a:t>37 周 / 800 秒エピソード・16 m/s (制限速度) で無衝突 — fast トラック</a:t>
+              <a:t>python export_onnx.py &lt;model.zip&gt; -m 3   # エンジン用 NHWC [1,12,12,10] (推奨)</a:t>
+            </a:r>
+          </a:p>
+          <a:p>
+            <a:pPr lvl="1">
+              <a:spcAft>
+                <a:spcPts val="500"/>
+              </a:spcAft>
+            </a:pPr>
+            <a:r>
+              <a:rPr sz="1500" b="0">
+                <a:solidFill>
+                  <a:srgbClr val="595959"/>
+                </a:solidFill>
+                <a:latin typeface="Meiryo"/>
+              </a:rPr>
+              <a:t>  -m 1: full policy / 2: actor CHW / 3: actor NHWC / 0: 全部 — 各エクスポートは torch と自動照合</a:t>
             </a:r>
           </a:p>
           <a:p>
             <a:pPr>
               <a:spcAft>
-                <a:spcPts val="600"/>
+                <a:spcPts val="500"/>
               </a:spcAft>
             </a:pPr>
             <a:r>
-              <a:rPr sz="2000" b="0">
+              <a:rPr sz="1700" b="0">
                 <a:solidFill>
                   <a:srgbClr val="222222"/>
                 </a:solidFill>
                 <a:latin typeface="Meiryo"/>
               </a:rPr>
-              <a:t>周回能力は 3〜6 万ステップで獲得 (実測) — fast-dev (12万) でも確実に周回</a:t>
+              <a:t>python re_engine/convert_onnx_nhwc.py &lt;actor.onnx&gt;   # 既存 CHW を NHWC 化</a:t>
             </a:r>
           </a:p>
           <a:p>
             <a:pPr>
               <a:spcAft>
-                <a:spcPts val="600"/>
+                <a:spcPts val="500"/>
               </a:spcAft>
             </a:pPr>
             <a:r>
-              <a:rPr sz="2000" b="1">
+              <a:rPr sz="1700" b="0">
                 <a:solidFill>
                   <a:srgbClr val="222222"/>
                 </a:solidFill>
                 <a:latin typeface="Meiryo"/>
               </a:rPr>
-              <a:t>汎化モデル: 1 つの方策で 5 トラックすべてを 2 分間ノーミス走行</a:t>
+              <a:t>python re_engine/export_track_json.py   # トラック/観測変更後に参照データ再生成</a:t>
             </a:r>
           </a:p>
           <a:p>
             <a:pPr>
               <a:spcAft>
-                <a:spcPts val="600"/>
+                <a:spcPts val="500"/>
               </a:spcAft>
             </a:pPr>
             <a:r>
-              <a:rPr sz="2000" b="0">
-                <a:solidFill>
-                  <a:srgbClr val="222222"/>
-                </a:solidFill>
-                <a:latin typeface="Meiryo"/>
-              </a:rPr>
-              <a:t>ゼロショット転移: fast のみで学習した方策が他 4 トラックも制限速度で走行</a:t>
+              <a:rPr sz="1700" b="1">
+                <a:solidFill>
+                  <a:srgbClr val="B32D2D"/>
+                </a:solidFill>
+                <a:latin typeface="Meiryo"/>
+              </a:rPr>
+              <a:t>症状で覚える: 出力がほぼ一定 (throttle≈0.4, steer≈0.2) = レイアウト不一致</a:t>
             </a:r>
           </a:p>
           <a:p>
             <a:pPr>
               <a:spcAft>
-                <a:spcPts val="600"/>
+                <a:spcPts val="500"/>
               </a:spcAft>
             </a:pPr>
             <a:r>
-              <a:rPr sz="2000" b="1">
+              <a:rPr sz="1700" b="0">
                 <a:solidFill>
                   <a:srgbClr val="222222"/>
                 </a:solidFill>
                 <a:latin typeface="Meiryo"/>
               </a:rPr>
-              <a:t>C# 観測ポート: Python とビット一致 (maxDiff = 0.0) を検証ハーネスで保証</a:t>
+              <a:t>定数同期: accel/steer レンジ・5 Hz・グリッド設定は C# に複製 — 変更時は 4 点セット</a:t>
             </a:r>
           </a:p>
           <a:p>
             <a:pPr>
               <a:spcAft>
-                <a:spcPts val="600"/>
+                <a:spcPts val="500"/>
               </a:spcAft>
             </a:pPr>
             <a:r>
-              <a:rPr sz="2000" b="0">
+              <a:rPr sz="1700" b="0">
                 <a:solidFill>
                   <a:srgbClr val="222222"/>
                 </a:solidFill>
                 <a:latin typeface="Meiryo"/>
               </a:rPr>
-              <a:t>ONNX 3 種 (full / actor CHW / actor NHWC) をエクスポート、エンジンは NHWC を使用</a:t>
+              <a:t>単位は全て m/s・m・rad。km/h の Vector3 は KphToMs で変換 (kph 直入れは無警告で劣化)</a:t>
+            </a:r>
+          </a:p>
+        </p:txBody>
+      </p:sp>
+    </p:spTree>
+  </p:cSld>
+  <p:clrMapOvr>
+    <a:masterClrMapping/>
+  </p:clrMapOvr>
+</p:sld>
+</file>
+
+<file path=ppt/slides/slide21.xml><?xml version="1.0" encoding="utf-8"?>
+<p:sld xmlns:a="http://schemas.openxmlformats.org/drawingml/2006/main" xmlns:p="http://schemas.openxmlformats.org/presentationml/2006/main" xmlns:r="http://schemas.openxmlformats.org/officeDocument/2006/relationships">
+  <p:cSld>
+    <p:spTree>
+      <p:nvGrpSpPr>
+        <p:cNvPr id="1" name=""/>
+        <p:cNvGrpSpPr/>
+        <p:nvPr/>
+      </p:nvGrpSpPr>
+      <p:grpSpPr/>
+      <p:sp>
+        <p:nvSpPr>
+          <p:cNvPr id="2" name="TextBox 1"/>
+          <p:cNvSpPr txBox="1"/>
+          <p:nvPr/>
+        </p:nvSpPr>
+        <p:spPr>
+          <a:xfrm>
+            <a:off x="457200" y="201168"/>
+            <a:ext cx="11247120" cy="777240"/>
+          </a:xfrm>
+          <a:prstGeom prst="rect">
+            <a:avLst/>
+          </a:prstGeom>
+          <a:noFill/>
+        </p:spPr>
+        <p:txBody>
+          <a:bodyPr wrap="none">
+            <a:spAutoFit/>
+          </a:bodyPr>
+          <a:lstStyle/>
+          <a:p>
+            <a:r>
+              <a:rPr sz="2800" b="1">
+                <a:solidFill>
+                  <a:srgbClr val="1B5EA8"/>
+                </a:solidFill>
+                <a:latin typeface="Meiryo"/>
+              </a:rPr>
+              <a:t>まとめ — 環境設計こそが学習を決める</a:t>
+            </a:r>
+          </a:p>
+        </p:txBody>
+      </p:sp>
+      <p:sp>
+        <p:nvSpPr>
+          <p:cNvPr id="3" name="TextBox 2"/>
+          <p:cNvSpPr txBox="1"/>
+          <p:nvPr/>
+        </p:nvSpPr>
+        <p:spPr>
+          <a:xfrm>
+            <a:off x="548640" y="1417320"/>
+            <a:ext cx="11064240" cy="5394960"/>
+          </a:xfrm>
+          <a:prstGeom prst="rect">
+            <a:avLst/>
+          </a:prstGeom>
+          <a:noFill/>
+        </p:spPr>
+        <p:txBody>
+          <a:bodyPr wrap="square">
+            <a:spAutoFit/>
+          </a:bodyPr>
+          <a:lstStyle/>
+          <a:p>
+            <a:pPr>
+              <a:spcAft>
+                <a:spcPts val="500"/>
+              </a:spcAft>
+            </a:pPr>
+            <a:r>
+              <a:rPr sz="1900" b="1">
+                <a:solidFill>
+                  <a:srgbClr val="222222"/>
+                </a:solidFill>
+                <a:latin typeface="Meiryo"/>
+              </a:rPr>
+              <a:t>デフォルト racetrack → ゲーム環境へ: 行動・壁・報酬・観測・トラックを段階的に進化</a:t>
+            </a:r>
+          </a:p>
+          <a:p>
+            <a:pPr>
+              <a:spcAft>
+                <a:spcPts val="500"/>
+              </a:spcAft>
+            </a:pPr>
+            <a:r>
+              <a:rPr sz="1900" b="1">
+                <a:solidFill>
+                  <a:srgbClr val="222222"/>
+                </a:solidFill>
+                <a:latin typeface="Meiryo"/>
+              </a:rPr>
+              <a:t>抜け道 (ショートカット / wall-riding / 壁這い) を報酬の経済設計で排除 → 6 万ステップで周回</a:t>
+            </a:r>
+          </a:p>
+          <a:p>
+            <a:pPr>
+              <a:spcAft>
+                <a:spcPts val="500"/>
+              </a:spcAft>
+            </a:pPr>
+            <a:r>
+              <a:rPr sz="1900" b="1">
+                <a:solidFill>
+                  <a:srgbClr val="222222"/>
+                </a:solidFill>
+                <a:latin typeface="Meiryo"/>
+              </a:rPr>
+              <a:t>自己位置を観測に入れない設計が 5 コース汎化を生んだ</a:t>
+            </a:r>
+          </a:p>
+          <a:p>
+            <a:pPr>
+              <a:spcAft>
+                <a:spcPts val="500"/>
+              </a:spcAft>
+            </a:pPr>
+            <a:r>
+              <a:rPr sz="1900" b="0">
+                <a:solidFill>
+                  <a:srgbClr val="222222"/>
+                </a:solidFill>
+                <a:latin typeface="Meiryo"/>
+              </a:rPr>
+              <a:t>C# ポートは観測ビット一致 + 物理 1e-7 一致 — 「動くはず」ではなく「同じ」</a:t>
+            </a:r>
+          </a:p>
+          <a:p>
+            <a:pPr>
+              <a:spcAft>
+                <a:spcPts val="500"/>
+              </a:spcAft>
+            </a:pPr>
+            <a:r>
+              <a:rPr sz="1900" b="0">
+                <a:solidFill>
+                  <a:srgbClr val="222222"/>
+                </a:solidFill>
+                <a:latin typeface="Meiryo"/>
+              </a:rPr>
+              <a:t>媒体生成コードはすべてノートブック内 (Presentation Media セル) — 本スライドは再現可能</a:t>
+            </a:r>
+          </a:p>
+          <a:p>
+            <a:pPr>
+              <a:spcAft>
+                <a:spcPts val="500"/>
+              </a:spcAft>
+            </a:pPr>
+            <a:r>
+              <a:rPr sz="1900" b="0">
+                <a:solidFill>
+                  <a:srgbClr val="222222"/>
+                </a:solidFill>
+                <a:latin typeface="Meiryo"/>
+              </a:rPr>
+              <a:t>次のステップ: RE Engine 実走検証・実車ダイナミクス適合・NPC レース</a:t>
             </a:r>
           </a:p>
         </p:txBody>
@@ -4829,8 +7146,8 @@
         </p:nvSpPr>
         <p:spPr>
           <a:xfrm>
-            <a:off x="457200" y="228600"/>
-            <a:ext cx="11247120" cy="822960"/>
+            <a:off x="457200" y="201168"/>
+            <a:ext cx="11247120" cy="777240"/>
           </a:xfrm>
           <a:prstGeom prst="rect">
             <a:avLst/>
@@ -4844,13 +7161,13 @@
           <a:lstStyle/>
           <a:p>
             <a:r>
-              <a:rPr sz="3000" b="1">
+              <a:rPr sz="2800" b="1">
                 <a:solidFill>
                   <a:srgbClr val="1B5EA8"/>
                 </a:solidFill>
                 <a:latin typeface="Meiryo"/>
               </a:rPr>
-              <a:t>学習曲線 — 周回数 vs 学習ステップ</a:t>
+              <a:t>学習曲線 — 周回能力は 3〜6 万ステップで立ち上がる</a:t>
             </a:r>
           </a:p>
         </p:txBody>
@@ -4871,8 +7188,8 @@
         </p:blipFill>
         <p:spPr>
           <a:xfrm>
-            <a:off x="2377440" y="1234440"/>
-            <a:ext cx="7498079" cy="4198924"/>
+            <a:off x="2468880" y="1234440"/>
+            <a:ext cx="7315200" cy="4096512"/>
           </a:xfrm>
           <a:prstGeom prst="rect">
             <a:avLst/>
@@ -4905,8 +7222,8 @@
         </p:nvSpPr>
         <p:spPr>
           <a:xfrm>
-            <a:off x="457200" y="228600"/>
-            <a:ext cx="11247120" cy="822960"/>
+            <a:off x="457200" y="201168"/>
+            <a:ext cx="11247120" cy="777240"/>
           </a:xfrm>
           <a:prstGeom prst="rect">
             <a:avLst/>
@@ -4920,13 +7237,13 @@
           <a:lstStyle/>
           <a:p>
             <a:r>
-              <a:rPr sz="3000" b="1">
+              <a:rPr sz="2800" b="1">
                 <a:solidFill>
                   <a:srgbClr val="1B5EA8"/>
                 </a:solidFill>
                 <a:latin typeface="Meiryo"/>
               </a:rPr>
-              <a:t>走行軌跡 — fast トラック (fast-dev モデル)</a:t>
+              <a:t>走行軌跡 — 減速と立ち上がりの質</a:t>
             </a:r>
           </a:p>
         </p:txBody>
@@ -4981,8 +7298,8 @@
         </p:nvSpPr>
         <p:spPr>
           <a:xfrm>
-            <a:off x="457200" y="228600"/>
-            <a:ext cx="11247120" cy="822960"/>
+            <a:off x="457200" y="201168"/>
+            <a:ext cx="11247120" cy="777240"/>
           </a:xfrm>
           <a:prstGeom prst="rect">
             <a:avLst/>
@@ -4996,101 +7313,141 @@
           <a:lstStyle/>
           <a:p>
             <a:r>
-              <a:rPr sz="3000" b="1">
+              <a:rPr sz="2800" b="1">
                 <a:solidFill>
                   <a:srgbClr val="1B5EA8"/>
                 </a:solidFill>
                 <a:latin typeface="Meiryo"/>
               </a:rPr>
-              <a:t>汎化モデル — 1 つの方策で 5 トラック</a:t>
-            </a:r>
-          </a:p>
-        </p:txBody>
-      </p:sp>
-      <p:pic>
-        <p:nvPicPr>
-          <p:cNvPr id="3" name="Picture 2" descr="gen_tracks_grid.png"/>
-          <p:cNvPicPr>
-            <a:picLocks noChangeAspect="1"/>
-          </p:cNvPicPr>
+              <a:t>結果サマリ (すべて実測値)</a:t>
+            </a:r>
+          </a:p>
+        </p:txBody>
+      </p:sp>
+      <p:sp>
+        <p:nvSpPr>
+          <p:cNvPr id="3" name="TextBox 2"/>
+          <p:cNvSpPr txBox="1"/>
           <p:nvPr/>
-        </p:nvPicPr>
-        <p:blipFill>
-          <a:blip r:embed="rId3"/>
-          <a:stretch>
-            <a:fillRect/>
-          </a:stretch>
-        </p:blipFill>
+        </p:nvSpPr>
         <p:spPr>
           <a:xfrm>
-            <a:off x="411480" y="1371600"/>
-            <a:ext cx="11338560" cy="2789689"/>
+            <a:off x="548640" y="1325880"/>
+            <a:ext cx="11064240" cy="5394960"/>
           </a:xfrm>
           <a:prstGeom prst="rect">
             <a:avLst/>
           </a:prstGeom>
+          <a:noFill/>
         </p:spPr>
-      </p:pic>
-      <p:pic>
-        <p:nvPicPr>
-          <p:cNvPr id="4" name="gen_all_tracks.mp4">
-            <a:hlinkClick r:id="" action="ppaction://media"/>
-          </p:cNvPr>
-          <p:cNvPicPr>
-            <a:picLocks noChangeAspect="1"/>
-          </p:cNvPicPr>
-          <p:nvPr>
-            <a:videoFile r:link="rId5"/>
-            <p:extLst>
-              <p:ext uri="{DAA4B4D4-6D71-4841-9C94-3DE7FCFB9230}">
-                <p14:media xmlns:p14="http://schemas.microsoft.com/office/powerpoint/2010/main" r:embed="rId4"/>
-              </p:ext>
-            </p:extLst>
-          </p:nvPr>
-        </p:nvPicPr>
-        <p:blipFill>
-          <a:blip r:embed="rId3"/>
-          <a:stretch>
-            <a:fillRect/>
-          </a:stretch>
-        </p:blipFill>
-        <p:spPr>
-          <a:xfrm>
-            <a:off x="3566160" y="4206240"/>
-            <a:ext cx="5029200" cy="1508760"/>
-          </a:xfrm>
-          <a:prstGeom prst="rect">
-            <a:avLst/>
-          </a:prstGeom>
-        </p:spPr>
-      </p:pic>
+        <p:txBody>
+          <a:bodyPr wrap="square">
+            <a:spAutoFit/>
+          </a:bodyPr>
+          <a:lstStyle/>
+          <a:p>
+            <a:pPr>
+              <a:spcAft>
+                <a:spcPts val="500"/>
+              </a:spcAft>
+            </a:pPr>
+            <a:r>
+              <a:rPr sz="1900" b="1">
+                <a:solidFill>
+                  <a:srgbClr val="222222"/>
+                </a:solidFill>
+                <a:latin typeface="Meiryo"/>
+              </a:rPr>
+              <a:t>fast トラック: 37 周 / 800 秒・16 m/s (制限速度)・無衝突</a:t>
+            </a:r>
+          </a:p>
+          <a:p>
+            <a:pPr>
+              <a:spcAft>
+                <a:spcPts val="500"/>
+              </a:spcAft>
+            </a:pPr>
+            <a:r>
+              <a:rPr sz="1900" b="0">
+                <a:solidFill>
+                  <a:srgbClr val="222222"/>
+                </a:solidFill>
+                <a:latin typeface="Meiryo"/>
+              </a:rPr>
+              <a:t>周回能力の獲得: 3〜6 万ステップ (6 万で 32 周 → 9 万で 36 周)</a:t>
+            </a:r>
+          </a:p>
+          <a:p>
+            <a:pPr>
+              <a:spcAft>
+                <a:spcPts val="500"/>
+              </a:spcAft>
+            </a:pPr>
+            <a:r>
+              <a:rPr sz="1900" b="0">
+                <a:solidFill>
+                  <a:srgbClr val="222222"/>
+                </a:solidFill>
+                <a:latin typeface="Meiryo"/>
+              </a:rPr>
+              <a:t>fast-dev (12 万, 本番ハイパラ): フェーズ 2 (NPC あり lr 3e-4) 込みで 37 周 — 退行なし</a:t>
+            </a:r>
+          </a:p>
+          <a:p>
+            <a:pPr>
+              <a:spcAft>
+                <a:spcPts val="500"/>
+              </a:spcAft>
+            </a:pPr>
+            <a:r>
+              <a:rPr sz="1900" b="1">
+                <a:solidFill>
+                  <a:srgbClr val="222222"/>
+                </a:solidFill>
+                <a:latin typeface="Meiryo"/>
+              </a:rPr>
+              <a:t>汎化モデル (random 学習 15 万): 5 トラックすべて 2 分間ノーミス・平均 15.7 m/s</a:t>
+            </a:r>
+          </a:p>
+          <a:p>
+            <a:pPr>
+              <a:spcAft>
+                <a:spcPts val="500"/>
+              </a:spcAft>
+            </a:pPr>
+            <a:r>
+              <a:rPr sz="1900" b="0">
+                <a:solidFill>
+                  <a:srgbClr val="222222"/>
+                </a:solidFill>
+                <a:latin typeface="Meiryo"/>
+              </a:rPr>
+              <a:t>ゼロショット転移: fast 専用モデルも他 4 コースを制限速度で走行 (自己位置非観測が鍵)</a:t>
+            </a:r>
+          </a:p>
+          <a:p>
+            <a:pPr>
+              <a:spcAft>
+                <a:spcPts val="500"/>
+              </a:spcAft>
+            </a:pPr>
+            <a:r>
+              <a:rPr sz="1900" b="1">
+                <a:solidFill>
+                  <a:srgbClr val="222222"/>
+                </a:solidFill>
+                <a:latin typeface="Meiryo"/>
+              </a:rPr>
+              <a:t>C# デプロイ: 観測ビット一致 (maxDiff=0.0) + 車両物理 1e-7 一致 — 検証ハーネスで自動確認</a:t>
+            </a:r>
+          </a:p>
+        </p:txBody>
+      </p:sp>
     </p:spTree>
   </p:cSld>
   <p:clrMapOvr>
     <a:masterClrMapping/>
   </p:clrMapOvr>
-  <p:timing>
-    <p:tnLst>
-      <p:par>
-        <p:cTn id="1" dur="indefinite" restart="never" nodeType="tmRoot">
-          <p:childTnLst>
-            <p:video>
-              <p:cMediaNode vol="80000">
-                <p:cTn id="2" fill="hold" display="0">
-                  <p:stCondLst>
-                    <p:cond delay="indefinite"/>
-                  </p:stCondLst>
-                </p:cTn>
-                <p:tgtEl>
-                  <p:spTgt spid="4"/>
-                </p:tgtEl>
-              </p:cMediaNode>
-            </p:video>
-          </p:childTnLst>
-        </p:cTn>
-      </p:par>
-    </p:tnLst>
-  </p:timing>
 </p:sld>
 </file>
 
@@ -5112,8 +7469,8 @@
         </p:nvSpPr>
         <p:spPr>
           <a:xfrm>
-            <a:off x="457200" y="228600"/>
-            <a:ext cx="11247120" cy="822960"/>
+            <a:off x="457200" y="201168"/>
+            <a:ext cx="11247120" cy="777240"/>
           </a:xfrm>
           <a:prstGeom prst="rect">
             <a:avLst/>
@@ -5127,41 +7484,152 @@
           <a:lstStyle/>
           <a:p>
             <a:r>
-              <a:rPr sz="3000" b="1">
+              <a:rPr sz="2800" b="1">
                 <a:solidFill>
                   <a:srgbClr val="1B5EA8"/>
                 </a:solidFill>
                 <a:latin typeface="Meiryo"/>
               </a:rPr>
-              <a:t>学習トラック一覧 (race_env.py)</a:t>
-            </a:r>
-          </a:p>
-        </p:txBody>
-      </p:sp>
-      <p:pic>
-        <p:nvPicPr>
-          <p:cNvPr id="3" name="Picture 2" descr="track_shapes.png"/>
-          <p:cNvPicPr>
-            <a:picLocks noChangeAspect="1"/>
-          </p:cNvPicPr>
+              <a:t>ベースライン: highway-env の racetrack 環境 (デフォルト設定)</a:t>
+            </a:r>
+          </a:p>
+        </p:txBody>
+      </p:sp>
+      <p:sp>
+        <p:nvSpPr>
+          <p:cNvPr id="3" name="TextBox 2"/>
+          <p:cNvSpPr txBox="1"/>
           <p:nvPr/>
-        </p:nvPicPr>
-        <p:blipFill>
-          <a:blip r:embed="rId3"/>
-          <a:stretch>
-            <a:fillRect/>
-          </a:stretch>
-        </p:blipFill>
+        </p:nvSpPr>
         <p:spPr>
           <a:xfrm>
-            <a:off x="411480" y="1737360"/>
-            <a:ext cx="11338560" cy="2267712"/>
+            <a:off x="548640" y="1280160"/>
+            <a:ext cx="11064240" cy="5394960"/>
           </a:xfrm>
           <a:prstGeom prst="rect">
             <a:avLst/>
           </a:prstGeom>
+          <a:noFill/>
         </p:spPr>
-      </p:pic>
+        <p:txBody>
+          <a:bodyPr wrap="square">
+            <a:spAutoFit/>
+          </a:bodyPr>
+          <a:lstStyle/>
+          <a:p>
+            <a:pPr>
+              <a:spcAft>
+                <a:spcPts val="500"/>
+              </a:spcAft>
+            </a:pPr>
+            <a:r>
+              <a:rPr sz="1700" b="1">
+                <a:solidFill>
+                  <a:srgbClr val="222222"/>
+                </a:solidFill>
+                <a:latin typeface="Meiryo"/>
+              </a:rPr>
+              <a:t>行動: ステアリングのみ (longitudinal=False)。速度は離散 target_speeds [0, 5, 10] から選択</a:t>
+            </a:r>
+          </a:p>
+          <a:p>
+            <a:pPr>
+              <a:spcAft>
+                <a:spcPts val="500"/>
+              </a:spcAft>
+            </a:pPr>
+            <a:r>
+              <a:rPr sz="1700" b="1">
+                <a:solidFill>
+                  <a:srgbClr val="222222"/>
+                </a:solidFill>
+                <a:latin typeface="Meiryo"/>
+              </a:rPr>
+              <a:t>観測: OccupancyGrid 2ch (presence / on_road) のみ、±18 m の対称視野</a:t>
+            </a:r>
+          </a:p>
+          <a:p>
+            <a:pPr>
+              <a:spcAft>
+                <a:spcPts val="500"/>
+              </a:spcAft>
+            </a:pPr>
+            <a:r>
+              <a:rPr sz="1700" b="1">
+                <a:solidFill>
+                  <a:srgbClr val="222222"/>
+                </a:solidFill>
+                <a:latin typeface="Meiryo"/>
+              </a:rPr>
+              <a:t>報酬: 車線中央維持 1/(1+4·lat²) + 操作量ペナルティ −0.3·|action| + 衝突 −1</a:t>
+            </a:r>
+          </a:p>
+          <a:p>
+            <a:pPr>
+              <a:spcAft>
+                <a:spcPts val="500"/>
+              </a:spcAft>
+            </a:pPr>
+            <a:r>
+              <a:rPr sz="1700" b="0">
+                <a:solidFill>
+                  <a:srgbClr val="222222"/>
+                </a:solidFill>
+                <a:latin typeface="Meiryo"/>
+              </a:rPr>
+              <a:t>速度: speed_limit 10 m/s。「速く走る」インセンティブが存在しない</a:t>
+            </a:r>
+          </a:p>
+          <a:p>
+            <a:pPr>
+              <a:spcAft>
+                <a:spcPts val="500"/>
+              </a:spcAft>
+            </a:pPr>
+            <a:r>
+              <a:rPr sz="1700" b="1">
+                <a:solidFill>
+                  <a:srgbClr val="222222"/>
+                </a:solidFill>
+                <a:latin typeface="Meiryo"/>
+              </a:rPr>
+              <a:t>壁: 存在しない — 路外は終了 (または放置)。すり抜け・ショートカットが物理的に可能</a:t>
+            </a:r>
+          </a:p>
+          <a:p>
+            <a:pPr>
+              <a:spcAft>
+                <a:spcPts val="500"/>
+              </a:spcAft>
+            </a:pPr>
+            <a:r>
+              <a:rPr sz="1700" b="0">
+                <a:solidFill>
+                  <a:srgbClr val="222222"/>
+                </a:solidFill>
+                <a:latin typeface="Meiryo"/>
+              </a:rPr>
+              <a:t>車両: 運動学 Bicycle (スリップなし)。NPC 1 台、エピソード 300 秒</a:t>
+            </a:r>
+          </a:p>
+          <a:p>
+            <a:pPr>
+              <a:spcAft>
+                <a:spcPts val="500"/>
+              </a:spcAft>
+            </a:pPr>
+            <a:r>
+              <a:rPr sz="1700" b="1">
+                <a:solidFill>
+                  <a:srgbClr val="B32D2D"/>
+                </a:solidFill>
+                <a:latin typeface="Meiryo"/>
+              </a:rPr>
+              <a:t>→ 「レーンをなぞる」研究環境としては優秀。しかしゲームのレースには遠い</a:t>
+            </a:r>
+          </a:p>
+        </p:txBody>
+      </p:sp>
     </p:spTree>
   </p:cSld>
   <p:clrMapOvr>
@@ -5188,8 +7656,8 @@
         </p:nvSpPr>
         <p:spPr>
           <a:xfrm>
-            <a:off x="457200" y="228600"/>
-            <a:ext cx="11247120" cy="822960"/>
+            <a:off x="457200" y="201168"/>
+            <a:ext cx="11247120" cy="777240"/>
           </a:xfrm>
           <a:prstGeom prst="rect">
             <a:avLst/>
@@ -5203,168 +7671,41 @@
           <a:lstStyle/>
           <a:p>
             <a:r>
-              <a:rPr sz="3000" b="1">
+              <a:rPr sz="2800" b="1">
                 <a:solidFill>
                   <a:srgbClr val="1B5EA8"/>
                 </a:solidFill>
                 <a:latin typeface="Meiryo"/>
               </a:rPr>
-              <a:t>highway-env からの変更点 (1) 環境</a:t>
-            </a:r>
-          </a:p>
-        </p:txBody>
-      </p:sp>
-      <p:sp>
-        <p:nvSpPr>
-          <p:cNvPr id="3" name="TextBox 2"/>
-          <p:cNvSpPr txBox="1"/>
+              <a:t>デフォルト racetrack と本プロジェクトの fast トラック</a:t>
+            </a:r>
+          </a:p>
+        </p:txBody>
+      </p:sp>
+      <p:pic>
+        <p:nvPicPr>
+          <p:cNvPr id="3" name="Picture 2" descr="default_vs_ours.png"/>
+          <p:cNvPicPr>
+            <a:picLocks noChangeAspect="1"/>
+          </p:cNvPicPr>
           <p:nvPr/>
-        </p:nvSpPr>
+        </p:nvPicPr>
+        <p:blipFill>
+          <a:blip r:embed="rId3"/>
+          <a:stretch>
+            <a:fillRect/>
+          </a:stretch>
+        </p:blipFill>
         <p:spPr>
           <a:xfrm>
-            <a:off x="548640" y="1280160"/>
-            <a:ext cx="11064240" cy="5120640"/>
+            <a:off x="822960" y="1371600"/>
+            <a:ext cx="10515600" cy="3720905"/>
           </a:xfrm>
           <a:prstGeom prst="rect">
             <a:avLst/>
           </a:prstGeom>
-          <a:noFill/>
         </p:spPr>
-        <p:txBody>
-          <a:bodyPr wrap="square">
-            <a:spAutoFit/>
-          </a:bodyPr>
-          <a:lstStyle/>
-          <a:p>
-            <a:pPr>
-              <a:spcAft>
-                <a:spcPts val="600"/>
-              </a:spcAft>
-            </a:pPr>
-            <a:r>
-              <a:rPr sz="1700" b="1">
-                <a:solidFill>
-                  <a:srgbClr val="222222"/>
-                </a:solidFill>
-                <a:latin typeface="Meiryo"/>
-              </a:rPr>
-              <a:t>壁 = コース外周のみ (車線境界線は壁ではない)・接触で停止・バックで脱出</a:t>
-            </a:r>
-          </a:p>
-          <a:p>
-            <a:pPr lvl="1">
-              <a:spcAft>
-                <a:spcPts val="600"/>
-              </a:spcAft>
-            </a:pPr>
-            <a:r>
-              <a:rPr sz="1500" b="0">
-                <a:solidFill>
-                  <a:srgbClr val="666666"/>
-                </a:solidFill>
-                <a:latin typeface="Meiryo"/>
-              </a:rPr>
-              <a:t>理由: ゲーム側の物理と一致させ、壁ずり走行 (wall-riding) を防ぐ</a:t>
-            </a:r>
-          </a:p>
-          <a:p>
-            <a:pPr>
-              <a:spcAft>
-                <a:spcPts val="600"/>
-              </a:spcAft>
-            </a:pPr>
-            <a:r>
-              <a:rPr sz="1700" b="0">
-                <a:solidFill>
-                  <a:srgbClr val="222222"/>
-                </a:solidFill>
-                <a:latin typeface="Meiryo"/>
-              </a:rPr>
-              <a:t>壁接触が 35 ステップ続くとクラッシュ扱いで終了 — 壁沿い周回の悪用を遮断</a:t>
-            </a:r>
-          </a:p>
-          <a:p>
-            <a:pPr>
-              <a:spcAft>
-                <a:spcPts val="600"/>
-              </a:spcAft>
-            </a:pPr>
-            <a:r>
-              <a:rPr sz="1700" b="1">
-                <a:solidFill>
-                  <a:srgbClr val="222222"/>
-                </a:solidFill>
-                <a:latin typeface="Meiryo"/>
-              </a:rPr>
-              <a:t>報酬: 速度 + 車線中央 + チェックポイント/ラップボーナス → lmap [-3,3]→[0,1]</a:t>
-            </a:r>
-          </a:p>
-          <a:p>
-            <a:pPr lvl="1">
-              <a:spcAft>
-                <a:spcPts val="600"/>
-              </a:spcAft>
-            </a:pPr>
-            <a:r>
-              <a:rPr sz="1500" b="0">
-                <a:solidFill>
-                  <a:srgbClr val="666666"/>
-                </a:solidFill>
-                <a:latin typeface="Meiryo"/>
-              </a:rPr>
-              <a:t>理由: 範囲が真の下限を覆わないと悪い状態が 0 に飽和し勾配消失 (導出をコメントで管理)</a:t>
-            </a:r>
-          </a:p>
-          <a:p>
-            <a:pPr>
-              <a:spcAft>
-                <a:spcPts val="600"/>
-              </a:spcAft>
-            </a:pPr>
-            <a:r>
-              <a:rPr sz="1700" b="1">
-                <a:solidFill>
-                  <a:srgbClr val="222222"/>
-                </a:solidFill>
-                <a:latin typeface="Meiryo"/>
-              </a:rPr>
-              <a:t>壁脱出ゾーン (1 m): バック免除 + 距離増加に報酬</a:t>
-            </a:r>
-          </a:p>
-          <a:p>
-            <a:pPr lvl="1">
-              <a:spcAft>
-                <a:spcPts val="600"/>
-              </a:spcAft>
-            </a:pPr>
-            <a:r>
-              <a:rPr sz="1500" b="0">
-                <a:solidFill>
-                  <a:srgbClr val="666666"/>
-                </a:solidFill>
-                <a:latin typeface="Meiryo"/>
-              </a:rPr>
-              <a:t>理由: 脱出直後に罰すると「壁を這う」局所解に陥る (実測で確認)</a:t>
-            </a:r>
-          </a:p>
-          <a:p>
-            <a:pPr>
-              <a:spcAft>
-                <a:spcPts val="600"/>
-              </a:spcAft>
-            </a:pPr>
-            <a:r>
-              <a:rPr sz="1700" b="0">
-                <a:solidFill>
-                  <a:srgbClr val="222222"/>
-                </a:solidFill>
-                <a:latin typeface="Meiryo"/>
-              </a:rPr>
-              <a:t>トラック 5 種 + random (エピソード毎に再抽選) で汎化学習</a:t>
-            </a:r>
-          </a:p>
-        </p:txBody>
-      </p:sp>
+      </p:pic>
     </p:spTree>
   </p:cSld>
   <p:clrMapOvr>
@@ -5391,8 +7732,8 @@
         </p:nvSpPr>
         <p:spPr>
           <a:xfrm>
-            <a:off x="457200" y="228600"/>
-            <a:ext cx="11247120" cy="822960"/>
+            <a:off x="457200" y="201168"/>
+            <a:ext cx="11247120" cy="777240"/>
           </a:xfrm>
           <a:prstGeom prst="rect">
             <a:avLst/>
@@ -5406,13 +7747,13 @@
           <a:lstStyle/>
           <a:p>
             <a:r>
-              <a:rPr sz="3000" b="1">
+              <a:rPr sz="2800" b="1">
                 <a:solidFill>
                   <a:srgbClr val="1B5EA8"/>
                 </a:solidFill>
                 <a:latin typeface="Meiryo"/>
               </a:rPr>
-              <a:t>highway-env からの変更点 (2) 観測・行動・学習設定</a:t>
+              <a:t>問題の形式化 — POMDP・意思決定周波数・割引</a:t>
             </a:r>
           </a:p>
         </p:txBody>
@@ -5425,8 +7766,8 @@
         </p:nvSpPr>
         <p:spPr>
           <a:xfrm>
-            <a:off x="548640" y="1280160"/>
-            <a:ext cx="11064240" cy="5120640"/>
+            <a:off x="548640" y="1325880"/>
+            <a:ext cx="11064240" cy="5394960"/>
           </a:xfrm>
           <a:prstGeom prst="rect">
             <a:avLst/>
@@ -5441,7 +7782,7 @@
           <a:p>
             <a:pPr>
               <a:spcAft>
-                <a:spcPts val="600"/>
+                <a:spcPts val="500"/>
               </a:spcAft>
             </a:pPr>
             <a:r>
@@ -5451,29 +7792,29 @@
                 </a:solidFill>
                 <a:latin typeface="Meiryo"/>
               </a:rPr>
-              <a:t>観測: OccupancyGrid (10ch, 12x12), 前方 27 m / 後方 9 m の非対称視野</a:t>
-            </a:r>
-          </a:p>
-          <a:p>
-            <a:pPr lvl="1">
+              <a:t>POMDP: 自己位置なし・前方 27 m の局所観測 — 方策は反射的 (メモリレス) に制約</a:t>
+            </a:r>
+          </a:p>
+          <a:p>
+            <a:pPr>
               <a:spcAft>
-                <a:spcPts val="600"/>
+                <a:spcPts val="500"/>
               </a:spcAft>
             </a:pPr>
             <a:r>
-              <a:rPr sz="1500" b="0">
-                <a:solidFill>
-                  <a:srgbClr val="666666"/>
-                </a:solidFill>
-                <a:latin typeface="Meiryo"/>
-              </a:rPr>
-              <a:t>理由: 制動距離とコーナー先読み (16 m/s から 5 m/s² 制動で 25.6 m &lt; 27 m)</a:t>
+              <a:rPr sz="1700" b="0">
+                <a:solidFill>
+                  <a:srgbClr val="222222"/>
+                </a:solidFill>
+                <a:latin typeface="Meiryo"/>
+              </a:rPr>
+              <a:t>意思決定 5 Hz / 物理 15 Hz (action repeat = 3) — 制御の滑らかさと学習効率のトレード</a:t>
             </a:r>
           </a:p>
           <a:p>
             <a:pPr>
               <a:spcAft>
-                <a:spcPts val="600"/>
+                <a:spcPts val="500"/>
               </a:spcAft>
             </a:pPr>
             <a:r>
@@ -5483,13 +7824,13 @@
                 </a:solidFill>
                 <a:latin typeface="Meiryo"/>
               </a:rPr>
-              <a:t>行動: 連続スロットル [-5,5] m/s² + ステア ±π/6, dynamical=True (タイヤスリップ)</a:t>
+              <a:t>フレームスタック不使用: 相対速度 vx,vy と lat/ang_off が状態を近似マルコフ化</a:t>
             </a:r>
           </a:p>
           <a:p>
             <a:pPr>
               <a:spcAft>
-                <a:spcPts val="600"/>
+                <a:spcPts val="500"/>
               </a:spcAft>
             </a:pPr>
             <a:r>
@@ -5499,13 +7840,13 @@
                 </a:solidFill>
                 <a:latin typeface="Meiryo"/>
               </a:rPr>
-              <a:t>2 フェーズ PPO: ①NPC なしでレーン追従 → ②NPC ありで追い越し (lr を下げて FT)</a:t>
+              <a:t>γ = 0.99 @5 Hz → 実効ホライズン ≈ 20 s ≈ 1 周 — コーナー進入の信用割当が届く</a:t>
             </a:r>
           </a:p>
           <a:p>
             <a:pPr>
               <a:spcAft>
-                <a:spcPts val="600"/>
+                <a:spcPts val="500"/>
               </a:spcAft>
             </a:pPr>
             <a:r>
@@ -5515,55 +7856,23 @@
                 </a:solidFill>
                 <a:latin typeface="Meiryo"/>
               </a:rPr>
-              <a:t>カスタム CNN 特徴抽出器 + 初期スロットルバイアス +0.4 (前進探索を促進)</a:t>
+              <a:t>GAE λ = 0.98: 長ホライズンのバイアス-分散トレードを分散側に寄せる (密報酬なので許容)</a:t>
             </a:r>
           </a:p>
           <a:p>
             <a:pPr>
               <a:spcAft>
-                <a:spcPts val="600"/>
+                <a:spcPts val="500"/>
               </a:spcAft>
             </a:pPr>
             <a:r>
-              <a:rPr sz="1700" b="1">
+              <a:rPr sz="1700" b="0">
                 <a:solidFill>
                   <a:srgbClr val="222222"/>
                 </a:solidFill>
                 <a:latin typeface="Meiryo"/>
               </a:rPr>
-              <a:t>fast-dev = 12 万ステップ・本番ハイパラ (ent 0.02, lr 2e-4) — 周回到達を実測保証</a:t>
-            </a:r>
-          </a:p>
-          <a:p>
-            <a:pPr lvl="1">
-              <a:spcAft>
-                <a:spcPts val="600"/>
-              </a:spcAft>
-            </a:pPr>
-            <a:r>
-              <a:rPr sz="1500" b="0">
-                <a:solidFill>
-                  <a:srgbClr val="666666"/>
-                </a:solidFill>
-                <a:latin typeface="Meiryo"/>
-              </a:rPr>
-              <a:t>理由: 高エントロピー設定 (旧 0.10) は方策がランダムに留まり永遠に曲がれない</a:t>
-            </a:r>
-          </a:p>
-          <a:p>
-            <a:pPr>
-              <a:spcAft>
-                <a:spcPts val="600"/>
-              </a:spcAft>
-            </a:pPr>
-            <a:r>
-              <a:rPr sz="1700" b="0">
-                <a:solidFill>
-                  <a:srgbClr val="222222"/>
-                </a:solidFill>
-                <a:latin typeface="Meiryo"/>
-              </a:rPr>
-              <a:t>EvalCallback のベストモデルを採用 (PPO は終盤に退行することがある)</a:t>
+              <a:t>報酬 ∈ [0,1]/step → 理論上の episodic return 上限 = ステップ数 (4000) — 診断が容易</a:t>
             </a:r>
           </a:p>
         </p:txBody>
@@ -5594,8 +7903,8 @@
         </p:nvSpPr>
         <p:spPr>
           <a:xfrm>
-            <a:off x="457200" y="228600"/>
-            <a:ext cx="11247120" cy="822960"/>
+            <a:off x="457200" y="201168"/>
+            <a:ext cx="11247120" cy="777240"/>
           </a:xfrm>
           <a:prstGeom prst="rect">
             <a:avLst/>
@@ -5609,13 +7918,13 @@
           <a:lstStyle/>
           <a:p>
             <a:r>
-              <a:rPr sz="3000" b="1">
+              <a:rPr sz="2800" b="1">
                 <a:solidFill>
                   <a:srgbClr val="1B5EA8"/>
                 </a:solidFill>
                 <a:latin typeface="Meiryo"/>
               </a:rPr>
-              <a:t>セットアップとノートブックの使い方</a:t>
+              <a:t>進化 (1) 行動と車両 — スロットルを持たせ、実車に近づける</a:t>
             </a:r>
           </a:p>
         </p:txBody>
@@ -5628,8 +7937,8 @@
         </p:nvSpPr>
         <p:spPr>
           <a:xfrm>
-            <a:off x="548640" y="1280160"/>
-            <a:ext cx="11064240" cy="5120640"/>
+            <a:off x="548640" y="1097280"/>
+            <a:ext cx="11064240" cy="5394960"/>
           </a:xfrm>
           <a:prstGeom prst="rect">
             <a:avLst/>
@@ -5644,133 +7953,61 @@
           <a:p>
             <a:pPr>
               <a:spcAft>
-                <a:spcPts val="600"/>
+                <a:spcPts val="500"/>
               </a:spcAft>
             </a:pPr>
             <a:r>
-              <a:rPr sz="1700" b="1">
+              <a:rPr sz="1600" b="1">
                 <a:solidFill>
                   <a:srgbClr val="222222"/>
                 </a:solidFill>
                 <a:latin typeface="Meiryo"/>
               </a:rPr>
-              <a:t>pip install "highway-env&gt;=1.8" "stable-baselines3[extra]&gt;=2.0" gymnasium torch tensorboard moviepy onnx onnxruntime</a:t>
-            </a:r>
-          </a:p>
-          <a:p>
-            <a:pPr lvl="1">
+              <a:t>ContinuousAction: ステアのみ → スロットル + ステア (±5 m/s², ±π/6)、dynamical=True</a:t>
+            </a:r>
+          </a:p>
+          <a:p>
+            <a:pPr>
               <a:spcAft>
-                <a:spcPts val="600"/>
+                <a:spcPts val="500"/>
               </a:spcAft>
             </a:pPr>
             <a:r>
-              <a:rPr sz="1500" b="0">
-                <a:solidFill>
-                  <a:srgbClr val="666666"/>
-                </a:solidFill>
-                <a:latin typeface="Meiryo"/>
-              </a:rPr>
-              <a:t>注意: リポジトリの requirements.txt は旧スタック (TF2.6/gym0.21) 用 — 使わない</a:t>
-            </a:r>
-          </a:p>
-          <a:p>
-            <a:pPr>
-              <a:spcAft>
-                <a:spcPts val="600"/>
-              </a:spcAft>
-            </a:pPr>
-            <a:r>
-              <a:rPr sz="1700" b="0">
+              <a:rPr sz="1600" b="0">
                 <a:solidFill>
                   <a:srgbClr val="222222"/>
                 </a:solidFill>
                 <a:latin typeface="Meiryo"/>
               </a:rPr>
-              <a:t>task2_laning_overtaking_sb3_ppo.ipynb — fast トラック専用の学習</a:t>
-            </a:r>
-          </a:p>
-          <a:p>
-            <a:pPr>
-              <a:spcAft>
-                <a:spcPts val="600"/>
-              </a:spcAft>
-            </a:pPr>
-            <a:r>
-              <a:rPr sz="1700" b="0">
-                <a:solidFill>
-                  <a:srgbClr val="222222"/>
-                </a:solidFill>
-                <a:latin typeface="Meiryo"/>
-              </a:rPr>
-              <a:t>task3_generalization_sb3_ppo.ipynb — random トラック学習 + トラック別評価レポート + 5 連動画</a:t>
-            </a:r>
-          </a:p>
-          <a:p>
-            <a:pPr>
-              <a:spcAft>
-                <a:spcPts val="600"/>
-              </a:spcAft>
-            </a:pPr>
-            <a:r>
-              <a:rPr sz="1700" b="1">
-                <a:solidFill>
-                  <a:srgbClr val="222222"/>
-                </a:solidFill>
-                <a:latin typeface="Meiryo"/>
-              </a:rPr>
-              <a:t>FAST_DEV_RUN=True: 12〜15 万ステップの短縮学習 (周回まで到達) / False: 本番 (100万+)</a:t>
-            </a:r>
-          </a:p>
-          <a:p>
-            <a:pPr>
-              <a:spcAft>
-                <a:spcPts val="600"/>
-              </a:spcAft>
-            </a:pPr>
-            <a:r>
-              <a:rPr sz="1700" b="0">
-                <a:solidFill>
-                  <a:srgbClr val="222222"/>
-                </a:solidFill>
-                <a:latin typeface="Meiryo"/>
-              </a:rPr>
-              <a:t>Reward yardstick セル: eval/mean_reward を「周回数」として読むための換算値を表示</a:t>
-            </a:r>
-          </a:p>
-          <a:p>
-            <a:pPr>
-              <a:spcAft>
-                <a:spcPts val="600"/>
-              </a:spcAft>
-            </a:pPr>
-            <a:r>
-              <a:rPr sz="1700" b="0">
-                <a:solidFill>
-                  <a:srgbClr val="222222"/>
-                </a:solidFill>
-                <a:latin typeface="Meiryo"/>
-              </a:rPr>
-              <a:t>ベストモデルは runs/&lt;EXP_ID&gt;/models/best/phase1|phase2/best_model.zip に保存</a:t>
-            </a:r>
-          </a:p>
-          <a:p>
-            <a:pPr>
-              <a:spcAft>
-                <a:spcPts val="600"/>
-              </a:spcAft>
-            </a:pPr>
-            <a:r>
-              <a:rPr sz="1700" b="0">
-                <a:solidFill>
-                  <a:srgbClr val="222222"/>
-                </a:solidFill>
-                <a:latin typeface="Meiryo"/>
-              </a:rPr>
-              <a:t>検証: cd re_engine/verify &amp;&amp; dotnet run -- ..  → ALL SCENARIOS MATCH</a:t>
-            </a:r>
-          </a:p>
-        </p:txBody>
-      </p:sp>
+              <a:t>速度上限 10 → 16 m/s、前進報酬を追加 — 「速く走る」動機を導入</a:t>
+            </a:r>
+          </a:p>
+        </p:txBody>
+      </p:sp>
+      <p:pic>
+        <p:nvPicPr>
+          <p:cNvPr id="4" name="Picture 3" descr="range_experiment.png"/>
+          <p:cNvPicPr>
+            <a:picLocks noChangeAspect="1"/>
+          </p:cNvPicPr>
+          <p:nvPr/>
+        </p:nvPicPr>
+        <p:blipFill>
+          <a:blip r:embed="rId3"/>
+          <a:stretch>
+            <a:fillRect/>
+          </a:stretch>
+        </p:blipFill>
+        <p:spPr>
+          <a:xfrm>
+            <a:off x="3017520" y="2286000"/>
+            <a:ext cx="6217920" cy="3316224"/>
+          </a:xfrm>
+          <a:prstGeom prst="rect">
+            <a:avLst/>
+          </a:prstGeom>
+        </p:spPr>
+      </p:pic>
     </p:spTree>
   </p:cSld>
   <p:clrMapOvr>

</xml_diff>

<commit_message>
slides: add全体比較表 slide (highway-env default vs CircuitAgents)
New slide 9 (after the track comparison figure): a 7-row comparison table
covering the changed axes — action/vehicle, speed target, walls, reward,
observation, tracks — with columns for the highway-env default, our setting,
and the reason for each change. Mirrors the docs comparison tables so the
deck opens the evolution section with a one-glance before/after overview
before the per-change slides. Deck is now 21 slides; speaker notes added.

Co-Authored-By: Claude Opus 4.8 <noreply@anthropic.com>
Claude-Session: https://claude.ai/code/session_01RNWAkxuGbbryAR3VqKTcDq
</commit_message>
<xml_diff>
--- a/docs/CircuitAgents_intro_ja.pptx
+++ b/docs/CircuitAgents_intro_ja.pptx
@@ -25,6 +25,7 @@
     <p:sldId id="273" r:id="rId25"/>
     <p:sldId id="274" r:id="rId26"/>
     <p:sldId id="275" r:id="rId27"/>
+    <p:sldId id="276" r:id="rId28"/>
   </p:sldIdLst>
   <p:sldSz cx="12191695" cy="6858000" type="screen4x3"/>
   <p:notesSz cx="6858000" cy="9144000"/>
@@ -591,7 +592,7 @@
           <a:lstStyle/>
           <a:p>
             <a:r>
-              <a:t>第二の変更、壁です。ここが一番試行錯誤しました。壁なしではコーナーを路外ショートカットする走りを学習します。反発壁を入れると、今度は壁に擦って曲がる wall-riding が最速解になりました。壁が方向転換を代行するのでステアを学ぶ必要がなくなるんです。最終形は停止壁です。壁に当たると止まり、バックでしか脱出できない。壁接触中は速度報酬ゼロ、接触 7 秒でクラッシュ扱い終了。加えて壁摩擦 0.6 を設定し、接線方向速度を物理フレーム毎に減衰させます。もう 1 つの要点は壁の定義で、コース外周のみが壁です。実装当初、最も近い車線単位で判定してしまい車線境界の白線が壁になるバグを踏みました。現在はコリドー両端の車線の外側だけを壁とする実装です。</a:t>
+              <a:t>第一の変更は行動空間です。連続スロットルとステアの 2 次元にし、動的 Bicycle モデルに切り替えました。ここで各レンジの意味を明確にしておきます。acceleration_range ±5 m/s² は方策の正規化出力 [−1,1] を実際の加速度に線形写像する係数です。steering_range ±π/6 は前輪舵角の上限で、最小旋回半径約 8 m を与え、最小コーナー半径 10 m に余裕を持って対応します。±5 という数字は実験で正当化しています。右のグラフの赤破線が ±2.5 m/s² 実験で、22 周までは学習するものの巡航が 10 m/s に頭打ちし終盤退行しました。原因は制動距離で、16 m/s から 2.5 m/s² では 51 m 必要ですが前方視野は 27 m しかない。「見えてから減速」が物理的に間に合わないのです。出力を絞るならブレーキだけ残す非対称 [−5, +2.5] を推奨します。</a:t>
             </a:r>
           </a:p>
         </p:txBody>
@@ -661,7 +662,7 @@
           <a:lstStyle/>
           <a:p>
             <a:r>
-              <a:t>第三の変更、報酬です。左のグラフは代表状態の 1 ステップ報酬の実測値です。設計目標は、どんな抜け道よりも普通に走る方が儲かる順序を作ること。運転 0.97 が最上位、壁からのバック脱出 0.51 がスタック 0.45 や壁擦り 0.42 より上、というのが要点です。壁脱出は最初、壁接触中しか報酬が出ず、脱出の一歩目でバックペナルティが復活して「壁を這う」局所解を生みました。現在は壁から 1 m の脱出ゾーンでバック免除、クリアランス増加に報酬を与えます。理論的には、クリアランスをポテンシャル関数とする potential-based shaping で、最適方策を原理的に歪めない形です。正規化にも罠があり、合成報酬を [-3,3]→[0,1] に写像しますが、この範囲が真の下限を覆わないと悪い状態が全部 0 に飽和し勾配が消えます。範囲の導出はコードにコメントで残し、重み変更時に再導出するルールです。</a:t>
+              <a:t>第二の変更、壁です。ここが一番試行錯誤しました。壁なしではコーナーを路外ショートカットする走りを学習します。反発壁を入れると、今度は壁に擦って曲がる wall-riding が最速解になりました。壁が方向転換を代行するのでステアを学ぶ必要がなくなるんです。最終形は停止壁です。壁に当たると止まり、バックでしか脱出できない。壁接触中は速度報酬ゼロ、接触 7 秒でクラッシュ扱い終了。加えて壁摩擦 0.6 を設定し、接線方向速度を物理フレーム毎に減衰させます。もう 1 つの要点は壁の定義で、コース外周のみが壁です。実装当初、最も近い車線単位で判定してしまい車線境界の白線が壁になるバグを踏みました。現在はコリドー両端の車線の外側だけを壁とする実装です。</a:t>
             </a:r>
           </a:p>
         </p:txBody>
@@ -731,7 +732,7 @@
           <a:lstStyle/>
           <a:p>
             <a:r>
-              <a:t>第四の変更、観測です。2 チャネルから 10 チャネルに拡張しました。各チャネルの意味を説明します。presence は車がいるセルに 1。on_road はレーン中心線が通るセルに 1 で、塗りつぶした路面マスクではない点が移植時の要注意です。x, y, vx, vy は他車の自車相対の位置と速度で、値はトラック座標系のまま、セルの位置だけが自車向きに回転します。cos_h, sin_h は各車の絶対進行方向。lat_off は最寄りレーン中心からの横ずれ、ang_off はレーン方向との角度差で、この 2 つが車線維持の主信号です。features_range は正規化の分母で、例えば vx の ±20 m/s は「±20 を ±1 に写像する」という意味です。ここに km/h の値を入れると 3.6 倍されて飽和する、という単位事故がデプロイで最も起きやすい罠です。視野は前方 27 m・後方 9 m の非対称で、27 m は制動距離 25.6 m から逆算しています。右の軌跡でヘアピン手前の減速開始位置がちょうど視野に対応しているのが分かります。</a:t>
+              <a:t>第三の変更、報酬です。左のグラフは代表状態の 1 ステップ報酬の実測値です。設計目標は、どんな抜け道よりも普通に走る方が儲かる順序を作ること。運転 0.97 が最上位、壁からのバック脱出 0.51 がスタック 0.45 や壁擦り 0.42 より上、というのが要点です。壁脱出は最初、壁接触中しか報酬が出ず、脱出の一歩目でバックペナルティが復活して「壁を這う」局所解を生みました。現在は壁から 1 m の脱出ゾーンでバック免除、クリアランス増加に報酬を与えます。理論的には、クリアランスをポテンシャル関数とする potential-based shaping で、最適方策を原理的に歪めない形です。正規化にも罠があり、合成報酬を [-3,3]→[0,1] に写像しますが、この範囲が真の下限を覆わないと悪い状態が全部 0 に飽和し勾配が消えます。範囲の導出はコードにコメントで残し、重み変更時に再導出するルールです。</a:t>
             </a:r>
           </a:p>
         </p:txBody>
@@ -801,7 +802,7 @@
           <a:lstStyle/>
           <a:p>
             <a:r>
-              <a:t>第五の変更、トラックです。oval と stadium が基礎、rect が 90 度の反復、chicane が左右切り返しと最小半径 10 m のキンク、fast がメインの難コース。track を random にするとエピソード毎に再抽選され、これはドメインランダマイゼーションの一種です。ただし汎化の本質は観測の帰納バイアス側にあり、fast 単体学習の方策も未見 4 コースをゼロショットで走ります。各トラックは C# プリセットと JSON に複製され、検証ハーネスが幾何一致を自動チェックします。</a:t>
+              <a:t>第四の変更、観測です。2 チャネルから 10 チャネルに拡張しました。各チャネルの意味を説明します。presence は車がいるセルに 1。on_road はレーン中心線が通るセルに 1 で、塗りつぶした路面マスクではない点が移植時の要注意です。x, y, vx, vy は他車の自車相対の位置と速度で、値はトラック座標系のまま、セルの位置だけが自車向きに回転します。cos_h, sin_h は各車の絶対進行方向。lat_off は最寄りレーン中心からの横ずれ、ang_off はレーン方向との角度差で、この 2 つが車線維持の主信号です。features_range は正規化の分母で、例えば vx の ±20 m/s は「±20 を ±1 に写像する」という意味です。ここに km/h の値を入れると 3.6 倍されて飽和する、という単位事故がデプロイで最も起きやすい罠です。視野は前方 27 m・後方 9 m の非対称で、27 m は制動距離 25.6 m から逆算しています。右の軌跡でヘアピン手前の減速開始位置がちょうど視野に対応しているのが分かります。</a:t>
             </a:r>
           </a:p>
         </p:txBody>
@@ -871,7 +872,7 @@
           <a:lstStyle/>
           <a:p>
             <a:r>
-              <a:t>学習の全体像です。フェーズ 1 で他車なしのレーン追従、フェーズ 2 で NPC を入れて学習率を下げ追い越しを学習します。特徴抽出はカスタム CNN で、初期方策のスロットルバイアスを +0.4 に手動シフトします。ガウス方策の平均が 0 のままだと前進と後退が等確率で、前進報酬を発見する前に壁ペナルティばかり集めるためです。動作確認用の fast-dev はかつてエントロピー係数 0.10 で、何度回しても曲がれませんでした。エントロピーボーナスが「ランダムでいること」に支払われ、[0,1] に圧縮された報酬差に勝ってしまうためです。現在は本番ハイパラのまま 12 万ステップに短縮し、周回到達をエンドツーエンドで実測保証しています。</a:t>
+              <a:t>第五の変更、トラックです。oval と stadium が基礎、rect が 90 度の反復、chicane が左右切り返しと最小半径 10 m のキンク、fast がメインの難コース。track を random にするとエピソード毎に再抽選され、これはドメインランダマイゼーションの一種です。ただし汎化の本質は観測の帰納バイアス側にあり、fast 単体学習の方策も未見 4 コースをゼロショットで走ります。各トラックは C# プリセットと JSON に複製され、検証ハーネスが幾何一致を自動チェックします。</a:t>
             </a:r>
           </a:p>
         </p:txBody>
@@ -941,7 +942,7 @@
           <a:lstStyle/>
           <a:p>
             <a:r>
-              <a:t>PPO の設定判断です。オンポリシーを選んだのは、環境を頻繁に改造するためリプレイ経験がすぐ無効になること、シミュレータが軽く壁時計効率が支配的なことによります。クリップ範囲 0.15 は標準の 0.2 より狭く、壁ペナルティ由来の高分散アドバンテージでの方策崩壊を抑えます。GAE λ 0.98 は密報酬前提で分散側に寄せ、コーナー 1 つ分の信用割当を確保します。エントロピー係数は報酬スケールと結合する、が本プロジェクト最大の教訓の 1 つです。なお PPO はアドバンテージ正規化により報酬のアフィン変換に不変なので、[0,1] 正規化自体は学習のためではなく診断のための設計です。</a:t>
+              <a:t>学習の全体像です。フェーズ 1 で他車なしのレーン追従、フェーズ 2 で NPC を入れて学習率を下げ追い越しを学習します。特徴抽出はカスタム CNN で、初期方策のスロットルバイアスを +0.4 に手動シフトします。ガウス方策の平均が 0 のままだと前進と後退が等確率で、前進報酬を発見する前に壁ペナルティばかり集めるためです。動作確認用の fast-dev はかつてエントロピー係数 0.10 で、何度回しても曲がれませんでした。エントロピーボーナスが「ランダムでいること」に支払われ、[0,1] に圧縮された報酬差に勝ってしまうためです。現在は本番ハイパラのまま 12 万ステップに短縮し、周回到達をエンドツーエンドで実測保証しています。</a:t>
             </a:r>
           </a:p>
         </p:txBody>
@@ -1011,7 +1012,7 @@
           <a:lstStyle/>
           <a:p>
             <a:r>
-              <a:t>ここは正直に、シミュレータが実ゲームから何を省いているかの一覧です。車両動力学では、タイヤが線形モデルでグリップ飽和がありません。実車はスリップ角が深くなると横力が頭打ちになりますが、シムでは増え続けます。質量は 1 kg の正規化値で、荷重移動もサスもない。加速度は直接指令で、エンジン特性・ギア・空気抵抗・転がり抵抗がありません。つまりシムの車は惰性で減速しない。壁は速度を消す理想化された壁で、実ゲームの衝突インパルスや車体の回転、ダメージはモデル化していません。壁摩擦 0.6 も実測合わせが必要な仮の値です。ステアは瞬時に舵角が立つ理想アクチュエータ。タイミング面では、5 Hz の等間隔意思決定を仮定しており、フレーム時間の揺らぎや推論レイテンシ 1 フレーム分は学習に含まれていません。地形も 2D 平面で、縁石・バンク・高低差・路面 μ の変化はありません。</a:t>
+              <a:t>PPO の設定判断です。オンポリシーを選んだのは、環境を頻繁に改造するためリプレイ経験がすぐ無効になること、シミュレータが軽く壁時計効率が支配的なことによります。クリップ範囲 0.15 は標準の 0.2 より狭く、壁ペナルティ由来の高分散アドバンテージでの方策崩壊を抑えます。GAE λ 0.98 は密報酬前提で分散側に寄せ、コーナー 1 つ分の信用割当を確保します。エントロピー係数は報酬スケールと結合する、が本プロジェクト最大の教訓の 1 つです。なお PPO はアドバンテージ正規化により報酬のアフィン変換に不変なので、[0,1] 正規化自体は学習のためではなく診断のための設計です。</a:t>
             </a:r>
           </a:p>
         </p:txBody>
@@ -1081,7 +1082,7 @@
           <a:lstStyle/>
           <a:p>
             <a:r>
-              <a:t>ギャップへの対処は二層です。第一層、消せるギャップは移植の数値一致で消す。観測ビルダーはビット一致、車両物理は 1e-7 一致で C# に移植済みなので、『移植したら挙動が変わった』という自由度は存在しません。第二層、実ゲーム固有の動力学差は方策を再学習せず、デプロイ側のアクションフィルタで吸収します。EMA 平滑化は観測の 3 m 量子化由来のステア蛇行を消し、実測で符号反転が 1/3 になります。CorneringLimiter はステア速度制限と、曲率から計算した限界速度超過に比例する弱いブレーキで、グリップ飽和がないシム方策の過信を抑えます。StuckRecovery は移動距離ベースで壁刺さりを検出しバックを指示します。フィルタは閉ループ特性を変えるため、シミュレータ内で同じフィルタを通した評価で周回数が落ちないことを確認しています。それでも残る差が大きければ、壁摩擦・加速度レンジなどを実ゲーム実測に合わせて環境側を再調整し、再学習する道があります。</a:t>
+              <a:t>ここは正直に、シミュレータが実ゲームから何を省いているかの一覧です。車両動力学では、タイヤが線形モデルでグリップ飽和がありません。実車はスリップ角が深くなると横力が頭打ちになりますが、シムでは増え続けます。質量は 1 kg の正規化値で、荷重移動もサスもない。加速度は直接指令で、エンジン特性・ギア・空気抵抗・転がり抵抗がありません。つまりシムの車は惰性で減速しない。壁は速度を消す理想化された壁で、実ゲームの衝突インパルスや車体の回転、ダメージはモデル化していません。壁摩擦 0.6 も実測合わせが必要な仮の値です。ステアは瞬時に舵角が立つ理想アクチュエータ。タイミング面では、5 Hz の等間隔意思決定を仮定しており、フレーム時間の揺らぎや推論レイテンシ 1 フレーム分は学習に含まれていません。地形も 2D 平面で、縁石・バンク・高低差・路面 μ の変化はありません。</a:t>
             </a:r>
           </a:p>
         </p:txBody>
@@ -1151,7 +1152,7 @@
           <a:lstStyle/>
           <a:p>
             <a:r>
-              <a:t>使い方です。環境構築は 1 行。リポジトリ直下の requirements.txt は旧スタック用なので使いません。ノートブックは task2 が fast 専用、task3 が汎化学習。FAST_DEV_RUN で短縮と本番を切り替えます。学習の判断材料として、eval 報酬を周回数に換算するヤードスティックセルがあり、TensorBoard の数字だけで局所解か周回かを判別できます。スライドの図と動画を生成・保存するセルもノートブック内にあります。</a:t>
+              <a:t>ギャップへの対処は二層です。第一層、消せるギャップは移植の数値一致で消す。観測ビルダーはビット一致、車両物理は 1e-7 一致で C# に移植済みなので、『移植したら挙動が変わった』という自由度は存在しません。第二層、実ゲーム固有の動力学差は方策を再学習せず、デプロイ側のアクションフィルタで吸収します。EMA 平滑化は観測の 3 m 量子化由来のステア蛇行を消し、実測で符号反転が 1/3 になります。CorneringLimiter はステア速度制限と、曲率から計算した限界速度超過に比例する弱いブレーキで、グリップ飽和がないシム方策の過信を抑えます。StuckRecovery は移動距離ベースで壁刺さりを検出しバックを指示します。フィルタは閉ループ特性を変えるため、シミュレータ内で同じフィルタを通した評価で周回数が落ちないことを確認しています。それでも残る差が大きければ、壁摩擦・加速度レンジなどを実ゲーム実測に合わせて環境側を再調整し、再学習する道があります。</a:t>
             </a:r>
           </a:p>
         </p:txBody>
@@ -1221,7 +1222,7 @@
           <a:lstStyle/>
           <a:p>
             <a:r>
-              <a:t>エクスポートは export_onnx.py で、モード 3 のエンジン用 NHWC 版が推奨です。C# ビルダーは H×W×C の平坦配列を出すため、channels-first 版に入れるとチャネルが混ざり、スロットル 0.4・ステア 0.2 程度のほぼ一定出力に退化します。この症状は実際にデバッグで踏んだので、症状として覚えてください。トラックや観測を変えたらexport_track_json.py で C# 側の正解データを再生成し検証ハーネスを回します。レンジ等の定数は C# に意図的に複製されているので、変更時は 4 点セットを忘れずに。</a:t>
+              <a:t>使い方です。環境構築は 1 行。リポジトリ直下の requirements.txt は旧スタック用なので使いません。ノートブックは task2 が fast 専用、task3 が汎化学習。FAST_DEV_RUN で短縮と本番を切り替えます。学習の判断材料として、eval 報酬を周回数に換算するヤードスティックセルがあり、TensorBoard の数字だけで局所解か周回かを判別できます。スライドの図と動画を生成・保存するセルもノートブック内にあります。</a:t>
             </a:r>
           </a:p>
         </p:txBody>
@@ -1361,6 +1362,76 @@
           <a:lstStyle/>
           <a:p>
             <a:r>
+              <a:t>エクスポートは export_onnx.py で、モード 3 のエンジン用 NHWC 版が推奨です。C# ビルダーは H×W×C の平坦配列を出すため、channels-first 版に入れるとチャネルが混ざり、スロットル 0.4・ステア 0.2 程度のほぼ一定出力に退化します。この症状は実際にデバッグで踏んだので、症状として覚えてください。トラックや観測を変えたらexport_track_json.py で C# 側の正解データを再生成し検証ハーネスを回します。レンジ等の定数は C# に意図的に複製されているので、変更時は 4 点セットを忘れずに。</a:t>
+            </a:r>
+          </a:p>
+        </p:txBody>
+      </p:sp>
+      <p:sp>
+        <p:nvSpPr>
+          <p:cNvPr id="4" name="Slide Number Placeholder 3"/>
+          <p:cNvSpPr>
+            <a:spLocks noGrp="1"/>
+          </p:cNvSpPr>
+          <p:nvPr>
+            <p:ph type="sldNum" idx="5" sz="quarter"/>
+          </p:nvPr>
+        </p:nvSpPr>
+        <p:spPr/>
+      </p:sp>
+    </p:spTree>
+  </p:cSld>
+  <p:clrMapOvr>
+    <a:masterClrMapping/>
+  </p:clrMapOvr>
+</p:notes>
+</file>
+
+<file path=ppt/notesSlides/notesSlide21.xml><?xml version="1.0" encoding="utf-8"?>
+<p:notes xmlns:a="http://schemas.openxmlformats.org/drawingml/2006/main" xmlns:p="http://schemas.openxmlformats.org/presentationml/2006/main" xmlns:r="http://schemas.openxmlformats.org/officeDocument/2006/relationships">
+  <p:cSld>
+    <p:spTree>
+      <p:nvGrpSpPr>
+        <p:cNvPr id="1" name=""/>
+        <p:cNvGrpSpPr/>
+        <p:nvPr/>
+      </p:nvGrpSpPr>
+      <p:grpSpPr>
+        <a:xfrm>
+          <a:off x="0" y="0"/>
+          <a:ext cx="0" cy="0"/>
+          <a:chOff x="0" y="0"/>
+          <a:chExt cx="0" cy="0"/>
+        </a:xfrm>
+      </p:grpSpPr>
+      <p:sp>
+        <p:nvSpPr>
+          <p:cNvPr id="2" name="Slide Image Placeholder 1"/>
+          <p:cNvSpPr>
+            <a:spLocks noGrp="1"/>
+          </p:cNvSpPr>
+          <p:nvPr>
+            <p:ph type="sldImg" idx="2"/>
+          </p:nvPr>
+        </p:nvSpPr>
+        <p:spPr/>
+      </p:sp>
+      <p:sp>
+        <p:nvSpPr>
+          <p:cNvPr id="3" name="Notes Placeholder 2"/>
+          <p:cNvSpPr>
+            <a:spLocks noGrp="1"/>
+          </p:cNvSpPr>
+          <p:nvPr>
+            <p:ph type="body" idx="3" sz="quarter"/>
+          </p:nvPr>
+        </p:nvSpPr>
+        <p:spPr/>
+        <p:txBody>
+          <a:bodyPr/>
+          <a:lstStyle/>
+          <a:p>
+            <a:r>
               <a:t>まとめです。デフォルトのステア専用レーン追従環境に、行動・壁・報酬・観測・トラックの5 段階の進化を施し、抜け道を経済的に割に合わなくした結果、6 万ステップで周回を学習する環境になりました。汎化は自己位置を見せない観測設計の帰結です。実ゲームとのギャップは一覧化した上で、消せるものは数値一致移植で消し、残差はデプロイ側フィルタで吸収する二層戦略を取っています。次のステップは RE Engine 内での実走検証と、実測に基づく壁摩擦・動力学パラメータの適合です。ご清聴ありがとうございました。</a:t>
             </a:r>
           </a:p>
@@ -1851,7 +1922,7 @@
           <a:lstStyle/>
           <a:p>
             <a:r>
-              <a:t>第一の変更は行動空間です。連続スロットルとステアの 2 次元にし、動的 Bicycle モデルに切り替えました。ここで各レンジの意味を明確にしておきます。acceleration_range ±5 m/s² は方策の正規化出力 [−1,1] を実際の加速度に線形写像する係数です。steering_range ±π/6 は前輪舵角の上限で、最小旋回半径約 8 m を与え、最小コーナー半径 10 m に余裕を持って対応します。±5 という数字は実験で正当化しています。右のグラフの赤破線が ±2.5 m/s² 実験で、22 周までは学習するものの巡航が 10 m/s に頭打ちし終盤退行しました。原因は制動距離で、16 m/s から 2.5 m/s² では 51 m 必要ですが前方視野は 27 m しかない。「見えてから減速」が物理的に間に合わないのです。出力を絞るならブレーキだけ残す非対称 [−5, +2.5] を推奨します。</a:t>
+              <a:t>個別の説明に入る前に、変更点を一枚の表で俯瞰します。左が highway-env のデフォルト、真ん中が我々の設定、右がその狙いです。行動はステアのみから連続スロットル＋ステアへ、車両は運動学から動的モデルへ。速度目標は 10 から 16 m/s に上げ前進報酬を足して『速く走る』動機を作りました。壁は存在しないデフォルトに対し、外周のみ物理的な停止壁と摩擦を導入。報酬は中央維持だけの薄い信号から、速度・前進・周回を含む密な設計に。観測は 2 チャネルから 10 チャネルへ拡張し視野も前方に伸ばしました。トラックは単一から 5 種＋ランダムへ。以降のスライドはこの表の各行を一つずつ掘り下げ、変更の理由と実測で確認した副作用を説明します。</a:t>
             </a:r>
           </a:p>
         </p:txBody>
@@ -4960,7 +5031,7 @@
                 </a:solidFill>
                 <a:latin typeface="Meiryo"/>
               </a:rPr>
-              <a:t>進化 (2) 壁の物理 — なし → 反発 → 停止</a:t>
+              <a:t>進化 (1) 行動と車両 — スロットルの導入と制御量の設計</a:t>
             </a:r>
           </a:p>
         </p:txBody>
@@ -4993,13 +5064,13 @@
               </a:spcAft>
             </a:pPr>
             <a:r>
-              <a:rPr sz="1500" b="1">
+              <a:rPr sz="1600" b="1">
                 <a:solidFill>
                   <a:srgbClr val="222222"/>
                 </a:solidFill>
                 <a:latin typeface="Meiryo"/>
               </a:rPr>
-              <a:t>変遷と各段階の失敗</a:t>
+              <a:t>変更: ステアのみ → 連続 (スロットル, ステア)、dynamical=True (タイヤスリップ)</a:t>
             </a:r>
           </a:p>
           <a:p>
@@ -5009,13 +5080,13 @@
               </a:spcAft>
             </a:pPr>
             <a:r>
-              <a:rPr sz="1300" b="0">
+              <a:rPr sz="1400" b="0">
                 <a:solidFill>
                   <a:srgbClr val="595959"/>
                 </a:solidFill>
                 <a:latin typeface="Meiryo"/>
               </a:rPr>
-              <a:t>・v0 壁なし (デフォルト): 路外ショートカットを学習</a:t>
+              <a:t>・acceleration_range ±5 m/s²: 方策出力 [−1,1] → 加速度への写像係数</a:t>
             </a:r>
           </a:p>
           <a:p>
@@ -5025,13 +5096,13 @@
               </a:spcAft>
             </a:pPr>
             <a:r>
-              <a:rPr sz="1300" b="0">
-                <a:solidFill>
-                  <a:srgbClr val="B32D2D"/>
-                </a:solidFill>
-                <a:latin typeface="Meiryo"/>
-              </a:rPr>
-              <a:t>・v1 反発壁 (bounce): wall-riding — 壁が方向転換を代行し最速解に</a:t>
+              <a:rPr sz="1400" b="0">
+                <a:solidFill>
+                  <a:srgbClr val="595959"/>
+                </a:solidFill>
+                <a:latin typeface="Meiryo"/>
+              </a:rPr>
+              <a:t>・steering_range ±π/6 (30°): 前輪舵角上限 → 最小旋回半径 ≈ 8 m &lt; コーナー最小 10 m</a:t>
             </a:r>
           </a:p>
           <a:p>
@@ -5041,129 +5112,41 @@
               </a:spcAft>
             </a:pPr>
             <a:r>
-              <a:rPr sz="1300" b="1">
+              <a:rPr sz="1400" b="0">
                 <a:solidFill>
                   <a:srgbClr val="595959"/>
                 </a:solidFill>
                 <a:latin typeface="Meiryo"/>
               </a:rPr>
-              <a:t>・v2 停止壁 (stop): 接触で停止、バックのみで脱出可 — ゲーム物理と一致</a:t>
-            </a:r>
-          </a:p>
-          <a:p>
-            <a:pPr>
-              <a:spcAft>
-                <a:spcPts val="600"/>
-              </a:spcAft>
-            </a:pPr>
-            <a:r>
-              <a:rPr sz="1500" b="1">
-                <a:solidFill>
-                  <a:srgbClr val="222222"/>
-                </a:solidFill>
-                <a:latin typeface="Meiryo"/>
-              </a:rPr>
-              <a:t>抜け道の遮断</a:t>
-            </a:r>
-          </a:p>
-          <a:p>
-            <a:pPr lvl="1">
-              <a:spcAft>
-                <a:spcPts val="200"/>
-              </a:spcAft>
-            </a:pPr>
-            <a:r>
-              <a:rPr sz="1300" b="0">
-                <a:solidFill>
-                  <a:srgbClr val="595959"/>
-                </a:solidFill>
-                <a:latin typeface="Meiryo"/>
-              </a:rPr>
-              <a:t>・壁接触中は速度・前進報酬をゼロ化 (wall-riding の収益を絶つ)</a:t>
-            </a:r>
-          </a:p>
-          <a:p>
-            <a:pPr lvl="1">
-              <a:spcAft>
-                <a:spcPts val="200"/>
-              </a:spcAft>
-            </a:pPr>
-            <a:r>
-              <a:rPr sz="1300" b="0">
-                <a:solidFill>
-                  <a:srgbClr val="595959"/>
-                </a:solidFill>
-                <a:latin typeface="Meiryo"/>
-              </a:rPr>
-              <a:t>・接触 35 ステップ (7 秒) 継続でクラッシュ扱い終了 (壁沿い周回の禁止)</a:t>
-            </a:r>
-          </a:p>
-          <a:p>
-            <a:pPr lvl="1">
-              <a:spcAft>
-                <a:spcPts val="200"/>
-              </a:spcAft>
-            </a:pPr>
-            <a:r>
-              <a:rPr sz="1300" b="0">
-                <a:solidFill>
-                  <a:srgbClr val="595959"/>
-                </a:solidFill>
-                <a:latin typeface="Meiryo"/>
-              </a:rPr>
-              <a:t>・壁摩擦 0.6: 接線速度を物理フレーム毎に減衰 — 擦っても速度が残らない</a:t>
-            </a:r>
-          </a:p>
-          <a:p>
-            <a:pPr>
-              <a:spcAft>
-                <a:spcPts val="600"/>
-              </a:spcAft>
-            </a:pPr>
-            <a:r>
-              <a:rPr sz="1500" b="1">
-                <a:solidFill>
-                  <a:srgbClr val="222222"/>
-                </a:solidFill>
-                <a:latin typeface="Meiryo"/>
-              </a:rPr>
-              <a:t>壁の定義</a:t>
-            </a:r>
-          </a:p>
-          <a:p>
-            <a:pPr lvl="1">
-              <a:spcAft>
-                <a:spcPts val="200"/>
-              </a:spcAft>
-            </a:pPr>
-            <a:r>
-              <a:rPr sz="1300" b="1">
-                <a:solidFill>
-                  <a:srgbClr val="595959"/>
-                </a:solidFill>
-                <a:latin typeface="Meiryo"/>
-              </a:rPr>
-              <a:t>・コース外周のみが壁。車線境界の白線は壁ではない (2 車線を使うライン取りを許す)</a:t>
-            </a:r>
-          </a:p>
-          <a:p>
-            <a:pPr lvl="2">
-              <a:spcAft>
-                <a:spcPts val="200"/>
-              </a:spcAft>
-            </a:pPr>
-            <a:r>
-              <a:rPr sz="1100" b="0">
-                <a:solidFill>
-                  <a:srgbClr val="595959"/>
-                </a:solidFill>
-                <a:latin typeface="Meiryo"/>
-              </a:rPr>
-              <a:t>− 初期実装は車線単位判定で白線が壁化するバグ → コリドー両端判定に修正</a:t>
-            </a:r>
-          </a:p>
-        </p:txBody>
-      </p:sp>
+              <a:t>・speed_limit 16 m/s + 前進速度報酬 — 「速く走る」動機を導入</a:t>
+            </a:r>
+          </a:p>
+        </p:txBody>
+      </p:sp>
+      <p:pic>
+        <p:nvPicPr>
+          <p:cNvPr id="4" name="Picture 3" descr="range_experiment.png"/>
+          <p:cNvPicPr>
+            <a:picLocks noChangeAspect="1"/>
+          </p:cNvPicPr>
+          <p:nvPr/>
+        </p:nvPicPr>
+        <p:blipFill>
+          <a:blip r:embed="rId3"/>
+          <a:stretch>
+            <a:fillRect/>
+          </a:stretch>
+        </p:blipFill>
+        <p:spPr>
+          <a:xfrm>
+            <a:off x="3108960" y="2651760"/>
+            <a:ext cx="5852160" cy="3121152"/>
+          </a:xfrm>
+          <a:prstGeom prst="rect">
+            <a:avLst/>
+          </a:prstGeom>
+        </p:spPr>
+      </p:pic>
     </p:spTree>
   </p:cSld>
   <p:clrMapOvr>
@@ -5173,6 +5156,257 @@
 </file>
 
 <file path=ppt/slides/slide11.xml><?xml version="1.0" encoding="utf-8"?>
+<p:sld xmlns:a="http://schemas.openxmlformats.org/drawingml/2006/main" xmlns:p="http://schemas.openxmlformats.org/presentationml/2006/main" xmlns:r="http://schemas.openxmlformats.org/officeDocument/2006/relationships">
+  <p:cSld>
+    <p:spTree>
+      <p:nvGrpSpPr>
+        <p:cNvPr id="1" name=""/>
+        <p:cNvGrpSpPr/>
+        <p:nvPr/>
+      </p:nvGrpSpPr>
+      <p:grpSpPr/>
+      <p:sp>
+        <p:nvSpPr>
+          <p:cNvPr id="2" name="TextBox 1"/>
+          <p:cNvSpPr txBox="1"/>
+          <p:nvPr/>
+        </p:nvSpPr>
+        <p:spPr>
+          <a:xfrm>
+            <a:off x="457200" y="182880"/>
+            <a:ext cx="11247120" cy="731520"/>
+          </a:xfrm>
+          <a:prstGeom prst="rect">
+            <a:avLst/>
+          </a:prstGeom>
+          <a:noFill/>
+        </p:spPr>
+        <p:txBody>
+          <a:bodyPr wrap="none">
+            <a:spAutoFit/>
+          </a:bodyPr>
+          <a:lstStyle/>
+          <a:p>
+            <a:r>
+              <a:rPr sz="2700" b="1">
+                <a:solidFill>
+                  <a:srgbClr val="1B5EA8"/>
+                </a:solidFill>
+                <a:latin typeface="Meiryo"/>
+              </a:rPr>
+              <a:t>進化 (2) 壁の物理 — なし → 反発 → 停止</a:t>
+            </a:r>
+          </a:p>
+        </p:txBody>
+      </p:sp>
+      <p:sp>
+        <p:nvSpPr>
+          <p:cNvPr id="3" name="TextBox 2"/>
+          <p:cNvSpPr txBox="1"/>
+          <p:nvPr/>
+        </p:nvSpPr>
+        <p:spPr>
+          <a:xfrm>
+            <a:off x="548640" y="1097280"/>
+            <a:ext cx="11064240" cy="5486400"/>
+          </a:xfrm>
+          <a:prstGeom prst="rect">
+            <a:avLst/>
+          </a:prstGeom>
+          <a:noFill/>
+        </p:spPr>
+        <p:txBody>
+          <a:bodyPr wrap="square">
+            <a:spAutoFit/>
+          </a:bodyPr>
+          <a:lstStyle/>
+          <a:p>
+            <a:pPr>
+              <a:spcAft>
+                <a:spcPts val="600"/>
+              </a:spcAft>
+            </a:pPr>
+            <a:r>
+              <a:rPr sz="1500" b="1">
+                <a:solidFill>
+                  <a:srgbClr val="222222"/>
+                </a:solidFill>
+                <a:latin typeface="Meiryo"/>
+              </a:rPr>
+              <a:t>変遷と各段階の失敗</a:t>
+            </a:r>
+          </a:p>
+          <a:p>
+            <a:pPr lvl="1">
+              <a:spcAft>
+                <a:spcPts val="200"/>
+              </a:spcAft>
+            </a:pPr>
+            <a:r>
+              <a:rPr sz="1300" b="0">
+                <a:solidFill>
+                  <a:srgbClr val="595959"/>
+                </a:solidFill>
+                <a:latin typeface="Meiryo"/>
+              </a:rPr>
+              <a:t>・v0 壁なし (デフォルト): 路外ショートカットを学習</a:t>
+            </a:r>
+          </a:p>
+          <a:p>
+            <a:pPr lvl="1">
+              <a:spcAft>
+                <a:spcPts val="200"/>
+              </a:spcAft>
+            </a:pPr>
+            <a:r>
+              <a:rPr sz="1300" b="0">
+                <a:solidFill>
+                  <a:srgbClr val="B32D2D"/>
+                </a:solidFill>
+                <a:latin typeface="Meiryo"/>
+              </a:rPr>
+              <a:t>・v1 反発壁 (bounce): wall-riding — 壁が方向転換を代行し最速解に</a:t>
+            </a:r>
+          </a:p>
+          <a:p>
+            <a:pPr lvl="1">
+              <a:spcAft>
+                <a:spcPts val="200"/>
+              </a:spcAft>
+            </a:pPr>
+            <a:r>
+              <a:rPr sz="1300" b="1">
+                <a:solidFill>
+                  <a:srgbClr val="595959"/>
+                </a:solidFill>
+                <a:latin typeface="Meiryo"/>
+              </a:rPr>
+              <a:t>・v2 停止壁 (stop): 接触で停止、バックのみで脱出可 — ゲーム物理と一致</a:t>
+            </a:r>
+          </a:p>
+          <a:p>
+            <a:pPr>
+              <a:spcAft>
+                <a:spcPts val="600"/>
+              </a:spcAft>
+            </a:pPr>
+            <a:r>
+              <a:rPr sz="1500" b="1">
+                <a:solidFill>
+                  <a:srgbClr val="222222"/>
+                </a:solidFill>
+                <a:latin typeface="Meiryo"/>
+              </a:rPr>
+              <a:t>抜け道の遮断</a:t>
+            </a:r>
+          </a:p>
+          <a:p>
+            <a:pPr lvl="1">
+              <a:spcAft>
+                <a:spcPts val="200"/>
+              </a:spcAft>
+            </a:pPr>
+            <a:r>
+              <a:rPr sz="1300" b="0">
+                <a:solidFill>
+                  <a:srgbClr val="595959"/>
+                </a:solidFill>
+                <a:latin typeface="Meiryo"/>
+              </a:rPr>
+              <a:t>・壁接触中は速度・前進報酬をゼロ化 (wall-riding の収益を絶つ)</a:t>
+            </a:r>
+          </a:p>
+          <a:p>
+            <a:pPr lvl="1">
+              <a:spcAft>
+                <a:spcPts val="200"/>
+              </a:spcAft>
+            </a:pPr>
+            <a:r>
+              <a:rPr sz="1300" b="0">
+                <a:solidFill>
+                  <a:srgbClr val="595959"/>
+                </a:solidFill>
+                <a:latin typeface="Meiryo"/>
+              </a:rPr>
+              <a:t>・接触 35 ステップ (7 秒) 継続でクラッシュ扱い終了 (壁沿い周回の禁止)</a:t>
+            </a:r>
+          </a:p>
+          <a:p>
+            <a:pPr lvl="1">
+              <a:spcAft>
+                <a:spcPts val="200"/>
+              </a:spcAft>
+            </a:pPr>
+            <a:r>
+              <a:rPr sz="1300" b="0">
+                <a:solidFill>
+                  <a:srgbClr val="595959"/>
+                </a:solidFill>
+                <a:latin typeface="Meiryo"/>
+              </a:rPr>
+              <a:t>・壁摩擦 0.6: 接線速度を物理フレーム毎に減衰 — 擦っても速度が残らない</a:t>
+            </a:r>
+          </a:p>
+          <a:p>
+            <a:pPr>
+              <a:spcAft>
+                <a:spcPts val="600"/>
+              </a:spcAft>
+            </a:pPr>
+            <a:r>
+              <a:rPr sz="1500" b="1">
+                <a:solidFill>
+                  <a:srgbClr val="222222"/>
+                </a:solidFill>
+                <a:latin typeface="Meiryo"/>
+              </a:rPr>
+              <a:t>壁の定義</a:t>
+            </a:r>
+          </a:p>
+          <a:p>
+            <a:pPr lvl="1">
+              <a:spcAft>
+                <a:spcPts val="200"/>
+              </a:spcAft>
+            </a:pPr>
+            <a:r>
+              <a:rPr sz="1300" b="1">
+                <a:solidFill>
+                  <a:srgbClr val="595959"/>
+                </a:solidFill>
+                <a:latin typeface="Meiryo"/>
+              </a:rPr>
+              <a:t>・コース外周のみが壁。車線境界の白線は壁ではない (2 車線を使うライン取りを許す)</a:t>
+            </a:r>
+          </a:p>
+          <a:p>
+            <a:pPr lvl="2">
+              <a:spcAft>
+                <a:spcPts val="200"/>
+              </a:spcAft>
+            </a:pPr>
+            <a:r>
+              <a:rPr sz="1100" b="0">
+                <a:solidFill>
+                  <a:srgbClr val="595959"/>
+                </a:solidFill>
+                <a:latin typeface="Meiryo"/>
+              </a:rPr>
+              <a:t>− 初期実装は車線単位判定で白線が壁化するバグ → コリドー両端判定に修正</a:t>
+            </a:r>
+          </a:p>
+        </p:txBody>
+      </p:sp>
+    </p:spTree>
+  </p:cSld>
+  <p:clrMapOvr>
+    <a:masterClrMapping/>
+  </p:clrMapOvr>
+</p:sld>
+</file>
+
+<file path=ppt/slides/slide12.xml><?xml version="1.0" encoding="utf-8"?>
 <p:sld xmlns:a="http://schemas.openxmlformats.org/drawingml/2006/main" xmlns:p="http://schemas.openxmlformats.org/presentationml/2006/main" xmlns:r="http://schemas.openxmlformats.org/officeDocument/2006/relationships">
   <p:cSld>
     <p:spTree>
@@ -5431,7 +5665,7 @@
 </p:sld>
 </file>
 
-<file path=ppt/slides/slide12.xml><?xml version="1.0" encoding="utf-8"?>
+<file path=ppt/slides/slide13.xml><?xml version="1.0" encoding="utf-8"?>
 <p:sld xmlns:a="http://schemas.openxmlformats.org/drawingml/2006/main" xmlns:p="http://schemas.openxmlformats.org/presentationml/2006/main" xmlns:r="http://schemas.openxmlformats.org/officeDocument/2006/relationships">
   <p:cSld>
     <p:spTree>
@@ -5658,7 +5892,7 @@
 </p:sld>
 </file>
 
-<file path=ppt/slides/slide13.xml><?xml version="1.0" encoding="utf-8"?>
+<file path=ppt/slides/slide14.xml><?xml version="1.0" encoding="utf-8"?>
 <p:sld xmlns:a="http://schemas.openxmlformats.org/drawingml/2006/main" xmlns:p="http://schemas.openxmlformats.org/presentationml/2006/main" xmlns:r="http://schemas.openxmlformats.org/officeDocument/2006/relationships">
   <p:cSld>
     <p:spTree>
@@ -5773,7 +6007,7 @@
 </p:sld>
 </file>
 
-<file path=ppt/slides/slide14.xml><?xml version="1.0" encoding="utf-8"?>
+<file path=ppt/slides/slide15.xml><?xml version="1.0" encoding="utf-8"?>
 <p:sld xmlns:a="http://schemas.openxmlformats.org/drawingml/2006/main" xmlns:p="http://schemas.openxmlformats.org/presentationml/2006/main" xmlns:r="http://schemas.openxmlformats.org/officeDocument/2006/relationships">
   <p:cSld>
     <p:spTree>
@@ -5996,209 +6230,6 @@
                 <a:latin typeface="Meiryo"/>
               </a:rPr>
               <a:t>・EvalCallback の決定論的評価ベスト採用 (PPO は終盤退行あり / stochastic 評価は過小評価)</a:t>
-            </a:r>
-          </a:p>
-        </p:txBody>
-      </p:sp>
-    </p:spTree>
-  </p:cSld>
-  <p:clrMapOvr>
-    <a:masterClrMapping/>
-  </p:clrMapOvr>
-</p:sld>
-</file>
-
-<file path=ppt/slides/slide15.xml><?xml version="1.0" encoding="utf-8"?>
-<p:sld xmlns:a="http://schemas.openxmlformats.org/drawingml/2006/main" xmlns:p="http://schemas.openxmlformats.org/presentationml/2006/main" xmlns:r="http://schemas.openxmlformats.org/officeDocument/2006/relationships">
-  <p:cSld>
-    <p:spTree>
-      <p:nvGrpSpPr>
-        <p:cNvPr id="1" name=""/>
-        <p:cNvGrpSpPr/>
-        <p:nvPr/>
-      </p:nvGrpSpPr>
-      <p:grpSpPr/>
-      <p:sp>
-        <p:nvSpPr>
-          <p:cNvPr id="2" name="TextBox 1"/>
-          <p:cNvSpPr txBox="1"/>
-          <p:nvPr/>
-        </p:nvSpPr>
-        <p:spPr>
-          <a:xfrm>
-            <a:off x="457200" y="182880"/>
-            <a:ext cx="11247120" cy="731520"/>
-          </a:xfrm>
-          <a:prstGeom prst="rect">
-            <a:avLst/>
-          </a:prstGeom>
-          <a:noFill/>
-        </p:spPr>
-        <p:txBody>
-          <a:bodyPr wrap="none">
-            <a:spAutoFit/>
-          </a:bodyPr>
-          <a:lstStyle/>
-          <a:p>
-            <a:r>
-              <a:rPr sz="2700" b="1">
-                <a:solidFill>
-                  <a:srgbClr val="1B5EA8"/>
-                </a:solidFill>
-                <a:latin typeface="Meiryo"/>
-              </a:rPr>
-              <a:t>PPO ハイパーパラメータの設計判断 (専門家向け)</a:t>
-            </a:r>
-          </a:p>
-        </p:txBody>
-      </p:sp>
-      <p:sp>
-        <p:nvSpPr>
-          <p:cNvPr id="3" name="TextBox 2"/>
-          <p:cNvSpPr txBox="1"/>
-          <p:nvPr/>
-        </p:nvSpPr>
-        <p:spPr>
-          <a:xfrm>
-            <a:off x="548640" y="1188720"/>
-            <a:ext cx="11064240" cy="5486400"/>
-          </a:xfrm>
-          <a:prstGeom prst="rect">
-            <a:avLst/>
-          </a:prstGeom>
-          <a:noFill/>
-        </p:spPr>
-        <p:txBody>
-          <a:bodyPr wrap="square">
-            <a:spAutoFit/>
-          </a:bodyPr>
-          <a:lstStyle/>
-          <a:p>
-            <a:pPr>
-              <a:spcAft>
-                <a:spcPts val="600"/>
-              </a:spcAft>
-            </a:pPr>
-            <a:r>
-              <a:rPr sz="1600" b="1">
-                <a:solidFill>
-                  <a:srgbClr val="222222"/>
-                </a:solidFill>
-                <a:latin typeface="Meiryo"/>
-              </a:rPr>
-              <a:t>アルゴリズム選択</a:t>
-            </a:r>
-          </a:p>
-          <a:p>
-            <a:pPr lvl="1">
-              <a:spcAft>
-                <a:spcPts val="200"/>
-              </a:spcAft>
-            </a:pPr>
-            <a:r>
-              <a:rPr sz="1400" b="0">
-                <a:solidFill>
-                  <a:srgbClr val="595959"/>
-                </a:solidFill>
-                <a:latin typeface="Meiryo"/>
-              </a:rPr>
-              <a:t>・オンポリシー (PPO): 環境改造が頻繁 → 古い経験が即無効 / sim 軽量で wall-clock 優位</a:t>
-            </a:r>
-          </a:p>
-          <a:p>
-            <a:pPr>
-              <a:spcAft>
-                <a:spcPts val="600"/>
-              </a:spcAft>
-            </a:pPr>
-            <a:r>
-              <a:rPr sz="1600" b="1">
-                <a:solidFill>
-                  <a:srgbClr val="222222"/>
-                </a:solidFill>
-                <a:latin typeface="Meiryo"/>
-              </a:rPr>
-              <a:t>主要ハイパラ</a:t>
-            </a:r>
-          </a:p>
-          <a:p>
-            <a:pPr lvl="1">
-              <a:spcAft>
-                <a:spcPts val="200"/>
-              </a:spcAft>
-            </a:pPr>
-            <a:r>
-              <a:rPr sz="1400" b="0">
-                <a:solidFill>
-                  <a:srgbClr val="595959"/>
-                </a:solidFill>
-                <a:latin typeface="Meiryo"/>
-              </a:rPr>
-              <a:t>・clip ε 0.15 (&lt;0.2): 高分散アドバンテージ下の方策崩壊を抑制</a:t>
-            </a:r>
-          </a:p>
-          <a:p>
-            <a:pPr lvl="1">
-              <a:spcAft>
-                <a:spcPts val="200"/>
-              </a:spcAft>
-            </a:pPr>
-            <a:r>
-              <a:rPr sz="1400" b="0">
-                <a:solidFill>
-                  <a:srgbClr val="595959"/>
-                </a:solidFill>
-                <a:latin typeface="Meiryo"/>
-              </a:rPr>
-              <a:t>・γ 0.99 / GAE λ 0.98 / n_steps 512×8env / minibatch 256 / 8〜15 epochs / linear LR decay</a:t>
-            </a:r>
-          </a:p>
-          <a:p>
-            <a:pPr lvl="1">
-              <a:spcAft>
-                <a:spcPts val="200"/>
-              </a:spcAft>
-            </a:pPr>
-            <a:r>
-              <a:rPr sz="1400" b="1">
-                <a:solidFill>
-                  <a:srgbClr val="595959"/>
-                </a:solidFill>
-                <a:latin typeface="Meiryo"/>
-              </a:rPr>
-              <a:t>・ent_coef 0.02: [0,1] 圧縮報酬との結合に注意 (0.10 は実質ランダム方策に収束)</a:t>
-            </a:r>
-          </a:p>
-          <a:p>
-            <a:pPr>
-              <a:spcAft>
-                <a:spcPts val="600"/>
-              </a:spcAft>
-            </a:pPr>
-            <a:r>
-              <a:rPr sz="1600" b="1">
-                <a:solidFill>
-                  <a:srgbClr val="222222"/>
-                </a:solidFill>
-                <a:latin typeface="Meiryo"/>
-              </a:rPr>
-              <a:t>備考</a:t>
-            </a:r>
-          </a:p>
-          <a:p>
-            <a:pPr lvl="1">
-              <a:spcAft>
-                <a:spcPts val="200"/>
-              </a:spcAft>
-            </a:pPr>
-            <a:r>
-              <a:rPr sz="1400" b="0">
-                <a:solidFill>
-                  <a:srgbClr val="595959"/>
-                </a:solidFill>
-                <a:latin typeface="Meiryo"/>
-              </a:rPr>
-              <a:t>・アドバンテージ正規化 → 報酬のアフィン変換に不変。[0,1] 化は診断用の設計</a:t>
             </a:r>
           </a:p>
         </p:txBody>
@@ -6250,6 +6281,209 @@
                 </a:solidFill>
                 <a:latin typeface="Meiryo"/>
               </a:rPr>
+              <a:t>PPO ハイパーパラメータの設計判断 (専門家向け)</a:t>
+            </a:r>
+          </a:p>
+        </p:txBody>
+      </p:sp>
+      <p:sp>
+        <p:nvSpPr>
+          <p:cNvPr id="3" name="TextBox 2"/>
+          <p:cNvSpPr txBox="1"/>
+          <p:nvPr/>
+        </p:nvSpPr>
+        <p:spPr>
+          <a:xfrm>
+            <a:off x="548640" y="1188720"/>
+            <a:ext cx="11064240" cy="5486400"/>
+          </a:xfrm>
+          <a:prstGeom prst="rect">
+            <a:avLst/>
+          </a:prstGeom>
+          <a:noFill/>
+        </p:spPr>
+        <p:txBody>
+          <a:bodyPr wrap="square">
+            <a:spAutoFit/>
+          </a:bodyPr>
+          <a:lstStyle/>
+          <a:p>
+            <a:pPr>
+              <a:spcAft>
+                <a:spcPts val="600"/>
+              </a:spcAft>
+            </a:pPr>
+            <a:r>
+              <a:rPr sz="1600" b="1">
+                <a:solidFill>
+                  <a:srgbClr val="222222"/>
+                </a:solidFill>
+                <a:latin typeface="Meiryo"/>
+              </a:rPr>
+              <a:t>アルゴリズム選択</a:t>
+            </a:r>
+          </a:p>
+          <a:p>
+            <a:pPr lvl="1">
+              <a:spcAft>
+                <a:spcPts val="200"/>
+              </a:spcAft>
+            </a:pPr>
+            <a:r>
+              <a:rPr sz="1400" b="0">
+                <a:solidFill>
+                  <a:srgbClr val="595959"/>
+                </a:solidFill>
+                <a:latin typeface="Meiryo"/>
+              </a:rPr>
+              <a:t>・オンポリシー (PPO): 環境改造が頻繁 → 古い経験が即無効 / sim 軽量で wall-clock 優位</a:t>
+            </a:r>
+          </a:p>
+          <a:p>
+            <a:pPr>
+              <a:spcAft>
+                <a:spcPts val="600"/>
+              </a:spcAft>
+            </a:pPr>
+            <a:r>
+              <a:rPr sz="1600" b="1">
+                <a:solidFill>
+                  <a:srgbClr val="222222"/>
+                </a:solidFill>
+                <a:latin typeface="Meiryo"/>
+              </a:rPr>
+              <a:t>主要ハイパラ</a:t>
+            </a:r>
+          </a:p>
+          <a:p>
+            <a:pPr lvl="1">
+              <a:spcAft>
+                <a:spcPts val="200"/>
+              </a:spcAft>
+            </a:pPr>
+            <a:r>
+              <a:rPr sz="1400" b="0">
+                <a:solidFill>
+                  <a:srgbClr val="595959"/>
+                </a:solidFill>
+                <a:latin typeface="Meiryo"/>
+              </a:rPr>
+              <a:t>・clip ε 0.15 (&lt;0.2): 高分散アドバンテージ下の方策崩壊を抑制</a:t>
+            </a:r>
+          </a:p>
+          <a:p>
+            <a:pPr lvl="1">
+              <a:spcAft>
+                <a:spcPts val="200"/>
+              </a:spcAft>
+            </a:pPr>
+            <a:r>
+              <a:rPr sz="1400" b="0">
+                <a:solidFill>
+                  <a:srgbClr val="595959"/>
+                </a:solidFill>
+                <a:latin typeface="Meiryo"/>
+              </a:rPr>
+              <a:t>・γ 0.99 / GAE λ 0.98 / n_steps 512×8env / minibatch 256 / 8〜15 epochs / linear LR decay</a:t>
+            </a:r>
+          </a:p>
+          <a:p>
+            <a:pPr lvl="1">
+              <a:spcAft>
+                <a:spcPts val="200"/>
+              </a:spcAft>
+            </a:pPr>
+            <a:r>
+              <a:rPr sz="1400" b="1">
+                <a:solidFill>
+                  <a:srgbClr val="595959"/>
+                </a:solidFill>
+                <a:latin typeface="Meiryo"/>
+              </a:rPr>
+              <a:t>・ent_coef 0.02: [0,1] 圧縮報酬との結合に注意 (0.10 は実質ランダム方策に収束)</a:t>
+            </a:r>
+          </a:p>
+          <a:p>
+            <a:pPr>
+              <a:spcAft>
+                <a:spcPts val="600"/>
+              </a:spcAft>
+            </a:pPr>
+            <a:r>
+              <a:rPr sz="1600" b="1">
+                <a:solidFill>
+                  <a:srgbClr val="222222"/>
+                </a:solidFill>
+                <a:latin typeface="Meiryo"/>
+              </a:rPr>
+              <a:t>備考</a:t>
+            </a:r>
+          </a:p>
+          <a:p>
+            <a:pPr lvl="1">
+              <a:spcAft>
+                <a:spcPts val="200"/>
+              </a:spcAft>
+            </a:pPr>
+            <a:r>
+              <a:rPr sz="1400" b="0">
+                <a:solidFill>
+                  <a:srgbClr val="595959"/>
+                </a:solidFill>
+                <a:latin typeface="Meiryo"/>
+              </a:rPr>
+              <a:t>・アドバンテージ正規化 → 報酬のアフィン変換に不変。[0,1] 化は診断用の設計</a:t>
+            </a:r>
+          </a:p>
+        </p:txBody>
+      </p:sp>
+    </p:spTree>
+  </p:cSld>
+  <p:clrMapOvr>
+    <a:masterClrMapping/>
+  </p:clrMapOvr>
+</p:sld>
+</file>
+
+<file path=ppt/slides/slide17.xml><?xml version="1.0" encoding="utf-8"?>
+<p:sld xmlns:a="http://schemas.openxmlformats.org/drawingml/2006/main" xmlns:p="http://schemas.openxmlformats.org/presentationml/2006/main" xmlns:r="http://schemas.openxmlformats.org/officeDocument/2006/relationships">
+  <p:cSld>
+    <p:spTree>
+      <p:nvGrpSpPr>
+        <p:cNvPr id="1" name=""/>
+        <p:cNvGrpSpPr/>
+        <p:nvPr/>
+      </p:nvGrpSpPr>
+      <p:grpSpPr/>
+      <p:sp>
+        <p:nvSpPr>
+          <p:cNvPr id="2" name="TextBox 1"/>
+          <p:cNvSpPr txBox="1"/>
+          <p:nvPr/>
+        </p:nvSpPr>
+        <p:spPr>
+          <a:xfrm>
+            <a:off x="457200" y="182880"/>
+            <a:ext cx="11247120" cy="731520"/>
+          </a:xfrm>
+          <a:prstGeom prst="rect">
+            <a:avLst/>
+          </a:prstGeom>
+          <a:noFill/>
+        </p:spPr>
+        <p:txBody>
+          <a:bodyPr wrap="none">
+            <a:spAutoFit/>
+          </a:bodyPr>
+          <a:lstStyle/>
+          <a:p>
+            <a:r>
+              <a:rPr sz="2700" b="1">
+                <a:solidFill>
+                  <a:srgbClr val="1B5EA8"/>
+                </a:solidFill>
+                <a:latin typeface="Meiryo"/>
+              </a:rPr>
               <a:t>実ゲームとのギャップ — シミュレーションが省いているもの</a:t>
             </a:r>
           </a:p>
@@ -6446,7 +6680,7 @@
 </p:sld>
 </file>
 
-<file path=ppt/slides/slide17.xml><?xml version="1.0" encoding="utf-8"?>
+<file path=ppt/slides/slide18.xml><?xml version="1.0" encoding="utf-8"?>
 <p:sld xmlns:a="http://schemas.openxmlformats.org/drawingml/2006/main" xmlns:p="http://schemas.openxmlformats.org/presentationml/2006/main" xmlns:r="http://schemas.openxmlformats.org/officeDocument/2006/relationships">
   <p:cSld>
     <p:spTree>
@@ -6673,7 +6907,7 @@
 </p:sld>
 </file>
 
-<file path=ppt/slides/slide18.xml><?xml version="1.0" encoding="utf-8"?>
+<file path=ppt/slides/slide19.xml><?xml version="1.0" encoding="utf-8"?>
 <p:sld xmlns:a="http://schemas.openxmlformats.org/drawingml/2006/main" xmlns:p="http://schemas.openxmlformats.org/presentationml/2006/main" xmlns:r="http://schemas.openxmlformats.org/officeDocument/2006/relationships">
   <p:cSld>
     <p:spTree>
@@ -6896,257 +7130,6 @@
                 <a:latin typeface="Meiryo"/>
               </a:rPr>
               <a:t>C# 検証: cd re_engine/verify &amp;&amp; dotnet run -- ..  → ALL SCENARIOS MATCH</a:t>
-            </a:r>
-          </a:p>
-        </p:txBody>
-      </p:sp>
-    </p:spTree>
-  </p:cSld>
-  <p:clrMapOvr>
-    <a:masterClrMapping/>
-  </p:clrMapOvr>
-</p:sld>
-</file>
-
-<file path=ppt/slides/slide19.xml><?xml version="1.0" encoding="utf-8"?>
-<p:sld xmlns:a="http://schemas.openxmlformats.org/drawingml/2006/main" xmlns:p="http://schemas.openxmlformats.org/presentationml/2006/main" xmlns:r="http://schemas.openxmlformats.org/officeDocument/2006/relationships">
-  <p:cSld>
-    <p:spTree>
-      <p:nvGrpSpPr>
-        <p:cNvPr id="1" name=""/>
-        <p:cNvGrpSpPr/>
-        <p:nvPr/>
-      </p:nvGrpSpPr>
-      <p:grpSpPr/>
-      <p:sp>
-        <p:nvSpPr>
-          <p:cNvPr id="2" name="TextBox 1"/>
-          <p:cNvSpPr txBox="1"/>
-          <p:nvPr/>
-        </p:nvSpPr>
-        <p:spPr>
-          <a:xfrm>
-            <a:off x="457200" y="182880"/>
-            <a:ext cx="11247120" cy="731520"/>
-          </a:xfrm>
-          <a:prstGeom prst="rect">
-            <a:avLst/>
-          </a:prstGeom>
-          <a:noFill/>
-        </p:spPr>
-        <p:txBody>
-          <a:bodyPr wrap="none">
-            <a:spAutoFit/>
-          </a:bodyPr>
-          <a:lstStyle/>
-          <a:p>
-            <a:r>
-              <a:rPr sz="2700" b="1">
-                <a:solidFill>
-                  <a:srgbClr val="1B5EA8"/>
-                </a:solidFill>
-                <a:latin typeface="Meiryo"/>
-              </a:rPr>
-              <a:t>エクスポートツールと ONNX の注意点</a:t>
-            </a:r>
-          </a:p>
-        </p:txBody>
-      </p:sp>
-      <p:sp>
-        <p:nvSpPr>
-          <p:cNvPr id="3" name="TextBox 2"/>
-          <p:cNvSpPr txBox="1"/>
-          <p:nvPr/>
-        </p:nvSpPr>
-        <p:spPr>
-          <a:xfrm>
-            <a:off x="548640" y="1143000"/>
-            <a:ext cx="11064240" cy="5486400"/>
-          </a:xfrm>
-          <a:prstGeom prst="rect">
-            <a:avLst/>
-          </a:prstGeom>
-          <a:noFill/>
-        </p:spPr>
-        <p:txBody>
-          <a:bodyPr wrap="square">
-            <a:spAutoFit/>
-          </a:bodyPr>
-          <a:lstStyle/>
-          <a:p>
-            <a:pPr>
-              <a:spcAft>
-                <a:spcPts val="600"/>
-              </a:spcAft>
-            </a:pPr>
-            <a:r>
-              <a:rPr sz="1500" b="1">
-                <a:solidFill>
-                  <a:srgbClr val="222222"/>
-                </a:solidFill>
-                <a:latin typeface="Meiryo"/>
-              </a:rPr>
-              <a:t>エクスポート</a:t>
-            </a:r>
-          </a:p>
-          <a:p>
-            <a:pPr lvl="1">
-              <a:spcAft>
-                <a:spcPts val="200"/>
-              </a:spcAft>
-            </a:pPr>
-            <a:r>
-              <a:rPr sz="1300" b="1">
-                <a:solidFill>
-                  <a:srgbClr val="595959"/>
-                </a:solidFill>
-                <a:latin typeface="Meiryo"/>
-              </a:rPr>
-              <a:t>・python export_onnx.py &lt;model.zip&gt; -m 3   # NHWC [1,12,12,10] エンジン用 (推奨)</a:t>
-            </a:r>
-          </a:p>
-          <a:p>
-            <a:pPr lvl="2">
-              <a:spcAft>
-                <a:spcPts val="200"/>
-              </a:spcAft>
-            </a:pPr>
-            <a:r>
-              <a:rPr sz="1100" b="0">
-                <a:solidFill>
-                  <a:srgbClr val="595959"/>
-                </a:solidFill>
-                <a:latin typeface="Meiryo"/>
-              </a:rPr>
-              <a:t>− -m 1: full policy / 2: actor CHW / 0: 全部 — 各出力は torch と自動照合 (≤4e-6)</a:t>
-            </a:r>
-          </a:p>
-          <a:p>
-            <a:pPr lvl="1">
-              <a:spcAft>
-                <a:spcPts val="200"/>
-              </a:spcAft>
-            </a:pPr>
-            <a:r>
-              <a:rPr sz="1300" b="0">
-                <a:solidFill>
-                  <a:srgbClr val="595959"/>
-                </a:solidFill>
-                <a:latin typeface="Meiryo"/>
-              </a:rPr>
-              <a:t>・python re_engine/convert_onnx_nhwc.py &lt;actor.onnx&gt;  # 既存 CHW の NHWC 化</a:t>
-            </a:r>
-          </a:p>
-          <a:p>
-            <a:pPr>
-              <a:spcAft>
-                <a:spcPts val="600"/>
-              </a:spcAft>
-            </a:pPr>
-            <a:r>
-              <a:rPr sz="1500" b="1">
-                <a:solidFill>
-                  <a:srgbClr val="222222"/>
-                </a:solidFill>
-                <a:latin typeface="Meiryo"/>
-              </a:rPr>
-              <a:t>再生成・検証</a:t>
-            </a:r>
-          </a:p>
-          <a:p>
-            <a:pPr lvl="1">
-              <a:spcAft>
-                <a:spcPts val="200"/>
-              </a:spcAft>
-            </a:pPr>
-            <a:r>
-              <a:rPr sz="1300" b="0">
-                <a:solidFill>
-                  <a:srgbClr val="595959"/>
-                </a:solidFill>
-                <a:latin typeface="Meiryo"/>
-              </a:rPr>
-              <a:t>・python re_engine/export_track_json.py  → dotnet run で ALL SCENARIOS MATCH を確認</a:t>
-            </a:r>
-          </a:p>
-          <a:p>
-            <a:pPr>
-              <a:spcAft>
-                <a:spcPts val="600"/>
-              </a:spcAft>
-            </a:pPr>
-            <a:r>
-              <a:rPr sz="1500" b="1">
-                <a:solidFill>
-                  <a:srgbClr val="222222"/>
-                </a:solidFill>
-                <a:latin typeface="Meiryo"/>
-              </a:rPr>
-              <a:t>よくある事故 (症状で覚える)</a:t>
-            </a:r>
-          </a:p>
-          <a:p>
-            <a:pPr lvl="1">
-              <a:spcAft>
-                <a:spcPts val="200"/>
-              </a:spcAft>
-            </a:pPr>
-            <a:r>
-              <a:rPr sz="1300" b="1">
-                <a:solidFill>
-                  <a:srgbClr val="B32D2D"/>
-                </a:solidFill>
-                <a:latin typeface="Meiryo"/>
-              </a:rPr>
-              <a:t>・出力がほぼ一定 (thr≈0.4, str≈0.2) = テンソルレイアウト不一致</a:t>
-            </a:r>
-          </a:p>
-          <a:p>
-            <a:pPr lvl="1">
-              <a:spcAft>
-                <a:spcPts val="200"/>
-              </a:spcAft>
-            </a:pPr>
-            <a:r>
-              <a:rPr sz="1300" b="0">
-                <a:solidFill>
-                  <a:srgbClr val="B32D2D"/>
-                </a:solidFill>
-                <a:latin typeface="Meiryo"/>
-              </a:rPr>
-              <a:t>・観測が全部飽和・挙動が雑 = km/h を m/s に変換し忘れ (KphToMs)</a:t>
-            </a:r>
-          </a:p>
-          <a:p>
-            <a:pPr lvl="1">
-              <a:spcAft>
-                <a:spcPts val="200"/>
-              </a:spcAft>
-            </a:pPr>
-            <a:r>
-              <a:rPr sz="1300" b="0">
-                <a:solidFill>
-                  <a:srgbClr val="B32D2D"/>
-                </a:solidFill>
-                <a:latin typeface="Meiryo"/>
-              </a:rPr>
-              <a:t>・グリッドが横向き = heading に生の yaw を使用 (正: 90° − yaw または forward から Atan2)</a:t>
-            </a:r>
-          </a:p>
-          <a:p>
-            <a:pPr>
-              <a:spcAft>
-                <a:spcPts val="600"/>
-              </a:spcAft>
-            </a:pPr>
-            <a:r>
-              <a:rPr sz="1500" b="0">
-                <a:solidFill>
-                  <a:srgbClr val="222222"/>
-                </a:solidFill>
-                <a:latin typeface="Meiryo"/>
-              </a:rPr>
-              <a:t>定数同期: レンジ・5 Hz・グリッド設定の変更は C# 定数 + JSON + 検証 + ONNX の 4 点セット</a:t>
             </a:r>
           </a:p>
         </p:txBody>
@@ -7329,6 +7312,257 @@
                 </a:solidFill>
                 <a:latin typeface="Meiryo"/>
               </a:rPr>
+              <a:t>エクスポートツールと ONNX の注意点</a:t>
+            </a:r>
+          </a:p>
+        </p:txBody>
+      </p:sp>
+      <p:sp>
+        <p:nvSpPr>
+          <p:cNvPr id="3" name="TextBox 2"/>
+          <p:cNvSpPr txBox="1"/>
+          <p:nvPr/>
+        </p:nvSpPr>
+        <p:spPr>
+          <a:xfrm>
+            <a:off x="548640" y="1143000"/>
+            <a:ext cx="11064240" cy="5486400"/>
+          </a:xfrm>
+          <a:prstGeom prst="rect">
+            <a:avLst/>
+          </a:prstGeom>
+          <a:noFill/>
+        </p:spPr>
+        <p:txBody>
+          <a:bodyPr wrap="square">
+            <a:spAutoFit/>
+          </a:bodyPr>
+          <a:lstStyle/>
+          <a:p>
+            <a:pPr>
+              <a:spcAft>
+                <a:spcPts val="600"/>
+              </a:spcAft>
+            </a:pPr>
+            <a:r>
+              <a:rPr sz="1500" b="1">
+                <a:solidFill>
+                  <a:srgbClr val="222222"/>
+                </a:solidFill>
+                <a:latin typeface="Meiryo"/>
+              </a:rPr>
+              <a:t>エクスポート</a:t>
+            </a:r>
+          </a:p>
+          <a:p>
+            <a:pPr lvl="1">
+              <a:spcAft>
+                <a:spcPts val="200"/>
+              </a:spcAft>
+            </a:pPr>
+            <a:r>
+              <a:rPr sz="1300" b="1">
+                <a:solidFill>
+                  <a:srgbClr val="595959"/>
+                </a:solidFill>
+                <a:latin typeface="Meiryo"/>
+              </a:rPr>
+              <a:t>・python export_onnx.py &lt;model.zip&gt; -m 3   # NHWC [1,12,12,10] エンジン用 (推奨)</a:t>
+            </a:r>
+          </a:p>
+          <a:p>
+            <a:pPr lvl="2">
+              <a:spcAft>
+                <a:spcPts val="200"/>
+              </a:spcAft>
+            </a:pPr>
+            <a:r>
+              <a:rPr sz="1100" b="0">
+                <a:solidFill>
+                  <a:srgbClr val="595959"/>
+                </a:solidFill>
+                <a:latin typeface="Meiryo"/>
+              </a:rPr>
+              <a:t>− -m 1: full policy / 2: actor CHW / 0: 全部 — 各出力は torch と自動照合 (≤4e-6)</a:t>
+            </a:r>
+          </a:p>
+          <a:p>
+            <a:pPr lvl="1">
+              <a:spcAft>
+                <a:spcPts val="200"/>
+              </a:spcAft>
+            </a:pPr>
+            <a:r>
+              <a:rPr sz="1300" b="0">
+                <a:solidFill>
+                  <a:srgbClr val="595959"/>
+                </a:solidFill>
+                <a:latin typeface="Meiryo"/>
+              </a:rPr>
+              <a:t>・python re_engine/convert_onnx_nhwc.py &lt;actor.onnx&gt;  # 既存 CHW の NHWC 化</a:t>
+            </a:r>
+          </a:p>
+          <a:p>
+            <a:pPr>
+              <a:spcAft>
+                <a:spcPts val="600"/>
+              </a:spcAft>
+            </a:pPr>
+            <a:r>
+              <a:rPr sz="1500" b="1">
+                <a:solidFill>
+                  <a:srgbClr val="222222"/>
+                </a:solidFill>
+                <a:latin typeface="Meiryo"/>
+              </a:rPr>
+              <a:t>再生成・検証</a:t>
+            </a:r>
+          </a:p>
+          <a:p>
+            <a:pPr lvl="1">
+              <a:spcAft>
+                <a:spcPts val="200"/>
+              </a:spcAft>
+            </a:pPr>
+            <a:r>
+              <a:rPr sz="1300" b="0">
+                <a:solidFill>
+                  <a:srgbClr val="595959"/>
+                </a:solidFill>
+                <a:latin typeface="Meiryo"/>
+              </a:rPr>
+              <a:t>・python re_engine/export_track_json.py  → dotnet run で ALL SCENARIOS MATCH を確認</a:t>
+            </a:r>
+          </a:p>
+          <a:p>
+            <a:pPr>
+              <a:spcAft>
+                <a:spcPts val="600"/>
+              </a:spcAft>
+            </a:pPr>
+            <a:r>
+              <a:rPr sz="1500" b="1">
+                <a:solidFill>
+                  <a:srgbClr val="222222"/>
+                </a:solidFill>
+                <a:latin typeface="Meiryo"/>
+              </a:rPr>
+              <a:t>よくある事故 (症状で覚える)</a:t>
+            </a:r>
+          </a:p>
+          <a:p>
+            <a:pPr lvl="1">
+              <a:spcAft>
+                <a:spcPts val="200"/>
+              </a:spcAft>
+            </a:pPr>
+            <a:r>
+              <a:rPr sz="1300" b="1">
+                <a:solidFill>
+                  <a:srgbClr val="B32D2D"/>
+                </a:solidFill>
+                <a:latin typeface="Meiryo"/>
+              </a:rPr>
+              <a:t>・出力がほぼ一定 (thr≈0.4, str≈0.2) = テンソルレイアウト不一致</a:t>
+            </a:r>
+          </a:p>
+          <a:p>
+            <a:pPr lvl="1">
+              <a:spcAft>
+                <a:spcPts val="200"/>
+              </a:spcAft>
+            </a:pPr>
+            <a:r>
+              <a:rPr sz="1300" b="0">
+                <a:solidFill>
+                  <a:srgbClr val="B32D2D"/>
+                </a:solidFill>
+                <a:latin typeface="Meiryo"/>
+              </a:rPr>
+              <a:t>・観測が全部飽和・挙動が雑 = km/h を m/s に変換し忘れ (KphToMs)</a:t>
+            </a:r>
+          </a:p>
+          <a:p>
+            <a:pPr lvl="1">
+              <a:spcAft>
+                <a:spcPts val="200"/>
+              </a:spcAft>
+            </a:pPr>
+            <a:r>
+              <a:rPr sz="1300" b="0">
+                <a:solidFill>
+                  <a:srgbClr val="B32D2D"/>
+                </a:solidFill>
+                <a:latin typeface="Meiryo"/>
+              </a:rPr>
+              <a:t>・グリッドが横向き = heading に生の yaw を使用 (正: 90° − yaw または forward から Atan2)</a:t>
+            </a:r>
+          </a:p>
+          <a:p>
+            <a:pPr>
+              <a:spcAft>
+                <a:spcPts val="600"/>
+              </a:spcAft>
+            </a:pPr>
+            <a:r>
+              <a:rPr sz="1500" b="0">
+                <a:solidFill>
+                  <a:srgbClr val="222222"/>
+                </a:solidFill>
+                <a:latin typeface="Meiryo"/>
+              </a:rPr>
+              <a:t>定数同期: レンジ・5 Hz・グリッド設定の変更は C# 定数 + JSON + 検証 + ONNX の 4 点セット</a:t>
+            </a:r>
+          </a:p>
+        </p:txBody>
+      </p:sp>
+    </p:spTree>
+  </p:cSld>
+  <p:clrMapOvr>
+    <a:masterClrMapping/>
+  </p:clrMapOvr>
+</p:sld>
+</file>
+
+<file path=ppt/slides/slide21.xml><?xml version="1.0" encoding="utf-8"?>
+<p:sld xmlns:a="http://schemas.openxmlformats.org/drawingml/2006/main" xmlns:p="http://schemas.openxmlformats.org/presentationml/2006/main" xmlns:r="http://schemas.openxmlformats.org/officeDocument/2006/relationships">
+  <p:cSld>
+    <p:spTree>
+      <p:nvGrpSpPr>
+        <p:cNvPr id="1" name=""/>
+        <p:cNvGrpSpPr/>
+        <p:nvPr/>
+      </p:nvGrpSpPr>
+      <p:grpSpPr/>
+      <p:sp>
+        <p:nvSpPr>
+          <p:cNvPr id="2" name="TextBox 1"/>
+          <p:cNvSpPr txBox="1"/>
+          <p:nvPr/>
+        </p:nvSpPr>
+        <p:spPr>
+          <a:xfrm>
+            <a:off x="457200" y="182880"/>
+            <a:ext cx="11247120" cy="731520"/>
+          </a:xfrm>
+          <a:prstGeom prst="rect">
+            <a:avLst/>
+          </a:prstGeom>
+          <a:noFill/>
+        </p:spPr>
+        <p:txBody>
+          <a:bodyPr wrap="none">
+            <a:spAutoFit/>
+          </a:bodyPr>
+          <a:lstStyle/>
+          <a:p>
+            <a:r>
+              <a:rPr sz="2700" b="1">
+                <a:solidFill>
+                  <a:srgbClr val="1B5EA8"/>
+                </a:solidFill>
+                <a:latin typeface="Meiryo"/>
+              </a:rPr>
               <a:t>まとめ — 環境設計こそが学習を決める</a:t>
             </a:r>
           </a:p>
@@ -8433,122 +8667,669 @@
                 </a:solidFill>
                 <a:latin typeface="Meiryo"/>
               </a:rPr>
-              <a:t>進化 (1) 行動と車両 — スロットルの導入と制御量の設計</a:t>
-            </a:r>
-          </a:p>
-        </p:txBody>
-      </p:sp>
-      <p:sp>
-        <p:nvSpPr>
-          <p:cNvPr id="3" name="TextBox 2"/>
-          <p:cNvSpPr txBox="1"/>
+              <a:t>全体比較表 — デフォルトから変えた軸と狙い</a:t>
+            </a:r>
+          </a:p>
+        </p:txBody>
+      </p:sp>
+      <p:graphicFrame>
+        <p:nvGraphicFramePr>
+          <p:cNvPr id="3" name="Table 2"/>
+          <p:cNvGraphicFramePr>
+            <a:graphicFrameLocks noGrp="1"/>
+          </p:cNvGraphicFramePr>
           <p:nvPr/>
-        </p:nvSpPr>
-        <p:spPr>
-          <a:xfrm>
-            <a:off x="548640" y="1097280"/>
-            <a:ext cx="11064240" cy="5486400"/>
-          </a:xfrm>
-          <a:prstGeom prst="rect">
-            <a:avLst/>
-          </a:prstGeom>
-          <a:noFill/>
-        </p:spPr>
-        <p:txBody>
-          <a:bodyPr wrap="square">
-            <a:spAutoFit/>
-          </a:bodyPr>
-          <a:lstStyle/>
-          <a:p>
-            <a:pPr>
-              <a:spcAft>
-                <a:spcPts val="600"/>
-              </a:spcAft>
-            </a:pPr>
-            <a:r>
-              <a:rPr sz="1600" b="1">
-                <a:solidFill>
-                  <a:srgbClr val="222222"/>
-                </a:solidFill>
-                <a:latin typeface="Meiryo"/>
-              </a:rPr>
-              <a:t>変更: ステアのみ → 連続 (スロットル, ステア)、dynamical=True (タイヤスリップ)</a:t>
-            </a:r>
-          </a:p>
-          <a:p>
-            <a:pPr lvl="1">
-              <a:spcAft>
-                <a:spcPts val="200"/>
-              </a:spcAft>
-            </a:pPr>
-            <a:r>
-              <a:rPr sz="1400" b="0">
-                <a:solidFill>
-                  <a:srgbClr val="595959"/>
-                </a:solidFill>
-                <a:latin typeface="Meiryo"/>
-              </a:rPr>
-              <a:t>・acceleration_range ±5 m/s²: 方策出力 [−1,1] → 加速度への写像係数</a:t>
-            </a:r>
-          </a:p>
-          <a:p>
-            <a:pPr lvl="1">
-              <a:spcAft>
-                <a:spcPts val="200"/>
-              </a:spcAft>
-            </a:pPr>
-            <a:r>
-              <a:rPr sz="1400" b="0">
-                <a:solidFill>
-                  <a:srgbClr val="595959"/>
-                </a:solidFill>
-                <a:latin typeface="Meiryo"/>
-              </a:rPr>
-              <a:t>・steering_range ±π/6 (30°): 前輪舵角上限 → 最小旋回半径 ≈ 8 m &lt; コーナー最小 10 m</a:t>
-            </a:r>
-          </a:p>
-          <a:p>
-            <a:pPr lvl="1">
-              <a:spcAft>
-                <a:spcPts val="200"/>
-              </a:spcAft>
-            </a:pPr>
-            <a:r>
-              <a:rPr sz="1400" b="0">
-                <a:solidFill>
-                  <a:srgbClr val="595959"/>
-                </a:solidFill>
-                <a:latin typeface="Meiryo"/>
-              </a:rPr>
-              <a:t>・speed_limit 16 m/s + 前進速度報酬 — 「速く走る」動機を導入</a:t>
-            </a:r>
-          </a:p>
-        </p:txBody>
-      </p:sp>
-      <p:pic>
-        <p:nvPicPr>
-          <p:cNvPr id="4" name="Picture 3" descr="range_experiment.png"/>
-          <p:cNvPicPr>
-            <a:picLocks noChangeAspect="1"/>
-          </p:cNvPicPr>
-          <p:nvPr/>
-        </p:nvPicPr>
-        <p:blipFill>
-          <a:blip r:embed="rId3"/>
-          <a:stretch>
-            <a:fillRect/>
-          </a:stretch>
-        </p:blipFill>
-        <p:spPr>
-          <a:xfrm>
-            <a:off x="3108960" y="2651760"/>
-            <a:ext cx="5852160" cy="3121152"/>
-          </a:xfrm>
-          <a:prstGeom prst="rect">
-            <a:avLst/>
-          </a:prstGeom>
-        </p:spPr>
-      </p:pic>
+        </p:nvGraphicFramePr>
+        <p:xfrm>
+          <a:off x="411480" y="1234440"/>
+          <a:ext cx="11384280" cy="5120633"/>
+        </p:xfrm>
+        <a:graphic>
+          <a:graphicData uri="http://schemas.openxmlformats.org/drawingml/2006/table">
+            <a:tbl>
+              <a:tblPr firstRow="1" bandRow="1">
+                <a:tableStyleId>{5C22544A-7EE6-4342-B048-85BDC9FD1C3A}</a:tableStyleId>
+              </a:tblPr>
+              <a:tblGrid>
+                <a:gridCol w="1417320"/>
+                <a:gridCol w="3063240"/>
+                <a:gridCol w="3246120"/>
+                <a:gridCol w="3657600"/>
+              </a:tblGrid>
+              <a:tr h="731519">
+                <a:tc>
+                  <a:txBody>
+                    <a:bodyPr wrap="square"/>
+                    <a:lstStyle/>
+                    <a:p>
+                      <a:r>
+                        <a:rPr sz="1300" b="1">
+                          <a:solidFill>
+                            <a:srgbClr val="FFFFFF"/>
+                          </a:solidFill>
+                          <a:latin typeface="Meiryo"/>
+                        </a:rPr>
+                        <a:t>軸</a:t>
+                      </a:r>
+                    </a:p>
+                  </a:txBody>
+                  <a:tcPr marL="64008" marR="64008" marT="27432" marB="27432">
+                    <a:solidFill>
+                      <a:srgbClr val="1B5EA8"/>
+                    </a:solidFill>
+                  </a:tcPr>
+                </a:tc>
+                <a:tc>
+                  <a:txBody>
+                    <a:bodyPr wrap="square"/>
+                    <a:lstStyle/>
+                    <a:p>
+                      <a:r>
+                        <a:rPr sz="1300" b="1">
+                          <a:solidFill>
+                            <a:srgbClr val="FFFFFF"/>
+                          </a:solidFill>
+                          <a:latin typeface="Meiryo"/>
+                        </a:rPr>
+                        <a:t>highway-env デフォルト</a:t>
+                      </a:r>
+                    </a:p>
+                  </a:txBody>
+                  <a:tcPr marL="64008" marR="64008" marT="27432" marB="27432">
+                    <a:solidFill>
+                      <a:srgbClr val="1B5EA8"/>
+                    </a:solidFill>
+                  </a:tcPr>
+                </a:tc>
+                <a:tc>
+                  <a:txBody>
+                    <a:bodyPr wrap="square"/>
+                    <a:lstStyle/>
+                    <a:p>
+                      <a:r>
+                        <a:rPr sz="1300" b="1">
+                          <a:solidFill>
+                            <a:srgbClr val="FFFFFF"/>
+                          </a:solidFill>
+                          <a:latin typeface="Meiryo"/>
+                        </a:rPr>
+                        <a:t>CircuitAgents</a:t>
+                      </a:r>
+                    </a:p>
+                  </a:txBody>
+                  <a:tcPr marL="64008" marR="64008" marT="27432" marB="27432">
+                    <a:solidFill>
+                      <a:srgbClr val="1B5EA8"/>
+                    </a:solidFill>
+                  </a:tcPr>
+                </a:tc>
+                <a:tc>
+                  <a:txBody>
+                    <a:bodyPr wrap="square"/>
+                    <a:lstStyle/>
+                    <a:p>
+                      <a:r>
+                        <a:rPr sz="1300" b="1">
+                          <a:solidFill>
+                            <a:srgbClr val="FFFFFF"/>
+                          </a:solidFill>
+                          <a:latin typeface="Meiryo"/>
+                        </a:rPr>
+                        <a:t>狙い</a:t>
+                      </a:r>
+                    </a:p>
+                  </a:txBody>
+                  <a:tcPr marL="64008" marR="64008" marT="27432" marB="27432">
+                    <a:solidFill>
+                      <a:srgbClr val="1B5EA8"/>
+                    </a:solidFill>
+                  </a:tcPr>
+                </a:tc>
+              </a:tr>
+              <a:tr h="731519">
+                <a:tc>
+                  <a:txBody>
+                    <a:bodyPr wrap="square"/>
+                    <a:lstStyle/>
+                    <a:p>
+                      <a:r>
+                        <a:rPr sz="1200" b="1">
+                          <a:solidFill>
+                            <a:srgbClr val="1B5EA8"/>
+                          </a:solidFill>
+                          <a:latin typeface="Meiryo"/>
+                        </a:rPr>
+                        <a:t>行動・車両</a:t>
+                      </a:r>
+                    </a:p>
+                  </a:txBody>
+                  <a:tcPr marL="64008" marR="64008" marT="27432" marB="27432">
+                    <a:solidFill>
+                      <a:srgbClr val="F2F5FA"/>
+                    </a:solidFill>
+                  </a:tcPr>
+                </a:tc>
+                <a:tc>
+                  <a:txBody>
+                    <a:bodyPr wrap="square"/>
+                    <a:lstStyle/>
+                    <a:p>
+                      <a:r>
+                        <a:rPr sz="1200" b="0">
+                          <a:solidFill>
+                            <a:srgbClr val="222222"/>
+                          </a:solidFill>
+                          <a:latin typeface="Meiryo"/>
+                        </a:rPr>
+                        <a:t>ステアのみ / 運動学 Bicycle</a:t>
+                      </a:r>
+                    </a:p>
+                  </a:txBody>
+                  <a:tcPr marL="64008" marR="64008" marT="27432" marB="27432">
+                    <a:solidFill>
+                      <a:srgbClr val="F2F5FA"/>
+                    </a:solidFill>
+                  </a:tcPr>
+                </a:tc>
+                <a:tc>
+                  <a:txBody>
+                    <a:bodyPr wrap="square"/>
+                    <a:lstStyle/>
+                    <a:p>
+                      <a:r>
+                        <a:rPr sz="1200" b="0">
+                          <a:solidFill>
+                            <a:srgbClr val="222222"/>
+                          </a:solidFill>
+                          <a:latin typeface="Meiryo"/>
+                        </a:rPr>
+                        <a:t>連続 (スロットル,ステア) / 動的 Bicycle</a:t>
+                      </a:r>
+                    </a:p>
+                  </a:txBody>
+                  <a:tcPr marL="64008" marR="64008" marT="27432" marB="27432">
+                    <a:solidFill>
+                      <a:srgbClr val="F2F5FA"/>
+                    </a:solidFill>
+                  </a:tcPr>
+                </a:tc>
+                <a:tc>
+                  <a:txBody>
+                    <a:bodyPr wrap="square"/>
+                    <a:lstStyle/>
+                    <a:p>
+                      <a:r>
+                        <a:rPr sz="1200" b="0">
+                          <a:solidFill>
+                            <a:srgbClr val="222222"/>
+                          </a:solidFill>
+                          <a:latin typeface="Meiryo"/>
+                        </a:rPr>
+                        <a:t>アクセルを踏むレースにし慣性・横滑りを再現</a:t>
+                      </a:r>
+                    </a:p>
+                  </a:txBody>
+                  <a:tcPr marL="64008" marR="64008" marT="27432" marB="27432">
+                    <a:solidFill>
+                      <a:srgbClr val="F2F5FA"/>
+                    </a:solidFill>
+                  </a:tcPr>
+                </a:tc>
+              </a:tr>
+              <a:tr h="731519">
+                <a:tc>
+                  <a:txBody>
+                    <a:bodyPr wrap="square"/>
+                    <a:lstStyle/>
+                    <a:p>
+                      <a:r>
+                        <a:rPr sz="1200" b="1">
+                          <a:solidFill>
+                            <a:srgbClr val="1B5EA8"/>
+                          </a:solidFill>
+                          <a:latin typeface="Meiryo"/>
+                        </a:rPr>
+                        <a:t>速度目標</a:t>
+                      </a:r>
+                    </a:p>
+                  </a:txBody>
+                  <a:tcPr marL="64008" marR="64008" marT="27432" marB="27432">
+                    <a:solidFill>
+                      <a:srgbClr val="FFFFFF"/>
+                    </a:solidFill>
+                  </a:tcPr>
+                </a:tc>
+                <a:tc>
+                  <a:txBody>
+                    <a:bodyPr wrap="square"/>
+                    <a:lstStyle/>
+                    <a:p>
+                      <a:r>
+                        <a:rPr sz="1200" b="0">
+                          <a:solidFill>
+                            <a:srgbClr val="222222"/>
+                          </a:solidFill>
+                          <a:latin typeface="Meiryo"/>
+                        </a:rPr>
+                        <a:t>離散 [0,5,10] m/s、速さの動機なし</a:t>
+                      </a:r>
+                    </a:p>
+                  </a:txBody>
+                  <a:tcPr marL="64008" marR="64008" marT="27432" marB="27432">
+                    <a:solidFill>
+                      <a:srgbClr val="FFFFFF"/>
+                    </a:solidFill>
+                  </a:tcPr>
+                </a:tc>
+                <a:tc>
+                  <a:txBody>
+                    <a:bodyPr wrap="square"/>
+                    <a:lstStyle/>
+                    <a:p>
+                      <a:r>
+                        <a:rPr sz="1200" b="0">
+                          <a:solidFill>
+                            <a:srgbClr val="222222"/>
+                          </a:solidFill>
+                          <a:latin typeface="Meiryo"/>
+                        </a:rPr>
+                        <a:t>16 m/s + 前進速度報酬</a:t>
+                      </a:r>
+                    </a:p>
+                  </a:txBody>
+                  <a:tcPr marL="64008" marR="64008" marT="27432" marB="27432">
+                    <a:solidFill>
+                      <a:srgbClr val="FFFFFF"/>
+                    </a:solidFill>
+                  </a:tcPr>
+                </a:tc>
+                <a:tc>
+                  <a:txBody>
+                    <a:bodyPr wrap="square"/>
+                    <a:lstStyle/>
+                    <a:p>
+                      <a:r>
+                        <a:rPr sz="1200" b="0">
+                          <a:solidFill>
+                            <a:srgbClr val="222222"/>
+                          </a:solidFill>
+                          <a:latin typeface="Meiryo"/>
+                        </a:rPr>
+                        <a:t>「速さを競う」動機を導入</a:t>
+                      </a:r>
+                    </a:p>
+                  </a:txBody>
+                  <a:tcPr marL="64008" marR="64008" marT="27432" marB="27432">
+                    <a:solidFill>
+                      <a:srgbClr val="FFFFFF"/>
+                    </a:solidFill>
+                  </a:tcPr>
+                </a:tc>
+              </a:tr>
+              <a:tr h="731519">
+                <a:tc>
+                  <a:txBody>
+                    <a:bodyPr wrap="square"/>
+                    <a:lstStyle/>
+                    <a:p>
+                      <a:r>
+                        <a:rPr sz="1200" b="1">
+                          <a:solidFill>
+                            <a:srgbClr val="1B5EA8"/>
+                          </a:solidFill>
+                          <a:latin typeface="Meiryo"/>
+                        </a:rPr>
+                        <a:t>壁</a:t>
+                      </a:r>
+                    </a:p>
+                  </a:txBody>
+                  <a:tcPr marL="64008" marR="64008" marT="27432" marB="27432">
+                    <a:solidFill>
+                      <a:srgbClr val="F2F5FA"/>
+                    </a:solidFill>
+                  </a:tcPr>
+                </a:tc>
+                <a:tc>
+                  <a:txBody>
+                    <a:bodyPr wrap="square"/>
+                    <a:lstStyle/>
+                    <a:p>
+                      <a:r>
+                        <a:rPr sz="1200" b="0">
+                          <a:solidFill>
+                            <a:srgbClr val="222222"/>
+                          </a:solidFill>
+                          <a:latin typeface="Meiryo"/>
+                        </a:rPr>
+                        <a:t>存在しない (路外=終了/すり抜け)</a:t>
+                      </a:r>
+                    </a:p>
+                  </a:txBody>
+                  <a:tcPr marL="64008" marR="64008" marT="27432" marB="27432">
+                    <a:solidFill>
+                      <a:srgbClr val="F2F5FA"/>
+                    </a:solidFill>
+                  </a:tcPr>
+                </a:tc>
+                <a:tc>
+                  <a:txBody>
+                    <a:bodyPr wrap="square"/>
+                    <a:lstStyle/>
+                    <a:p>
+                      <a:r>
+                        <a:rPr sz="1200" b="0">
+                          <a:solidFill>
+                            <a:srgbClr val="222222"/>
+                          </a:solidFill>
+                          <a:latin typeface="Meiryo"/>
+                        </a:rPr>
+                        <a:t>外周のみ停止壁 + 摩擦 0.6</a:t>
+                      </a:r>
+                    </a:p>
+                  </a:txBody>
+                  <a:tcPr marL="64008" marR="64008" marT="27432" marB="27432">
+                    <a:solidFill>
+                      <a:srgbClr val="F2F5FA"/>
+                    </a:solidFill>
+                  </a:tcPr>
+                </a:tc>
+                <a:tc>
+                  <a:txBody>
+                    <a:bodyPr wrap="square"/>
+                    <a:lstStyle/>
+                    <a:p>
+                      <a:r>
+                        <a:rPr sz="1200" b="0">
+                          <a:solidFill>
+                            <a:srgbClr val="222222"/>
+                          </a:solidFill>
+                          <a:latin typeface="Meiryo"/>
+                        </a:rPr>
+                        <a:t>ゲームの壁制約 / ショートカット・壁擦りを封じる</a:t>
+                      </a:r>
+                    </a:p>
+                  </a:txBody>
+                  <a:tcPr marL="64008" marR="64008" marT="27432" marB="27432">
+                    <a:solidFill>
+                      <a:srgbClr val="F2F5FA"/>
+                    </a:solidFill>
+                  </a:tcPr>
+                </a:tc>
+              </a:tr>
+              <a:tr h="731519">
+                <a:tc>
+                  <a:txBody>
+                    <a:bodyPr wrap="square"/>
+                    <a:lstStyle/>
+                    <a:p>
+                      <a:r>
+                        <a:rPr sz="1200" b="1">
+                          <a:solidFill>
+                            <a:srgbClr val="1B5EA8"/>
+                          </a:solidFill>
+                          <a:latin typeface="Meiryo"/>
+                        </a:rPr>
+                        <a:t>報酬</a:t>
+                      </a:r>
+                    </a:p>
+                  </a:txBody>
+                  <a:tcPr marL="64008" marR="64008" marT="27432" marB="27432">
+                    <a:solidFill>
+                      <a:srgbClr val="FFFFFF"/>
+                    </a:solidFill>
+                  </a:tcPr>
+                </a:tc>
+                <a:tc>
+                  <a:txBody>
+                    <a:bodyPr wrap="square"/>
+                    <a:lstStyle/>
+                    <a:p>
+                      <a:r>
+                        <a:rPr sz="1200" b="0">
+                          <a:solidFill>
+                            <a:srgbClr val="222222"/>
+                          </a:solidFill>
+                          <a:latin typeface="Meiryo"/>
+                        </a:rPr>
+                        <a:t>中央維持 1/(1+4·lat²) − 0.3‖a‖</a:t>
+                      </a:r>
+                    </a:p>
+                  </a:txBody>
+                  <a:tcPr marL="64008" marR="64008" marT="27432" marB="27432">
+                    <a:solidFill>
+                      <a:srgbClr val="FFFFFF"/>
+                    </a:solidFill>
+                  </a:tcPr>
+                </a:tc>
+                <a:tc>
+                  <a:txBody>
+                    <a:bodyPr wrap="square"/>
+                    <a:lstStyle/>
+                    <a:p>
+                      <a:r>
+                        <a:rPr sz="1200" b="0">
+                          <a:solidFill>
+                            <a:srgbClr val="222222"/>
+                          </a:solidFill>
+                          <a:latin typeface="Meiryo"/>
+                        </a:rPr>
+                        <a:t>dense(速度+中央+前進)+sparse(周回)</a:t>
+                      </a:r>
+                    </a:p>
+                  </a:txBody>
+                  <a:tcPr marL="64008" marR="64008" marT="27432" marB="27432">
+                    <a:solidFill>
+                      <a:srgbClr val="FFFFFF"/>
+                    </a:solidFill>
+                  </a:tcPr>
+                </a:tc>
+                <a:tc>
+                  <a:txBody>
+                    <a:bodyPr wrap="square"/>
+                    <a:lstStyle/>
+                    <a:p>
+                      <a:r>
+                        <a:rPr sz="1200" b="0">
+                          <a:solidFill>
+                            <a:srgbClr val="222222"/>
+                          </a:solidFill>
+                          <a:latin typeface="Meiryo"/>
+                        </a:rPr>
+                        <a:t>周回に密な勾配 / 抜け道を経済的に不利に</a:t>
+                      </a:r>
+                    </a:p>
+                  </a:txBody>
+                  <a:tcPr marL="64008" marR="64008" marT="27432" marB="27432">
+                    <a:solidFill>
+                      <a:srgbClr val="FFFFFF"/>
+                    </a:solidFill>
+                  </a:tcPr>
+                </a:tc>
+              </a:tr>
+              <a:tr h="731519">
+                <a:tc>
+                  <a:txBody>
+                    <a:bodyPr wrap="square"/>
+                    <a:lstStyle/>
+                    <a:p>
+                      <a:r>
+                        <a:rPr sz="1200" b="1">
+                          <a:solidFill>
+                            <a:srgbClr val="1B5EA8"/>
+                          </a:solidFill>
+                          <a:latin typeface="Meiryo"/>
+                        </a:rPr>
+                        <a:t>観測</a:t>
+                      </a:r>
+                    </a:p>
+                  </a:txBody>
+                  <a:tcPr marL="64008" marR="64008" marT="27432" marB="27432">
+                    <a:solidFill>
+                      <a:srgbClr val="F2F5FA"/>
+                    </a:solidFill>
+                  </a:tcPr>
+                </a:tc>
+                <a:tc>
+                  <a:txBody>
+                    <a:bodyPr wrap="square"/>
+                    <a:lstStyle/>
+                    <a:p>
+                      <a:r>
+                        <a:rPr sz="1200" b="0">
+                          <a:solidFill>
+                            <a:srgbClr val="222222"/>
+                          </a:solidFill>
+                          <a:latin typeface="Meiryo"/>
+                        </a:rPr>
+                        <a:t>2ch (presence/on_road)、±18 m 対称</a:t>
+                      </a:r>
+                    </a:p>
+                  </a:txBody>
+                  <a:tcPr marL="64008" marR="64008" marT="27432" marB="27432">
+                    <a:solidFill>
+                      <a:srgbClr val="F2F5FA"/>
+                    </a:solidFill>
+                  </a:tcPr>
+                </a:tc>
+                <a:tc>
+                  <a:txBody>
+                    <a:bodyPr wrap="square"/>
+                    <a:lstStyle/>
+                    <a:p>
+                      <a:r>
+                        <a:rPr sz="1200" b="0">
+                          <a:solidFill>
+                            <a:srgbClr val="222222"/>
+                          </a:solidFill>
+                          <a:latin typeface="Meiryo"/>
+                        </a:rPr>
+                        <a:t>10ch、前方 27 m / 後方 9 m 非対称</a:t>
+                      </a:r>
+                    </a:p>
+                  </a:txBody>
+                  <a:tcPr marL="64008" marR="64008" marT="27432" marB="27432">
+                    <a:solidFill>
+                      <a:srgbClr val="F2F5FA"/>
+                    </a:solidFill>
+                  </a:tcPr>
+                </a:tc>
+                <a:tc>
+                  <a:txBody>
+                    <a:bodyPr wrap="square"/>
+                    <a:lstStyle/>
+                    <a:p>
+                      <a:r>
+                        <a:rPr sz="1200" b="0">
+                          <a:solidFill>
+                            <a:srgbClr val="222222"/>
+                          </a:solidFill>
+                          <a:latin typeface="Meiryo"/>
+                        </a:rPr>
+                        <a:t>相対速度・車線ずれを可視化 / 制動距離を視野に</a:t>
+                      </a:r>
+                    </a:p>
+                  </a:txBody>
+                  <a:tcPr marL="64008" marR="64008" marT="27432" marB="27432">
+                    <a:solidFill>
+                      <a:srgbClr val="F2F5FA"/>
+                    </a:solidFill>
+                  </a:tcPr>
+                </a:tc>
+              </a:tr>
+              <a:tr h="731519">
+                <a:tc>
+                  <a:txBody>
+                    <a:bodyPr wrap="square"/>
+                    <a:lstStyle/>
+                    <a:p>
+                      <a:r>
+                        <a:rPr sz="1200" b="1">
+                          <a:solidFill>
+                            <a:srgbClr val="1B5EA8"/>
+                          </a:solidFill>
+                          <a:latin typeface="Meiryo"/>
+                        </a:rPr>
+                        <a:t>トラック</a:t>
+                      </a:r>
+                    </a:p>
+                  </a:txBody>
+                  <a:tcPr marL="64008" marR="64008" marT="27432" marB="27432">
+                    <a:solidFill>
+                      <a:srgbClr val="FFFFFF"/>
+                    </a:solidFill>
+                  </a:tcPr>
+                </a:tc>
+                <a:tc>
+                  <a:txBody>
+                    <a:bodyPr wrap="square"/>
+                    <a:lstStyle/>
+                    <a:p>
+                      <a:r>
+                        <a:rPr sz="1200" b="0">
+                          <a:solidFill>
+                            <a:srgbClr val="222222"/>
+                          </a:solidFill>
+                          <a:latin typeface="Meiryo"/>
+                        </a:rPr>
+                        <a:t>単一レイアウト、NPC 1 台</a:t>
+                      </a:r>
+                    </a:p>
+                  </a:txBody>
+                  <a:tcPr marL="64008" marR="64008" marT="27432" marB="27432">
+                    <a:solidFill>
+                      <a:srgbClr val="FFFFFF"/>
+                    </a:solidFill>
+                  </a:tcPr>
+                </a:tc>
+                <a:tc>
+                  <a:txBody>
+                    <a:bodyPr wrap="square"/>
+                    <a:lstStyle/>
+                    <a:p>
+                      <a:r>
+                        <a:rPr sz="1200" b="0">
+                          <a:solidFill>
+                            <a:srgbClr val="222222"/>
+                          </a:solidFill>
+                          <a:latin typeface="Meiryo"/>
+                        </a:rPr>
+                        <a:t>5 種 + random、NPC は P2 で追加</a:t>
+                      </a:r>
+                    </a:p>
+                  </a:txBody>
+                  <a:tcPr marL="64008" marR="64008" marT="27432" marB="27432">
+                    <a:solidFill>
+                      <a:srgbClr val="FFFFFF"/>
+                    </a:solidFill>
+                  </a:tcPr>
+                </a:tc>
+                <a:tc>
+                  <a:txBody>
+                    <a:bodyPr wrap="square"/>
+                    <a:lstStyle/>
+                    <a:p>
+                      <a:r>
+                        <a:rPr sz="1200" b="0">
+                          <a:solidFill>
+                            <a:srgbClr val="222222"/>
+                          </a:solidFill>
+                          <a:latin typeface="Meiryo"/>
+                        </a:rPr>
+                        <a:t>ドメインランダム化で汎化を補強</a:t>
+                      </a:r>
+                    </a:p>
+                  </a:txBody>
+                  <a:tcPr marL="64008" marR="64008" marT="27432" marB="27432">
+                    <a:solidFill>
+                      <a:srgbClr val="FFFFFF"/>
+                    </a:solidFill>
+                  </a:tcPr>
+                </a:tc>
+              </a:tr>
+            </a:tbl>
+          </a:graphicData>
+        </a:graphic>
+      </p:graphicFrame>
     </p:spTree>
   </p:cSld>
   <p:clrMapOvr>

</xml_diff>

<commit_message>
docs+slides: add reward & simulation config reference
- docs 4.6: full config reference from RacetrackFast.default_config() —
  reward weights (value, per-step range contribution, purpose), simulation/
  action/observation params, and wall/NPC params, as three tables; notes the
  lmap [-3,3] range derivation and that constants are C#-duplicated
- slide 13: condensed two-table config-reference slide (reward weights |
  range, and sim/action/observation | value) with speaker notes; deck now 22

Co-Authored-By: Claude Opus 4.8 <noreply@anthropic.com>
Claude-Session: https://claude.ai/code/session_01RNWAkxuGbbryAR3VqKTcDq
</commit_message>
<xml_diff>
--- a/docs/CircuitAgents_intro_ja.pptx
+++ b/docs/CircuitAgents_intro_ja.pptx
@@ -26,6 +26,7 @@
     <p:sldId id="274" r:id="rId26"/>
     <p:sldId id="275" r:id="rId27"/>
     <p:sldId id="276" r:id="rId28"/>
+    <p:sldId id="277" r:id="rId29"/>
   </p:sldIdLst>
   <p:sldSz cx="12191695" cy="6858000" type="screen4x3"/>
   <p:notesSz cx="6858000" cy="9144000"/>
@@ -802,7 +803,7 @@
           <a:lstStyle/>
           <a:p>
             <a:r>
-              <a:t>第四の変更、観測です。2 チャネルから 10 チャネルに拡張しました。各チャネルの意味を説明します。presence は車がいるセルに 1。on_road はレーン中心線が通るセルに 1 で、塗りつぶした路面マスクではない点が移植時の要注意です。x, y, vx, vy は他車の自車相対の位置と速度で、値はトラック座標系のまま、セルの位置だけが自車向きに回転します。cos_h, sin_h は各車の絶対進行方向。lat_off は最寄りレーン中心からの横ずれ、ang_off はレーン方向との角度差で、この 2 つが車線維持の主信号です。features_range は正規化の分母で、例えば vx の ±20 m/s は「±20 を ±1 に写像する」という意味です。ここに km/h の値を入れると 3.6 倍されて飽和する、という単位事故がデプロイで最も起きやすい罠です。視野は前方 27 m・後方 9 m の非対称で、27 m は制動距離 25.6 m から逆算しています。右の軌跡でヘアピン手前の減速開始位置がちょうど視野に対応しているのが分かります。</a:t>
+              <a:t>実際に使った設定値を左右の表にまとめます。左が報酬の重み、右がシミュレーションと行動・観測です。報酬は中央維持を基礎に、速度と前進投影で『前へ速く』を作り、後退・停止・壁擦りに離散ペナルティ、チェックポイントとラップは生単位で加算します。全項を合成したあと lmap で [0,1] に正規化し、範囲 [−3,3] は通常ステップの上下限 ±2.8 を覆うように選んでいます。右側、物理は 15 Hz・意思決定は 5 Hz で 1 アクションを 3 回保持。加速度は ±5 m/s²、舵角は ±π/6。壁は停止モードで摩擦 0.6、7 秒接触で終端。これらの定数は C# 側にも複製されるため、変更時は 4 点セットの同期が必要です。</a:t>
             </a:r>
           </a:p>
         </p:txBody>
@@ -872,7 +873,7 @@
           <a:lstStyle/>
           <a:p>
             <a:r>
-              <a:t>第五の変更、トラックです。oval と stadium が基礎、rect が 90 度の反復、chicane が左右切り返しと最小半径 10 m のキンク、fast がメインの難コース。track を random にするとエピソード毎に再抽選され、これはドメインランダマイゼーションの一種です。ただし汎化の本質は観測の帰納バイアス側にあり、fast 単体学習の方策も未見 4 コースをゼロショットで走ります。各トラックは C# プリセットと JSON に複製され、検証ハーネスが幾何一致を自動チェックします。</a:t>
+              <a:t>第四の変更、観測です。2 チャネルから 10 チャネルに拡張しました。各チャネルの意味を説明します。presence は車がいるセルに 1。on_road はレーン中心線が通るセルに 1 で、塗りつぶした路面マスクではない点が移植時の要注意です。x, y, vx, vy は他車の自車相対の位置と速度で、値はトラック座標系のまま、セルの位置だけが自車向きに回転します。cos_h, sin_h は各車の絶対進行方向。lat_off は最寄りレーン中心からの横ずれ、ang_off はレーン方向との角度差で、この 2 つが車線維持の主信号です。features_range は正規化の分母で、例えば vx の ±20 m/s は「±20 を ±1 に写像する」という意味です。ここに km/h の値を入れると 3.6 倍されて飽和する、という単位事故がデプロイで最も起きやすい罠です。視野は前方 27 m・後方 9 m の非対称で、27 m は制動距離 25.6 m から逆算しています。右の軌跡でヘアピン手前の減速開始位置がちょうど視野に対応しているのが分かります。</a:t>
             </a:r>
           </a:p>
         </p:txBody>
@@ -942,7 +943,7 @@
           <a:lstStyle/>
           <a:p>
             <a:r>
-              <a:t>学習の全体像です。フェーズ 1 で他車なしのレーン追従、フェーズ 2 で NPC を入れて学習率を下げ追い越しを学習します。特徴抽出はカスタム CNN で、初期方策のスロットルバイアスを +0.4 に手動シフトします。ガウス方策の平均が 0 のままだと前進と後退が等確率で、前進報酬を発見する前に壁ペナルティばかり集めるためです。動作確認用の fast-dev はかつてエントロピー係数 0.10 で、何度回しても曲がれませんでした。エントロピーボーナスが「ランダムでいること」に支払われ、[0,1] に圧縮された報酬差に勝ってしまうためです。現在は本番ハイパラのまま 12 万ステップに短縮し、周回到達をエンドツーエンドで実測保証しています。</a:t>
+              <a:t>第五の変更、トラックです。oval と stadium が基礎、rect が 90 度の反復、chicane が左右切り返しと最小半径 10 m のキンク、fast がメインの難コース。track を random にするとエピソード毎に再抽選され、これはドメインランダマイゼーションの一種です。ただし汎化の本質は観測の帰納バイアス側にあり、fast 単体学習の方策も未見 4 コースをゼロショットで走ります。各トラックは C# プリセットと JSON に複製され、検証ハーネスが幾何一致を自動チェックします。</a:t>
             </a:r>
           </a:p>
         </p:txBody>
@@ -1012,7 +1013,7 @@
           <a:lstStyle/>
           <a:p>
             <a:r>
-              <a:t>PPO の設定判断です。オンポリシーを選んだのは、環境を頻繁に改造するためリプレイ経験がすぐ無効になること、シミュレータが軽く壁時計効率が支配的なことによります。クリップ範囲 0.15 は標準の 0.2 より狭く、壁ペナルティ由来の高分散アドバンテージでの方策崩壊を抑えます。GAE λ 0.98 は密報酬前提で分散側に寄せ、コーナー 1 つ分の信用割当を確保します。エントロピー係数は報酬スケールと結合する、が本プロジェクト最大の教訓の 1 つです。なお PPO はアドバンテージ正規化により報酬のアフィン変換に不変なので、[0,1] 正規化自体は学習のためではなく診断のための設計です。</a:t>
+              <a:t>学習の全体像です。フェーズ 1 で他車なしのレーン追従、フェーズ 2 で NPC を入れて学習率を下げ追い越しを学習します。特徴抽出はカスタム CNN で、初期方策のスロットルバイアスを +0.4 に手動シフトします。ガウス方策の平均が 0 のままだと前進と後退が等確率で、前進報酬を発見する前に壁ペナルティばかり集めるためです。動作確認用の fast-dev はかつてエントロピー係数 0.10 で、何度回しても曲がれませんでした。エントロピーボーナスが「ランダムでいること」に支払われ、[0,1] に圧縮された報酬差に勝ってしまうためです。現在は本番ハイパラのまま 12 万ステップに短縮し、周回到達をエンドツーエンドで実測保証しています。</a:t>
             </a:r>
           </a:p>
         </p:txBody>
@@ -1082,7 +1083,7 @@
           <a:lstStyle/>
           <a:p>
             <a:r>
-              <a:t>ここは正直に、シミュレータが実ゲームから何を省いているかの一覧です。車両動力学では、タイヤが線形モデルでグリップ飽和がありません。実車はスリップ角が深くなると横力が頭打ちになりますが、シムでは増え続けます。質量は 1 kg の正規化値で、荷重移動もサスもない。加速度は直接指令で、エンジン特性・ギア・空気抵抗・転がり抵抗がありません。つまりシムの車は惰性で減速しない。壁は速度を消す理想化された壁で、実ゲームの衝突インパルスや車体の回転、ダメージはモデル化していません。壁摩擦 0.6 も実測合わせが必要な仮の値です。ステアは瞬時に舵角が立つ理想アクチュエータ。タイミング面では、5 Hz の等間隔意思決定を仮定しており、フレーム時間の揺らぎや推論レイテンシ 1 フレーム分は学習に含まれていません。地形も 2D 平面で、縁石・バンク・高低差・路面 μ の変化はありません。</a:t>
+              <a:t>PPO の設定判断です。オンポリシーを選んだのは、環境を頻繁に改造するためリプレイ経験がすぐ無効になること、シミュレータが軽く壁時計効率が支配的なことによります。クリップ範囲 0.15 は標準の 0.2 より狭く、壁ペナルティ由来の高分散アドバンテージでの方策崩壊を抑えます。GAE λ 0.98 は密報酬前提で分散側に寄せ、コーナー 1 つ分の信用割当を確保します。エントロピー係数は報酬スケールと結合する、が本プロジェクト最大の教訓の 1 つです。なお PPO はアドバンテージ正規化により報酬のアフィン変換に不変なので、[0,1] 正規化自体は学習のためではなく診断のための設計です。</a:t>
             </a:r>
           </a:p>
         </p:txBody>
@@ -1152,7 +1153,7 @@
           <a:lstStyle/>
           <a:p>
             <a:r>
-              <a:t>ギャップへの対処は二層です。第一層、消せるギャップは移植の数値一致で消す。観測ビルダーはビット一致、車両物理は 1e-7 一致で C# に移植済みなので、『移植したら挙動が変わった』という自由度は存在しません。第二層、実ゲーム固有の動力学差は方策を再学習せず、デプロイ側のアクションフィルタで吸収します。EMA 平滑化は観測の 3 m 量子化由来のステア蛇行を消し、実測で符号反転が 1/3 になります。CorneringLimiter はステア速度制限と、曲率から計算した限界速度超過に比例する弱いブレーキで、グリップ飽和がないシム方策の過信を抑えます。StuckRecovery は移動距離ベースで壁刺さりを検出しバックを指示します。フィルタは閉ループ特性を変えるため、シミュレータ内で同じフィルタを通した評価で周回数が落ちないことを確認しています。それでも残る差が大きければ、壁摩擦・加速度レンジなどを実ゲーム実測に合わせて環境側を再調整し、再学習する道があります。</a:t>
+              <a:t>ここは正直に、シミュレータが実ゲームから何を省いているかの一覧です。車両動力学では、タイヤが線形モデルでグリップ飽和がありません。実車はスリップ角が深くなると横力が頭打ちになりますが、シムでは増え続けます。質量は 1 kg の正規化値で、荷重移動もサスもない。加速度は直接指令で、エンジン特性・ギア・空気抵抗・転がり抵抗がありません。つまりシムの車は惰性で減速しない。壁は速度を消す理想化された壁で、実ゲームの衝突インパルスや車体の回転、ダメージはモデル化していません。壁摩擦 0.6 も実測合わせが必要な仮の値です。ステアは瞬時に舵角が立つ理想アクチュエータ。タイミング面では、5 Hz の等間隔意思決定を仮定しており、フレーム時間の揺らぎや推論レイテンシ 1 フレーム分は学習に含まれていません。地形も 2D 平面で、縁石・バンク・高低差・路面 μ の変化はありません。</a:t>
             </a:r>
           </a:p>
         </p:txBody>
@@ -1222,7 +1223,7 @@
           <a:lstStyle/>
           <a:p>
             <a:r>
-              <a:t>使い方です。環境構築は 1 行。リポジトリ直下の requirements.txt は旧スタック用なので使いません。ノートブックは task2 が fast 専用、task3 が汎化学習。FAST_DEV_RUN で短縮と本番を切り替えます。学習の判断材料として、eval 報酬を周回数に換算するヤードスティックセルがあり、TensorBoard の数字だけで局所解か周回かを判別できます。スライドの図と動画を生成・保存するセルもノートブック内にあります。</a:t>
+              <a:t>ギャップへの対処は二層です。第一層、消せるギャップは移植の数値一致で消す。観測ビルダーはビット一致、車両物理は 1e-7 一致で C# に移植済みなので、『移植したら挙動が変わった』という自由度は存在しません。第二層、実ゲーム固有の動力学差は方策を再学習せず、デプロイ側のアクションフィルタで吸収します。EMA 平滑化は観測の 3 m 量子化由来のステア蛇行を消し、実測で符号反転が 1/3 になります。CorneringLimiter はステア速度制限と、曲率から計算した限界速度超過に比例する弱いブレーキで、グリップ飽和がないシム方策の過信を抑えます。StuckRecovery は移動距離ベースで壁刺さりを検出しバックを指示します。フィルタは閉ループ特性を変えるため、シミュレータ内で同じフィルタを通した評価で周回数が落ちないことを確認しています。それでも残る差が大きければ、壁摩擦・加速度レンジなどを実ゲーム実測に合わせて環境側を再調整し、再学習する道があります。</a:t>
             </a:r>
           </a:p>
         </p:txBody>
@@ -1362,7 +1363,7 @@
           <a:lstStyle/>
           <a:p>
             <a:r>
-              <a:t>エクスポートは export_onnx.py で、モード 3 のエンジン用 NHWC 版が推奨です。C# ビルダーは H×W×C の平坦配列を出すため、channels-first 版に入れるとチャネルが混ざり、スロットル 0.4・ステア 0.2 程度のほぼ一定出力に退化します。この症状は実際にデバッグで踏んだので、症状として覚えてください。トラックや観測を変えたらexport_track_json.py で C# 側の正解データを再生成し検証ハーネスを回します。レンジ等の定数は C# に意図的に複製されているので、変更時は 4 点セットを忘れずに。</a:t>
+              <a:t>使い方です。環境構築は 1 行。リポジトリ直下の requirements.txt は旧スタック用なので使いません。ノートブックは task2 が fast 専用、task3 が汎化学習。FAST_DEV_RUN で短縮と本番を切り替えます。学習の判断材料として、eval 報酬を周回数に換算するヤードスティックセルがあり、TensorBoard の数字だけで局所解か周回かを判別できます。スライドの図と動画を生成・保存するセルもノートブック内にあります。</a:t>
             </a:r>
           </a:p>
         </p:txBody>
@@ -1388,6 +1389,76 @@
 </file>
 
 <file path=ppt/notesSlides/notesSlide21.xml><?xml version="1.0" encoding="utf-8"?>
+<p:notes xmlns:a="http://schemas.openxmlformats.org/drawingml/2006/main" xmlns:p="http://schemas.openxmlformats.org/presentationml/2006/main" xmlns:r="http://schemas.openxmlformats.org/officeDocument/2006/relationships">
+  <p:cSld>
+    <p:spTree>
+      <p:nvGrpSpPr>
+        <p:cNvPr id="1" name=""/>
+        <p:cNvGrpSpPr/>
+        <p:nvPr/>
+      </p:nvGrpSpPr>
+      <p:grpSpPr>
+        <a:xfrm>
+          <a:off x="0" y="0"/>
+          <a:ext cx="0" cy="0"/>
+          <a:chOff x="0" y="0"/>
+          <a:chExt cx="0" cy="0"/>
+        </a:xfrm>
+      </p:grpSpPr>
+      <p:sp>
+        <p:nvSpPr>
+          <p:cNvPr id="2" name="Slide Image Placeholder 1"/>
+          <p:cNvSpPr>
+            <a:spLocks noGrp="1"/>
+          </p:cNvSpPr>
+          <p:nvPr>
+            <p:ph type="sldImg" idx="2"/>
+          </p:nvPr>
+        </p:nvSpPr>
+        <p:spPr/>
+      </p:sp>
+      <p:sp>
+        <p:nvSpPr>
+          <p:cNvPr id="3" name="Notes Placeholder 2"/>
+          <p:cNvSpPr>
+            <a:spLocks noGrp="1"/>
+          </p:cNvSpPr>
+          <p:nvPr>
+            <p:ph type="body" idx="3" sz="quarter"/>
+          </p:nvPr>
+        </p:nvSpPr>
+        <p:spPr/>
+        <p:txBody>
+          <a:bodyPr/>
+          <a:lstStyle/>
+          <a:p>
+            <a:r>
+              <a:t>エクスポートは export_onnx.py で、モード 3 のエンジン用 NHWC 版が推奨です。C# ビルダーは H×W×C の平坦配列を出すため、channels-first 版に入れるとチャネルが混ざり、スロットル 0.4・ステア 0.2 程度のほぼ一定出力に退化します。この症状は実際にデバッグで踏んだので、症状として覚えてください。トラックや観測を変えたらexport_track_json.py で C# 側の正解データを再生成し検証ハーネスを回します。レンジ等の定数は C# に意図的に複製されているので、変更時は 4 点セットを忘れずに。</a:t>
+            </a:r>
+          </a:p>
+        </p:txBody>
+      </p:sp>
+      <p:sp>
+        <p:nvSpPr>
+          <p:cNvPr id="4" name="Slide Number Placeholder 3"/>
+          <p:cNvSpPr>
+            <a:spLocks noGrp="1"/>
+          </p:cNvSpPr>
+          <p:nvPr>
+            <p:ph type="sldNum" idx="5" sz="quarter"/>
+          </p:nvPr>
+        </p:nvSpPr>
+        <p:spPr/>
+      </p:sp>
+    </p:spTree>
+  </p:cSld>
+  <p:clrMapOvr>
+    <a:masterClrMapping/>
+  </p:clrMapOvr>
+</p:notes>
+</file>
+
+<file path=ppt/notesSlides/notesSlide22.xml><?xml version="1.0" encoding="utf-8"?>
 <p:notes xmlns:a="http://schemas.openxmlformats.org/drawingml/2006/main" xmlns:p="http://schemas.openxmlformats.org/presentationml/2006/main" xmlns:r="http://schemas.openxmlformats.org/officeDocument/2006/relationships">
   <p:cSld>
     <p:spTree>
@@ -5704,6 +5775,1030 @@
                 </a:solidFill>
                 <a:latin typeface="Meiryo"/>
               </a:rPr>
+              <a:t>設定リファレンス — 報酬とシミュレーションの実値</a:t>
+            </a:r>
+          </a:p>
+        </p:txBody>
+      </p:sp>
+      <p:graphicFrame>
+        <p:nvGraphicFramePr>
+          <p:cNvPr id="3" name="Table 2"/>
+          <p:cNvGraphicFramePr>
+            <a:graphicFrameLocks noGrp="1"/>
+          </p:cNvGraphicFramePr>
+          <p:nvPr/>
+        </p:nvGraphicFramePr>
+        <p:xfrm>
+          <a:off x="365760" y="1280160"/>
+          <a:ext cx="5623560" cy="5029200"/>
+        </p:xfrm>
+        <a:graphic>
+          <a:graphicData uri="http://schemas.openxmlformats.org/drawingml/2006/table">
+            <a:tbl>
+              <a:tblPr firstRow="1" bandRow="1">
+                <a:tableStyleId>{5C22544A-7EE6-4342-B048-85BDC9FD1C3A}</a:tableStyleId>
+              </a:tblPr>
+              <a:tblGrid>
+                <a:gridCol w="2834640"/>
+                <a:gridCol w="2788920"/>
+              </a:tblGrid>
+              <a:tr h="502920">
+                <a:tc>
+                  <a:txBody>
+                    <a:bodyPr wrap="square"/>
+                    <a:lstStyle/>
+                    <a:p>
+                      <a:r>
+                        <a:rPr sz="1300" b="1">
+                          <a:solidFill>
+                            <a:srgbClr val="FFFFFF"/>
+                          </a:solidFill>
+                          <a:latin typeface="Meiryo"/>
+                        </a:rPr>
+                        <a:t>報酬の重み</a:t>
+                      </a:r>
+                    </a:p>
+                  </a:txBody>
+                  <a:tcPr marL="64008" marR="64008" marT="27432" marB="27432">
+                    <a:solidFill>
+                      <a:srgbClr val="1B5EA8"/>
+                    </a:solidFill>
+                  </a:tcPr>
+                </a:tc>
+                <a:tc>
+                  <a:txBody>
+                    <a:bodyPr wrap="square"/>
+                    <a:lstStyle/>
+                    <a:p>
+                      <a:r>
+                        <a:rPr sz="1300" b="1">
+                          <a:solidFill>
+                            <a:srgbClr val="FFFFFF"/>
+                          </a:solidFill>
+                          <a:latin typeface="Meiryo"/>
+                        </a:rPr>
+                        <a:t>値 / 範囲寄与</a:t>
+                      </a:r>
+                    </a:p>
+                  </a:txBody>
+                  <a:tcPr marL="64008" marR="64008" marT="27432" marB="27432">
+                    <a:solidFill>
+                      <a:srgbClr val="1B5EA8"/>
+                    </a:solidFill>
+                  </a:tcPr>
+                </a:tc>
+              </a:tr>
+              <a:tr h="502920">
+                <a:tc>
+                  <a:txBody>
+                    <a:bodyPr wrap="square"/>
+                    <a:lstStyle/>
+                    <a:p>
+                      <a:r>
+                        <a:rPr sz="1200" b="1">
+                          <a:solidFill>
+                            <a:srgbClr val="1B5EA8"/>
+                          </a:solidFill>
+                          <a:latin typeface="Meiryo"/>
+                        </a:rPr>
+                        <a:t>中央維持 1/(1+6·lat²)</a:t>
+                      </a:r>
+                    </a:p>
+                  </a:txBody>
+                  <a:tcPr marL="64008" marR="64008" marT="27432" marB="27432">
+                    <a:solidFill>
+                      <a:srgbClr val="F2F5FA"/>
+                    </a:solidFill>
+                  </a:tcPr>
+                </a:tc>
+                <a:tc>
+                  <a:txBody>
+                    <a:bodyPr wrap="square"/>
+                    <a:lstStyle/>
+                    <a:p>
+                      <a:r>
+                        <a:rPr sz="1200" b="0">
+                          <a:solidFill>
+                            <a:srgbClr val="222222"/>
+                          </a:solidFill>
+                          <a:latin typeface="Meiryo"/>
+                        </a:rPr>
+                        <a:t>重み 1.0 → [0, +1]</a:t>
+                      </a:r>
+                    </a:p>
+                  </a:txBody>
+                  <a:tcPr marL="64008" marR="64008" marT="27432" marB="27432">
+                    <a:solidFill>
+                      <a:srgbClr val="F2F5FA"/>
+                    </a:solidFill>
+                  </a:tcPr>
+                </a:tc>
+              </a:tr>
+              <a:tr h="502920">
+                <a:tc>
+                  <a:txBody>
+                    <a:bodyPr wrap="square"/>
+                    <a:lstStyle/>
+                    <a:p>
+                      <a:r>
+                        <a:rPr sz="1200" b="1">
+                          <a:solidFill>
+                            <a:srgbClr val="1B5EA8"/>
+                          </a:solidFill>
+                          <a:latin typeface="Meiryo"/>
+                        </a:rPr>
+                        <a:t>速度 (÷16 m/s)</a:t>
+                      </a:r>
+                    </a:p>
+                  </a:txBody>
+                  <a:tcPr marL="64008" marR="64008" marT="27432" marB="27432">
+                    <a:solidFill>
+                      <a:srgbClr val="FFFFFF"/>
+                    </a:solidFill>
+                  </a:tcPr>
+                </a:tc>
+                <a:tc>
+                  <a:txBody>
+                    <a:bodyPr wrap="square"/>
+                    <a:lstStyle/>
+                    <a:p>
+                      <a:r>
+                        <a:rPr sz="1200" b="0">
+                          <a:solidFill>
+                            <a:srgbClr val="222222"/>
+                          </a:solidFill>
+                          <a:latin typeface="Meiryo"/>
+                        </a:rPr>
+                        <a:t>1.0 → [−1, +1]</a:t>
+                      </a:r>
+                    </a:p>
+                  </a:txBody>
+                  <a:tcPr marL="64008" marR="64008" marT="27432" marB="27432">
+                    <a:solidFill>
+                      <a:srgbClr val="FFFFFF"/>
+                    </a:solidFill>
+                  </a:tcPr>
+                </a:tc>
+              </a:tr>
+              <a:tr h="502920">
+                <a:tc>
+                  <a:txBody>
+                    <a:bodyPr wrap="square"/>
+                    <a:lstStyle/>
+                    <a:p>
+                      <a:r>
+                        <a:rPr sz="1200" b="1">
+                          <a:solidFill>
+                            <a:srgbClr val="1B5EA8"/>
+                          </a:solidFill>
+                          <a:latin typeface="Meiryo"/>
+                        </a:rPr>
+                        <a:t>前進速度投影</a:t>
+                      </a:r>
+                    </a:p>
+                  </a:txBody>
+                  <a:tcPr marL="64008" marR="64008" marT="27432" marB="27432">
+                    <a:solidFill>
+                      <a:srgbClr val="F2F5FA"/>
+                    </a:solidFill>
+                  </a:tcPr>
+                </a:tc>
+                <a:tc>
+                  <a:txBody>
+                    <a:bodyPr wrap="square"/>
+                    <a:lstStyle/>
+                    <a:p>
+                      <a:r>
+                        <a:rPr sz="1200" b="0">
+                          <a:solidFill>
+                            <a:srgbClr val="222222"/>
+                          </a:solidFill>
+                          <a:latin typeface="Meiryo"/>
+                        </a:rPr>
+                        <a:t>0.8 → [−0.4, +0.8]</a:t>
+                      </a:r>
+                    </a:p>
+                  </a:txBody>
+                  <a:tcPr marL="64008" marR="64008" marT="27432" marB="27432">
+                    <a:solidFill>
+                      <a:srgbClr val="F2F5FA"/>
+                    </a:solidFill>
+                  </a:tcPr>
+                </a:tc>
+              </a:tr>
+              <a:tr h="502920">
+                <a:tc>
+                  <a:txBody>
+                    <a:bodyPr wrap="square"/>
+                    <a:lstStyle/>
+                    <a:p>
+                      <a:r>
+                        <a:rPr sz="1200" b="1">
+                          <a:solidFill>
+                            <a:srgbClr val="1B5EA8"/>
+                          </a:solidFill>
+                          <a:latin typeface="Meiryo"/>
+                        </a:rPr>
+                        <a:t>操舵 / ジャーク罰</a:t>
+                      </a:r>
+                    </a:p>
+                  </a:txBody>
+                  <a:tcPr marL="64008" marR="64008" marT="27432" marB="27432">
+                    <a:solidFill>
+                      <a:srgbClr val="FFFFFF"/>
+                    </a:solidFill>
+                  </a:tcPr>
+                </a:tc>
+                <a:tc>
+                  <a:txBody>
+                    <a:bodyPr wrap="square"/>
+                    <a:lstStyle/>
+                    <a:p>
+                      <a:r>
+                        <a:rPr sz="1200" b="0">
+                          <a:solidFill>
+                            <a:srgbClr val="222222"/>
+                          </a:solidFill>
+                          <a:latin typeface="Meiryo"/>
+                        </a:rPr>
+                        <a:t>0.10 / 0.20</a:t>
+                      </a:r>
+                    </a:p>
+                  </a:txBody>
+                  <a:tcPr marL="64008" marR="64008" marT="27432" marB="27432">
+                    <a:solidFill>
+                      <a:srgbClr val="FFFFFF"/>
+                    </a:solidFill>
+                  </a:tcPr>
+                </a:tc>
+              </a:tr>
+              <a:tr h="502920">
+                <a:tc>
+                  <a:txBody>
+                    <a:bodyPr wrap="square"/>
+                    <a:lstStyle/>
+                    <a:p>
+                      <a:r>
+                        <a:rPr sz="1200" b="1">
+                          <a:solidFill>
+                            <a:srgbClr val="1B5EA8"/>
+                          </a:solidFill>
+                          <a:latin typeface="Meiryo"/>
+                        </a:rPr>
+                        <a:t>後退 / 停止罰</a:t>
+                      </a:r>
+                    </a:p>
+                  </a:txBody>
+                  <a:tcPr marL="64008" marR="64008" marT="27432" marB="27432">
+                    <a:solidFill>
+                      <a:srgbClr val="F2F5FA"/>
+                    </a:solidFill>
+                  </a:tcPr>
+                </a:tc>
+                <a:tc>
+                  <a:txBody>
+                    <a:bodyPr wrap="square"/>
+                    <a:lstStyle/>
+                    <a:p>
+                      <a:r>
+                        <a:rPr sz="1200" b="0">
+                          <a:solidFill>
+                            <a:srgbClr val="222222"/>
+                          </a:solidFill>
+                          <a:latin typeface="Meiryo"/>
+                        </a:rPr>
+                        <a:t>0.80 / 0.80 (15 step 免除)</a:t>
+                      </a:r>
+                    </a:p>
+                  </a:txBody>
+                  <a:tcPr marL="64008" marR="64008" marT="27432" marB="27432">
+                    <a:solidFill>
+                      <a:srgbClr val="F2F5FA"/>
+                    </a:solidFill>
+                  </a:tcPr>
+                </a:tc>
+              </a:tr>
+              <a:tr h="502920">
+                <a:tc>
+                  <a:txBody>
+                    <a:bodyPr wrap="square"/>
+                    <a:lstStyle/>
+                    <a:p>
+                      <a:r>
+                        <a:rPr sz="1200" b="1">
+                          <a:solidFill>
+                            <a:srgbClr val="1B5EA8"/>
+                          </a:solidFill>
+                          <a:latin typeface="Meiryo"/>
+                        </a:rPr>
+                        <a:t>壁脱出 / 壁擦り</a:t>
+                      </a:r>
+                    </a:p>
+                  </a:txBody>
+                  <a:tcPr marL="64008" marR="64008" marT="27432" marB="27432">
+                    <a:solidFill>
+                      <a:srgbClr val="FFFFFF"/>
+                    </a:solidFill>
+                  </a:tcPr>
+                </a:tc>
+                <a:tc>
+                  <a:txBody>
+                    <a:bodyPr wrap="square"/>
+                    <a:lstStyle/>
+                    <a:p>
+                      <a:r>
+                        <a:rPr sz="1200" b="0">
+                          <a:solidFill>
+                            <a:srgbClr val="222222"/>
+                          </a:solidFill>
+                          <a:latin typeface="Meiryo"/>
+                        </a:rPr>
+                        <a:t>+0.4 / −0.6 (ゾーン 1 m)</a:t>
+                      </a:r>
+                    </a:p>
+                  </a:txBody>
+                  <a:tcPr marL="64008" marR="64008" marT="27432" marB="27432">
+                    <a:solidFill>
+                      <a:srgbClr val="FFFFFF"/>
+                    </a:solidFill>
+                  </a:tcPr>
+                </a:tc>
+              </a:tr>
+              <a:tr h="502920">
+                <a:tc>
+                  <a:txBody>
+                    <a:bodyPr wrap="square"/>
+                    <a:lstStyle/>
+                    <a:p>
+                      <a:r>
+                        <a:rPr sz="1200" b="1">
+                          <a:solidFill>
+                            <a:srgbClr val="1B5EA8"/>
+                          </a:solidFill>
+                          <a:latin typeface="Meiryo"/>
+                        </a:rPr>
+                        <a:t>CP / ラップ (生単位)</a:t>
+                      </a:r>
+                    </a:p>
+                  </a:txBody>
+                  <a:tcPr marL="64008" marR="64008" marT="27432" marB="27432">
+                    <a:solidFill>
+                      <a:srgbClr val="F2F5FA"/>
+                    </a:solidFill>
+                  </a:tcPr>
+                </a:tc>
+                <a:tc>
+                  <a:txBody>
+                    <a:bodyPr wrap="square"/>
+                    <a:lstStyle/>
+                    <a:p>
+                      <a:r>
+                        <a:rPr sz="1200" b="0">
+                          <a:solidFill>
+                            <a:srgbClr val="222222"/>
+                          </a:solidFill>
+                          <a:latin typeface="Meiryo"/>
+                        </a:rPr>
+                        <a:t>+1.0 / +2.0</a:t>
+                      </a:r>
+                    </a:p>
+                  </a:txBody>
+                  <a:tcPr marL="64008" marR="64008" marT="27432" marB="27432">
+                    <a:solidFill>
+                      <a:srgbClr val="F2F5FA"/>
+                    </a:solidFill>
+                  </a:tcPr>
+                </a:tc>
+              </a:tr>
+              <a:tr h="502920">
+                <a:tc>
+                  <a:txBody>
+                    <a:bodyPr wrap="square"/>
+                    <a:lstStyle/>
+                    <a:p>
+                      <a:r>
+                        <a:rPr sz="1200" b="1">
+                          <a:solidFill>
+                            <a:srgbClr val="1B5EA8"/>
+                          </a:solidFill>
+                          <a:latin typeface="Meiryo"/>
+                        </a:rPr>
+                        <a:t>衝突 (終端上書き)</a:t>
+                      </a:r>
+                    </a:p>
+                  </a:txBody>
+                  <a:tcPr marL="64008" marR="64008" marT="27432" marB="27432">
+                    <a:solidFill>
+                      <a:srgbClr val="FFFFFF"/>
+                    </a:solidFill>
+                  </a:tcPr>
+                </a:tc>
+                <a:tc>
+                  <a:txBody>
+                    <a:bodyPr wrap="square"/>
+                    <a:lstStyle/>
+                    <a:p>
+                      <a:r>
+                        <a:rPr sz="1200" b="0">
+                          <a:solidFill>
+                            <a:srgbClr val="222222"/>
+                          </a:solidFill>
+                          <a:latin typeface="Meiryo"/>
+                        </a:rPr>
+                        <a:t>−5.0</a:t>
+                      </a:r>
+                    </a:p>
+                  </a:txBody>
+                  <a:tcPr marL="64008" marR="64008" marT="27432" marB="27432">
+                    <a:solidFill>
+                      <a:srgbClr val="FFFFFF"/>
+                    </a:solidFill>
+                  </a:tcPr>
+                </a:tc>
+              </a:tr>
+              <a:tr h="502920">
+                <a:tc>
+                  <a:txBody>
+                    <a:bodyPr wrap="square"/>
+                    <a:lstStyle/>
+                    <a:p>
+                      <a:r>
+                        <a:rPr sz="1200" b="1">
+                          <a:solidFill>
+                            <a:srgbClr val="1B5EA8"/>
+                          </a:solidFill>
+                          <a:latin typeface="Meiryo"/>
+                        </a:rPr>
+                        <a:t>正規化</a:t>
+                      </a:r>
+                    </a:p>
+                  </a:txBody>
+                  <a:tcPr marL="64008" marR="64008" marT="27432" marB="27432">
+                    <a:solidFill>
+                      <a:srgbClr val="F2F5FA"/>
+                    </a:solidFill>
+                  </a:tcPr>
+                </a:tc>
+                <a:tc>
+                  <a:txBody>
+                    <a:bodyPr wrap="square"/>
+                    <a:lstStyle/>
+                    <a:p>
+                      <a:r>
+                        <a:rPr sz="1200" b="0">
+                          <a:solidFill>
+                            <a:srgbClr val="222222"/>
+                          </a:solidFill>
+                          <a:latin typeface="Meiryo"/>
+                        </a:rPr>
+                        <a:t>lmap [−3,3] → [0,1] → clip</a:t>
+                      </a:r>
+                    </a:p>
+                  </a:txBody>
+                  <a:tcPr marL="64008" marR="64008" marT="27432" marB="27432">
+                    <a:solidFill>
+                      <a:srgbClr val="F2F5FA"/>
+                    </a:solidFill>
+                  </a:tcPr>
+                </a:tc>
+              </a:tr>
+            </a:tbl>
+          </a:graphicData>
+        </a:graphic>
+      </p:graphicFrame>
+      <p:graphicFrame>
+        <p:nvGraphicFramePr>
+          <p:cNvPr id="4" name="Table 3"/>
+          <p:cNvGraphicFramePr>
+            <a:graphicFrameLocks noGrp="1"/>
+          </p:cNvGraphicFramePr>
+          <p:nvPr/>
+        </p:nvGraphicFramePr>
+        <p:xfrm>
+          <a:off x="6263640" y="1280160"/>
+          <a:ext cx="5577840" cy="5029200"/>
+        </p:xfrm>
+        <a:graphic>
+          <a:graphicData uri="http://schemas.openxmlformats.org/drawingml/2006/table">
+            <a:tbl>
+              <a:tblPr firstRow="1" bandRow="1">
+                <a:tableStyleId>{5C22544A-7EE6-4342-B048-85BDC9FD1C3A}</a:tableStyleId>
+              </a:tblPr>
+              <a:tblGrid>
+                <a:gridCol w="2606040"/>
+                <a:gridCol w="2971800"/>
+              </a:tblGrid>
+              <a:tr h="502920">
+                <a:tc>
+                  <a:txBody>
+                    <a:bodyPr wrap="square"/>
+                    <a:lstStyle/>
+                    <a:p>
+                      <a:r>
+                        <a:rPr sz="1300" b="1">
+                          <a:solidFill>
+                            <a:srgbClr val="FFFFFF"/>
+                          </a:solidFill>
+                          <a:latin typeface="Meiryo"/>
+                        </a:rPr>
+                        <a:t>シミュレーション / 行動 / 観測</a:t>
+                      </a:r>
+                    </a:p>
+                  </a:txBody>
+                  <a:tcPr marL="64008" marR="64008" marT="27432" marB="27432">
+                    <a:solidFill>
+                      <a:srgbClr val="1B5EA8"/>
+                    </a:solidFill>
+                  </a:tcPr>
+                </a:tc>
+                <a:tc>
+                  <a:txBody>
+                    <a:bodyPr wrap="square"/>
+                    <a:lstStyle/>
+                    <a:p>
+                      <a:r>
+                        <a:rPr sz="1300" b="1">
+                          <a:solidFill>
+                            <a:srgbClr val="FFFFFF"/>
+                          </a:solidFill>
+                          <a:latin typeface="Meiryo"/>
+                        </a:rPr>
+                        <a:t>値</a:t>
+                      </a:r>
+                    </a:p>
+                  </a:txBody>
+                  <a:tcPr marL="64008" marR="64008" marT="27432" marB="27432">
+                    <a:solidFill>
+                      <a:srgbClr val="1B5EA8"/>
+                    </a:solidFill>
+                  </a:tcPr>
+                </a:tc>
+              </a:tr>
+              <a:tr h="502920">
+                <a:tc>
+                  <a:txBody>
+                    <a:bodyPr wrap="square"/>
+                    <a:lstStyle/>
+                    <a:p>
+                      <a:r>
+                        <a:rPr sz="1200" b="1">
+                          <a:solidFill>
+                            <a:srgbClr val="1B5EA8"/>
+                          </a:solidFill>
+                          <a:latin typeface="Meiryo"/>
+                        </a:rPr>
+                        <a:t>物理 / 意思決定</a:t>
+                      </a:r>
+                    </a:p>
+                  </a:txBody>
+                  <a:tcPr marL="64008" marR="64008" marT="27432" marB="27432">
+                    <a:solidFill>
+                      <a:srgbClr val="F2F5FA"/>
+                    </a:solidFill>
+                  </a:tcPr>
+                </a:tc>
+                <a:tc>
+                  <a:txBody>
+                    <a:bodyPr wrap="square"/>
+                    <a:lstStyle/>
+                    <a:p>
+                      <a:r>
+                        <a:rPr sz="1200" b="0">
+                          <a:solidFill>
+                            <a:srgbClr val="222222"/>
+                          </a:solidFill>
+                          <a:latin typeface="Meiryo"/>
+                        </a:rPr>
+                        <a:t>15 Hz / 5 Hz (repeat 3)</a:t>
+                      </a:r>
+                    </a:p>
+                  </a:txBody>
+                  <a:tcPr marL="64008" marR="64008" marT="27432" marB="27432">
+                    <a:solidFill>
+                      <a:srgbClr val="F2F5FA"/>
+                    </a:solidFill>
+                  </a:tcPr>
+                </a:tc>
+              </a:tr>
+              <a:tr h="502920">
+                <a:tc>
+                  <a:txBody>
+                    <a:bodyPr wrap="square"/>
+                    <a:lstStyle/>
+                    <a:p>
+                      <a:r>
+                        <a:rPr sz="1200" b="1">
+                          <a:solidFill>
+                            <a:srgbClr val="1B5EA8"/>
+                          </a:solidFill>
+                          <a:latin typeface="Meiryo"/>
+                        </a:rPr>
+                        <a:t>制限速度</a:t>
+                      </a:r>
+                    </a:p>
+                  </a:txBody>
+                  <a:tcPr marL="64008" marR="64008" marT="27432" marB="27432">
+                    <a:solidFill>
+                      <a:srgbClr val="FFFFFF"/>
+                    </a:solidFill>
+                  </a:tcPr>
+                </a:tc>
+                <a:tc>
+                  <a:txBody>
+                    <a:bodyPr wrap="square"/>
+                    <a:lstStyle/>
+                    <a:p>
+                      <a:r>
+                        <a:rPr sz="1200" b="0">
+                          <a:solidFill>
+                            <a:srgbClr val="222222"/>
+                          </a:solidFill>
+                          <a:latin typeface="Meiryo"/>
+                        </a:rPr>
+                        <a:t>16 m/s</a:t>
+                      </a:r>
+                    </a:p>
+                  </a:txBody>
+                  <a:tcPr marL="64008" marR="64008" marT="27432" marB="27432">
+                    <a:solidFill>
+                      <a:srgbClr val="FFFFFF"/>
+                    </a:solidFill>
+                  </a:tcPr>
+                </a:tc>
+              </a:tr>
+              <a:tr h="502920">
+                <a:tc>
+                  <a:txBody>
+                    <a:bodyPr wrap="square"/>
+                    <a:lstStyle/>
+                    <a:p>
+                      <a:r>
+                        <a:rPr sz="1200" b="1">
+                          <a:solidFill>
+                            <a:srgbClr val="1B5EA8"/>
+                          </a:solidFill>
+                          <a:latin typeface="Meiryo"/>
+                        </a:rPr>
+                        <a:t>加速度レンジ</a:t>
+                      </a:r>
+                    </a:p>
+                  </a:txBody>
+                  <a:tcPr marL="64008" marR="64008" marT="27432" marB="27432">
+                    <a:solidFill>
+                      <a:srgbClr val="F2F5FA"/>
+                    </a:solidFill>
+                  </a:tcPr>
+                </a:tc>
+                <a:tc>
+                  <a:txBody>
+                    <a:bodyPr wrap="square"/>
+                    <a:lstStyle/>
+                    <a:p>
+                      <a:r>
+                        <a:rPr sz="1200" b="0">
+                          <a:solidFill>
+                            <a:srgbClr val="222222"/>
+                          </a:solidFill>
+                          <a:latin typeface="Meiryo"/>
+                        </a:rPr>
+                        <a:t>±5 m/s²</a:t>
+                      </a:r>
+                    </a:p>
+                  </a:txBody>
+                  <a:tcPr marL="64008" marR="64008" marT="27432" marB="27432">
+                    <a:solidFill>
+                      <a:srgbClr val="F2F5FA"/>
+                    </a:solidFill>
+                  </a:tcPr>
+                </a:tc>
+              </a:tr>
+              <a:tr h="502920">
+                <a:tc>
+                  <a:txBody>
+                    <a:bodyPr wrap="square"/>
+                    <a:lstStyle/>
+                    <a:p>
+                      <a:r>
+                        <a:rPr sz="1200" b="1">
+                          <a:solidFill>
+                            <a:srgbClr val="1B5EA8"/>
+                          </a:solidFill>
+                          <a:latin typeface="Meiryo"/>
+                        </a:rPr>
+                        <a:t>舵角レンジ</a:t>
+                      </a:r>
+                    </a:p>
+                  </a:txBody>
+                  <a:tcPr marL="64008" marR="64008" marT="27432" marB="27432">
+                    <a:solidFill>
+                      <a:srgbClr val="FFFFFF"/>
+                    </a:solidFill>
+                  </a:tcPr>
+                </a:tc>
+                <a:tc>
+                  <a:txBody>
+                    <a:bodyPr wrap="square"/>
+                    <a:lstStyle/>
+                    <a:p>
+                      <a:r>
+                        <a:rPr sz="1200" b="0">
+                          <a:solidFill>
+                            <a:srgbClr val="222222"/>
+                          </a:solidFill>
+                          <a:latin typeface="Meiryo"/>
+                        </a:rPr>
+                        <a:t>±π/6 (30°)</a:t>
+                      </a:r>
+                    </a:p>
+                  </a:txBody>
+                  <a:tcPr marL="64008" marR="64008" marT="27432" marB="27432">
+                    <a:solidFill>
+                      <a:srgbClr val="FFFFFF"/>
+                    </a:solidFill>
+                  </a:tcPr>
+                </a:tc>
+              </a:tr>
+              <a:tr h="502920">
+                <a:tc>
+                  <a:txBody>
+                    <a:bodyPr wrap="square"/>
+                    <a:lstStyle/>
+                    <a:p>
+                      <a:r>
+                        <a:rPr sz="1200" b="1">
+                          <a:solidFill>
+                            <a:srgbClr val="1B5EA8"/>
+                          </a:solidFill>
+                          <a:latin typeface="Meiryo"/>
+                        </a:rPr>
+                        <a:t>車両モデル</a:t>
+                      </a:r>
+                    </a:p>
+                  </a:txBody>
+                  <a:tcPr marL="64008" marR="64008" marT="27432" marB="27432">
+                    <a:solidFill>
+                      <a:srgbClr val="F2F5FA"/>
+                    </a:solidFill>
+                  </a:tcPr>
+                </a:tc>
+                <a:tc>
+                  <a:txBody>
+                    <a:bodyPr wrap="square"/>
+                    <a:lstStyle/>
+                    <a:p>
+                      <a:r>
+                        <a:rPr sz="1200" b="0">
+                          <a:solidFill>
+                            <a:srgbClr val="222222"/>
+                          </a:solidFill>
+                          <a:latin typeface="Meiryo"/>
+                        </a:rPr>
+                        <a:t>動的 Bicycle (RK4)</a:t>
+                      </a:r>
+                    </a:p>
+                  </a:txBody>
+                  <a:tcPr marL="64008" marR="64008" marT="27432" marB="27432">
+                    <a:solidFill>
+                      <a:srgbClr val="F2F5FA"/>
+                    </a:solidFill>
+                  </a:tcPr>
+                </a:tc>
+              </a:tr>
+              <a:tr h="502920">
+                <a:tc>
+                  <a:txBody>
+                    <a:bodyPr wrap="square"/>
+                    <a:lstStyle/>
+                    <a:p>
+                      <a:r>
+                        <a:rPr sz="1200" b="1">
+                          <a:solidFill>
+                            <a:srgbClr val="1B5EA8"/>
+                          </a:solidFill>
+                          <a:latin typeface="Meiryo"/>
+                        </a:rPr>
+                        <a:t>観測</a:t>
+                      </a:r>
+                    </a:p>
+                  </a:txBody>
+                  <a:tcPr marL="64008" marR="64008" marT="27432" marB="27432">
+                    <a:solidFill>
+                      <a:srgbClr val="FFFFFF"/>
+                    </a:solidFill>
+                  </a:tcPr>
+                </a:tc>
+                <a:tc>
+                  <a:txBody>
+                    <a:bodyPr wrap="square"/>
+                    <a:lstStyle/>
+                    <a:p>
+                      <a:r>
+                        <a:rPr sz="1200" b="0">
+                          <a:solidFill>
+                            <a:srgbClr val="222222"/>
+                          </a:solidFill>
+                          <a:latin typeface="Meiryo"/>
+                        </a:rPr>
+                        <a:t>10ch, 前27/後9/横±18 m, 3 m</a:t>
+                      </a:r>
+                    </a:p>
+                  </a:txBody>
+                  <a:tcPr marL="64008" marR="64008" marT="27432" marB="27432">
+                    <a:solidFill>
+                      <a:srgbClr val="FFFFFF"/>
+                    </a:solidFill>
+                  </a:tcPr>
+                </a:tc>
+              </a:tr>
+              <a:tr h="502920">
+                <a:tc>
+                  <a:txBody>
+                    <a:bodyPr wrap="square"/>
+                    <a:lstStyle/>
+                    <a:p>
+                      <a:r>
+                        <a:rPr sz="1200" b="1">
+                          <a:solidFill>
+                            <a:srgbClr val="1B5EA8"/>
+                          </a:solidFill>
+                          <a:latin typeface="Meiryo"/>
+                        </a:rPr>
+                        <a:t>壁</a:t>
+                      </a:r>
+                    </a:p>
+                  </a:txBody>
+                  <a:tcPr marL="64008" marR="64008" marT="27432" marB="27432">
+                    <a:solidFill>
+                      <a:srgbClr val="F2F5FA"/>
+                    </a:solidFill>
+                  </a:tcPr>
+                </a:tc>
+                <a:tc>
+                  <a:txBody>
+                    <a:bodyPr wrap="square"/>
+                    <a:lstStyle/>
+                    <a:p>
+                      <a:r>
+                        <a:rPr sz="1200" b="0">
+                          <a:solidFill>
+                            <a:srgbClr val="222222"/>
+                          </a:solidFill>
+                          <a:latin typeface="Meiryo"/>
+                        </a:rPr>
+                        <a:t>stop + 摩擦 0.6, 35 step 終端</a:t>
+                      </a:r>
+                    </a:p>
+                  </a:txBody>
+                  <a:tcPr marL="64008" marR="64008" marT="27432" marB="27432">
+                    <a:solidFill>
+                      <a:srgbClr val="F2F5FA"/>
+                    </a:solidFill>
+                  </a:tcPr>
+                </a:tc>
+              </a:tr>
+              <a:tr h="502920">
+                <a:tc>
+                  <a:txBody>
+                    <a:bodyPr wrap="square"/>
+                    <a:lstStyle/>
+                    <a:p>
+                      <a:r>
+                        <a:rPr sz="1200" b="1">
+                          <a:solidFill>
+                            <a:srgbClr val="1B5EA8"/>
+                          </a:solidFill>
+                          <a:latin typeface="Meiryo"/>
+                        </a:rPr>
+                        <a:t>エピソード長</a:t>
+                      </a:r>
+                    </a:p>
+                  </a:txBody>
+                  <a:tcPr marL="64008" marR="64008" marT="27432" marB="27432">
+                    <a:solidFill>
+                      <a:srgbClr val="FFFFFF"/>
+                    </a:solidFill>
+                  </a:tcPr>
+                </a:tc>
+                <a:tc>
+                  <a:txBody>
+                    <a:bodyPr wrap="square"/>
+                    <a:lstStyle/>
+                    <a:p>
+                      <a:r>
+                        <a:rPr sz="1200" b="0">
+                          <a:solidFill>
+                            <a:srgbClr val="222222"/>
+                          </a:solidFill>
+                          <a:latin typeface="Meiryo"/>
+                        </a:rPr>
+                        <a:t>800 s (評価 120/60 s)</a:t>
+                      </a:r>
+                    </a:p>
+                  </a:txBody>
+                  <a:tcPr marL="64008" marR="64008" marT="27432" marB="27432">
+                    <a:solidFill>
+                      <a:srgbClr val="FFFFFF"/>
+                    </a:solidFill>
+                  </a:tcPr>
+                </a:tc>
+              </a:tr>
+              <a:tr h="502920">
+                <a:tc>
+                  <a:txBody>
+                    <a:bodyPr wrap="square"/>
+                    <a:lstStyle/>
+                    <a:p>
+                      <a:r>
+                        <a:rPr sz="1200" b="1">
+                          <a:solidFill>
+                            <a:srgbClr val="1B5EA8"/>
+                          </a:solidFill>
+                          <a:latin typeface="Meiryo"/>
+                        </a:rPr>
+                        <a:t>路外</a:t>
+                      </a:r>
+                    </a:p>
+                  </a:txBody>
+                  <a:tcPr marL="64008" marR="64008" marT="27432" marB="27432">
+                    <a:solidFill>
+                      <a:srgbClr val="F2F5FA"/>
+                    </a:solidFill>
+                  </a:tcPr>
+                </a:tc>
+                <a:tc>
+                  <a:txBody>
+                    <a:bodyPr wrap="square"/>
+                    <a:lstStyle/>
+                    <a:p>
+                      <a:r>
+                        <a:rPr sz="1200" b="0">
+                          <a:solidFill>
+                            <a:srgbClr val="222222"/>
+                          </a:solidFill>
+                          <a:latin typeface="Meiryo"/>
+                        </a:rPr>
+                        <a:t>terminate_off_road=True</a:t>
+                      </a:r>
+                    </a:p>
+                  </a:txBody>
+                  <a:tcPr marL="64008" marR="64008" marT="27432" marB="27432">
+                    <a:solidFill>
+                      <a:srgbClr val="F2F5FA"/>
+                    </a:solidFill>
+                  </a:tcPr>
+                </a:tc>
+              </a:tr>
+            </a:tbl>
+          </a:graphicData>
+        </a:graphic>
+      </p:graphicFrame>
+    </p:spTree>
+  </p:cSld>
+  <p:clrMapOvr>
+    <a:masterClrMapping/>
+  </p:clrMapOvr>
+</p:sld>
+</file>
+
+<file path=ppt/slides/slide14.xml><?xml version="1.0" encoding="utf-8"?>
+<p:sld xmlns:a="http://schemas.openxmlformats.org/drawingml/2006/main" xmlns:p="http://schemas.openxmlformats.org/presentationml/2006/main" xmlns:r="http://schemas.openxmlformats.org/officeDocument/2006/relationships">
+  <p:cSld>
+    <p:spTree>
+      <p:nvGrpSpPr>
+        <p:cNvPr id="1" name=""/>
+        <p:cNvGrpSpPr/>
+        <p:nvPr/>
+      </p:nvGrpSpPr>
+      <p:grpSpPr/>
+      <p:sp>
+        <p:nvSpPr>
+          <p:cNvPr id="2" name="TextBox 1"/>
+          <p:cNvSpPr txBox="1"/>
+          <p:nvPr/>
+        </p:nvSpPr>
+        <p:spPr>
+          <a:xfrm>
+            <a:off x="457200" y="182880"/>
+            <a:ext cx="11247120" cy="731520"/>
+          </a:xfrm>
+          <a:prstGeom prst="rect">
+            <a:avLst/>
+          </a:prstGeom>
+          <a:noFill/>
+        </p:spPr>
+        <p:txBody>
+          <a:bodyPr wrap="none">
+            <a:spAutoFit/>
+          </a:bodyPr>
+          <a:lstStyle/>
+          <a:p>
+            <a:r>
+              <a:rPr sz="2700" b="1">
+                <a:solidFill>
+                  <a:srgbClr val="1B5EA8"/>
+                </a:solidFill>
+                <a:latin typeface="Meiryo"/>
+              </a:rPr>
               <a:t>進化 (4) 観測 — 10 チャネルの内訳と正規化レンジ</a:t>
             </a:r>
           </a:p>
@@ -5892,7 +6987,7 @@
 </p:sld>
 </file>
 
-<file path=ppt/slides/slide14.xml><?xml version="1.0" encoding="utf-8"?>
+<file path=ppt/slides/slide15.xml><?xml version="1.0" encoding="utf-8"?>
 <p:sld xmlns:a="http://schemas.openxmlformats.org/drawingml/2006/main" xmlns:p="http://schemas.openxmlformats.org/presentationml/2006/main" xmlns:r="http://schemas.openxmlformats.org/officeDocument/2006/relationships">
   <p:cSld>
     <p:spTree>
@@ -6007,7 +7102,7 @@
 </p:sld>
 </file>
 
-<file path=ppt/slides/slide15.xml><?xml version="1.0" encoding="utf-8"?>
+<file path=ppt/slides/slide16.xml><?xml version="1.0" encoding="utf-8"?>
 <p:sld xmlns:a="http://schemas.openxmlformats.org/drawingml/2006/main" xmlns:p="http://schemas.openxmlformats.org/presentationml/2006/main" xmlns:r="http://schemas.openxmlformats.org/officeDocument/2006/relationships">
   <p:cSld>
     <p:spTree>
@@ -6230,209 +7325,6 @@
                 <a:latin typeface="Meiryo"/>
               </a:rPr>
               <a:t>・EvalCallback の決定論的評価ベスト採用 (PPO は終盤退行あり / stochastic 評価は過小評価)</a:t>
-            </a:r>
-          </a:p>
-        </p:txBody>
-      </p:sp>
-    </p:spTree>
-  </p:cSld>
-  <p:clrMapOvr>
-    <a:masterClrMapping/>
-  </p:clrMapOvr>
-</p:sld>
-</file>
-
-<file path=ppt/slides/slide16.xml><?xml version="1.0" encoding="utf-8"?>
-<p:sld xmlns:a="http://schemas.openxmlformats.org/drawingml/2006/main" xmlns:p="http://schemas.openxmlformats.org/presentationml/2006/main" xmlns:r="http://schemas.openxmlformats.org/officeDocument/2006/relationships">
-  <p:cSld>
-    <p:spTree>
-      <p:nvGrpSpPr>
-        <p:cNvPr id="1" name=""/>
-        <p:cNvGrpSpPr/>
-        <p:nvPr/>
-      </p:nvGrpSpPr>
-      <p:grpSpPr/>
-      <p:sp>
-        <p:nvSpPr>
-          <p:cNvPr id="2" name="TextBox 1"/>
-          <p:cNvSpPr txBox="1"/>
-          <p:nvPr/>
-        </p:nvSpPr>
-        <p:spPr>
-          <a:xfrm>
-            <a:off x="457200" y="182880"/>
-            <a:ext cx="11247120" cy="731520"/>
-          </a:xfrm>
-          <a:prstGeom prst="rect">
-            <a:avLst/>
-          </a:prstGeom>
-          <a:noFill/>
-        </p:spPr>
-        <p:txBody>
-          <a:bodyPr wrap="none">
-            <a:spAutoFit/>
-          </a:bodyPr>
-          <a:lstStyle/>
-          <a:p>
-            <a:r>
-              <a:rPr sz="2700" b="1">
-                <a:solidFill>
-                  <a:srgbClr val="1B5EA8"/>
-                </a:solidFill>
-                <a:latin typeface="Meiryo"/>
-              </a:rPr>
-              <a:t>PPO ハイパーパラメータの設計判断 (専門家向け)</a:t>
-            </a:r>
-          </a:p>
-        </p:txBody>
-      </p:sp>
-      <p:sp>
-        <p:nvSpPr>
-          <p:cNvPr id="3" name="TextBox 2"/>
-          <p:cNvSpPr txBox="1"/>
-          <p:nvPr/>
-        </p:nvSpPr>
-        <p:spPr>
-          <a:xfrm>
-            <a:off x="548640" y="1188720"/>
-            <a:ext cx="11064240" cy="5486400"/>
-          </a:xfrm>
-          <a:prstGeom prst="rect">
-            <a:avLst/>
-          </a:prstGeom>
-          <a:noFill/>
-        </p:spPr>
-        <p:txBody>
-          <a:bodyPr wrap="square">
-            <a:spAutoFit/>
-          </a:bodyPr>
-          <a:lstStyle/>
-          <a:p>
-            <a:pPr>
-              <a:spcAft>
-                <a:spcPts val="600"/>
-              </a:spcAft>
-            </a:pPr>
-            <a:r>
-              <a:rPr sz="1600" b="1">
-                <a:solidFill>
-                  <a:srgbClr val="222222"/>
-                </a:solidFill>
-                <a:latin typeface="Meiryo"/>
-              </a:rPr>
-              <a:t>アルゴリズム選択</a:t>
-            </a:r>
-          </a:p>
-          <a:p>
-            <a:pPr lvl="1">
-              <a:spcAft>
-                <a:spcPts val="200"/>
-              </a:spcAft>
-            </a:pPr>
-            <a:r>
-              <a:rPr sz="1400" b="0">
-                <a:solidFill>
-                  <a:srgbClr val="595959"/>
-                </a:solidFill>
-                <a:latin typeface="Meiryo"/>
-              </a:rPr>
-              <a:t>・オンポリシー (PPO): 環境改造が頻繁 → 古い経験が即無効 / sim 軽量で wall-clock 優位</a:t>
-            </a:r>
-          </a:p>
-          <a:p>
-            <a:pPr>
-              <a:spcAft>
-                <a:spcPts val="600"/>
-              </a:spcAft>
-            </a:pPr>
-            <a:r>
-              <a:rPr sz="1600" b="1">
-                <a:solidFill>
-                  <a:srgbClr val="222222"/>
-                </a:solidFill>
-                <a:latin typeface="Meiryo"/>
-              </a:rPr>
-              <a:t>主要ハイパラ</a:t>
-            </a:r>
-          </a:p>
-          <a:p>
-            <a:pPr lvl="1">
-              <a:spcAft>
-                <a:spcPts val="200"/>
-              </a:spcAft>
-            </a:pPr>
-            <a:r>
-              <a:rPr sz="1400" b="0">
-                <a:solidFill>
-                  <a:srgbClr val="595959"/>
-                </a:solidFill>
-                <a:latin typeface="Meiryo"/>
-              </a:rPr>
-              <a:t>・clip ε 0.15 (&lt;0.2): 高分散アドバンテージ下の方策崩壊を抑制</a:t>
-            </a:r>
-          </a:p>
-          <a:p>
-            <a:pPr lvl="1">
-              <a:spcAft>
-                <a:spcPts val="200"/>
-              </a:spcAft>
-            </a:pPr>
-            <a:r>
-              <a:rPr sz="1400" b="0">
-                <a:solidFill>
-                  <a:srgbClr val="595959"/>
-                </a:solidFill>
-                <a:latin typeface="Meiryo"/>
-              </a:rPr>
-              <a:t>・γ 0.99 / GAE λ 0.98 / n_steps 512×8env / minibatch 256 / 8〜15 epochs / linear LR decay</a:t>
-            </a:r>
-          </a:p>
-          <a:p>
-            <a:pPr lvl="1">
-              <a:spcAft>
-                <a:spcPts val="200"/>
-              </a:spcAft>
-            </a:pPr>
-            <a:r>
-              <a:rPr sz="1400" b="1">
-                <a:solidFill>
-                  <a:srgbClr val="595959"/>
-                </a:solidFill>
-                <a:latin typeface="Meiryo"/>
-              </a:rPr>
-              <a:t>・ent_coef 0.02: [0,1] 圧縮報酬との結合に注意 (0.10 は実質ランダム方策に収束)</a:t>
-            </a:r>
-          </a:p>
-          <a:p>
-            <a:pPr>
-              <a:spcAft>
-                <a:spcPts val="600"/>
-              </a:spcAft>
-            </a:pPr>
-            <a:r>
-              <a:rPr sz="1600" b="1">
-                <a:solidFill>
-                  <a:srgbClr val="222222"/>
-                </a:solidFill>
-                <a:latin typeface="Meiryo"/>
-              </a:rPr>
-              <a:t>備考</a:t>
-            </a:r>
-          </a:p>
-          <a:p>
-            <a:pPr lvl="1">
-              <a:spcAft>
-                <a:spcPts val="200"/>
-              </a:spcAft>
-            </a:pPr>
-            <a:r>
-              <a:rPr sz="1400" b="0">
-                <a:solidFill>
-                  <a:srgbClr val="595959"/>
-                </a:solidFill>
-                <a:latin typeface="Meiryo"/>
-              </a:rPr>
-              <a:t>・アドバンテージ正規化 → 報酬のアフィン変換に不変。[0,1] 化は診断用の設計</a:t>
             </a:r>
           </a:p>
         </p:txBody>
@@ -6484,6 +7376,209 @@
                 </a:solidFill>
                 <a:latin typeface="Meiryo"/>
               </a:rPr>
+              <a:t>PPO ハイパーパラメータの設計判断 (専門家向け)</a:t>
+            </a:r>
+          </a:p>
+        </p:txBody>
+      </p:sp>
+      <p:sp>
+        <p:nvSpPr>
+          <p:cNvPr id="3" name="TextBox 2"/>
+          <p:cNvSpPr txBox="1"/>
+          <p:nvPr/>
+        </p:nvSpPr>
+        <p:spPr>
+          <a:xfrm>
+            <a:off x="548640" y="1188720"/>
+            <a:ext cx="11064240" cy="5486400"/>
+          </a:xfrm>
+          <a:prstGeom prst="rect">
+            <a:avLst/>
+          </a:prstGeom>
+          <a:noFill/>
+        </p:spPr>
+        <p:txBody>
+          <a:bodyPr wrap="square">
+            <a:spAutoFit/>
+          </a:bodyPr>
+          <a:lstStyle/>
+          <a:p>
+            <a:pPr>
+              <a:spcAft>
+                <a:spcPts val="600"/>
+              </a:spcAft>
+            </a:pPr>
+            <a:r>
+              <a:rPr sz="1600" b="1">
+                <a:solidFill>
+                  <a:srgbClr val="222222"/>
+                </a:solidFill>
+                <a:latin typeface="Meiryo"/>
+              </a:rPr>
+              <a:t>アルゴリズム選択</a:t>
+            </a:r>
+          </a:p>
+          <a:p>
+            <a:pPr lvl="1">
+              <a:spcAft>
+                <a:spcPts val="200"/>
+              </a:spcAft>
+            </a:pPr>
+            <a:r>
+              <a:rPr sz="1400" b="0">
+                <a:solidFill>
+                  <a:srgbClr val="595959"/>
+                </a:solidFill>
+                <a:latin typeface="Meiryo"/>
+              </a:rPr>
+              <a:t>・オンポリシー (PPO): 環境改造が頻繁 → 古い経験が即無効 / sim 軽量で wall-clock 優位</a:t>
+            </a:r>
+          </a:p>
+          <a:p>
+            <a:pPr>
+              <a:spcAft>
+                <a:spcPts val="600"/>
+              </a:spcAft>
+            </a:pPr>
+            <a:r>
+              <a:rPr sz="1600" b="1">
+                <a:solidFill>
+                  <a:srgbClr val="222222"/>
+                </a:solidFill>
+                <a:latin typeface="Meiryo"/>
+              </a:rPr>
+              <a:t>主要ハイパラ</a:t>
+            </a:r>
+          </a:p>
+          <a:p>
+            <a:pPr lvl="1">
+              <a:spcAft>
+                <a:spcPts val="200"/>
+              </a:spcAft>
+            </a:pPr>
+            <a:r>
+              <a:rPr sz="1400" b="0">
+                <a:solidFill>
+                  <a:srgbClr val="595959"/>
+                </a:solidFill>
+                <a:latin typeface="Meiryo"/>
+              </a:rPr>
+              <a:t>・clip ε 0.15 (&lt;0.2): 高分散アドバンテージ下の方策崩壊を抑制</a:t>
+            </a:r>
+          </a:p>
+          <a:p>
+            <a:pPr lvl="1">
+              <a:spcAft>
+                <a:spcPts val="200"/>
+              </a:spcAft>
+            </a:pPr>
+            <a:r>
+              <a:rPr sz="1400" b="0">
+                <a:solidFill>
+                  <a:srgbClr val="595959"/>
+                </a:solidFill>
+                <a:latin typeface="Meiryo"/>
+              </a:rPr>
+              <a:t>・γ 0.99 / GAE λ 0.98 / n_steps 512×8env / minibatch 256 / 8〜15 epochs / linear LR decay</a:t>
+            </a:r>
+          </a:p>
+          <a:p>
+            <a:pPr lvl="1">
+              <a:spcAft>
+                <a:spcPts val="200"/>
+              </a:spcAft>
+            </a:pPr>
+            <a:r>
+              <a:rPr sz="1400" b="1">
+                <a:solidFill>
+                  <a:srgbClr val="595959"/>
+                </a:solidFill>
+                <a:latin typeface="Meiryo"/>
+              </a:rPr>
+              <a:t>・ent_coef 0.02: [0,1] 圧縮報酬との結合に注意 (0.10 は実質ランダム方策に収束)</a:t>
+            </a:r>
+          </a:p>
+          <a:p>
+            <a:pPr>
+              <a:spcAft>
+                <a:spcPts val="600"/>
+              </a:spcAft>
+            </a:pPr>
+            <a:r>
+              <a:rPr sz="1600" b="1">
+                <a:solidFill>
+                  <a:srgbClr val="222222"/>
+                </a:solidFill>
+                <a:latin typeface="Meiryo"/>
+              </a:rPr>
+              <a:t>備考</a:t>
+            </a:r>
+          </a:p>
+          <a:p>
+            <a:pPr lvl="1">
+              <a:spcAft>
+                <a:spcPts val="200"/>
+              </a:spcAft>
+            </a:pPr>
+            <a:r>
+              <a:rPr sz="1400" b="0">
+                <a:solidFill>
+                  <a:srgbClr val="595959"/>
+                </a:solidFill>
+                <a:latin typeface="Meiryo"/>
+              </a:rPr>
+              <a:t>・アドバンテージ正規化 → 報酬のアフィン変換に不変。[0,1] 化は診断用の設計</a:t>
+            </a:r>
+          </a:p>
+        </p:txBody>
+      </p:sp>
+    </p:spTree>
+  </p:cSld>
+  <p:clrMapOvr>
+    <a:masterClrMapping/>
+  </p:clrMapOvr>
+</p:sld>
+</file>
+
+<file path=ppt/slides/slide18.xml><?xml version="1.0" encoding="utf-8"?>
+<p:sld xmlns:a="http://schemas.openxmlformats.org/drawingml/2006/main" xmlns:p="http://schemas.openxmlformats.org/presentationml/2006/main" xmlns:r="http://schemas.openxmlformats.org/officeDocument/2006/relationships">
+  <p:cSld>
+    <p:spTree>
+      <p:nvGrpSpPr>
+        <p:cNvPr id="1" name=""/>
+        <p:cNvGrpSpPr/>
+        <p:nvPr/>
+      </p:nvGrpSpPr>
+      <p:grpSpPr/>
+      <p:sp>
+        <p:nvSpPr>
+          <p:cNvPr id="2" name="TextBox 1"/>
+          <p:cNvSpPr txBox="1"/>
+          <p:nvPr/>
+        </p:nvSpPr>
+        <p:spPr>
+          <a:xfrm>
+            <a:off x="457200" y="182880"/>
+            <a:ext cx="11247120" cy="731520"/>
+          </a:xfrm>
+          <a:prstGeom prst="rect">
+            <a:avLst/>
+          </a:prstGeom>
+          <a:noFill/>
+        </p:spPr>
+        <p:txBody>
+          <a:bodyPr wrap="none">
+            <a:spAutoFit/>
+          </a:bodyPr>
+          <a:lstStyle/>
+          <a:p>
+            <a:r>
+              <a:rPr sz="2700" b="1">
+                <a:solidFill>
+                  <a:srgbClr val="1B5EA8"/>
+                </a:solidFill>
+                <a:latin typeface="Meiryo"/>
+              </a:rPr>
               <a:t>実ゲームとのギャップ — シミュレーションが省いているもの</a:t>
             </a:r>
           </a:p>
@@ -6680,7 +7775,7 @@
 </p:sld>
 </file>
 
-<file path=ppt/slides/slide18.xml><?xml version="1.0" encoding="utf-8"?>
+<file path=ppt/slides/slide19.xml><?xml version="1.0" encoding="utf-8"?>
 <p:sld xmlns:a="http://schemas.openxmlformats.org/drawingml/2006/main" xmlns:p="http://schemas.openxmlformats.org/presentationml/2006/main" xmlns:r="http://schemas.openxmlformats.org/officeDocument/2006/relationships">
   <p:cSld>
     <p:spTree>
@@ -6899,241 +7994,6 @@
           </a:prstGeom>
         </p:spPr>
       </p:pic>
-    </p:spTree>
-  </p:cSld>
-  <p:clrMapOvr>
-    <a:masterClrMapping/>
-  </p:clrMapOvr>
-</p:sld>
-</file>
-
-<file path=ppt/slides/slide19.xml><?xml version="1.0" encoding="utf-8"?>
-<p:sld xmlns:a="http://schemas.openxmlformats.org/drawingml/2006/main" xmlns:p="http://schemas.openxmlformats.org/presentationml/2006/main" xmlns:r="http://schemas.openxmlformats.org/officeDocument/2006/relationships">
-  <p:cSld>
-    <p:spTree>
-      <p:nvGrpSpPr>
-        <p:cNvPr id="1" name=""/>
-        <p:cNvGrpSpPr/>
-        <p:nvPr/>
-      </p:nvGrpSpPr>
-      <p:grpSpPr/>
-      <p:sp>
-        <p:nvSpPr>
-          <p:cNvPr id="2" name="TextBox 1"/>
-          <p:cNvSpPr txBox="1"/>
-          <p:nvPr/>
-        </p:nvSpPr>
-        <p:spPr>
-          <a:xfrm>
-            <a:off x="457200" y="182880"/>
-            <a:ext cx="11247120" cy="731520"/>
-          </a:xfrm>
-          <a:prstGeom prst="rect">
-            <a:avLst/>
-          </a:prstGeom>
-          <a:noFill/>
-        </p:spPr>
-        <p:txBody>
-          <a:bodyPr wrap="none">
-            <a:spAutoFit/>
-          </a:bodyPr>
-          <a:lstStyle/>
-          <a:p>
-            <a:r>
-              <a:rPr sz="2700" b="1">
-                <a:solidFill>
-                  <a:srgbClr val="1B5EA8"/>
-                </a:solidFill>
-                <a:latin typeface="Meiryo"/>
-              </a:rPr>
-              <a:t>セットアップとノートブックの使い方</a:t>
-            </a:r>
-          </a:p>
-        </p:txBody>
-      </p:sp>
-      <p:sp>
-        <p:nvSpPr>
-          <p:cNvPr id="3" name="TextBox 2"/>
-          <p:cNvSpPr txBox="1"/>
-          <p:nvPr/>
-        </p:nvSpPr>
-        <p:spPr>
-          <a:xfrm>
-            <a:off x="548640" y="1188720"/>
-            <a:ext cx="11064240" cy="5486400"/>
-          </a:xfrm>
-          <a:prstGeom prst="rect">
-            <a:avLst/>
-          </a:prstGeom>
-          <a:noFill/>
-        </p:spPr>
-        <p:txBody>
-          <a:bodyPr wrap="square">
-            <a:spAutoFit/>
-          </a:bodyPr>
-          <a:lstStyle/>
-          <a:p>
-            <a:pPr>
-              <a:spcAft>
-                <a:spcPts val="600"/>
-              </a:spcAft>
-            </a:pPr>
-            <a:r>
-              <a:rPr sz="1600" b="1">
-                <a:solidFill>
-                  <a:srgbClr val="222222"/>
-                </a:solidFill>
-                <a:latin typeface="Meiryo"/>
-              </a:rPr>
-              <a:t>環境構築</a:t>
-            </a:r>
-          </a:p>
-          <a:p>
-            <a:pPr lvl="1">
-              <a:spcAft>
-                <a:spcPts val="200"/>
-              </a:spcAft>
-            </a:pPr>
-            <a:r>
-              <a:rPr sz="1400" b="0">
-                <a:solidFill>
-                  <a:srgbClr val="595959"/>
-                </a:solidFill>
-                <a:latin typeface="Meiryo"/>
-              </a:rPr>
-              <a:t>・pip install "highway-env&gt;=1.8" "stable-baselines3[extra]&gt;=2.0" gymnasium torch tensorboard moviepy onnx onnxruntime</a:t>
-            </a:r>
-          </a:p>
-          <a:p>
-            <a:pPr lvl="1">
-              <a:spcAft>
-                <a:spcPts val="200"/>
-              </a:spcAft>
-            </a:pPr>
-            <a:r>
-              <a:rPr sz="1400" b="0">
-                <a:solidFill>
-                  <a:srgbClr val="B32D2D"/>
-                </a:solidFill>
-                <a:latin typeface="Meiryo"/>
-              </a:rPr>
-              <a:t>・リポジトリの requirements.txt は旧 TF スタック用 — 使わない</a:t>
-            </a:r>
-          </a:p>
-          <a:p>
-            <a:pPr>
-              <a:spcAft>
-                <a:spcPts val="600"/>
-              </a:spcAft>
-            </a:pPr>
-            <a:r>
-              <a:rPr sz="1600" b="1">
-                <a:solidFill>
-                  <a:srgbClr val="222222"/>
-                </a:solidFill>
-                <a:latin typeface="Meiryo"/>
-              </a:rPr>
-              <a:t>ノートブック</a:t>
-            </a:r>
-          </a:p>
-          <a:p>
-            <a:pPr lvl="1">
-              <a:spcAft>
-                <a:spcPts val="200"/>
-              </a:spcAft>
-            </a:pPr>
-            <a:r>
-              <a:rPr sz="1400" b="0">
-                <a:solidFill>
-                  <a:srgbClr val="595959"/>
-                </a:solidFill>
-                <a:latin typeface="Meiryo"/>
-              </a:rPr>
-              <a:t>・task2: fast トラック学習 / task3: random 学習 + トラック別レポート + 5 連動画</a:t>
-            </a:r>
-          </a:p>
-          <a:p>
-            <a:pPr lvl="1">
-              <a:spcAft>
-                <a:spcPts val="200"/>
-              </a:spcAft>
-            </a:pPr>
-            <a:r>
-              <a:rPr sz="1400" b="0">
-                <a:solidFill>
-                  <a:srgbClr val="595959"/>
-                </a:solidFill>
-                <a:latin typeface="Meiryo"/>
-              </a:rPr>
-              <a:t>・FAST_DEV_RUN=True: 12〜15 万 step (周回到達を実測保証) / False: 本番 100 万+</a:t>
-            </a:r>
-          </a:p>
-          <a:p>
-            <a:pPr>
-              <a:spcAft>
-                <a:spcPts val="600"/>
-              </a:spcAft>
-            </a:pPr>
-            <a:r>
-              <a:rPr sz="1600" b="1">
-                <a:solidFill>
-                  <a:srgbClr val="222222"/>
-                </a:solidFill>
-                <a:latin typeface="Meiryo"/>
-              </a:rPr>
-              <a:t>進捗の読み方</a:t>
-            </a:r>
-          </a:p>
-          <a:p>
-            <a:pPr lvl="1">
-              <a:spcAft>
-                <a:spcPts val="200"/>
-              </a:spcAft>
-            </a:pPr>
-            <a:r>
-              <a:rPr sz="1400" b="0">
-                <a:solidFill>
-                  <a:srgbClr val="595959"/>
-                </a:solidFill>
-                <a:latin typeface="Meiryo"/>
-              </a:rPr>
-              <a:t>・Reward yardstick: 1 周 ≈ 101 / アイドル床 ≈ 0.53/step — eval 値を周回数として読む</a:t>
-            </a:r>
-          </a:p>
-          <a:p>
-            <a:pPr lvl="1">
-              <a:spcAft>
-                <a:spcPts val="200"/>
-              </a:spcAft>
-            </a:pPr>
-            <a:r>
-              <a:rPr sz="1400" b="0">
-                <a:solidFill>
-                  <a:srgbClr val="595959"/>
-                </a:solidFill>
-                <a:latin typeface="Meiryo"/>
-              </a:rPr>
-              <a:t>・Presentation Media セル: 学習曲線・軌跡・5 連動画を生成し VIDEO_DIR に保存</a:t>
-            </a:r>
-          </a:p>
-          <a:p>
-            <a:pPr>
-              <a:spcAft>
-                <a:spcPts val="600"/>
-              </a:spcAft>
-            </a:pPr>
-            <a:r>
-              <a:rPr sz="1600" b="0">
-                <a:solidFill>
-                  <a:srgbClr val="222222"/>
-                </a:solidFill>
-                <a:latin typeface="Meiryo"/>
-              </a:rPr>
-              <a:t>C# 検証: cd re_engine/verify &amp;&amp; dotnet run -- ..  → ALL SCENARIOS MATCH</a:t>
-            </a:r>
-          </a:p>
-        </p:txBody>
-      </p:sp>
     </p:spTree>
   </p:cSld>
   <p:clrMapOvr>
@@ -7312,6 +8172,241 @@
                 </a:solidFill>
                 <a:latin typeface="Meiryo"/>
               </a:rPr>
+              <a:t>セットアップとノートブックの使い方</a:t>
+            </a:r>
+          </a:p>
+        </p:txBody>
+      </p:sp>
+      <p:sp>
+        <p:nvSpPr>
+          <p:cNvPr id="3" name="TextBox 2"/>
+          <p:cNvSpPr txBox="1"/>
+          <p:nvPr/>
+        </p:nvSpPr>
+        <p:spPr>
+          <a:xfrm>
+            <a:off x="548640" y="1188720"/>
+            <a:ext cx="11064240" cy="5486400"/>
+          </a:xfrm>
+          <a:prstGeom prst="rect">
+            <a:avLst/>
+          </a:prstGeom>
+          <a:noFill/>
+        </p:spPr>
+        <p:txBody>
+          <a:bodyPr wrap="square">
+            <a:spAutoFit/>
+          </a:bodyPr>
+          <a:lstStyle/>
+          <a:p>
+            <a:pPr>
+              <a:spcAft>
+                <a:spcPts val="600"/>
+              </a:spcAft>
+            </a:pPr>
+            <a:r>
+              <a:rPr sz="1600" b="1">
+                <a:solidFill>
+                  <a:srgbClr val="222222"/>
+                </a:solidFill>
+                <a:latin typeface="Meiryo"/>
+              </a:rPr>
+              <a:t>環境構築</a:t>
+            </a:r>
+          </a:p>
+          <a:p>
+            <a:pPr lvl="1">
+              <a:spcAft>
+                <a:spcPts val="200"/>
+              </a:spcAft>
+            </a:pPr>
+            <a:r>
+              <a:rPr sz="1400" b="0">
+                <a:solidFill>
+                  <a:srgbClr val="595959"/>
+                </a:solidFill>
+                <a:latin typeface="Meiryo"/>
+              </a:rPr>
+              <a:t>・pip install "highway-env&gt;=1.8" "stable-baselines3[extra]&gt;=2.0" gymnasium torch tensorboard moviepy onnx onnxruntime</a:t>
+            </a:r>
+          </a:p>
+          <a:p>
+            <a:pPr lvl="1">
+              <a:spcAft>
+                <a:spcPts val="200"/>
+              </a:spcAft>
+            </a:pPr>
+            <a:r>
+              <a:rPr sz="1400" b="0">
+                <a:solidFill>
+                  <a:srgbClr val="B32D2D"/>
+                </a:solidFill>
+                <a:latin typeface="Meiryo"/>
+              </a:rPr>
+              <a:t>・リポジトリの requirements.txt は旧 TF スタック用 — 使わない</a:t>
+            </a:r>
+          </a:p>
+          <a:p>
+            <a:pPr>
+              <a:spcAft>
+                <a:spcPts val="600"/>
+              </a:spcAft>
+            </a:pPr>
+            <a:r>
+              <a:rPr sz="1600" b="1">
+                <a:solidFill>
+                  <a:srgbClr val="222222"/>
+                </a:solidFill>
+                <a:latin typeface="Meiryo"/>
+              </a:rPr>
+              <a:t>ノートブック</a:t>
+            </a:r>
+          </a:p>
+          <a:p>
+            <a:pPr lvl="1">
+              <a:spcAft>
+                <a:spcPts val="200"/>
+              </a:spcAft>
+            </a:pPr>
+            <a:r>
+              <a:rPr sz="1400" b="0">
+                <a:solidFill>
+                  <a:srgbClr val="595959"/>
+                </a:solidFill>
+                <a:latin typeface="Meiryo"/>
+              </a:rPr>
+              <a:t>・task2: fast トラック学習 / task3: random 学習 + トラック別レポート + 5 連動画</a:t>
+            </a:r>
+          </a:p>
+          <a:p>
+            <a:pPr lvl="1">
+              <a:spcAft>
+                <a:spcPts val="200"/>
+              </a:spcAft>
+            </a:pPr>
+            <a:r>
+              <a:rPr sz="1400" b="0">
+                <a:solidFill>
+                  <a:srgbClr val="595959"/>
+                </a:solidFill>
+                <a:latin typeface="Meiryo"/>
+              </a:rPr>
+              <a:t>・FAST_DEV_RUN=True: 12〜15 万 step (周回到達を実測保証) / False: 本番 100 万+</a:t>
+            </a:r>
+          </a:p>
+          <a:p>
+            <a:pPr>
+              <a:spcAft>
+                <a:spcPts val="600"/>
+              </a:spcAft>
+            </a:pPr>
+            <a:r>
+              <a:rPr sz="1600" b="1">
+                <a:solidFill>
+                  <a:srgbClr val="222222"/>
+                </a:solidFill>
+                <a:latin typeface="Meiryo"/>
+              </a:rPr>
+              <a:t>進捗の読み方</a:t>
+            </a:r>
+          </a:p>
+          <a:p>
+            <a:pPr lvl="1">
+              <a:spcAft>
+                <a:spcPts val="200"/>
+              </a:spcAft>
+            </a:pPr>
+            <a:r>
+              <a:rPr sz="1400" b="0">
+                <a:solidFill>
+                  <a:srgbClr val="595959"/>
+                </a:solidFill>
+                <a:latin typeface="Meiryo"/>
+              </a:rPr>
+              <a:t>・Reward yardstick: 1 周 ≈ 101 / アイドル床 ≈ 0.53/step — eval 値を周回数として読む</a:t>
+            </a:r>
+          </a:p>
+          <a:p>
+            <a:pPr lvl="1">
+              <a:spcAft>
+                <a:spcPts val="200"/>
+              </a:spcAft>
+            </a:pPr>
+            <a:r>
+              <a:rPr sz="1400" b="0">
+                <a:solidFill>
+                  <a:srgbClr val="595959"/>
+                </a:solidFill>
+                <a:latin typeface="Meiryo"/>
+              </a:rPr>
+              <a:t>・Presentation Media セル: 学習曲線・軌跡・5 連動画を生成し VIDEO_DIR に保存</a:t>
+            </a:r>
+          </a:p>
+          <a:p>
+            <a:pPr>
+              <a:spcAft>
+                <a:spcPts val="600"/>
+              </a:spcAft>
+            </a:pPr>
+            <a:r>
+              <a:rPr sz="1600" b="0">
+                <a:solidFill>
+                  <a:srgbClr val="222222"/>
+                </a:solidFill>
+                <a:latin typeface="Meiryo"/>
+              </a:rPr>
+              <a:t>C# 検証: cd re_engine/verify &amp;&amp; dotnet run -- ..  → ALL SCENARIOS MATCH</a:t>
+            </a:r>
+          </a:p>
+        </p:txBody>
+      </p:sp>
+    </p:spTree>
+  </p:cSld>
+  <p:clrMapOvr>
+    <a:masterClrMapping/>
+  </p:clrMapOvr>
+</p:sld>
+</file>
+
+<file path=ppt/slides/slide21.xml><?xml version="1.0" encoding="utf-8"?>
+<p:sld xmlns:a="http://schemas.openxmlformats.org/drawingml/2006/main" xmlns:p="http://schemas.openxmlformats.org/presentationml/2006/main" xmlns:r="http://schemas.openxmlformats.org/officeDocument/2006/relationships">
+  <p:cSld>
+    <p:spTree>
+      <p:nvGrpSpPr>
+        <p:cNvPr id="1" name=""/>
+        <p:cNvGrpSpPr/>
+        <p:nvPr/>
+      </p:nvGrpSpPr>
+      <p:grpSpPr/>
+      <p:sp>
+        <p:nvSpPr>
+          <p:cNvPr id="2" name="TextBox 1"/>
+          <p:cNvSpPr txBox="1"/>
+          <p:nvPr/>
+        </p:nvSpPr>
+        <p:spPr>
+          <a:xfrm>
+            <a:off x="457200" y="182880"/>
+            <a:ext cx="11247120" cy="731520"/>
+          </a:xfrm>
+          <a:prstGeom prst="rect">
+            <a:avLst/>
+          </a:prstGeom>
+          <a:noFill/>
+        </p:spPr>
+        <p:txBody>
+          <a:bodyPr wrap="none">
+            <a:spAutoFit/>
+          </a:bodyPr>
+          <a:lstStyle/>
+          <a:p>
+            <a:r>
+              <a:rPr sz="2700" b="1">
+                <a:solidFill>
+                  <a:srgbClr val="1B5EA8"/>
+                </a:solidFill>
+                <a:latin typeface="Meiryo"/>
+              </a:rPr>
               <a:t>エクスポートツールと ONNX の注意点</a:t>
             </a:r>
           </a:p>
@@ -7524,7 +8619,7 @@
 </p:sld>
 </file>
 
-<file path=ppt/slides/slide21.xml><?xml version="1.0" encoding="utf-8"?>
+<file path=ppt/slides/slide22.xml><?xml version="1.0" encoding="utf-8"?>
 <p:sld xmlns:a="http://schemas.openxmlformats.org/drawingml/2006/main" xmlns:p="http://schemas.openxmlformats.org/presentationml/2006/main" xmlns:r="http://schemas.openxmlformats.org/officeDocument/2006/relationships">
   <p:cSld>
     <p:spTree>

</xml_diff>